<commit_message>
Praesentation optimiert: Slide 6 mit 2-Reihen-Netzplan aktualisiert, Folie 10 Tabellen-Layout perfektioniert, Typografie harmonisiert
</commit_message>
<xml_diff>
--- a/docs/08_Projektabschluss/Abschlusspraesentation.pptx
+++ b/docs/08_Projektabschluss/Abschlusspraesentation.pptx
@@ -4857,7 +4857,9 @@
           <a:bodyPr rtlCol="0" anchor="ctr"/>
           <a:lstStyle/>
           <a:p>
-            <a:pPr algn="ctr"/>
+            <a:pPr algn="ctr">
+              <a:defRPr/>
+            </a:pPr>
           </a:p>
         </p:txBody>
       </p:sp>
@@ -4968,7 +4970,9 @@
           <a:bodyPr rtlCol="0" anchor="ctr"/>
           <a:lstStyle/>
           <a:p>
-            <a:pPr algn="ctr"/>
+            <a:pPr algn="ctr">
+              <a:defRPr/>
+            </a:pPr>
           </a:p>
         </p:txBody>
       </p:sp>
@@ -5179,8 +5183,8 @@
         </p:nvSpPr>
         <p:spPr>
           <a:xfrm>
-            <a:off x="731520" y="1371600"/>
-            <a:ext cx="5257800" cy="4846320"/>
+            <a:off x="731520" y="1234440"/>
+            <a:ext cx="5257800" cy="4937760"/>
           </a:xfrm>
           <a:prstGeom prst="roundRect">
             <a:avLst/>
@@ -5188,9 +5192,9 @@
           <a:solidFill>
             <a:srgbClr val="FFFFFF"/>
           </a:solidFill>
-          <a:ln w="19050">
+          <a:ln w="15240">
             <a:solidFill>
-              <a:srgbClr val="B4C6E7"/>
+              <a:srgbClr val="C8D7EB"/>
             </a:solidFill>
           </a:ln>
         </p:spPr>
@@ -5218,174 +5222,23 @@
       </p:sp>
       <p:sp>
         <p:nvSpPr>
-          <p:cNvPr id="6" name="TextBox 5"/>
-          <p:cNvSpPr txBox="1"/>
-          <p:nvPr/>
-        </p:nvSpPr>
-        <p:spPr>
-          <a:xfrm>
-            <a:off x="914400" y="1554480"/>
-            <a:ext cx="4892040" cy="4480560"/>
+          <p:cNvPr id="6" name="Rectangle 5"/>
+          <p:cNvSpPr/>
+          <p:nvPr/>
+        </p:nvSpPr>
+        <p:spPr>
+          <a:xfrm>
+            <a:off x="731520" y="1234440"/>
+            <a:ext cx="5257800" cy="502920"/>
           </a:xfrm>
           <a:prstGeom prst="rect">
             <a:avLst/>
           </a:prstGeom>
-          <a:noFill/>
-        </p:spPr>
-        <p:txBody>
-          <a:bodyPr wrap="square">
-            <a:spAutoFit/>
-          </a:bodyPr>
-          <a:lstStyle/>
-          <a:p>
-            <a:pPr>
-              <a:defRPr b="1" sz="1200">
-                <a:solidFill>
-                  <a:srgbClr val="1F497D"/>
-                </a:solidFill>
-              </a:defRPr>
-            </a:pPr>
-            <a:r>
-              <a:t>Kaufmännisches Kalkulationsschema:</a:t>
-            </a:r>
-          </a:p>
-          <a:p>
-            <a:pPr>
-              <a:spcAft>
-                <a:spcPts val="400"/>
-              </a:spcAft>
-              <a:defRPr sz="1000">
-                <a:solidFill>
-                  <a:srgbClr val="262626"/>
-                </a:solidFill>
-              </a:defRPr>
-            </a:pPr>
-            <a:r>
-              <a:t>Bezugspreis (Einkauf Fachhandel netto)</a:t>
-            </a:r>
-            <a:br/>
-            <a:r>
-              <a:t>   ➔ Ausgangsbasis</a:t>
-            </a:r>
-          </a:p>
-          <a:p>
-            <a:pPr>
-              <a:spcAft>
-                <a:spcPts val="400"/>
-              </a:spcAft>
-              <a:defRPr sz="1000">
-                <a:solidFill>
-                  <a:srgbClr val="262626"/>
-                </a:solidFill>
-              </a:defRPr>
-            </a:pPr>
-            <a:r>
-              <a:t>+ Handlungskostenzuschlag (25,0 %)</a:t>
-            </a:r>
-            <a:br/>
-            <a:r>
-              <a:t>   ➔ = Selbstkostenpreis</a:t>
-            </a:r>
-          </a:p>
-          <a:p>
-            <a:pPr>
-              <a:spcAft>
-                <a:spcPts val="400"/>
-              </a:spcAft>
-              <a:defRPr sz="1000">
-                <a:solidFill>
-                  <a:srgbClr val="262626"/>
-                </a:solidFill>
-              </a:defRPr>
-            </a:pPr>
-            <a:r>
-              <a:t>+ Gewinnzuschlag (12,0 %)</a:t>
-            </a:r>
-            <a:br/>
-            <a:r>
-              <a:t>   ➔ = Barverkaufspreis</a:t>
-            </a:r>
-          </a:p>
-          <a:p>
-            <a:pPr>
-              <a:spcAft>
-                <a:spcPts val="400"/>
-              </a:spcAft>
-              <a:defRPr sz="1000">
-                <a:solidFill>
-                  <a:srgbClr val="262626"/>
-                </a:solidFill>
-              </a:defRPr>
-            </a:pPr>
-            <a:r>
-              <a:t>+ Kundenskonto (3,0 % im Hundert)</a:t>
-            </a:r>
-            <a:br/>
-            <a:r>
-              <a:t>   ➔ = Zielverkaufspreis</a:t>
-            </a:r>
-          </a:p>
-          <a:p>
-            <a:pPr>
-              <a:spcAft>
-                <a:spcPts val="400"/>
-              </a:spcAft>
-              <a:defRPr sz="1000">
-                <a:solidFill>
-                  <a:srgbClr val="262626"/>
-                </a:solidFill>
-              </a:defRPr>
-            </a:pPr>
-            <a:r>
-              <a:t>+ Kundenrabatt (0,0 % für Neukunde)</a:t>
-            </a:r>
-            <a:br/>
-            <a:r>
-              <a:t>   ➔ = Listenverkaufspreis netto</a:t>
-            </a:r>
-          </a:p>
-          <a:p>
-            <a:pPr>
-              <a:spcAft>
-                <a:spcPts val="400"/>
-              </a:spcAft>
-              <a:defRPr sz="1000">
-                <a:solidFill>
-                  <a:srgbClr val="262626"/>
-                </a:solidFill>
-              </a:defRPr>
-            </a:pPr>
-            <a:r>
-              <a:t>+ Gesetzliche Umsatzsteuer (19,0 %)</a:t>
-            </a:r>
-            <a:br/>
-            <a:r>
-              <a:t>   ➔ = Gesamtangebot brutto</a:t>
-            </a:r>
-          </a:p>
-        </p:txBody>
-      </p:sp>
-      <p:sp>
-        <p:nvSpPr>
-          <p:cNvPr id="7" name="Rounded Rectangle 6"/>
-          <p:cNvSpPr/>
-          <p:nvPr/>
-        </p:nvSpPr>
-        <p:spPr>
-          <a:xfrm>
-            <a:off x="6217920" y="1371600"/>
-            <a:ext cx="5257800" cy="4846320"/>
-          </a:xfrm>
-          <a:prstGeom prst="roundRect">
-            <a:avLst/>
-          </a:prstGeom>
           <a:solidFill>
-            <a:srgbClr val="FFFFFF"/>
+            <a:srgbClr val="1F497D"/>
           </a:solidFill>
-          <a:ln w="19050">
-            <a:solidFill>
-              <a:srgbClr val="B4C6E7"/>
-            </a:solidFill>
+          <a:ln>
+            <a:noFill/>
           </a:ln>
         </p:spPr>
         <p:style>
@@ -5406,20 +5259,1292 @@
           <a:bodyPr rtlCol="0" anchor="ctr"/>
           <a:lstStyle/>
           <a:p>
+            <a:pPr algn="ctr">
+              <a:defRPr sz="1200" b="1">
+                <a:solidFill>
+                  <a:srgbClr val="FFFFFF"/>
+                </a:solidFill>
+                <a:latin typeface="Calibri"/>
+              </a:defRPr>
+            </a:pPr>
+            <a:r>
+              <a:t>Kaufmännische Vorwärtskalkulation (IHK-Schema)</a:t>
+            </a:r>
+          </a:p>
+        </p:txBody>
+      </p:sp>
+      <p:graphicFrame>
+        <p:nvGraphicFramePr>
+          <p:cNvPr id="7" name="Table 6"/>
+          <p:cNvGraphicFramePr>
+            <a:graphicFrameLocks noGrp="1"/>
+          </p:cNvGraphicFramePr>
+          <p:nvPr/>
+        </p:nvGraphicFramePr>
+        <p:xfrm>
+          <a:off x="868680" y="1874519"/>
+          <a:ext cx="4983480" cy="4114800"/>
+        </p:xfrm>
+        <a:graphic>
+          <a:graphicData uri="http://schemas.openxmlformats.org/drawingml/2006/table">
+            <a:tbl>
+              <a:tblPr firstRow="1" bandRow="1">
+                <a:tableStyleId>{5C22544A-7EE6-4342-B048-85BDC9FD1C3A}</a:tableStyleId>
+              </a:tblPr>
+              <a:tblGrid>
+                <a:gridCol w="2011680"/>
+                <a:gridCol w="2194560"/>
+                <a:gridCol w="777240"/>
+              </a:tblGrid>
+              <a:tr h="411480">
+                <a:tc>
+                  <a:txBody>
+                    <a:bodyPr wrap="square"/>
+                    <a:lstStyle/>
+                    <a:p>
+                      <a:pPr>
+                        <a:defRPr sz="950" b="1">
+                          <a:solidFill>
+                            <a:srgbClr val="1F497D"/>
+                          </a:solidFill>
+                          <a:latin typeface="Calibri"/>
+                        </a:defRPr>
+                      </a:pPr>
+                      <a:r>
+                        <a:t>Kalkulationsschritt</a:t>
+                      </a:r>
+                    </a:p>
+                  </a:txBody>
+                  <a:tcPr>
+                    <a:solidFill>
+                      <a:srgbClr val="F0F3F8"/>
+                    </a:solidFill>
+                  </a:tcPr>
+                </a:tc>
+                <a:tc>
+                  <a:txBody>
+                    <a:bodyPr wrap="square"/>
+                    <a:lstStyle/>
+                    <a:p>
+                      <a:pPr>
+                        <a:defRPr sz="950" b="1">
+                          <a:solidFill>
+                            <a:srgbClr val="1F497D"/>
+                          </a:solidFill>
+                          <a:latin typeface="Calibri"/>
+                        </a:defRPr>
+                      </a:pPr>
+                      <a:r>
+                        <a:t>Bedeutung / Zuschlagssatz</a:t>
+                      </a:r>
+                    </a:p>
+                  </a:txBody>
+                  <a:tcPr>
+                    <a:solidFill>
+                      <a:srgbClr val="F0F3F8"/>
+                    </a:solidFill>
+                  </a:tcPr>
+                </a:tc>
+                <a:tc>
+                  <a:txBody>
+                    <a:bodyPr wrap="square"/>
+                    <a:lstStyle/>
+                    <a:p>
+                      <a:pPr>
+                        <a:defRPr sz="950" b="1">
+                          <a:solidFill>
+                            <a:srgbClr val="1F497D"/>
+                          </a:solidFill>
+                          <a:latin typeface="Calibri"/>
+                        </a:defRPr>
+                      </a:pPr>
+                      <a:r>
+                        <a:t>Wert</a:t>
+                      </a:r>
+                    </a:p>
+                  </a:txBody>
+                  <a:tcPr>
+                    <a:solidFill>
+                      <a:srgbClr val="F0F3F8"/>
+                    </a:solidFill>
+                  </a:tcPr>
+                </a:tc>
+              </a:tr>
+              <a:tr h="411480">
+                <a:tc>
+                  <a:txBody>
+                    <a:bodyPr wrap="square"/>
+                    <a:lstStyle/>
+                    <a:p>
+                      <a:pPr>
+                        <a:defRPr sz="900">
+                          <a:solidFill>
+                            <a:srgbClr val="262626"/>
+                          </a:solidFill>
+                          <a:latin typeface="Calibri"/>
+                        </a:defRPr>
+                      </a:pPr>
+                      <a:r>
+                        <a:t>Bezugspreis (BP)</a:t>
+                      </a:r>
+                    </a:p>
+                  </a:txBody>
+                  <a:tcPr>
+                    <a:solidFill>
+                      <a:srgbClr val="F9FAFC"/>
+                    </a:solidFill>
+                  </a:tcPr>
+                </a:tc>
+                <a:tc>
+                  <a:txBody>
+                    <a:bodyPr wrap="square"/>
+                    <a:lstStyle/>
+                    <a:p>
+                      <a:pPr>
+                        <a:defRPr sz="900">
+                          <a:solidFill>
+                            <a:srgbClr val="262626"/>
+                          </a:solidFill>
+                          <a:latin typeface="Calibri"/>
+                        </a:defRPr>
+                      </a:pPr>
+                      <a:r>
+                        <a:t>Ausgangsbasis (Einkauf Fachhandel)</a:t>
+                      </a:r>
+                    </a:p>
+                  </a:txBody>
+                  <a:tcPr>
+                    <a:solidFill>
+                      <a:srgbClr val="F9FAFC"/>
+                    </a:solidFill>
+                  </a:tcPr>
+                </a:tc>
+                <a:tc>
+                  <a:txBody>
+                    <a:bodyPr wrap="square"/>
+                    <a:lstStyle/>
+                    <a:p>
+                      <a:pPr>
+                        <a:defRPr sz="900">
+                          <a:solidFill>
+                            <a:srgbClr val="262626"/>
+                          </a:solidFill>
+                          <a:latin typeface="Calibri"/>
+                        </a:defRPr>
+                      </a:pPr>
+                      <a:r>
+                        <a:t>100,0 %</a:t>
+                      </a:r>
+                    </a:p>
+                  </a:txBody>
+                  <a:tcPr>
+                    <a:solidFill>
+                      <a:srgbClr val="F9FAFC"/>
+                    </a:solidFill>
+                  </a:tcPr>
+                </a:tc>
+              </a:tr>
+              <a:tr h="411480">
+                <a:tc>
+                  <a:txBody>
+                    <a:bodyPr wrap="square"/>
+                    <a:lstStyle/>
+                    <a:p>
+                      <a:pPr>
+                        <a:defRPr sz="900">
+                          <a:solidFill>
+                            <a:srgbClr val="262626"/>
+                          </a:solidFill>
+                          <a:latin typeface="Calibri"/>
+                        </a:defRPr>
+                      </a:pPr>
+                      <a:r>
+                        <a:t>+ Handlungskostenzuschlag</a:t>
+                      </a:r>
+                    </a:p>
+                  </a:txBody>
+                  <a:tcPr>
+                    <a:solidFill>
+                      <a:srgbClr val="FFFFFF"/>
+                    </a:solidFill>
+                  </a:tcPr>
+                </a:tc>
+                <a:tc>
+                  <a:txBody>
+                    <a:bodyPr wrap="square"/>
+                    <a:lstStyle/>
+                    <a:p>
+                      <a:pPr>
+                        <a:defRPr sz="900">
+                          <a:solidFill>
+                            <a:srgbClr val="262626"/>
+                          </a:solidFill>
+                          <a:latin typeface="Calibri"/>
+                        </a:defRPr>
+                      </a:pPr>
+                      <a:r>
+                        <a:t>25,0 % auf Bezugspreis</a:t>
+                      </a:r>
+                    </a:p>
+                  </a:txBody>
+                  <a:tcPr>
+                    <a:solidFill>
+                      <a:srgbClr val="FFFFFF"/>
+                    </a:solidFill>
+                  </a:tcPr>
+                </a:tc>
+                <a:tc>
+                  <a:txBody>
+                    <a:bodyPr wrap="square"/>
+                    <a:lstStyle/>
+                    <a:p>
+                      <a:pPr>
+                        <a:defRPr sz="900">
+                          <a:solidFill>
+                            <a:srgbClr val="262626"/>
+                          </a:solidFill>
+                          <a:latin typeface="Calibri"/>
+                        </a:defRPr>
+                      </a:pPr>
+                      <a:r>
+                        <a:t>+ 25,0 %</a:t>
+                      </a:r>
+                    </a:p>
+                  </a:txBody>
+                  <a:tcPr>
+                    <a:solidFill>
+                      <a:srgbClr val="FFFFFF"/>
+                    </a:solidFill>
+                  </a:tcPr>
+                </a:tc>
+              </a:tr>
+              <a:tr h="411480">
+                <a:tc>
+                  <a:txBody>
+                    <a:bodyPr wrap="square"/>
+                    <a:lstStyle/>
+                    <a:p>
+                      <a:pPr>
+                        <a:defRPr sz="900">
+                          <a:solidFill>
+                            <a:srgbClr val="262626"/>
+                          </a:solidFill>
+                          <a:latin typeface="Calibri"/>
+                        </a:defRPr>
+                      </a:pPr>
+                      <a:r>
+                        <a:t>= Selbstkostenpreis (SKP)</a:t>
+                      </a:r>
+                    </a:p>
+                  </a:txBody>
+                  <a:tcPr>
+                    <a:solidFill>
+                      <a:srgbClr val="F9FAFC"/>
+                    </a:solidFill>
+                  </a:tcPr>
+                </a:tc>
+                <a:tc>
+                  <a:txBody>
+                    <a:bodyPr wrap="square"/>
+                    <a:lstStyle/>
+                    <a:p>
+                      <a:pPr>
+                        <a:defRPr sz="900">
+                          <a:solidFill>
+                            <a:srgbClr val="262626"/>
+                          </a:solidFill>
+                          <a:latin typeface="Calibri"/>
+                        </a:defRPr>
+                      </a:pPr>
+                      <a:r>
+                        <a:t>Kostendeckender Mindestpreis</a:t>
+                      </a:r>
+                    </a:p>
+                  </a:txBody>
+                  <a:tcPr>
+                    <a:solidFill>
+                      <a:srgbClr val="F9FAFC"/>
+                    </a:solidFill>
+                  </a:tcPr>
+                </a:tc>
+                <a:tc>
+                  <a:txBody>
+                    <a:bodyPr wrap="square"/>
+                    <a:lstStyle/>
+                    <a:p>
+                      <a:pPr>
+                        <a:defRPr sz="900">
+                          <a:solidFill>
+                            <a:srgbClr val="262626"/>
+                          </a:solidFill>
+                          <a:latin typeface="Calibri"/>
+                        </a:defRPr>
+                      </a:pPr>
+                      <a:r>
+                        <a:t>= 125,0 %</a:t>
+                      </a:r>
+                    </a:p>
+                  </a:txBody>
+                  <a:tcPr>
+                    <a:solidFill>
+                      <a:srgbClr val="F9FAFC"/>
+                    </a:solidFill>
+                  </a:tcPr>
+                </a:tc>
+              </a:tr>
+              <a:tr h="411480">
+                <a:tc>
+                  <a:txBody>
+                    <a:bodyPr wrap="square"/>
+                    <a:lstStyle/>
+                    <a:p>
+                      <a:pPr>
+                        <a:defRPr sz="900">
+                          <a:solidFill>
+                            <a:srgbClr val="262626"/>
+                          </a:solidFill>
+                          <a:latin typeface="Calibri"/>
+                        </a:defRPr>
+                      </a:pPr>
+                      <a:r>
+                        <a:t>+ Gewinnzuschlag</a:t>
+                      </a:r>
+                    </a:p>
+                  </a:txBody>
+                  <a:tcPr>
+                    <a:solidFill>
+                      <a:srgbClr val="FFFFFF"/>
+                    </a:solidFill>
+                  </a:tcPr>
+                </a:tc>
+                <a:tc>
+                  <a:txBody>
+                    <a:bodyPr wrap="square"/>
+                    <a:lstStyle/>
+                    <a:p>
+                      <a:pPr>
+                        <a:defRPr sz="900">
+                          <a:solidFill>
+                            <a:srgbClr val="262626"/>
+                          </a:solidFill>
+                          <a:latin typeface="Calibri"/>
+                        </a:defRPr>
+                      </a:pPr>
+                      <a:r>
+                        <a:t>12,0 % auf Selbstkosten</a:t>
+                      </a:r>
+                    </a:p>
+                  </a:txBody>
+                  <a:tcPr>
+                    <a:solidFill>
+                      <a:srgbClr val="FFFFFF"/>
+                    </a:solidFill>
+                  </a:tcPr>
+                </a:tc>
+                <a:tc>
+                  <a:txBody>
+                    <a:bodyPr wrap="square"/>
+                    <a:lstStyle/>
+                    <a:p>
+                      <a:pPr>
+                        <a:defRPr sz="900">
+                          <a:solidFill>
+                            <a:srgbClr val="262626"/>
+                          </a:solidFill>
+                          <a:latin typeface="Calibri"/>
+                        </a:defRPr>
+                      </a:pPr>
+                      <a:r>
+                        <a:t>+ 15,0 %</a:t>
+                      </a:r>
+                    </a:p>
+                  </a:txBody>
+                  <a:tcPr>
+                    <a:solidFill>
+                      <a:srgbClr val="FFFFFF"/>
+                    </a:solidFill>
+                  </a:tcPr>
+                </a:tc>
+              </a:tr>
+              <a:tr h="411480">
+                <a:tc>
+                  <a:txBody>
+                    <a:bodyPr wrap="square"/>
+                    <a:lstStyle/>
+                    <a:p>
+                      <a:pPr>
+                        <a:defRPr sz="900">
+                          <a:solidFill>
+                            <a:srgbClr val="262626"/>
+                          </a:solidFill>
+                          <a:latin typeface="Calibri"/>
+                        </a:defRPr>
+                      </a:pPr>
+                      <a:r>
+                        <a:t>= Barverkaufspreis (BVP)</a:t>
+                      </a:r>
+                    </a:p>
+                  </a:txBody>
+                  <a:tcPr>
+                    <a:solidFill>
+                      <a:srgbClr val="F9FAFC"/>
+                    </a:solidFill>
+                  </a:tcPr>
+                </a:tc>
+                <a:tc>
+                  <a:txBody>
+                    <a:bodyPr wrap="square"/>
+                    <a:lstStyle/>
+                    <a:p>
+                      <a:pPr>
+                        <a:defRPr sz="900">
+                          <a:solidFill>
+                            <a:srgbClr val="262626"/>
+                          </a:solidFill>
+                          <a:latin typeface="Calibri"/>
+                        </a:defRPr>
+                      </a:pPr>
+                      <a:r>
+                        <a:t>Preis bei Sofortzahlung</a:t>
+                      </a:r>
+                    </a:p>
+                  </a:txBody>
+                  <a:tcPr>
+                    <a:solidFill>
+                      <a:srgbClr val="F9FAFC"/>
+                    </a:solidFill>
+                  </a:tcPr>
+                </a:tc>
+                <a:tc>
+                  <a:txBody>
+                    <a:bodyPr wrap="square"/>
+                    <a:lstStyle/>
+                    <a:p>
+                      <a:pPr>
+                        <a:defRPr sz="900">
+                          <a:solidFill>
+                            <a:srgbClr val="262626"/>
+                          </a:solidFill>
+                          <a:latin typeface="Calibri"/>
+                        </a:defRPr>
+                      </a:pPr>
+                      <a:r>
+                        <a:t>= 140,0 %</a:t>
+                      </a:r>
+                    </a:p>
+                  </a:txBody>
+                  <a:tcPr>
+                    <a:solidFill>
+                      <a:srgbClr val="F9FAFC"/>
+                    </a:solidFill>
+                  </a:tcPr>
+                </a:tc>
+              </a:tr>
+              <a:tr h="411480">
+                <a:tc>
+                  <a:txBody>
+                    <a:bodyPr wrap="square"/>
+                    <a:lstStyle/>
+                    <a:p>
+                      <a:pPr>
+                        <a:defRPr sz="900">
+                          <a:solidFill>
+                            <a:srgbClr val="262626"/>
+                          </a:solidFill>
+                          <a:latin typeface="Calibri"/>
+                        </a:defRPr>
+                      </a:pPr>
+                      <a:r>
+                        <a:t>+ Kundenskonto</a:t>
+                      </a:r>
+                    </a:p>
+                  </a:txBody>
+                  <a:tcPr>
+                    <a:solidFill>
+                      <a:srgbClr val="FFFFFF"/>
+                    </a:solidFill>
+                  </a:tcPr>
+                </a:tc>
+                <a:tc>
+                  <a:txBody>
+                    <a:bodyPr wrap="square"/>
+                    <a:lstStyle/>
+                    <a:p>
+                      <a:pPr>
+                        <a:defRPr sz="900">
+                          <a:solidFill>
+                            <a:srgbClr val="262626"/>
+                          </a:solidFill>
+                          <a:latin typeface="Calibri"/>
+                        </a:defRPr>
+                      </a:pPr>
+                      <a:r>
+                        <a:t>3,0 % im Hundert (ZVP = BVP ÷ 0,97)</a:t>
+                      </a:r>
+                    </a:p>
+                  </a:txBody>
+                  <a:tcPr>
+                    <a:solidFill>
+                      <a:srgbClr val="FFFFFF"/>
+                    </a:solidFill>
+                  </a:tcPr>
+                </a:tc>
+                <a:tc>
+                  <a:txBody>
+                    <a:bodyPr wrap="square"/>
+                    <a:lstStyle/>
+                    <a:p>
+                      <a:pPr>
+                        <a:defRPr sz="900">
+                          <a:solidFill>
+                            <a:srgbClr val="262626"/>
+                          </a:solidFill>
+                          <a:latin typeface="Calibri"/>
+                        </a:defRPr>
+                      </a:pPr>
+                      <a:r>
+                        <a:t>+ 4,33 %</a:t>
+                      </a:r>
+                    </a:p>
+                  </a:txBody>
+                  <a:tcPr>
+                    <a:solidFill>
+                      <a:srgbClr val="FFFFFF"/>
+                    </a:solidFill>
+                  </a:tcPr>
+                </a:tc>
+              </a:tr>
+              <a:tr h="411480">
+                <a:tc>
+                  <a:txBody>
+                    <a:bodyPr wrap="square"/>
+                    <a:lstStyle/>
+                    <a:p>
+                      <a:pPr>
+                        <a:defRPr sz="900" b="1">
+                          <a:solidFill>
+                            <a:srgbClr val="1F497D"/>
+                          </a:solidFill>
+                          <a:latin typeface="Calibri"/>
+                        </a:defRPr>
+                      </a:pPr>
+                      <a:r>
+                        <a:t>= Angebotspreis netto</a:t>
+                      </a:r>
+                    </a:p>
+                  </a:txBody>
+                  <a:tcPr>
+                    <a:solidFill>
+                      <a:srgbClr val="FFFDF5"/>
+                    </a:solidFill>
+                  </a:tcPr>
+                </a:tc>
+                <a:tc>
+                  <a:txBody>
+                    <a:bodyPr wrap="square"/>
+                    <a:lstStyle/>
+                    <a:p>
+                      <a:pPr>
+                        <a:defRPr sz="900" b="1">
+                          <a:solidFill>
+                            <a:srgbClr val="1F497D"/>
+                          </a:solidFill>
+                          <a:latin typeface="Calibri"/>
+                        </a:defRPr>
+                      </a:pPr>
+                      <a:r>
+                        <a:t>Listenverkaufspreis an Kunden</a:t>
+                      </a:r>
+                    </a:p>
+                  </a:txBody>
+                  <a:tcPr>
+                    <a:solidFill>
+                      <a:srgbClr val="FFFDF5"/>
+                    </a:solidFill>
+                  </a:tcPr>
+                </a:tc>
+                <a:tc>
+                  <a:txBody>
+                    <a:bodyPr wrap="square"/>
+                    <a:lstStyle/>
+                    <a:p>
+                      <a:pPr>
+                        <a:defRPr sz="900" b="1">
+                          <a:solidFill>
+                            <a:srgbClr val="1F497D"/>
+                          </a:solidFill>
+                          <a:latin typeface="Calibri"/>
+                        </a:defRPr>
+                      </a:pPr>
+                      <a:r>
+                        <a:t>= 67.179,32 €</a:t>
+                      </a:r>
+                    </a:p>
+                  </a:txBody>
+                  <a:tcPr>
+                    <a:solidFill>
+                      <a:srgbClr val="FFFDF5"/>
+                    </a:solidFill>
+                  </a:tcPr>
+                </a:tc>
+              </a:tr>
+              <a:tr h="411480">
+                <a:tc>
+                  <a:txBody>
+                    <a:bodyPr wrap="square"/>
+                    <a:lstStyle/>
+                    <a:p>
+                      <a:pPr>
+                        <a:defRPr sz="900">
+                          <a:solidFill>
+                            <a:srgbClr val="262626"/>
+                          </a:solidFill>
+                          <a:latin typeface="Calibri"/>
+                        </a:defRPr>
+                      </a:pPr>
+                      <a:r>
+                        <a:t>+ 19% Gesetzliche USt.</a:t>
+                      </a:r>
+                    </a:p>
+                  </a:txBody>
+                  <a:tcPr>
+                    <a:solidFill>
+                      <a:srgbClr val="FFFFFF"/>
+                    </a:solidFill>
+                  </a:tcPr>
+                </a:tc>
+                <a:tc>
+                  <a:txBody>
+                    <a:bodyPr wrap="square"/>
+                    <a:lstStyle/>
+                    <a:p>
+                      <a:pPr>
+                        <a:defRPr sz="900">
+                          <a:solidFill>
+                            <a:srgbClr val="262626"/>
+                          </a:solidFill>
+                          <a:latin typeface="Calibri"/>
+                        </a:defRPr>
+                      </a:pPr>
+                      <a:r>
+                        <a:t>Umsatzsteuer auf Gesamtangebot</a:t>
+                      </a:r>
+                    </a:p>
+                  </a:txBody>
+                  <a:tcPr>
+                    <a:solidFill>
+                      <a:srgbClr val="FFFFFF"/>
+                    </a:solidFill>
+                  </a:tcPr>
+                </a:tc>
+                <a:tc>
+                  <a:txBody>
+                    <a:bodyPr wrap="square"/>
+                    <a:lstStyle/>
+                    <a:p>
+                      <a:pPr>
+                        <a:defRPr sz="900">
+                          <a:solidFill>
+                            <a:srgbClr val="262626"/>
+                          </a:solidFill>
+                          <a:latin typeface="Calibri"/>
+                        </a:defRPr>
+                      </a:pPr>
+                      <a:r>
+                        <a:t>= 12.764,07 €</a:t>
+                      </a:r>
+                    </a:p>
+                  </a:txBody>
+                  <a:tcPr>
+                    <a:solidFill>
+                      <a:srgbClr val="FFFFFF"/>
+                    </a:solidFill>
+                  </a:tcPr>
+                </a:tc>
+              </a:tr>
+              <a:tr h="411480">
+                <a:tc>
+                  <a:txBody>
+                    <a:bodyPr wrap="square"/>
+                    <a:lstStyle/>
+                    <a:p>
+                      <a:pPr>
+                        <a:defRPr sz="900" b="1">
+                          <a:solidFill>
+                            <a:srgbClr val="C00000"/>
+                          </a:solidFill>
+                          <a:latin typeface="Calibri"/>
+                        </a:defRPr>
+                      </a:pPr>
+                      <a:r>
+                        <a:t>= Gesamtangebot brutto</a:t>
+                      </a:r>
+                    </a:p>
+                  </a:txBody>
+                  <a:tcPr>
+                    <a:solidFill>
+                      <a:srgbClr val="FFFDF5"/>
+                    </a:solidFill>
+                  </a:tcPr>
+                </a:tc>
+                <a:tc>
+                  <a:txBody>
+                    <a:bodyPr wrap="square"/>
+                    <a:lstStyle/>
+                    <a:p>
+                      <a:pPr>
+                        <a:defRPr sz="900" b="1">
+                          <a:solidFill>
+                            <a:srgbClr val="C00000"/>
+                          </a:solidFill>
+                          <a:latin typeface="Calibri"/>
+                        </a:defRPr>
+                      </a:pPr>
+                      <a:r>
+                        <a:t>Endbetrag für VektorPlan GmbH</a:t>
+                      </a:r>
+                    </a:p>
+                  </a:txBody>
+                  <a:tcPr>
+                    <a:solidFill>
+                      <a:srgbClr val="FFFDF5"/>
+                    </a:solidFill>
+                  </a:tcPr>
+                </a:tc>
+                <a:tc>
+                  <a:txBody>
+                    <a:bodyPr wrap="square"/>
+                    <a:lstStyle/>
+                    <a:p>
+                      <a:pPr>
+                        <a:defRPr sz="900" b="1">
+                          <a:solidFill>
+                            <a:srgbClr val="C00000"/>
+                          </a:solidFill>
+                          <a:latin typeface="Calibri"/>
+                        </a:defRPr>
+                      </a:pPr>
+                      <a:r>
+                        <a:t>= 79.943,39 €</a:t>
+                      </a:r>
+                    </a:p>
+                  </a:txBody>
+                  <a:tcPr>
+                    <a:solidFill>
+                      <a:srgbClr val="FFFDF5"/>
+                    </a:solidFill>
+                  </a:tcPr>
+                </a:tc>
+              </a:tr>
+            </a:tbl>
+          </a:graphicData>
+        </a:graphic>
+      </p:graphicFrame>
+      <p:sp>
+        <p:nvSpPr>
+          <p:cNvPr id="8" name="Rounded Rectangle 7"/>
+          <p:cNvSpPr/>
+          <p:nvPr/>
+        </p:nvSpPr>
+        <p:spPr>
+          <a:xfrm>
+            <a:off x="6217920" y="1234440"/>
+            <a:ext cx="5257800" cy="4937760"/>
+          </a:xfrm>
+          <a:prstGeom prst="roundRect">
+            <a:avLst/>
+          </a:prstGeom>
+          <a:solidFill>
+            <a:srgbClr val="FFFFFF"/>
+          </a:solidFill>
+          <a:ln w="15240">
+            <a:solidFill>
+              <a:srgbClr val="C8D7EB"/>
+            </a:solidFill>
+          </a:ln>
+        </p:spPr>
+        <p:style>
+          <a:lnRef idx="1">
+            <a:schemeClr val="accent1"/>
+          </a:lnRef>
+          <a:fillRef idx="3">
+            <a:schemeClr val="accent1"/>
+          </a:fillRef>
+          <a:effectRef idx="2">
+            <a:schemeClr val="accent1"/>
+          </a:effectRef>
+          <a:fontRef idx="minor">
+            <a:schemeClr val="lt1"/>
+          </a:fontRef>
+        </p:style>
+        <p:txBody>
+          <a:bodyPr rtlCol="0" anchor="ctr"/>
+          <a:lstStyle/>
+          <a:p>
             <a:pPr algn="ctr"/>
           </a:p>
         </p:txBody>
       </p:sp>
       <p:sp>
         <p:nvSpPr>
-          <p:cNvPr id="8" name="TextBox 7"/>
+          <p:cNvPr id="9" name="Rectangle 8"/>
+          <p:cNvSpPr/>
+          <p:nvPr/>
+        </p:nvSpPr>
+        <p:spPr>
+          <a:xfrm>
+            <a:off x="6217920" y="1234440"/>
+            <a:ext cx="5257800" cy="502920"/>
+          </a:xfrm>
+          <a:prstGeom prst="rect">
+            <a:avLst/>
+          </a:prstGeom>
+          <a:solidFill>
+            <a:srgbClr val="1F497D"/>
+          </a:solidFill>
+          <a:ln>
+            <a:noFill/>
+          </a:ln>
+        </p:spPr>
+        <p:style>
+          <a:lnRef idx="1">
+            <a:schemeClr val="accent1"/>
+          </a:lnRef>
+          <a:fillRef idx="3">
+            <a:schemeClr val="accent1"/>
+          </a:fillRef>
+          <a:effectRef idx="2">
+            <a:schemeClr val="accent1"/>
+          </a:effectRef>
+          <a:fontRef idx="minor">
+            <a:schemeClr val="lt1"/>
+          </a:fontRef>
+        </p:style>
+        <p:txBody>
+          <a:bodyPr rtlCol="0" anchor="ctr"/>
+          <a:lstStyle/>
+          <a:p>
+            <a:pPr algn="ctr">
+              <a:defRPr sz="1200" b="1">
+                <a:solidFill>
+                  <a:srgbClr val="FFFFFF"/>
+                </a:solidFill>
+                <a:latin typeface="Calibri"/>
+              </a:defRPr>
+            </a:pPr>
+            <a:r>
+              <a:t>Kaufmännisches Angebot (Nr. NL-2026-VP-001)</a:t>
+            </a:r>
+          </a:p>
+        </p:txBody>
+      </p:sp>
+      <p:graphicFrame>
+        <p:nvGraphicFramePr>
+          <p:cNvPr id="10" name="Table 9"/>
+          <p:cNvGraphicFramePr>
+            <a:graphicFrameLocks noGrp="1"/>
+          </p:cNvGraphicFramePr>
+          <p:nvPr/>
+        </p:nvGraphicFramePr>
+        <p:xfrm>
+          <a:off x="6355080" y="1874519"/>
+          <a:ext cx="4983480" cy="2194560"/>
+        </p:xfrm>
+        <a:graphic>
+          <a:graphicData uri="http://schemas.openxmlformats.org/drawingml/2006/table">
+            <a:tbl>
+              <a:tblPr firstRow="1" bandRow="1">
+                <a:tableStyleId>{5C22544A-7EE6-4342-B048-85BDC9FD1C3A}</a:tableStyleId>
+              </a:tblPr>
+              <a:tblGrid>
+                <a:gridCol w="3657600"/>
+                <a:gridCol w="1325880"/>
+              </a:tblGrid>
+              <a:tr h="313508">
+                <a:tc>
+                  <a:txBody>
+                    <a:bodyPr/>
+                    <a:lstStyle/>
+                    <a:p>
+                      <a:pPr>
+                        <a:defRPr sz="950" b="1">
+                          <a:solidFill>
+                            <a:srgbClr val="1F497D"/>
+                          </a:solidFill>
+                          <a:latin typeface="Calibri"/>
+                        </a:defRPr>
+                      </a:pPr>
+                      <a:r>
+                        <a:t>Position / Leistungsbereich</a:t>
+                      </a:r>
+                    </a:p>
+                  </a:txBody>
+                  <a:tcPr>
+                    <a:solidFill>
+                      <a:srgbClr val="F0F3F8"/>
+                    </a:solidFill>
+                  </a:tcPr>
+                </a:tc>
+                <a:tc>
+                  <a:txBody>
+                    <a:bodyPr/>
+                    <a:lstStyle/>
+                    <a:p>
+                      <a:pPr algn="r">
+                        <a:defRPr sz="950" b="1">
+                          <a:solidFill>
+                            <a:srgbClr val="1F497D"/>
+                          </a:solidFill>
+                          <a:latin typeface="Calibri"/>
+                        </a:defRPr>
+                      </a:pPr>
+                      <a:r>
+                        <a:t>Betrag Netto</a:t>
+                      </a:r>
+                    </a:p>
+                  </a:txBody>
+                  <a:tcPr>
+                    <a:solidFill>
+                      <a:srgbClr val="F0F3F8"/>
+                    </a:solidFill>
+                  </a:tcPr>
+                </a:tc>
+              </a:tr>
+              <a:tr h="313508">
+                <a:tc>
+                  <a:txBody>
+                    <a:bodyPr/>
+                    <a:lstStyle/>
+                    <a:p>
+                      <a:pPr>
+                        <a:defRPr sz="950">
+                          <a:latin typeface="Calibri"/>
+                        </a:defRPr>
+                      </a:pPr>
+                      <a:r>
+                        <a:t>1. Hardware (16 PCs, 32 Monitore, MFP, SSDs)</a:t>
+                      </a:r>
+                    </a:p>
+                  </a:txBody>
+                  <a:tcPr>
+                    <a:solidFill>
+                      <a:srgbClr val="F9FAFC"/>
+                    </a:solidFill>
+                  </a:tcPr>
+                </a:tc>
+                <a:tc>
+                  <a:txBody>
+                    <a:bodyPr/>
+                    <a:lstStyle/>
+                    <a:p>
+                      <a:pPr algn="r">
+                        <a:defRPr sz="950">
+                          <a:latin typeface="Calibri"/>
+                        </a:defRPr>
+                      </a:pPr>
+                      <a:r>
+                        <a:t>51.108,12 €</a:t>
+                      </a:r>
+                    </a:p>
+                  </a:txBody>
+                  <a:tcPr>
+                    <a:solidFill>
+                      <a:srgbClr val="F9FAFC"/>
+                    </a:solidFill>
+                  </a:tcPr>
+                </a:tc>
+              </a:tr>
+              <a:tr h="313508">
+                <a:tc>
+                  <a:txBody>
+                    <a:bodyPr/>
+                    <a:lstStyle/>
+                    <a:p>
+                      <a:pPr>
+                        <a:defRPr sz="950">
+                          <a:latin typeface="Calibri"/>
+                        </a:defRPr>
+                      </a:pPr>
+                      <a:r>
+                        <a:t>2. Software &amp; Lizenzen (1. Jahr: M365, Adobe, ESET)</a:t>
+                      </a:r>
+                    </a:p>
+                  </a:txBody>
+                  <a:tcPr>
+                    <a:solidFill>
+                      <a:srgbClr val="FFFFFF"/>
+                    </a:solidFill>
+                  </a:tcPr>
+                </a:tc>
+                <a:tc>
+                  <a:txBody>
+                    <a:bodyPr/>
+                    <a:lstStyle/>
+                    <a:p>
+                      <a:pPr algn="r">
+                        <a:defRPr sz="950">
+                          <a:latin typeface="Calibri"/>
+                        </a:defRPr>
+                      </a:pPr>
+                      <a:r>
+                        <a:t>10.021,20 €</a:t>
+                      </a:r>
+                    </a:p>
+                  </a:txBody>
+                  <a:tcPr>
+                    <a:solidFill>
+                      <a:srgbClr val="FFFFFF"/>
+                    </a:solidFill>
+                  </a:tcPr>
+                </a:tc>
+              </a:tr>
+              <a:tr h="313508">
+                <a:tc>
+                  <a:txBody>
+                    <a:bodyPr/>
+                    <a:lstStyle/>
+                    <a:p>
+                      <a:pPr>
+                        <a:defRPr sz="950">
+                          <a:latin typeface="Calibri"/>
+                        </a:defRPr>
+                      </a:pPr>
+                      <a:r>
+                        <a:t>3. Dienstleistungen (Staging, Montage, Abnahme)</a:t>
+                      </a:r>
+                    </a:p>
+                  </a:txBody>
+                  <a:tcPr>
+                    <a:solidFill>
+                      <a:srgbClr val="F9FAFC"/>
+                    </a:solidFill>
+                  </a:tcPr>
+                </a:tc>
+                <a:tc>
+                  <a:txBody>
+                    <a:bodyPr/>
+                    <a:lstStyle/>
+                    <a:p>
+                      <a:pPr algn="r">
+                        <a:defRPr sz="950">
+                          <a:latin typeface="Calibri"/>
+                        </a:defRPr>
+                      </a:pPr>
+                      <a:r>
+                        <a:t>6.050,00 €</a:t>
+                      </a:r>
+                    </a:p>
+                  </a:txBody>
+                  <a:tcPr>
+                    <a:solidFill>
+                      <a:srgbClr val="F9FAFC"/>
+                    </a:solidFill>
+                  </a:tcPr>
+                </a:tc>
+              </a:tr>
+              <a:tr h="313508">
+                <a:tc>
+                  <a:txBody>
+                    <a:bodyPr/>
+                    <a:lstStyle/>
+                    <a:p>
+                      <a:pPr>
+                        <a:defRPr sz="950" b="1">
+                          <a:solidFill>
+                            <a:srgbClr val="1F497D"/>
+                          </a:solidFill>
+                          <a:latin typeface="Calibri"/>
+                        </a:defRPr>
+                      </a:pPr>
+                      <a:r>
+                        <a:t>Gesamtangebot Netto</a:t>
+                      </a:r>
+                    </a:p>
+                  </a:txBody>
+                  <a:tcPr>
+                    <a:solidFill>
+                      <a:srgbClr val="FFFDF5"/>
+                    </a:solidFill>
+                  </a:tcPr>
+                </a:tc>
+                <a:tc>
+                  <a:txBody>
+                    <a:bodyPr/>
+                    <a:lstStyle/>
+                    <a:p>
+                      <a:pPr algn="r">
+                        <a:defRPr sz="950" b="1">
+                          <a:solidFill>
+                            <a:srgbClr val="1F497D"/>
+                          </a:solidFill>
+                          <a:latin typeface="Calibri"/>
+                        </a:defRPr>
+                      </a:pPr>
+                      <a:r>
+                        <a:t>67.179,32 €</a:t>
+                      </a:r>
+                    </a:p>
+                  </a:txBody>
+                  <a:tcPr>
+                    <a:solidFill>
+                      <a:srgbClr val="FFFDF5"/>
+                    </a:solidFill>
+                  </a:tcPr>
+                </a:tc>
+              </a:tr>
+              <a:tr h="313508">
+                <a:tc>
+                  <a:txBody>
+                    <a:bodyPr/>
+                    <a:lstStyle/>
+                    <a:p>
+                      <a:pPr>
+                        <a:defRPr sz="950">
+                          <a:latin typeface="Calibri"/>
+                        </a:defRPr>
+                      </a:pPr>
+                      <a:r>
+                        <a:t>+ 19% Gesetzliche Umsatzsteuer</a:t>
+                      </a:r>
+                    </a:p>
+                  </a:txBody>
+                  <a:tcPr>
+                    <a:solidFill>
+                      <a:srgbClr val="F9FAFC"/>
+                    </a:solidFill>
+                  </a:tcPr>
+                </a:tc>
+                <a:tc>
+                  <a:txBody>
+                    <a:bodyPr/>
+                    <a:lstStyle/>
+                    <a:p>
+                      <a:pPr algn="r">
+                        <a:defRPr sz="950">
+                          <a:latin typeface="Calibri"/>
+                        </a:defRPr>
+                      </a:pPr>
+                      <a:r>
+                        <a:t>12.764,07 €</a:t>
+                      </a:r>
+                    </a:p>
+                  </a:txBody>
+                  <a:tcPr>
+                    <a:solidFill>
+                      <a:srgbClr val="F9FAFC"/>
+                    </a:solidFill>
+                  </a:tcPr>
+                </a:tc>
+              </a:tr>
+              <a:tr h="313512">
+                <a:tc>
+                  <a:txBody>
+                    <a:bodyPr/>
+                    <a:lstStyle/>
+                    <a:p>
+                      <a:pPr>
+                        <a:defRPr sz="950" b="1">
+                          <a:solidFill>
+                            <a:srgbClr val="C00000"/>
+                          </a:solidFill>
+                          <a:latin typeface="Calibri"/>
+                        </a:defRPr>
+                      </a:pPr>
+                      <a:r>
+                        <a:t>Gesamtangebot Brutto</a:t>
+                      </a:r>
+                    </a:p>
+                  </a:txBody>
+                  <a:tcPr>
+                    <a:solidFill>
+                      <a:srgbClr val="FFFDF5"/>
+                    </a:solidFill>
+                  </a:tcPr>
+                </a:tc>
+                <a:tc>
+                  <a:txBody>
+                    <a:bodyPr/>
+                    <a:lstStyle/>
+                    <a:p>
+                      <a:pPr algn="r">
+                        <a:defRPr sz="950" b="1">
+                          <a:solidFill>
+                            <a:srgbClr val="C00000"/>
+                          </a:solidFill>
+                          <a:latin typeface="Calibri"/>
+                        </a:defRPr>
+                      </a:pPr>
+                      <a:r>
+                        <a:t>79.943,39 €</a:t>
+                      </a:r>
+                    </a:p>
+                  </a:txBody>
+                  <a:tcPr>
+                    <a:solidFill>
+                      <a:srgbClr val="FFFDF5"/>
+                    </a:solidFill>
+                  </a:tcPr>
+                </a:tc>
+              </a:tr>
+            </a:tbl>
+          </a:graphicData>
+        </a:graphic>
+      </p:graphicFrame>
+      <p:sp>
+        <p:nvSpPr>
+          <p:cNvPr id="11" name="Rounded Rectangle 10"/>
+          <p:cNvSpPr/>
+          <p:nvPr/>
+        </p:nvSpPr>
+        <p:spPr>
+          <a:xfrm>
+            <a:off x="6355080" y="4297680"/>
+            <a:ext cx="4983480" cy="1737360"/>
+          </a:xfrm>
+          <a:prstGeom prst="roundRect">
+            <a:avLst/>
+          </a:prstGeom>
+          <a:solidFill>
+            <a:srgbClr val="F5F8FC"/>
+          </a:solidFill>
+          <a:ln w="12700">
+            <a:solidFill>
+              <a:srgbClr val="D2E1F5"/>
+            </a:solidFill>
+          </a:ln>
+        </p:spPr>
+        <p:style>
+          <a:lnRef idx="1">
+            <a:schemeClr val="accent1"/>
+          </a:lnRef>
+          <a:fillRef idx="3">
+            <a:schemeClr val="accent1"/>
+          </a:fillRef>
+          <a:effectRef idx="2">
+            <a:schemeClr val="accent1"/>
+          </a:effectRef>
+          <a:fontRef idx="minor">
+            <a:schemeClr val="lt1"/>
+          </a:fontRef>
+        </p:style>
+        <p:txBody>
+          <a:bodyPr rtlCol="0" anchor="ctr"/>
+          <a:lstStyle/>
+          <a:p>
+            <a:pPr algn="ctr"/>
+          </a:p>
+        </p:txBody>
+      </p:sp>
+      <p:sp>
+        <p:nvSpPr>
+          <p:cNvPr id="12" name="TextBox 11"/>
           <p:cNvSpPr txBox="1"/>
           <p:nvPr/>
         </p:nvSpPr>
         <p:spPr>
           <a:xfrm>
-            <a:off x="6400800" y="1554480"/>
-            <a:ext cx="4892040" cy="4480560"/>
+            <a:off x="6492240" y="4389120"/>
+            <a:ext cx="4709160" cy="1554480"/>
           </a:xfrm>
           <a:prstGeom prst="rect">
             <a:avLst/>
@@ -5433,116 +6558,63 @@
           <a:lstStyle/>
           <a:p>
             <a:pPr>
-              <a:defRPr b="1" sz="1200">
+              <a:defRPr sz="1000" b="1">
                 <a:solidFill>
                   <a:srgbClr val="1F497D"/>
                 </a:solidFill>
-              </a:defRPr>
-            </a:pPr>
-            <a:r>
-              <a:t>Angebotsübersicht (Nr. NL-2026-VP-001):</a:t>
-            </a:r>
-          </a:p>
-          <a:p>
-            <a:pPr>
-              <a:defRPr sz="950">
-                <a:latin typeface="Consolas"/>
-              </a:defRPr>
-            </a:pPr>
-            <a:r>
-              <a:t>1. Hardware (16 PCs, 32 Monitore, MFP, SSDs)    51.108,12 €</a:t>
-            </a:r>
-          </a:p>
-          <a:p>
-            <a:pPr>
-              <a:defRPr sz="950">
-                <a:latin typeface="Consolas"/>
-              </a:defRPr>
-            </a:pPr>
-            <a:r>
-              <a:t>2. Software &amp; Lizenzen (1. Jahr: M365, Adobe, ESET)    10.021,20 €</a:t>
-            </a:r>
-          </a:p>
-          <a:p>
-            <a:pPr>
-              <a:defRPr sz="950">
-                <a:latin typeface="Consolas"/>
-              </a:defRPr>
-            </a:pPr>
-            <a:r>
-              <a:t>3. Dienstleistungen (Staging, Montage, Abnahme)     6.050,00 €</a:t>
-            </a:r>
-          </a:p>
-          <a:p>
-            <a:pPr>
-              <a:defRPr sz="950">
-                <a:latin typeface="Consolas"/>
-              </a:defRPr>
-            </a:pPr>
-            <a:r>
-              <a:t>─────────────────────────────────────────────    ───────────</a:t>
-            </a:r>
-          </a:p>
-          <a:p>
-            <a:pPr>
-              <a:defRPr sz="1050" b="1">
-                <a:solidFill>
-                  <a:srgbClr val="1F497D"/>
-                </a:solidFill>
-                <a:latin typeface="Consolas"/>
-              </a:defRPr>
-            </a:pPr>
-            <a:r>
-              <a:t>Gesamtbetrag Netto:                       67.179,32 €</a:t>
-            </a:r>
-          </a:p>
-          <a:p>
-            <a:pPr>
-              <a:defRPr sz="950">
-                <a:latin typeface="Consolas"/>
-              </a:defRPr>
-            </a:pPr>
-            <a:r>
-              <a:t>+ 19% Umsatzsteuer:                       12.764,07 €</a:t>
-            </a:r>
-          </a:p>
-          <a:p>
-            <a:pPr>
-              <a:defRPr sz="1050" b="1">
-                <a:solidFill>
-                  <a:srgbClr val="1F497D"/>
-                </a:solidFill>
-                <a:latin typeface="Consolas"/>
-              </a:defRPr>
-            </a:pPr>
-            <a:r>
-              <a:t>Gesamtbetrag Brutto:                      79.943,39 €</a:t>
-            </a:r>
-          </a:p>
-          <a:p>
-            <a:br/>
-            <a:pPr>
-              <a:defRPr sz="950">
-                <a:solidFill>
-                  <a:srgbClr val="595959"/>
-                </a:solidFill>
                 <a:latin typeface="Calibri"/>
               </a:defRPr>
             </a:pPr>
             <a:r>
               <a:t>Zahlungs- &amp; Lieferkonditionen:</a:t>
             </a:r>
-            <a:br/>
-            <a:r>
-              <a:t>• 14 Tage mit 3% Skonto (Ersparnis: 2.015,38 €), 30 Tage rein netto</a:t>
-            </a:r>
-            <a:br/>
-            <a:r>
-              <a:t>• Gewährleistung: 36 Monate Vor-Ort-Herstellerservice auf Neugeräte</a:t>
-            </a:r>
-            <a:br/>
-            <a:r>
-              <a:t>• Alternative: IT-Leasing ab ca. 1.580 € monatlich (OPEX-Vorteil)</a:t>
+          </a:p>
+          <a:p>
+            <a:pPr>
+              <a:spcBef>
+                <a:spcPts val="300"/>
+              </a:spcBef>
+              <a:defRPr sz="900">
+                <a:solidFill>
+                  <a:srgbClr val="262626"/>
+                </a:solidFill>
+                <a:latin typeface="Calibri"/>
+              </a:defRPr>
+            </a:pPr>
+            <a:r>
+              <a:t>• Zahlungsziel: 14 Tage mit 3 % Skonto (2.015,38 € Ersparnis) oder 30 Tage rein netto</a:t>
+            </a:r>
+          </a:p>
+          <a:p>
+            <a:pPr>
+              <a:spcBef>
+                <a:spcPts val="300"/>
+              </a:spcBef>
+              <a:defRPr sz="900">
+                <a:solidFill>
+                  <a:srgbClr val="262626"/>
+                </a:solidFill>
+                <a:latin typeface="Calibri"/>
+              </a:defRPr>
+            </a:pPr>
+            <a:r>
+              <a:t>• Garantie: 36 Monate Vor-Ort-Herstellerservice auf alle Arbeitsplätze</a:t>
+            </a:r>
+          </a:p>
+          <a:p>
+            <a:pPr>
+              <a:spcBef>
+                <a:spcPts val="300"/>
+              </a:spcBef>
+              <a:defRPr sz="900">
+                <a:solidFill>
+                  <a:srgbClr val="262626"/>
+                </a:solidFill>
+                <a:latin typeface="Calibri"/>
+              </a:defRPr>
+            </a:pPr>
+            <a:r>
+              <a:t>• Option IT-Leasing: Ab ca. 1.580 € monatlich (Voll amortisierbare Betriebsausgabe / OPEX)</a:t>
             </a:r>
           </a:p>
         </p:txBody>
@@ -5604,7 +6676,9 @@
           <a:bodyPr rtlCol="0" anchor="ctr"/>
           <a:lstStyle/>
           <a:p>
-            <a:pPr algn="ctr"/>
+            <a:pPr algn="ctr">
+              <a:defRPr/>
+            </a:pPr>
           </a:p>
         </p:txBody>
       </p:sp>
@@ -5734,7 +6808,9 @@
           <a:bodyPr rtlCol="0" anchor="ctr"/>
           <a:lstStyle/>
           <a:p>
-            <a:pPr algn="ctr"/>
+            <a:pPr algn="ctr">
+              <a:defRPr/>
+            </a:pPr>
           </a:p>
         </p:txBody>
       </p:sp>
@@ -5986,7 +7062,9 @@
           <a:bodyPr rtlCol="0" anchor="ctr"/>
           <a:lstStyle/>
           <a:p>
-            <a:pPr algn="ctr"/>
+            <a:pPr algn="ctr">
+              <a:defRPr/>
+            </a:pPr>
           </a:p>
         </p:txBody>
       </p:sp>
@@ -6269,7 +7347,9 @@
           <a:bodyPr rtlCol="0" anchor="ctr"/>
           <a:lstStyle/>
           <a:p>
-            <a:pPr algn="ctr"/>
+            <a:pPr algn="ctr">
+              <a:defRPr/>
+            </a:pPr>
           </a:p>
         </p:txBody>
       </p:sp>
@@ -6399,7 +7479,9 @@
           <a:bodyPr rtlCol="0" anchor="ctr"/>
           <a:lstStyle/>
           <a:p>
-            <a:pPr algn="ctr"/>
+            <a:pPr algn="ctr">
+              <a:defRPr/>
+            </a:pPr>
           </a:p>
         </p:txBody>
       </p:sp>
@@ -6442,7 +7524,9 @@
           <a:bodyPr rtlCol="0" anchor="ctr"/>
           <a:lstStyle/>
           <a:p>
-            <a:pPr algn="ctr"/>
+            <a:pPr algn="ctr">
+              <a:defRPr/>
+            </a:pPr>
           </a:p>
         </p:txBody>
       </p:sp>
@@ -6642,7 +7726,9 @@
           <a:bodyPr rtlCol="0" anchor="ctr"/>
           <a:lstStyle/>
           <a:p>
-            <a:pPr algn="ctr"/>
+            <a:pPr algn="ctr">
+              <a:defRPr/>
+            </a:pPr>
           </a:p>
         </p:txBody>
       </p:sp>
@@ -6685,7 +7771,9 @@
           <a:bodyPr rtlCol="0" anchor="ctr"/>
           <a:lstStyle/>
           <a:p>
-            <a:pPr algn="ctr"/>
+            <a:pPr algn="ctr">
+              <a:defRPr/>
+            </a:pPr>
           </a:p>
         </p:txBody>
       </p:sp>
@@ -6885,7 +7973,9 @@
           <a:bodyPr rtlCol="0" anchor="ctr"/>
           <a:lstStyle/>
           <a:p>
-            <a:pPr algn="ctr"/>
+            <a:pPr algn="ctr">
+              <a:defRPr/>
+            </a:pPr>
           </a:p>
         </p:txBody>
       </p:sp>
@@ -6928,7 +8018,9 @@
           <a:bodyPr rtlCol="0" anchor="ctr"/>
           <a:lstStyle/>
           <a:p>
-            <a:pPr algn="ctr"/>
+            <a:pPr algn="ctr">
+              <a:defRPr/>
+            </a:pPr>
           </a:p>
         </p:txBody>
       </p:sp>
@@ -7144,7 +8236,9 @@
           <a:bodyPr rtlCol="0" anchor="ctr"/>
           <a:lstStyle/>
           <a:p>
-            <a:pPr algn="ctr"/>
+            <a:pPr algn="ctr">
+              <a:defRPr/>
+            </a:pPr>
           </a:p>
         </p:txBody>
       </p:sp>
@@ -7274,7 +8368,9 @@
           <a:bodyPr rtlCol="0" anchor="ctr"/>
           <a:lstStyle/>
           <a:p>
-            <a:pPr algn="ctr"/>
+            <a:pPr algn="ctr">
+              <a:defRPr/>
+            </a:pPr>
           </a:p>
         </p:txBody>
       </p:sp>
@@ -7507,7 +8603,9 @@
           <a:bodyPr rtlCol="0" anchor="ctr"/>
           <a:lstStyle/>
           <a:p>
-            <a:pPr algn="ctr"/>
+            <a:pPr algn="ctr">
+              <a:defRPr/>
+            </a:pPr>
           </a:p>
         </p:txBody>
       </p:sp>
@@ -7740,7 +8838,9 @@
           <a:bodyPr rtlCol="0" anchor="ctr"/>
           <a:lstStyle/>
           <a:p>
-            <a:pPr algn="ctr"/>
+            <a:pPr algn="ctr">
+              <a:defRPr/>
+            </a:pPr>
           </a:p>
         </p:txBody>
       </p:sp>
@@ -7973,7 +9073,9 @@
           <a:bodyPr rtlCol="0" anchor="ctr"/>
           <a:lstStyle/>
           <a:p>
-            <a:pPr algn="ctr"/>
+            <a:pPr algn="ctr">
+              <a:defRPr/>
+            </a:pPr>
           </a:p>
         </p:txBody>
       </p:sp>
@@ -8222,7 +9324,9 @@
           <a:bodyPr rtlCol="0" anchor="ctr"/>
           <a:lstStyle/>
           <a:p>
-            <a:pPr algn="ctr"/>
+            <a:pPr algn="ctr">
+              <a:defRPr/>
+            </a:pPr>
           </a:p>
         </p:txBody>
       </p:sp>
@@ -8352,7 +9456,9 @@
           <a:bodyPr rtlCol="0" anchor="ctr"/>
           <a:lstStyle/>
           <a:p>
-            <a:pPr algn="ctr"/>
+            <a:pPr algn="ctr">
+              <a:defRPr/>
+            </a:pPr>
           </a:p>
         </p:txBody>
       </p:sp>
@@ -8397,7 +9503,9 @@
           <a:bodyPr rtlCol="0" anchor="ctr"/>
           <a:lstStyle/>
           <a:p>
-            <a:pPr algn="ctr"/>
+            <a:pPr algn="ctr">
+              <a:defRPr/>
+            </a:pPr>
           </a:p>
         </p:txBody>
       </p:sp>
@@ -8646,7 +9754,9 @@
           <a:bodyPr rtlCol="0" anchor="ctr"/>
           <a:lstStyle/>
           <a:p>
-            <a:pPr algn="ctr"/>
+            <a:pPr algn="ctr">
+              <a:defRPr/>
+            </a:pPr>
           </a:p>
         </p:txBody>
       </p:sp>
@@ -8691,7 +9801,9 @@
           <a:bodyPr rtlCol="0" anchor="ctr"/>
           <a:lstStyle/>
           <a:p>
-            <a:pPr algn="ctr"/>
+            <a:pPr algn="ctr">
+              <a:defRPr/>
+            </a:pPr>
           </a:p>
         </p:txBody>
       </p:sp>
@@ -8940,7 +10052,9 @@
           <a:bodyPr rtlCol="0" anchor="ctr"/>
           <a:lstStyle/>
           <a:p>
-            <a:pPr algn="ctr"/>
+            <a:pPr algn="ctr">
+              <a:defRPr/>
+            </a:pPr>
           </a:p>
         </p:txBody>
       </p:sp>
@@ -8985,7 +10099,9 @@
           <a:bodyPr rtlCol="0" anchor="ctr"/>
           <a:lstStyle/>
           <a:p>
-            <a:pPr algn="ctr"/>
+            <a:pPr algn="ctr">
+              <a:defRPr/>
+            </a:pPr>
           </a:p>
         </p:txBody>
       </p:sp>
@@ -9250,7 +10366,9 @@
           <a:bodyPr rtlCol="0" anchor="ctr"/>
           <a:lstStyle/>
           <a:p>
-            <a:pPr algn="ctr"/>
+            <a:pPr algn="ctr">
+              <a:defRPr/>
+            </a:pPr>
           </a:p>
         </p:txBody>
       </p:sp>
@@ -9380,7 +10498,9 @@
           <a:bodyPr rtlCol="0" anchor="ctr"/>
           <a:lstStyle/>
           <a:p>
-            <a:pPr algn="ctr"/>
+            <a:pPr algn="ctr">
+              <a:defRPr/>
+            </a:pPr>
           </a:p>
         </p:txBody>
       </p:sp>
@@ -9597,7 +10717,9 @@
           <a:bodyPr rtlCol="0" anchor="ctr"/>
           <a:lstStyle/>
           <a:p>
-            <a:pPr algn="ctr"/>
+            <a:pPr algn="ctr">
+              <a:defRPr/>
+            </a:pPr>
           </a:p>
         </p:txBody>
       </p:sp>
@@ -9830,7 +10952,9 @@
           <a:bodyPr rtlCol="0" anchor="ctr"/>
           <a:lstStyle/>
           <a:p>
-            <a:pPr algn="ctr"/>
+            <a:pPr algn="ctr">
+              <a:defRPr/>
+            </a:pPr>
           </a:p>
         </p:txBody>
       </p:sp>
@@ -9875,7 +10999,9 @@
           <a:bodyPr rtlCol="0" anchor="ctr"/>
           <a:lstStyle/>
           <a:p>
-            <a:pPr algn="ctr"/>
+            <a:pPr algn="ctr">
+              <a:defRPr/>
+            </a:pPr>
           </a:p>
         </p:txBody>
       </p:sp>
@@ -9966,7 +11092,9 @@
           <a:bodyPr rtlCol="0" anchor="ctr"/>
           <a:lstStyle/>
           <a:p>
-            <a:pPr algn="ctr"/>
+            <a:pPr algn="ctr">
+              <a:defRPr/>
+            </a:pPr>
           </a:p>
         </p:txBody>
       </p:sp>
@@ -10059,7 +11187,9 @@
           <a:bodyPr rtlCol="0" anchor="ctr"/>
           <a:lstStyle/>
           <a:p>
-            <a:pPr algn="ctr"/>
+            <a:pPr algn="ctr">
+              <a:defRPr/>
+            </a:pPr>
           </a:p>
         </p:txBody>
       </p:sp>
@@ -10180,7 +11310,9 @@
           <a:bodyPr rtlCol="0" anchor="ctr"/>
           <a:lstStyle/>
           <a:p>
-            <a:pPr algn="ctr"/>
+            <a:pPr algn="ctr">
+              <a:defRPr/>
+            </a:pPr>
           </a:p>
         </p:txBody>
       </p:sp>
@@ -10310,7 +11442,9 @@
           <a:bodyPr rtlCol="0" anchor="ctr"/>
           <a:lstStyle/>
           <a:p>
-            <a:pPr algn="ctr"/>
+            <a:pPr algn="ctr">
+              <a:defRPr/>
+            </a:pPr>
           </a:p>
         </p:txBody>
       </p:sp>
@@ -10404,7 +11538,9 @@
           <a:bodyPr rtlCol="0" anchor="ctr"/>
           <a:lstStyle/>
           <a:p>
-            <a:pPr algn="ctr"/>
+            <a:pPr algn="ctr">
+              <a:defRPr/>
+            </a:pPr>
           </a:p>
         </p:txBody>
       </p:sp>
@@ -10498,7 +11634,9 @@
           <a:bodyPr rtlCol="0" anchor="ctr"/>
           <a:lstStyle/>
           <a:p>
-            <a:pPr algn="ctr"/>
+            <a:pPr algn="ctr">
+              <a:defRPr/>
+            </a:pPr>
           </a:p>
         </p:txBody>
       </p:sp>
@@ -10592,7 +11730,9 @@
           <a:bodyPr rtlCol="0" anchor="ctr"/>
           <a:lstStyle/>
           <a:p>
-            <a:pPr algn="ctr"/>
+            <a:pPr algn="ctr">
+              <a:defRPr/>
+            </a:pPr>
           </a:p>
         </p:txBody>
       </p:sp>
@@ -10686,7 +11826,9 @@
           <a:bodyPr rtlCol="0" anchor="ctr"/>
           <a:lstStyle/>
           <a:p>
-            <a:pPr algn="ctr"/>
+            <a:pPr algn="ctr">
+              <a:defRPr/>
+            </a:pPr>
           </a:p>
         </p:txBody>
       </p:sp>
@@ -10780,7 +11922,9 @@
           <a:bodyPr rtlCol="0" anchor="ctr"/>
           <a:lstStyle/>
           <a:p>
-            <a:pPr algn="ctr"/>
+            <a:pPr algn="ctr">
+              <a:defRPr/>
+            </a:pPr>
           </a:p>
         </p:txBody>
       </p:sp>
@@ -10874,7 +12018,9 @@
           <a:bodyPr rtlCol="0" anchor="ctr"/>
           <a:lstStyle/>
           <a:p>
-            <a:pPr algn="ctr"/>
+            <a:pPr algn="ctr">
+              <a:defRPr/>
+            </a:pPr>
           </a:p>
         </p:txBody>
       </p:sp>
@@ -10968,7 +12114,9 @@
           <a:bodyPr rtlCol="0" anchor="ctr"/>
           <a:lstStyle/>
           <a:p>
-            <a:pPr algn="ctr"/>
+            <a:pPr algn="ctr">
+              <a:defRPr/>
+            </a:pPr>
           </a:p>
         </p:txBody>
       </p:sp>
@@ -11062,7 +12210,9 @@
           <a:bodyPr rtlCol="0" anchor="ctr"/>
           <a:lstStyle/>
           <a:p>
-            <a:pPr algn="ctr"/>
+            <a:pPr algn="ctr">
+              <a:defRPr/>
+            </a:pPr>
           </a:p>
         </p:txBody>
       </p:sp>
@@ -11156,7 +12306,9 @@
           <a:bodyPr rtlCol="0" anchor="ctr"/>
           <a:lstStyle/>
           <a:p>
-            <a:pPr algn="ctr"/>
+            <a:pPr algn="ctr">
+              <a:defRPr/>
+            </a:pPr>
           </a:p>
         </p:txBody>
       </p:sp>
@@ -11250,7 +12402,9 @@
           <a:bodyPr rtlCol="0" anchor="ctr"/>
           <a:lstStyle/>
           <a:p>
-            <a:pPr algn="ctr"/>
+            <a:pPr algn="ctr">
+              <a:defRPr/>
+            </a:pPr>
           </a:p>
         </p:txBody>
       </p:sp>
@@ -11344,7 +12498,9 @@
           <a:bodyPr rtlCol="0" anchor="ctr"/>
           <a:lstStyle/>
           <a:p>
-            <a:pPr algn="ctr"/>
+            <a:pPr algn="ctr">
+              <a:defRPr/>
+            </a:pPr>
           </a:p>
         </p:txBody>
       </p:sp>
@@ -11438,7 +12594,9 @@
           <a:bodyPr rtlCol="0" anchor="ctr"/>
           <a:lstStyle/>
           <a:p>
-            <a:pPr algn="ctr"/>
+            <a:pPr algn="ctr">
+              <a:defRPr/>
+            </a:pPr>
           </a:p>
         </p:txBody>
       </p:sp>
@@ -11532,7 +12690,9 @@
           <a:bodyPr rtlCol="0" anchor="ctr"/>
           <a:lstStyle/>
           <a:p>
-            <a:pPr algn="ctr"/>
+            <a:pPr algn="ctr">
+              <a:defRPr/>
+            </a:pPr>
           </a:p>
         </p:txBody>
       </p:sp>
@@ -11642,7 +12802,9 @@
           <a:bodyPr rtlCol="0" anchor="ctr"/>
           <a:lstStyle/>
           <a:p>
-            <a:pPr algn="ctr"/>
+            <a:pPr algn="ctr">
+              <a:defRPr/>
+            </a:pPr>
           </a:p>
         </p:txBody>
       </p:sp>
@@ -11772,7 +12934,9 @@
           <a:bodyPr rtlCol="0" anchor="ctr"/>
           <a:lstStyle/>
           <a:p>
-            <a:pPr algn="ctr"/>
+            <a:pPr algn="ctr">
+              <a:defRPr/>
+            </a:pPr>
           </a:p>
         </p:txBody>
       </p:sp>
@@ -11933,7 +13097,9 @@
           <a:bodyPr rtlCol="0" anchor="ctr"/>
           <a:lstStyle/>
           <a:p>
-            <a:pPr algn="ctr"/>
+            <a:pPr algn="ctr">
+              <a:defRPr/>
+            </a:pPr>
           </a:p>
         </p:txBody>
       </p:sp>
@@ -12158,7 +13324,9 @@
           <a:bodyPr rtlCol="0" anchor="ctr"/>
           <a:lstStyle/>
           <a:p>
-            <a:pPr algn="ctr"/>
+            <a:pPr algn="ctr">
+              <a:defRPr/>
+            </a:pPr>
           </a:p>
         </p:txBody>
       </p:sp>
@@ -12288,7 +13456,9 @@
           <a:bodyPr rtlCol="0" anchor="ctr"/>
           <a:lstStyle/>
           <a:p>
-            <a:pPr algn="ctr"/>
+            <a:pPr algn="ctr">
+              <a:defRPr/>
+            </a:pPr>
           </a:p>
         </p:txBody>
       </p:sp>
@@ -12331,7 +13501,9 @@
           <a:bodyPr rtlCol="0" anchor="ctr"/>
           <a:lstStyle/>
           <a:p>
-            <a:pPr algn="ctr"/>
+            <a:pPr algn="ctr">
+              <a:defRPr/>
+            </a:pPr>
           </a:p>
         </p:txBody>
       </p:sp>
@@ -12535,7 +13707,9 @@
           <a:bodyPr rtlCol="0" anchor="ctr"/>
           <a:lstStyle/>
           <a:p>
-            <a:pPr algn="ctr"/>
+            <a:pPr algn="ctr">
+              <a:defRPr/>
+            </a:pPr>
           </a:p>
         </p:txBody>
       </p:sp>
@@ -12578,7 +13752,9 @@
           <a:bodyPr rtlCol="0" anchor="ctr"/>
           <a:lstStyle/>
           <a:p>
-            <a:pPr algn="ctr"/>
+            <a:pPr algn="ctr">
+              <a:defRPr/>
+            </a:pPr>
           </a:p>
         </p:txBody>
       </p:sp>
@@ -12782,7 +13958,9 @@
           <a:bodyPr rtlCol="0" anchor="ctr"/>
           <a:lstStyle/>
           <a:p>
-            <a:pPr algn="ctr"/>
+            <a:pPr algn="ctr">
+              <a:defRPr/>
+            </a:pPr>
           </a:p>
         </p:txBody>
       </p:sp>
@@ -12825,7 +14003,9 @@
           <a:bodyPr rtlCol="0" anchor="ctr"/>
           <a:lstStyle/>
           <a:p>
-            <a:pPr algn="ctr"/>
+            <a:pPr algn="ctr">
+              <a:defRPr/>
+            </a:pPr>
           </a:p>
         </p:txBody>
       </p:sp>
@@ -13029,7 +14209,9 @@
           <a:bodyPr rtlCol="0" anchor="ctr"/>
           <a:lstStyle/>
           <a:p>
-            <a:pPr algn="ctr"/>
+            <a:pPr algn="ctr">
+              <a:defRPr/>
+            </a:pPr>
           </a:p>
         </p:txBody>
       </p:sp>
@@ -13072,7 +14254,9 @@
           <a:bodyPr rtlCol="0" anchor="ctr"/>
           <a:lstStyle/>
           <a:p>
-            <a:pPr algn="ctr"/>
+            <a:pPr algn="ctr">
+              <a:defRPr/>
+            </a:pPr>
           </a:p>
         </p:txBody>
       </p:sp>
@@ -13276,7 +14460,9 @@
           <a:bodyPr rtlCol="0" anchor="ctr"/>
           <a:lstStyle/>
           <a:p>
-            <a:pPr algn="ctr"/>
+            <a:pPr algn="ctr">
+              <a:defRPr/>
+            </a:pPr>
           </a:p>
         </p:txBody>
       </p:sp>
@@ -13319,7 +14505,9 @@
           <a:bodyPr rtlCol="0" anchor="ctr"/>
           <a:lstStyle/>
           <a:p>
-            <a:pPr algn="ctr"/>
+            <a:pPr algn="ctr">
+              <a:defRPr/>
+            </a:pPr>
           </a:p>
         </p:txBody>
       </p:sp>
@@ -13539,7 +14727,9 @@
           <a:bodyPr rtlCol="0" anchor="ctr"/>
           <a:lstStyle/>
           <a:p>
-            <a:pPr algn="ctr"/>
+            <a:pPr algn="ctr">
+              <a:defRPr/>
+            </a:pPr>
           </a:p>
         </p:txBody>
       </p:sp>
@@ -13737,7 +14927,9 @@
           <a:bodyPr rtlCol="0" anchor="ctr"/>
           <a:lstStyle/>
           <a:p>
-            <a:pPr algn="ctr"/>
+            <a:pPr algn="ctr">
+              <a:defRPr/>
+            </a:pPr>
           </a:p>
         </p:txBody>
       </p:sp>
@@ -13780,7 +14972,9 @@
           <a:bodyPr rtlCol="0" anchor="ctr"/>
           <a:lstStyle/>
           <a:p>
-            <a:pPr algn="ctr"/>
+            <a:pPr algn="ctr">
+              <a:defRPr/>
+            </a:pPr>
           </a:p>
         </p:txBody>
       </p:sp>
@@ -14016,7 +15210,9 @@
           <a:bodyPr rtlCol="0" anchor="ctr"/>
           <a:lstStyle/>
           <a:p>
-            <a:pPr algn="ctr"/>
+            <a:pPr algn="ctr">
+              <a:defRPr/>
+            </a:pPr>
           </a:p>
         </p:txBody>
       </p:sp>
@@ -14059,7 +15255,9 @@
           <a:bodyPr rtlCol="0" anchor="ctr"/>
           <a:lstStyle/>
           <a:p>
-            <a:pPr algn="ctr"/>
+            <a:pPr algn="ctr">
+              <a:defRPr/>
+            </a:pPr>
           </a:p>
         </p:txBody>
       </p:sp>
@@ -14295,7 +15493,9 @@
           <a:bodyPr rtlCol="0" anchor="ctr"/>
           <a:lstStyle/>
           <a:p>
-            <a:pPr algn="ctr"/>
+            <a:pPr algn="ctr">
+              <a:defRPr/>
+            </a:pPr>
           </a:p>
         </p:txBody>
       </p:sp>
@@ -14338,7 +15538,9 @@
           <a:bodyPr rtlCol="0" anchor="ctr"/>
           <a:lstStyle/>
           <a:p>
-            <a:pPr algn="ctr"/>
+            <a:pPr algn="ctr">
+              <a:defRPr/>
+            </a:pPr>
           </a:p>
         </p:txBody>
       </p:sp>
@@ -14574,7 +15776,9 @@
           <a:bodyPr rtlCol="0" anchor="ctr"/>
           <a:lstStyle/>
           <a:p>
-            <a:pPr algn="ctr"/>
+            <a:pPr algn="ctr">
+              <a:defRPr/>
+            </a:pPr>
           </a:p>
         </p:txBody>
       </p:sp>
@@ -14617,7 +15821,9 @@
           <a:bodyPr rtlCol="0" anchor="ctr"/>
           <a:lstStyle/>
           <a:p>
-            <a:pPr algn="ctr"/>
+            <a:pPr algn="ctr">
+              <a:defRPr/>
+            </a:pPr>
           </a:p>
         </p:txBody>
       </p:sp>
@@ -14853,7 +16059,9 @@
           <a:bodyPr rtlCol="0" anchor="ctr"/>
           <a:lstStyle/>
           <a:p>
-            <a:pPr algn="ctr"/>
+            <a:pPr algn="ctr">
+              <a:defRPr/>
+            </a:pPr>
           </a:p>
         </p:txBody>
       </p:sp>
@@ -14896,7 +16104,9 @@
           <a:bodyPr rtlCol="0" anchor="ctr"/>
           <a:lstStyle/>
           <a:p>
-            <a:pPr algn="ctr"/>
+            <a:pPr algn="ctr">
+              <a:defRPr/>
+            </a:pPr>
           </a:p>
         </p:txBody>
       </p:sp>
@@ -15239,64 +16449,28 @@
       </p:sp>
       <p:pic>
         <p:nvPicPr>
-          <p:cNvPr id="5" name="Picture 4" descr="Netzplan.png"/>
+          <p:cNvPr id="5" name="Picture 4" descr="netzplan_inline.png"/>
           <p:cNvPicPr>
             <a:picLocks noChangeAspect="1"/>
           </p:cNvPicPr>
           <p:nvPr/>
         </p:nvPicPr>
         <p:blipFill>
-          <a:blip r:embed="rId3"/>
+          <a:blip r:embed="rId4"/>
           <a:stretch>
             <a:fillRect/>
           </a:stretch>
         </p:blipFill>
         <p:spPr>
           <a:xfrm>
-            <a:off x="1615287" y="1234440"/>
-            <a:ext cx="8961120" cy="4572000"/>
+            <a:off x="700887" y="1078992"/>
+            <a:ext cx="10789920" cy="5212080"/>
           </a:xfrm>
           <a:prstGeom prst="rect">
             <a:avLst/>
           </a:prstGeom>
         </p:spPr>
       </p:pic>
-      <p:sp>
-        <p:nvSpPr>
-          <p:cNvPr id="6" name="TextBox 5"/>
-          <p:cNvSpPr txBox="1"/>
-          <p:nvPr/>
-        </p:nvSpPr>
-        <p:spPr>
-          <a:xfrm>
-            <a:off x="731520" y="5897880"/>
-            <a:ext cx="10728655" cy="411480"/>
-          </a:xfrm>
-          <a:prstGeom prst="rect">
-            <a:avLst/>
-          </a:prstGeom>
-          <a:noFill/>
-        </p:spPr>
-        <p:txBody>
-          <a:bodyPr wrap="square">
-            <a:spAutoFit/>
-          </a:bodyPr>
-          <a:lstStyle/>
-          <a:p>
-            <a:pPr algn="ctr">
-              <a:defRPr sz="1100" b="1">
-                <a:solidFill>
-                  <a:srgbClr val="9C0006"/>
-                </a:solidFill>
-                <a:latin typeface="Calibri"/>
-              </a:defRPr>
-            </a:pPr>
-            <a:r>
-              <a:t>KRITISCHER PFAD (ROT): V1 ➔ V2 ➔ V3 ➔ V4 ➔ V5 ➔ V6 ➔ V7 ➔ V8 ➔ V9 ➔ V11 ➔ V12 ➔ V13 ➔ V14  |  DAUER: 46 TAGE  |  PUFFER V10: 1 TAG</a:t>
-            </a:r>
-          </a:p>
-        </p:txBody>
-      </p:sp>
     </p:spTree>
   </p:cSld>
   <p:clrMapOvr>
@@ -15354,7 +16528,9 @@
           <a:bodyPr rtlCol="0" anchor="ctr"/>
           <a:lstStyle/>
           <a:p>
-            <a:pPr algn="ctr"/>
+            <a:pPr algn="ctr">
+              <a:defRPr/>
+            </a:pPr>
           </a:p>
         </p:txBody>
       </p:sp>
@@ -15484,7 +16660,9 @@
           <a:bodyPr rtlCol="0" anchor="ctr"/>
           <a:lstStyle/>
           <a:p>
-            <a:pPr algn="ctr"/>
+            <a:pPr algn="ctr">
+              <a:defRPr/>
+            </a:pPr>
           </a:p>
         </p:txBody>
       </p:sp>
@@ -15527,7 +16705,9 @@
           <a:bodyPr rtlCol="0" anchor="ctr"/>
           <a:lstStyle/>
           <a:p>
-            <a:pPr algn="ctr"/>
+            <a:pPr algn="ctr">
+              <a:defRPr/>
+            </a:pPr>
           </a:p>
         </p:txBody>
       </p:sp>
@@ -15811,7 +16991,9 @@
           <a:bodyPr rtlCol="0" anchor="ctr"/>
           <a:lstStyle/>
           <a:p>
-            <a:pPr algn="ctr"/>
+            <a:pPr algn="ctr">
+              <a:defRPr/>
+            </a:pPr>
           </a:p>
         </p:txBody>
       </p:sp>
@@ -15854,7 +17036,9 @@
           <a:bodyPr rtlCol="0" anchor="ctr"/>
           <a:lstStyle/>
           <a:p>
-            <a:pPr algn="ctr"/>
+            <a:pPr algn="ctr">
+              <a:defRPr/>
+            </a:pPr>
           </a:p>
         </p:txBody>
       </p:sp>
@@ -16138,7 +17322,9 @@
           <a:bodyPr rtlCol="0" anchor="ctr"/>
           <a:lstStyle/>
           <a:p>
-            <a:pPr algn="ctr"/>
+            <a:pPr algn="ctr">
+              <a:defRPr/>
+            </a:pPr>
           </a:p>
         </p:txBody>
       </p:sp>
@@ -16181,7 +17367,9 @@
           <a:bodyPr rtlCol="0" anchor="ctr"/>
           <a:lstStyle/>
           <a:p>
-            <a:pPr algn="ctr"/>
+            <a:pPr algn="ctr">
+              <a:defRPr/>
+            </a:pPr>
           </a:p>
         </p:txBody>
       </p:sp>
@@ -16481,7 +17669,9 @@
           <a:bodyPr rtlCol="0" anchor="ctr"/>
           <a:lstStyle/>
           <a:p>
-            <a:pPr algn="ctr"/>
+            <a:pPr algn="ctr">
+              <a:defRPr/>
+            </a:pPr>
           </a:p>
         </p:txBody>
       </p:sp>
@@ -16611,7 +17801,9 @@
           <a:bodyPr rtlCol="0" anchor="ctr"/>
           <a:lstStyle/>
           <a:p>
-            <a:pPr algn="ctr"/>
+            <a:pPr algn="ctr">
+              <a:defRPr/>
+            </a:pPr>
           </a:p>
         </p:txBody>
       </p:sp>
@@ -16845,7 +18037,9 @@
           <a:bodyPr rtlCol="0" anchor="ctr"/>
           <a:lstStyle/>
           <a:p>
-            <a:pPr algn="ctr"/>
+            <a:pPr algn="ctr">
+              <a:defRPr/>
+            </a:pPr>
           </a:p>
         </p:txBody>
       </p:sp>
@@ -17079,7 +18273,9 @@
           <a:bodyPr rtlCol="0" anchor="ctr"/>
           <a:lstStyle/>
           <a:p>
-            <a:pPr algn="ctr"/>
+            <a:pPr algn="ctr">
+              <a:defRPr/>
+            </a:pPr>
           </a:p>
         </p:txBody>
       </p:sp>
@@ -17313,7 +18509,9 @@
           <a:bodyPr rtlCol="0" anchor="ctr"/>
           <a:lstStyle/>
           <a:p>
-            <a:pPr algn="ctr"/>
+            <a:pPr algn="ctr">
+              <a:defRPr/>
+            </a:pPr>
           </a:p>
         </p:txBody>
       </p:sp>
@@ -17563,7 +18761,9 @@
           <a:bodyPr rtlCol="0" anchor="ctr"/>
           <a:lstStyle/>
           <a:p>
-            <a:pPr algn="ctr"/>
+            <a:pPr algn="ctr">
+              <a:defRPr/>
+            </a:pPr>
           </a:p>
         </p:txBody>
       </p:sp>
@@ -17693,7 +18893,9 @@
           <a:bodyPr rtlCol="0" anchor="ctr"/>
           <a:lstStyle/>
           <a:p>
-            <a:pPr algn="ctr"/>
+            <a:pPr algn="ctr">
+              <a:defRPr/>
+            </a:pPr>
           </a:p>
         </p:txBody>
       </p:sp>
@@ -17920,7 +19122,9 @@
           <a:bodyPr rtlCol="0" anchor="ctr"/>
           <a:lstStyle/>
           <a:p>
-            <a:pPr algn="ctr"/>
+            <a:pPr algn="ctr">
+              <a:defRPr/>
+            </a:pPr>
           </a:p>
         </p:txBody>
       </p:sp>

</xml_diff>

<commit_message>
Folie 10 Preisanzeige korrigiert: Spaltenbreite Wert erweitert, kein Zeilenumbruch bei Euro-Symbol, Betraege rechtsbuendig formatiert
</commit_message>
<xml_diff>
--- a/docs/08_Projektabschluss/Abschlusspraesentation.pptx
+++ b/docs/08_Projektabschluss/Abschlusspraesentation.pptx
@@ -5183,8 +5183,8 @@
         </p:nvSpPr>
         <p:spPr>
           <a:xfrm>
-            <a:off x="731520" y="1234440"/>
-            <a:ext cx="5257800" cy="4937760"/>
+            <a:off x="685800" y="1234440"/>
+            <a:ext cx="5303520" cy="4937760"/>
           </a:xfrm>
           <a:prstGeom prst="roundRect">
             <a:avLst/>
@@ -5228,8 +5228,8 @@
         </p:nvSpPr>
         <p:spPr>
           <a:xfrm>
-            <a:off x="731520" y="1234440"/>
-            <a:ext cx="5257800" cy="502920"/>
+            <a:off x="685800" y="1234440"/>
+            <a:ext cx="5303520" cy="502920"/>
           </a:xfrm>
           <a:prstGeom prst="rect">
             <a:avLst/>
@@ -5282,8 +5282,8 @@
           <p:nvPr/>
         </p:nvGraphicFramePr>
         <p:xfrm>
-          <a:off x="868680" y="1874519"/>
-          <a:ext cx="4983480" cy="4114800"/>
+          <a:off x="777240" y="1874519"/>
+          <a:ext cx="5120640" cy="4114800"/>
         </p:xfrm>
         <a:graphic>
           <a:graphicData uri="http://schemas.openxmlformats.org/drawingml/2006/table">
@@ -5292,14 +5292,14 @@
                 <a:tableStyleId>{5C22544A-7EE6-4342-B048-85BDC9FD1C3A}</a:tableStyleId>
               </a:tblPr>
               <a:tblGrid>
+                <a:gridCol w="1783080"/>
                 <a:gridCol w="2011680"/>
-                <a:gridCol w="2194560"/>
-                <a:gridCol w="777240"/>
+                <a:gridCol w="1325880"/>
               </a:tblGrid>
               <a:tr h="411480">
                 <a:tc>
                   <a:txBody>
-                    <a:bodyPr wrap="square"/>
+                    <a:bodyPr wrap="none"/>
                     <a:lstStyle/>
                     <a:p>
                       <a:pPr>
@@ -5315,7 +5315,7 @@
                       </a:r>
                     </a:p>
                   </a:txBody>
-                  <a:tcPr>
+                  <a:tcPr marL="36576" marR="36576" marT="27432" marB="27432">
                     <a:solidFill>
                       <a:srgbClr val="F0F3F8"/>
                     </a:solidFill>
@@ -5323,7 +5323,7 @@
                 </a:tc>
                 <a:tc>
                   <a:txBody>
-                    <a:bodyPr wrap="square"/>
+                    <a:bodyPr wrap="none"/>
                     <a:lstStyle/>
                     <a:p>
                       <a:pPr>
@@ -5339,7 +5339,7 @@
                       </a:r>
                     </a:p>
                   </a:txBody>
-                  <a:tcPr>
+                  <a:tcPr marL="36576" marR="36576" marT="27432" marB="27432">
                     <a:solidFill>
                       <a:srgbClr val="F0F3F8"/>
                     </a:solidFill>
@@ -5347,10 +5347,10 @@
                 </a:tc>
                 <a:tc>
                   <a:txBody>
-                    <a:bodyPr wrap="square"/>
+                    <a:bodyPr wrap="none"/>
                     <a:lstStyle/>
                     <a:p>
-                      <a:pPr>
+                      <a:pPr algn="r">
                         <a:defRPr sz="950" b="1">
                           <a:solidFill>
                             <a:srgbClr val="1F497D"/>
@@ -5363,7 +5363,7 @@
                       </a:r>
                     </a:p>
                   </a:txBody>
-                  <a:tcPr>
+                  <a:tcPr marL="36576" marR="36576" marT="27432" marB="27432">
                     <a:solidFill>
                       <a:srgbClr val="F0F3F8"/>
                     </a:solidFill>
@@ -5373,7 +5373,7 @@
               <a:tr h="411480">
                 <a:tc>
                   <a:txBody>
-                    <a:bodyPr wrap="square"/>
+                    <a:bodyPr/>
                     <a:lstStyle/>
                     <a:p>
                       <a:pPr>
@@ -5389,7 +5389,7 @@
                       </a:r>
                     </a:p>
                   </a:txBody>
-                  <a:tcPr>
+                  <a:tcPr marL="36576" marR="36576" marT="27432" marB="27432">
                     <a:solidFill>
                       <a:srgbClr val="F9FAFC"/>
                     </a:solidFill>
@@ -5397,7 +5397,7 @@
                 </a:tc>
                 <a:tc>
                   <a:txBody>
-                    <a:bodyPr wrap="square"/>
+                    <a:bodyPr/>
                     <a:lstStyle/>
                     <a:p>
                       <a:pPr>
@@ -5413,7 +5413,7 @@
                       </a:r>
                     </a:p>
                   </a:txBody>
-                  <a:tcPr>
+                  <a:tcPr marL="36576" marR="36576" marT="27432" marB="27432">
                     <a:solidFill>
                       <a:srgbClr val="F9FAFC"/>
                     </a:solidFill>
@@ -5421,10 +5421,10 @@
                 </a:tc>
                 <a:tc>
                   <a:txBody>
-                    <a:bodyPr wrap="square"/>
+                    <a:bodyPr wrap="none"/>
                     <a:lstStyle/>
                     <a:p>
-                      <a:pPr>
+                      <a:pPr algn="r">
                         <a:defRPr sz="900">
                           <a:solidFill>
                             <a:srgbClr val="262626"/>
@@ -5437,7 +5437,7 @@
                       </a:r>
                     </a:p>
                   </a:txBody>
-                  <a:tcPr>
+                  <a:tcPr marL="36576" marR="36576" marT="27432" marB="27432">
                     <a:solidFill>
                       <a:srgbClr val="F9FAFC"/>
                     </a:solidFill>
@@ -5447,7 +5447,7 @@
               <a:tr h="411480">
                 <a:tc>
                   <a:txBody>
-                    <a:bodyPr wrap="square"/>
+                    <a:bodyPr/>
                     <a:lstStyle/>
                     <a:p>
                       <a:pPr>
@@ -5463,7 +5463,7 @@
                       </a:r>
                     </a:p>
                   </a:txBody>
-                  <a:tcPr>
+                  <a:tcPr marL="36576" marR="36576" marT="27432" marB="27432">
                     <a:solidFill>
                       <a:srgbClr val="FFFFFF"/>
                     </a:solidFill>
@@ -5471,7 +5471,7 @@
                 </a:tc>
                 <a:tc>
                   <a:txBody>
-                    <a:bodyPr wrap="square"/>
+                    <a:bodyPr/>
                     <a:lstStyle/>
                     <a:p>
                       <a:pPr>
@@ -5487,7 +5487,7 @@
                       </a:r>
                     </a:p>
                   </a:txBody>
-                  <a:tcPr>
+                  <a:tcPr marL="36576" marR="36576" marT="27432" marB="27432">
                     <a:solidFill>
                       <a:srgbClr val="FFFFFF"/>
                     </a:solidFill>
@@ -5495,10 +5495,10 @@
                 </a:tc>
                 <a:tc>
                   <a:txBody>
-                    <a:bodyPr wrap="square"/>
+                    <a:bodyPr wrap="none"/>
                     <a:lstStyle/>
                     <a:p>
-                      <a:pPr>
+                      <a:pPr algn="r">
                         <a:defRPr sz="900">
                           <a:solidFill>
                             <a:srgbClr val="262626"/>
@@ -5511,7 +5511,7 @@
                       </a:r>
                     </a:p>
                   </a:txBody>
-                  <a:tcPr>
+                  <a:tcPr marL="36576" marR="36576" marT="27432" marB="27432">
                     <a:solidFill>
                       <a:srgbClr val="FFFFFF"/>
                     </a:solidFill>
@@ -5521,7 +5521,7 @@
               <a:tr h="411480">
                 <a:tc>
                   <a:txBody>
-                    <a:bodyPr wrap="square"/>
+                    <a:bodyPr/>
                     <a:lstStyle/>
                     <a:p>
                       <a:pPr>
@@ -5537,7 +5537,7 @@
                       </a:r>
                     </a:p>
                   </a:txBody>
-                  <a:tcPr>
+                  <a:tcPr marL="36576" marR="36576" marT="27432" marB="27432">
                     <a:solidFill>
                       <a:srgbClr val="F9FAFC"/>
                     </a:solidFill>
@@ -5545,7 +5545,7 @@
                 </a:tc>
                 <a:tc>
                   <a:txBody>
-                    <a:bodyPr wrap="square"/>
+                    <a:bodyPr/>
                     <a:lstStyle/>
                     <a:p>
                       <a:pPr>
@@ -5561,7 +5561,7 @@
                       </a:r>
                     </a:p>
                   </a:txBody>
-                  <a:tcPr>
+                  <a:tcPr marL="36576" marR="36576" marT="27432" marB="27432">
                     <a:solidFill>
                       <a:srgbClr val="F9FAFC"/>
                     </a:solidFill>
@@ -5569,10 +5569,10 @@
                 </a:tc>
                 <a:tc>
                   <a:txBody>
-                    <a:bodyPr wrap="square"/>
+                    <a:bodyPr wrap="none"/>
                     <a:lstStyle/>
                     <a:p>
-                      <a:pPr>
+                      <a:pPr algn="r">
                         <a:defRPr sz="900">
                           <a:solidFill>
                             <a:srgbClr val="262626"/>
@@ -5585,7 +5585,7 @@
                       </a:r>
                     </a:p>
                   </a:txBody>
-                  <a:tcPr>
+                  <a:tcPr marL="36576" marR="36576" marT="27432" marB="27432">
                     <a:solidFill>
                       <a:srgbClr val="F9FAFC"/>
                     </a:solidFill>
@@ -5595,7 +5595,7 @@
               <a:tr h="411480">
                 <a:tc>
                   <a:txBody>
-                    <a:bodyPr wrap="square"/>
+                    <a:bodyPr/>
                     <a:lstStyle/>
                     <a:p>
                       <a:pPr>
@@ -5611,7 +5611,7 @@
                       </a:r>
                     </a:p>
                   </a:txBody>
-                  <a:tcPr>
+                  <a:tcPr marL="36576" marR="36576" marT="27432" marB="27432">
                     <a:solidFill>
                       <a:srgbClr val="FFFFFF"/>
                     </a:solidFill>
@@ -5619,7 +5619,7 @@
                 </a:tc>
                 <a:tc>
                   <a:txBody>
-                    <a:bodyPr wrap="square"/>
+                    <a:bodyPr/>
                     <a:lstStyle/>
                     <a:p>
                       <a:pPr>
@@ -5635,7 +5635,7 @@
                       </a:r>
                     </a:p>
                   </a:txBody>
-                  <a:tcPr>
+                  <a:tcPr marL="36576" marR="36576" marT="27432" marB="27432">
                     <a:solidFill>
                       <a:srgbClr val="FFFFFF"/>
                     </a:solidFill>
@@ -5643,10 +5643,10 @@
                 </a:tc>
                 <a:tc>
                   <a:txBody>
-                    <a:bodyPr wrap="square"/>
+                    <a:bodyPr wrap="none"/>
                     <a:lstStyle/>
                     <a:p>
-                      <a:pPr>
+                      <a:pPr algn="r">
                         <a:defRPr sz="900">
                           <a:solidFill>
                             <a:srgbClr val="262626"/>
@@ -5659,7 +5659,7 @@
                       </a:r>
                     </a:p>
                   </a:txBody>
-                  <a:tcPr>
+                  <a:tcPr marL="36576" marR="36576" marT="27432" marB="27432">
                     <a:solidFill>
                       <a:srgbClr val="FFFFFF"/>
                     </a:solidFill>
@@ -5669,7 +5669,7 @@
               <a:tr h="411480">
                 <a:tc>
                   <a:txBody>
-                    <a:bodyPr wrap="square"/>
+                    <a:bodyPr/>
                     <a:lstStyle/>
                     <a:p>
                       <a:pPr>
@@ -5685,7 +5685,7 @@
                       </a:r>
                     </a:p>
                   </a:txBody>
-                  <a:tcPr>
+                  <a:tcPr marL="36576" marR="36576" marT="27432" marB="27432">
                     <a:solidFill>
                       <a:srgbClr val="F9FAFC"/>
                     </a:solidFill>
@@ -5693,7 +5693,7 @@
                 </a:tc>
                 <a:tc>
                   <a:txBody>
-                    <a:bodyPr wrap="square"/>
+                    <a:bodyPr/>
                     <a:lstStyle/>
                     <a:p>
                       <a:pPr>
@@ -5709,7 +5709,7 @@
                       </a:r>
                     </a:p>
                   </a:txBody>
-                  <a:tcPr>
+                  <a:tcPr marL="36576" marR="36576" marT="27432" marB="27432">
                     <a:solidFill>
                       <a:srgbClr val="F9FAFC"/>
                     </a:solidFill>
@@ -5717,10 +5717,10 @@
                 </a:tc>
                 <a:tc>
                   <a:txBody>
-                    <a:bodyPr wrap="square"/>
+                    <a:bodyPr wrap="none"/>
                     <a:lstStyle/>
                     <a:p>
-                      <a:pPr>
+                      <a:pPr algn="r">
                         <a:defRPr sz="900">
                           <a:solidFill>
                             <a:srgbClr val="262626"/>
@@ -5733,7 +5733,7 @@
                       </a:r>
                     </a:p>
                   </a:txBody>
-                  <a:tcPr>
+                  <a:tcPr marL="36576" marR="36576" marT="27432" marB="27432">
                     <a:solidFill>
                       <a:srgbClr val="F9FAFC"/>
                     </a:solidFill>
@@ -5743,7 +5743,7 @@
               <a:tr h="411480">
                 <a:tc>
                   <a:txBody>
-                    <a:bodyPr wrap="square"/>
+                    <a:bodyPr/>
                     <a:lstStyle/>
                     <a:p>
                       <a:pPr>
@@ -5759,7 +5759,7 @@
                       </a:r>
                     </a:p>
                   </a:txBody>
-                  <a:tcPr>
+                  <a:tcPr marL="36576" marR="36576" marT="27432" marB="27432">
                     <a:solidFill>
                       <a:srgbClr val="FFFFFF"/>
                     </a:solidFill>
@@ -5767,7 +5767,7 @@
                 </a:tc>
                 <a:tc>
                   <a:txBody>
-                    <a:bodyPr wrap="square"/>
+                    <a:bodyPr/>
                     <a:lstStyle/>
                     <a:p>
                       <a:pPr>
@@ -5783,7 +5783,7 @@
                       </a:r>
                     </a:p>
                   </a:txBody>
-                  <a:tcPr>
+                  <a:tcPr marL="36576" marR="36576" marT="27432" marB="27432">
                     <a:solidFill>
                       <a:srgbClr val="FFFFFF"/>
                     </a:solidFill>
@@ -5791,10 +5791,10 @@
                 </a:tc>
                 <a:tc>
                   <a:txBody>
-                    <a:bodyPr wrap="square"/>
+                    <a:bodyPr wrap="none"/>
                     <a:lstStyle/>
                     <a:p>
-                      <a:pPr>
+                      <a:pPr algn="r">
                         <a:defRPr sz="900">
                           <a:solidFill>
                             <a:srgbClr val="262626"/>
@@ -5807,7 +5807,7 @@
                       </a:r>
                     </a:p>
                   </a:txBody>
-                  <a:tcPr>
+                  <a:tcPr marL="36576" marR="36576" marT="27432" marB="27432">
                     <a:solidFill>
                       <a:srgbClr val="FFFFFF"/>
                     </a:solidFill>
@@ -5817,7 +5817,7 @@
               <a:tr h="411480">
                 <a:tc>
                   <a:txBody>
-                    <a:bodyPr wrap="square"/>
+                    <a:bodyPr/>
                     <a:lstStyle/>
                     <a:p>
                       <a:pPr>
@@ -5833,7 +5833,7 @@
                       </a:r>
                     </a:p>
                   </a:txBody>
-                  <a:tcPr>
+                  <a:tcPr marL="36576" marR="36576" marT="27432" marB="27432">
                     <a:solidFill>
                       <a:srgbClr val="FFFDF5"/>
                     </a:solidFill>
@@ -5841,7 +5841,7 @@
                 </a:tc>
                 <a:tc>
                   <a:txBody>
-                    <a:bodyPr wrap="square"/>
+                    <a:bodyPr/>
                     <a:lstStyle/>
                     <a:p>
                       <a:pPr>
@@ -5857,7 +5857,7 @@
                       </a:r>
                     </a:p>
                   </a:txBody>
-                  <a:tcPr>
+                  <a:tcPr marL="36576" marR="36576" marT="27432" marB="27432">
                     <a:solidFill>
                       <a:srgbClr val="FFFDF5"/>
                     </a:solidFill>
@@ -5865,10 +5865,10 @@
                 </a:tc>
                 <a:tc>
                   <a:txBody>
-                    <a:bodyPr wrap="square"/>
+                    <a:bodyPr wrap="none"/>
                     <a:lstStyle/>
                     <a:p>
-                      <a:pPr>
+                      <a:pPr algn="r">
                         <a:defRPr sz="900" b="1">
                           <a:solidFill>
                             <a:srgbClr val="1F497D"/>
@@ -5877,11 +5877,11 @@
                         </a:defRPr>
                       </a:pPr>
                       <a:r>
-                        <a:t>= 67.179,32 €</a:t>
+                        <a:t>= 67.179,32 €</a:t>
                       </a:r>
                     </a:p>
                   </a:txBody>
-                  <a:tcPr>
+                  <a:tcPr marL="36576" marR="36576" marT="27432" marB="27432">
                     <a:solidFill>
                       <a:srgbClr val="FFFDF5"/>
                     </a:solidFill>
@@ -5891,7 +5891,7 @@
               <a:tr h="411480">
                 <a:tc>
                   <a:txBody>
-                    <a:bodyPr wrap="square"/>
+                    <a:bodyPr/>
                     <a:lstStyle/>
                     <a:p>
                       <a:pPr>
@@ -5907,7 +5907,7 @@
                       </a:r>
                     </a:p>
                   </a:txBody>
-                  <a:tcPr>
+                  <a:tcPr marL="36576" marR="36576" marT="27432" marB="27432">
                     <a:solidFill>
                       <a:srgbClr val="FFFFFF"/>
                     </a:solidFill>
@@ -5915,7 +5915,7 @@
                 </a:tc>
                 <a:tc>
                   <a:txBody>
-                    <a:bodyPr wrap="square"/>
+                    <a:bodyPr/>
                     <a:lstStyle/>
                     <a:p>
                       <a:pPr>
@@ -5931,7 +5931,7 @@
                       </a:r>
                     </a:p>
                   </a:txBody>
-                  <a:tcPr>
+                  <a:tcPr marL="36576" marR="36576" marT="27432" marB="27432">
                     <a:solidFill>
                       <a:srgbClr val="FFFFFF"/>
                     </a:solidFill>
@@ -5939,10 +5939,10 @@
                 </a:tc>
                 <a:tc>
                   <a:txBody>
-                    <a:bodyPr wrap="square"/>
+                    <a:bodyPr wrap="none"/>
                     <a:lstStyle/>
                     <a:p>
-                      <a:pPr>
+                      <a:pPr algn="r">
                         <a:defRPr sz="900">
                           <a:solidFill>
                             <a:srgbClr val="262626"/>
@@ -5951,11 +5951,11 @@
                         </a:defRPr>
                       </a:pPr>
                       <a:r>
-                        <a:t>= 12.764,07 €</a:t>
+                        <a:t>+ 12.764,07 €</a:t>
                       </a:r>
                     </a:p>
                   </a:txBody>
-                  <a:tcPr>
+                  <a:tcPr marL="36576" marR="36576" marT="27432" marB="27432">
                     <a:solidFill>
                       <a:srgbClr val="FFFFFF"/>
                     </a:solidFill>
@@ -5965,7 +5965,7 @@
               <a:tr h="411480">
                 <a:tc>
                   <a:txBody>
-                    <a:bodyPr wrap="square"/>
+                    <a:bodyPr/>
                     <a:lstStyle/>
                     <a:p>
                       <a:pPr>
@@ -5981,7 +5981,7 @@
                       </a:r>
                     </a:p>
                   </a:txBody>
-                  <a:tcPr>
+                  <a:tcPr marL="36576" marR="36576" marT="27432" marB="27432">
                     <a:solidFill>
                       <a:srgbClr val="FFFDF5"/>
                     </a:solidFill>
@@ -5989,7 +5989,7 @@
                 </a:tc>
                 <a:tc>
                   <a:txBody>
-                    <a:bodyPr wrap="square"/>
+                    <a:bodyPr/>
                     <a:lstStyle/>
                     <a:p>
                       <a:pPr>
@@ -6005,7 +6005,7 @@
                       </a:r>
                     </a:p>
                   </a:txBody>
-                  <a:tcPr>
+                  <a:tcPr marL="36576" marR="36576" marT="27432" marB="27432">
                     <a:solidFill>
                       <a:srgbClr val="FFFDF5"/>
                     </a:solidFill>
@@ -6013,10 +6013,10 @@
                 </a:tc>
                 <a:tc>
                   <a:txBody>
-                    <a:bodyPr wrap="square"/>
+                    <a:bodyPr wrap="none"/>
                     <a:lstStyle/>
                     <a:p>
-                      <a:pPr>
+                      <a:pPr algn="r">
                         <a:defRPr sz="900" b="1">
                           <a:solidFill>
                             <a:srgbClr val="C00000"/>
@@ -6025,11 +6025,11 @@
                         </a:defRPr>
                       </a:pPr>
                       <a:r>
-                        <a:t>= 79.943,39 €</a:t>
+                        <a:t>= 79.943,39 €</a:t>
                       </a:r>
                     </a:p>
                   </a:txBody>
-                  <a:tcPr>
+                  <a:tcPr marL="36576" marR="36576" marT="27432" marB="27432">
                     <a:solidFill>
                       <a:srgbClr val="FFFDF5"/>
                     </a:solidFill>
@@ -6048,8 +6048,8 @@
         </p:nvSpPr>
         <p:spPr>
           <a:xfrm>
-            <a:off x="6217920" y="1234440"/>
-            <a:ext cx="5257800" cy="4937760"/>
+            <a:off x="6172200" y="1234440"/>
+            <a:ext cx="5303520" cy="4937760"/>
           </a:xfrm>
           <a:prstGeom prst="roundRect">
             <a:avLst/>
@@ -6093,8 +6093,8 @@
         </p:nvSpPr>
         <p:spPr>
           <a:xfrm>
-            <a:off x="6217920" y="1234440"/>
-            <a:ext cx="5257800" cy="502920"/>
+            <a:off x="6172200" y="1234440"/>
+            <a:ext cx="5303520" cy="502920"/>
           </a:xfrm>
           <a:prstGeom prst="rect">
             <a:avLst/>
@@ -6147,8 +6147,8 @@
           <p:nvPr/>
         </p:nvGraphicFramePr>
         <p:xfrm>
-          <a:off x="6355080" y="1874519"/>
-          <a:ext cx="4983480" cy="2194560"/>
+          <a:off x="6263640" y="1874519"/>
+          <a:ext cx="5120639" cy="2194560"/>
         </p:xfrm>
         <a:graphic>
           <a:graphicData uri="http://schemas.openxmlformats.org/drawingml/2006/table">
@@ -6157,13 +6157,13 @@
                 <a:tableStyleId>{5C22544A-7EE6-4342-B048-85BDC9FD1C3A}</a:tableStyleId>
               </a:tblPr>
               <a:tblGrid>
-                <a:gridCol w="3657600"/>
-                <a:gridCol w="1325880"/>
+                <a:gridCol w="3749039"/>
+                <a:gridCol w="1371600"/>
               </a:tblGrid>
               <a:tr h="313508">
                 <a:tc>
                   <a:txBody>
-                    <a:bodyPr/>
+                    <a:bodyPr wrap="none"/>
                     <a:lstStyle/>
                     <a:p>
                       <a:pPr>
@@ -6179,7 +6179,7 @@
                       </a:r>
                     </a:p>
                   </a:txBody>
-                  <a:tcPr>
+                  <a:tcPr marL="36576" marR="36576" marT="27432" marB="27432">
                     <a:solidFill>
                       <a:srgbClr val="F0F3F8"/>
                     </a:solidFill>
@@ -6187,7 +6187,7 @@
                 </a:tc>
                 <a:tc>
                   <a:txBody>
-                    <a:bodyPr/>
+                    <a:bodyPr wrap="none"/>
                     <a:lstStyle/>
                     <a:p>
                       <a:pPr algn="r">
@@ -6203,7 +6203,7 @@
                       </a:r>
                     </a:p>
                   </a:txBody>
-                  <a:tcPr>
+                  <a:tcPr marL="36576" marR="36576" marT="27432" marB="27432">
                     <a:solidFill>
                       <a:srgbClr val="F0F3F8"/>
                     </a:solidFill>
@@ -6226,7 +6226,7 @@
                       </a:r>
                     </a:p>
                   </a:txBody>
-                  <a:tcPr>
+                  <a:tcPr marL="36576" marR="36576" marT="27432" marB="27432">
                     <a:solidFill>
                       <a:srgbClr val="F9FAFC"/>
                     </a:solidFill>
@@ -6234,7 +6234,7 @@
                 </a:tc>
                 <a:tc>
                   <a:txBody>
-                    <a:bodyPr/>
+                    <a:bodyPr wrap="none"/>
                     <a:lstStyle/>
                     <a:p>
                       <a:pPr algn="r">
@@ -6243,11 +6243,11 @@
                         </a:defRPr>
                       </a:pPr>
                       <a:r>
-                        <a:t>51.108,12 €</a:t>
+                        <a:t>51.108,12 €</a:t>
                       </a:r>
                     </a:p>
                   </a:txBody>
-                  <a:tcPr>
+                  <a:tcPr marL="36576" marR="36576" marT="27432" marB="27432">
                     <a:solidFill>
                       <a:srgbClr val="F9FAFC"/>
                     </a:solidFill>
@@ -6270,7 +6270,7 @@
                       </a:r>
                     </a:p>
                   </a:txBody>
-                  <a:tcPr>
+                  <a:tcPr marL="36576" marR="36576" marT="27432" marB="27432">
                     <a:solidFill>
                       <a:srgbClr val="FFFFFF"/>
                     </a:solidFill>
@@ -6278,7 +6278,7 @@
                 </a:tc>
                 <a:tc>
                   <a:txBody>
-                    <a:bodyPr/>
+                    <a:bodyPr wrap="none"/>
                     <a:lstStyle/>
                     <a:p>
                       <a:pPr algn="r">
@@ -6287,11 +6287,11 @@
                         </a:defRPr>
                       </a:pPr>
                       <a:r>
-                        <a:t>10.021,20 €</a:t>
+                        <a:t>10.021,20 €</a:t>
                       </a:r>
                     </a:p>
                   </a:txBody>
-                  <a:tcPr>
+                  <a:tcPr marL="36576" marR="36576" marT="27432" marB="27432">
                     <a:solidFill>
                       <a:srgbClr val="FFFFFF"/>
                     </a:solidFill>
@@ -6314,7 +6314,7 @@
                       </a:r>
                     </a:p>
                   </a:txBody>
-                  <a:tcPr>
+                  <a:tcPr marL="36576" marR="36576" marT="27432" marB="27432">
                     <a:solidFill>
                       <a:srgbClr val="F9FAFC"/>
                     </a:solidFill>
@@ -6322,7 +6322,7 @@
                 </a:tc>
                 <a:tc>
                   <a:txBody>
-                    <a:bodyPr/>
+                    <a:bodyPr wrap="none"/>
                     <a:lstStyle/>
                     <a:p>
                       <a:pPr algn="r">
@@ -6331,11 +6331,11 @@
                         </a:defRPr>
                       </a:pPr>
                       <a:r>
-                        <a:t>6.050,00 €</a:t>
+                        <a:t>6.050,00 €</a:t>
                       </a:r>
                     </a:p>
                   </a:txBody>
-                  <a:tcPr>
+                  <a:tcPr marL="36576" marR="36576" marT="27432" marB="27432">
                     <a:solidFill>
                       <a:srgbClr val="F9FAFC"/>
                     </a:solidFill>
@@ -6361,7 +6361,7 @@
                       </a:r>
                     </a:p>
                   </a:txBody>
-                  <a:tcPr>
+                  <a:tcPr marL="36576" marR="36576" marT="27432" marB="27432">
                     <a:solidFill>
                       <a:srgbClr val="FFFDF5"/>
                     </a:solidFill>
@@ -6369,7 +6369,7 @@
                 </a:tc>
                 <a:tc>
                   <a:txBody>
-                    <a:bodyPr/>
+                    <a:bodyPr wrap="none"/>
                     <a:lstStyle/>
                     <a:p>
                       <a:pPr algn="r">
@@ -6381,11 +6381,11 @@
                         </a:defRPr>
                       </a:pPr>
                       <a:r>
-                        <a:t>67.179,32 €</a:t>
+                        <a:t>67.179,32 €</a:t>
                       </a:r>
                     </a:p>
                   </a:txBody>
-                  <a:tcPr>
+                  <a:tcPr marL="36576" marR="36576" marT="27432" marB="27432">
                     <a:solidFill>
                       <a:srgbClr val="FFFDF5"/>
                     </a:solidFill>
@@ -6408,7 +6408,7 @@
                       </a:r>
                     </a:p>
                   </a:txBody>
-                  <a:tcPr>
+                  <a:tcPr marL="36576" marR="36576" marT="27432" marB="27432">
                     <a:solidFill>
                       <a:srgbClr val="F9FAFC"/>
                     </a:solidFill>
@@ -6416,7 +6416,7 @@
                 </a:tc>
                 <a:tc>
                   <a:txBody>
-                    <a:bodyPr/>
+                    <a:bodyPr wrap="none"/>
                     <a:lstStyle/>
                     <a:p>
                       <a:pPr algn="r">
@@ -6425,11 +6425,11 @@
                         </a:defRPr>
                       </a:pPr>
                       <a:r>
-                        <a:t>12.764,07 €</a:t>
+                        <a:t>12.764,07 €</a:t>
                       </a:r>
                     </a:p>
                   </a:txBody>
-                  <a:tcPr>
+                  <a:tcPr marL="36576" marR="36576" marT="27432" marB="27432">
                     <a:solidFill>
                       <a:srgbClr val="F9FAFC"/>
                     </a:solidFill>
@@ -6455,7 +6455,7 @@
                       </a:r>
                     </a:p>
                   </a:txBody>
-                  <a:tcPr>
+                  <a:tcPr marL="36576" marR="36576" marT="27432" marB="27432">
                     <a:solidFill>
                       <a:srgbClr val="FFFDF5"/>
                     </a:solidFill>
@@ -6463,7 +6463,7 @@
                 </a:tc>
                 <a:tc>
                   <a:txBody>
-                    <a:bodyPr/>
+                    <a:bodyPr wrap="none"/>
                     <a:lstStyle/>
                     <a:p>
                       <a:pPr algn="r">
@@ -6475,11 +6475,11 @@
                         </a:defRPr>
                       </a:pPr>
                       <a:r>
-                        <a:t>79.943,39 €</a:t>
+                        <a:t>79.943,39 €</a:t>
                       </a:r>
                     </a:p>
                   </a:txBody>
-                  <a:tcPr>
+                  <a:tcPr marL="36576" marR="36576" marT="27432" marB="27432">
                     <a:solidFill>
                       <a:srgbClr val="FFFDF5"/>
                     </a:solidFill>
@@ -6498,8 +6498,8 @@
         </p:nvSpPr>
         <p:spPr>
           <a:xfrm>
-            <a:off x="6355080" y="4297680"/>
-            <a:ext cx="4983480" cy="1737360"/>
+            <a:off x="6263640" y="4297680"/>
+            <a:ext cx="5120640" cy="1737360"/>
           </a:xfrm>
           <a:prstGeom prst="roundRect">
             <a:avLst/>
@@ -6543,8 +6543,8 @@
         </p:nvSpPr>
         <p:spPr>
           <a:xfrm>
-            <a:off x="6492240" y="4389120"/>
-            <a:ext cx="4709160" cy="1554480"/>
+            <a:off x="6400800" y="4389120"/>
+            <a:ext cx="4846320" cy="1554480"/>
           </a:xfrm>
           <a:prstGeom prst="rect">
             <a:avLst/>
@@ -6582,7 +6582,7 @@
               </a:defRPr>
             </a:pPr>
             <a:r>
-              <a:t>• Zahlungsziel: 14 Tage mit 3 % Skonto (2.015,38 € Ersparnis) oder 30 Tage rein netto</a:t>
+              <a:t>• Zahlungsziel: 14 Tage mit 3 % Skonto (2.015,38 € Ersparnis) oder 30 Tage rein netto</a:t>
             </a:r>
           </a:p>
           <a:p>
@@ -6614,7 +6614,7 @@
               </a:defRPr>
             </a:pPr>
             <a:r>
-              <a:t>• Option IT-Leasing: Ab ca. 1.580 € monatlich (Voll amortisierbare Betriebsausgabe / OPEX)</a:t>
+              <a:t>• Option IT-Leasing: Ab ca. 1.580 € monatlich (Voll amortisierbare Betriebsausgabe / OPEX)</a:t>
             </a:r>
           </a:p>
         </p:txBody>

</xml_diff>

<commit_message>
Folie 5: Tatsaechlichen DIN 69901 Projektstrukturplan aus Excel mit allen 5 Teilprojekten und 30 Arbeitspaketen komplett eingearbeitet
</commit_message>
<xml_diff>
--- a/docs/08_Projektabschluss/Abschlusspraesentation.pptx
+++ b/docs/08_Projektabschluss/Abschlusspraesentation.pptx
@@ -1463,13 +1463,13 @@
           <a:p/>
           <a:p>
             <a:r>
-              <a:t>Hallo zusammen, hier sehen Sie unseren Projektstrukturplan nach DIN 69901.</a:t>
+              <a:t>Hallo zusammen, hier sehen Sie unseren tatsächlichen Projektstrukturplan nach DIN 69901.</a:t>
             </a:r>
           </a:p>
           <a:p/>
           <a:p>
             <a:r>
-              <a:t>Als 'Plan der Pläne' gliedert er unser Projekt in fünf logische Säulen: Hardware, Software, Netzwerk/Server, Qualitätsmanagement und Rollout/Projektleitung. Insgesamt haben wir 28 konkrete Arbeitspakete definiert. Jeder Bereich hat einen festen Verantwortlichen. Das verhindert Kompetenzgerangel und stellt sicher, dass kein Detail – wie die Patchkabel oder die BSI-Löschung des Altdruckers – vergessen wird.</a:t>
+              <a:t>Als 'Plan der Pläne' gliedert er unser Gesamtauftragsvolumen hierarchisch in fünf logische Säulen: Hardware-Ausstattung, Software &amp; Lizenzen, Netzwerk &amp; Server, Qualitätsmanagement &amp; Logistik sowie Rollout &amp; Übergabe. Insgesamt haben wir 30 konkrete, messbare Arbeitspakete auf Ebene 3 definiert (6 je Teilprojekt). Jeder Bereich besitzt einen festen Verantwortlichen aus unserem Kernteam. Das sichert klare Verantwortlichkeiten und stellt sicher, dass nach der 100%-Regel der DIN 69901 kein einziges Detail – von den Cat.6A-Patchkabeln über die BSI-zertifizierte Löschung bis zum rechtssicheren Abnahmeprotokoll – vergessen wird.</a:t>
             </a:r>
           </a:p>
         </p:txBody>
@@ -14818,1489 +14818,30 @@
           </a:p>
         </p:txBody>
       </p:sp>
-      <p:sp>
-        <p:nvSpPr>
-          <p:cNvPr id="5" name="Rounded Rectangle 4"/>
-          <p:cNvSpPr/>
-          <p:nvPr/>
-        </p:nvSpPr>
-        <p:spPr>
-          <a:xfrm>
-            <a:off x="3352190" y="1280160"/>
-            <a:ext cx="5486400" cy="685800"/>
-          </a:xfrm>
-          <a:prstGeom prst="roundRect">
-            <a:avLst/>
-          </a:prstGeom>
-          <a:solidFill>
-            <a:srgbClr val="1F497D"/>
-          </a:solidFill>
-          <a:ln w="19050">
-            <a:solidFill>
-              <a:srgbClr val="8EA9DB"/>
-            </a:solidFill>
-          </a:ln>
-        </p:spPr>
-        <p:style>
-          <a:lnRef idx="1">
-            <a:schemeClr val="accent1"/>
-          </a:lnRef>
-          <a:fillRef idx="3">
-            <a:schemeClr val="accent1"/>
-          </a:fillRef>
-          <a:effectRef idx="2">
-            <a:schemeClr val="accent1"/>
-          </a:effectRef>
-          <a:fontRef idx="minor">
-            <a:schemeClr val="lt1"/>
-          </a:fontRef>
-        </p:style>
-        <p:txBody>
-          <a:bodyPr rtlCol="0" anchor="ctr"/>
-          <a:lstStyle/>
-          <a:p>
-            <a:pPr algn="ctr">
-              <a:defRPr sz="1200" b="1">
-                <a:solidFill>
-                  <a:srgbClr val="FFFFFF"/>
-                </a:solidFill>
-                <a:latin typeface="Calibri"/>
-              </a:defRPr>
-            </a:pPr>
-            <a:r>
-              <a:t>1.0 IT-Ausstattung Planungs- und Konstruktionsbüro</a:t>
-            </a:r>
-          </a:p>
-          <a:p>
-            <a:pPr algn="ctr">
-              <a:defRPr sz="1000">
-                <a:solidFill>
-                  <a:srgbClr val="DEEBF7"/>
-                </a:solidFill>
-                <a:latin typeface="Calibri"/>
-              </a:defRPr>
-            </a:pPr>
-            <a:r>
-              <a:t>Projektleiter: Jan Kluth  |  NextLevel IT Solutions GmbH</a:t>
-            </a:r>
-          </a:p>
-        </p:txBody>
-      </p:sp>
-      <p:sp>
-        <p:nvSpPr>
-          <p:cNvPr id="6" name="Rounded Rectangle 5"/>
-          <p:cNvSpPr/>
-          <p:nvPr/>
-        </p:nvSpPr>
-        <p:spPr>
-          <a:xfrm>
-            <a:off x="731520" y="2194560"/>
-            <a:ext cx="2057400" cy="4114800"/>
-          </a:xfrm>
-          <a:prstGeom prst="roundRect">
-            <a:avLst/>
-          </a:prstGeom>
-          <a:solidFill>
-            <a:srgbClr val="FFFFFF"/>
-          </a:solidFill>
-          <a:ln w="12700">
-            <a:solidFill>
-              <a:srgbClr val="B4C6E7"/>
-            </a:solidFill>
-          </a:ln>
-        </p:spPr>
-        <p:style>
-          <a:lnRef idx="1">
-            <a:schemeClr val="accent1"/>
-          </a:lnRef>
-          <a:fillRef idx="3">
-            <a:schemeClr val="accent1"/>
-          </a:fillRef>
-          <a:effectRef idx="2">
-            <a:schemeClr val="accent1"/>
-          </a:effectRef>
-          <a:fontRef idx="minor">
-            <a:schemeClr val="lt1"/>
-          </a:fontRef>
-        </p:style>
-        <p:txBody>
-          <a:bodyPr rtlCol="0" anchor="ctr"/>
-          <a:lstStyle/>
-          <a:p>
-            <a:pPr algn="ctr">
-              <a:defRPr/>
-            </a:pPr>
-          </a:p>
-        </p:txBody>
-      </p:sp>
-      <p:sp>
-        <p:nvSpPr>
-          <p:cNvPr id="7" name="Rectangle 6"/>
-          <p:cNvSpPr/>
-          <p:nvPr/>
-        </p:nvSpPr>
-        <p:spPr>
-          <a:xfrm>
-            <a:off x="731520" y="2194560"/>
-            <a:ext cx="2057400" cy="685800"/>
+      <p:pic>
+        <p:nvPicPr>
+          <p:cNvPr id="5" name="Picture 4" descr="psp_inline.png"/>
+          <p:cNvPicPr>
+            <a:picLocks noChangeAspect="1"/>
+          </p:cNvPicPr>
+          <p:nvPr/>
+        </p:nvPicPr>
+        <p:blipFill>
+          <a:blip r:embed="rId3"/>
+          <a:stretch>
+            <a:fillRect/>
+          </a:stretch>
+        </p:blipFill>
+        <p:spPr>
+          <a:xfrm>
+            <a:off x="700887" y="1078992"/>
+            <a:ext cx="10789920" cy="5212080"/>
           </a:xfrm>
           <a:prstGeom prst="rect">
             <a:avLst/>
           </a:prstGeom>
-          <a:solidFill>
-            <a:srgbClr val="2F5597"/>
-          </a:solidFill>
-          <a:ln>
-            <a:noFill/>
-          </a:ln>
-        </p:spPr>
-        <p:style>
-          <a:lnRef idx="1">
-            <a:schemeClr val="accent1"/>
-          </a:lnRef>
-          <a:fillRef idx="3">
-            <a:schemeClr val="accent1"/>
-          </a:fillRef>
-          <a:effectRef idx="2">
-            <a:schemeClr val="accent1"/>
-          </a:effectRef>
-          <a:fontRef idx="minor">
-            <a:schemeClr val="lt1"/>
-          </a:fontRef>
-        </p:style>
-        <p:txBody>
-          <a:bodyPr rtlCol="0" anchor="ctr"/>
-          <a:lstStyle/>
-          <a:p>
-            <a:pPr algn="ctr">
-              <a:defRPr/>
-            </a:pPr>
-          </a:p>
-        </p:txBody>
-      </p:sp>
-      <p:sp>
-        <p:nvSpPr>
-          <p:cNvPr id="8" name="TextBox 7"/>
-          <p:cNvSpPr txBox="1"/>
-          <p:nvPr/>
-        </p:nvSpPr>
-        <p:spPr>
-          <a:xfrm>
-            <a:off x="731520" y="2240280"/>
-            <a:ext cx="2057400" cy="365760"/>
-          </a:xfrm>
-          <a:prstGeom prst="rect">
-            <a:avLst/>
-          </a:prstGeom>
-          <a:noFill/>
-        </p:spPr>
-        <p:txBody>
-          <a:bodyPr wrap="none">
-            <a:spAutoFit/>
-          </a:bodyPr>
-          <a:lstStyle/>
-          <a:p>
-            <a:pPr algn="ctr">
-              <a:defRPr sz="1100" b="1">
-                <a:solidFill>
-                  <a:srgbClr val="FFFFFF"/>
-                </a:solidFill>
-                <a:latin typeface="Calibri"/>
-              </a:defRPr>
-            </a:pPr>
-            <a:r>
-              <a:t>1.1 Hardware</a:t>
-            </a:r>
-          </a:p>
-        </p:txBody>
-      </p:sp>
-      <p:sp>
-        <p:nvSpPr>
-          <p:cNvPr id="9" name="TextBox 8"/>
-          <p:cNvSpPr txBox="1"/>
-          <p:nvPr/>
-        </p:nvSpPr>
-        <p:spPr>
-          <a:xfrm>
-            <a:off x="731520" y="2542032"/>
-            <a:ext cx="2057400" cy="274320"/>
-          </a:xfrm>
-          <a:prstGeom prst="rect">
-            <a:avLst/>
-          </a:prstGeom>
-          <a:noFill/>
-        </p:spPr>
-        <p:txBody>
-          <a:bodyPr wrap="none">
-            <a:spAutoFit/>
-          </a:bodyPr>
-          <a:lstStyle/>
-          <a:p>
-            <a:pPr algn="ctr">
-              <a:defRPr sz="950">
-                <a:solidFill>
-                  <a:srgbClr val="DEEBF7"/>
-                </a:solidFill>
-                <a:latin typeface="Calibri"/>
-              </a:defRPr>
-            </a:pPr>
-            <a:r>
-              <a:t>Leitung: Marian Bolecke</a:t>
-            </a:r>
-          </a:p>
-        </p:txBody>
-      </p:sp>
-      <p:sp>
-        <p:nvSpPr>
-          <p:cNvPr id="10" name="TextBox 9"/>
-          <p:cNvSpPr txBox="1"/>
-          <p:nvPr/>
-        </p:nvSpPr>
-        <p:spPr>
-          <a:xfrm>
-            <a:off x="822960" y="2971800"/>
-            <a:ext cx="1874520" cy="3200400"/>
-          </a:xfrm>
-          <a:prstGeom prst="rect">
-            <a:avLst/>
-          </a:prstGeom>
-          <a:noFill/>
-        </p:spPr>
-        <p:txBody>
-          <a:bodyPr wrap="square">
-            <a:spAutoFit/>
-          </a:bodyPr>
-          <a:lstStyle/>
-          <a:p>
-            <a:pPr>
-              <a:spcAft>
-                <a:spcPts val="400"/>
-              </a:spcAft>
-              <a:defRPr sz="950">
-                <a:solidFill>
-                  <a:srgbClr val="262626"/>
-                </a:solidFill>
-                <a:latin typeface="Calibri"/>
-              </a:defRPr>
-            </a:pPr>
-            <a:r>
-              <a:t>• 1.1.1 12x Standard-PCs</a:t>
-            </a:r>
-          </a:p>
-          <a:p>
-            <a:pPr>
-              <a:spcAft>
-                <a:spcPts val="400"/>
-              </a:spcAft>
-              <a:defRPr sz="950">
-                <a:solidFill>
-                  <a:srgbClr val="262626"/>
-                </a:solidFill>
-                <a:latin typeface="Calibri"/>
-              </a:defRPr>
-            </a:pPr>
-            <a:r>
-              <a:t>• 1.1.2 4x CAD-Workstations</a:t>
-            </a:r>
-          </a:p>
-          <a:p>
-            <a:pPr>
-              <a:spcAft>
-                <a:spcPts val="400"/>
-              </a:spcAft>
-              <a:defRPr sz="950">
-                <a:solidFill>
-                  <a:srgbClr val="262626"/>
-                </a:solidFill>
-                <a:latin typeface="Calibri"/>
-              </a:defRPr>
-            </a:pPr>
-            <a:r>
-              <a:t>• 1.1.3 32x Monitore (WQHD)</a:t>
-            </a:r>
-          </a:p>
-          <a:p>
-            <a:pPr>
-              <a:spcAft>
-                <a:spcPts val="400"/>
-              </a:spcAft>
-              <a:defRPr sz="950">
-                <a:solidFill>
-                  <a:srgbClr val="262626"/>
-                </a:solidFill>
-                <a:latin typeface="Calibri"/>
-              </a:defRPr>
-            </a:pPr>
-            <a:r>
-              <a:t>• 1.1.4 16x Funk-Eingabesets</a:t>
-            </a:r>
-          </a:p>
-          <a:p>
-            <a:pPr>
-              <a:spcAft>
-                <a:spcPts val="400"/>
-              </a:spcAft>
-              <a:defRPr sz="950">
-                <a:solidFill>
-                  <a:srgbClr val="262626"/>
-                </a:solidFill>
-                <a:latin typeface="Calibri"/>
-              </a:defRPr>
-            </a:pPr>
-            <a:r>
-              <a:t>• 1.1.5 16x Externe 1TB SSDs</a:t>
-            </a:r>
-          </a:p>
-          <a:p>
-            <a:pPr>
-              <a:spcAft>
-                <a:spcPts val="400"/>
-              </a:spcAft>
-              <a:defRPr sz="950">
-                <a:solidFill>
-                  <a:srgbClr val="262626"/>
-                </a:solidFill>
-                <a:latin typeface="Calibri"/>
-              </a:defRPr>
-            </a:pPr>
-            <a:r>
-              <a:t>• 1.1.6 1x Farblaser-MFP A3</a:t>
-            </a:r>
-          </a:p>
-        </p:txBody>
-      </p:sp>
-      <p:sp>
-        <p:nvSpPr>
-          <p:cNvPr id="11" name="Rounded Rectangle 10"/>
-          <p:cNvSpPr/>
-          <p:nvPr/>
-        </p:nvSpPr>
-        <p:spPr>
-          <a:xfrm>
-            <a:off x="2907791" y="2194560"/>
-            <a:ext cx="2057400" cy="4114800"/>
-          </a:xfrm>
-          <a:prstGeom prst="roundRect">
-            <a:avLst/>
-          </a:prstGeom>
-          <a:solidFill>
-            <a:srgbClr val="FFFFFF"/>
-          </a:solidFill>
-          <a:ln w="12700">
-            <a:solidFill>
-              <a:srgbClr val="B4C6E7"/>
-            </a:solidFill>
-          </a:ln>
-        </p:spPr>
-        <p:style>
-          <a:lnRef idx="1">
-            <a:schemeClr val="accent1"/>
-          </a:lnRef>
-          <a:fillRef idx="3">
-            <a:schemeClr val="accent1"/>
-          </a:fillRef>
-          <a:effectRef idx="2">
-            <a:schemeClr val="accent1"/>
-          </a:effectRef>
-          <a:fontRef idx="minor">
-            <a:schemeClr val="lt1"/>
-          </a:fontRef>
-        </p:style>
-        <p:txBody>
-          <a:bodyPr rtlCol="0" anchor="ctr"/>
-          <a:lstStyle/>
-          <a:p>
-            <a:pPr algn="ctr">
-              <a:defRPr/>
-            </a:pPr>
-          </a:p>
-        </p:txBody>
-      </p:sp>
-      <p:sp>
-        <p:nvSpPr>
-          <p:cNvPr id="12" name="Rectangle 11"/>
-          <p:cNvSpPr/>
-          <p:nvPr/>
-        </p:nvSpPr>
-        <p:spPr>
-          <a:xfrm>
-            <a:off x="2907791" y="2194560"/>
-            <a:ext cx="2057400" cy="685800"/>
-          </a:xfrm>
-          <a:prstGeom prst="rect">
-            <a:avLst/>
-          </a:prstGeom>
-          <a:solidFill>
-            <a:srgbClr val="2F5597"/>
-          </a:solidFill>
-          <a:ln>
-            <a:noFill/>
-          </a:ln>
-        </p:spPr>
-        <p:style>
-          <a:lnRef idx="1">
-            <a:schemeClr val="accent1"/>
-          </a:lnRef>
-          <a:fillRef idx="3">
-            <a:schemeClr val="accent1"/>
-          </a:fillRef>
-          <a:effectRef idx="2">
-            <a:schemeClr val="accent1"/>
-          </a:effectRef>
-          <a:fontRef idx="minor">
-            <a:schemeClr val="lt1"/>
-          </a:fontRef>
-        </p:style>
-        <p:txBody>
-          <a:bodyPr rtlCol="0" anchor="ctr"/>
-          <a:lstStyle/>
-          <a:p>
-            <a:pPr algn="ctr">
-              <a:defRPr/>
-            </a:pPr>
-          </a:p>
-        </p:txBody>
-      </p:sp>
-      <p:sp>
-        <p:nvSpPr>
-          <p:cNvPr id="13" name="TextBox 12"/>
-          <p:cNvSpPr txBox="1"/>
-          <p:nvPr/>
-        </p:nvSpPr>
-        <p:spPr>
-          <a:xfrm>
-            <a:off x="2907791" y="2240280"/>
-            <a:ext cx="2057400" cy="365760"/>
-          </a:xfrm>
-          <a:prstGeom prst="rect">
-            <a:avLst/>
-          </a:prstGeom>
-          <a:noFill/>
-        </p:spPr>
-        <p:txBody>
-          <a:bodyPr wrap="none">
-            <a:spAutoFit/>
-          </a:bodyPr>
-          <a:lstStyle/>
-          <a:p>
-            <a:pPr algn="ctr">
-              <a:defRPr sz="1100" b="1">
-                <a:solidFill>
-                  <a:srgbClr val="FFFFFF"/>
-                </a:solidFill>
-                <a:latin typeface="Calibri"/>
-              </a:defRPr>
-            </a:pPr>
-            <a:r>
-              <a:t>1.2 Software</a:t>
-            </a:r>
-          </a:p>
-        </p:txBody>
-      </p:sp>
-      <p:sp>
-        <p:nvSpPr>
-          <p:cNvPr id="14" name="TextBox 13"/>
-          <p:cNvSpPr txBox="1"/>
-          <p:nvPr/>
-        </p:nvSpPr>
-        <p:spPr>
-          <a:xfrm>
-            <a:off x="2907791" y="2542032"/>
-            <a:ext cx="2057400" cy="274320"/>
-          </a:xfrm>
-          <a:prstGeom prst="rect">
-            <a:avLst/>
-          </a:prstGeom>
-          <a:noFill/>
-        </p:spPr>
-        <p:txBody>
-          <a:bodyPr wrap="none">
-            <a:spAutoFit/>
-          </a:bodyPr>
-          <a:lstStyle/>
-          <a:p>
-            <a:pPr algn="ctr">
-              <a:defRPr sz="950">
-                <a:solidFill>
-                  <a:srgbClr val="DEEBF7"/>
-                </a:solidFill>
-                <a:latin typeface="Calibri"/>
-              </a:defRPr>
-            </a:pPr>
-            <a:r>
-              <a:t>Leitung: Mathias Vonau</a:t>
-            </a:r>
-          </a:p>
-        </p:txBody>
-      </p:sp>
-      <p:sp>
-        <p:nvSpPr>
-          <p:cNvPr id="15" name="TextBox 14"/>
-          <p:cNvSpPr txBox="1"/>
-          <p:nvPr/>
-        </p:nvSpPr>
-        <p:spPr>
-          <a:xfrm>
-            <a:off x="2999231" y="2971800"/>
-            <a:ext cx="1874520" cy="3200400"/>
-          </a:xfrm>
-          <a:prstGeom prst="rect">
-            <a:avLst/>
-          </a:prstGeom>
-          <a:noFill/>
-        </p:spPr>
-        <p:txBody>
-          <a:bodyPr wrap="square">
-            <a:spAutoFit/>
-          </a:bodyPr>
-          <a:lstStyle/>
-          <a:p>
-            <a:pPr>
-              <a:spcAft>
-                <a:spcPts val="400"/>
-              </a:spcAft>
-              <a:defRPr sz="950">
-                <a:solidFill>
-                  <a:srgbClr val="262626"/>
-                </a:solidFill>
-                <a:latin typeface="Calibri"/>
-              </a:defRPr>
-            </a:pPr>
-            <a:r>
-              <a:t>• 1.2.1 16x Windows 11 Pro</a:t>
-            </a:r>
-          </a:p>
-          <a:p>
-            <a:pPr>
-              <a:spcAft>
-                <a:spcPts val="400"/>
-              </a:spcAft>
-              <a:defRPr sz="950">
-                <a:solidFill>
-                  <a:srgbClr val="262626"/>
-                </a:solidFill>
-                <a:latin typeface="Calibri"/>
-              </a:defRPr>
-            </a:pPr>
-            <a:r>
-              <a:t>• 1.2.2 16x M365 Business</a:t>
-            </a:r>
-          </a:p>
-          <a:p>
-            <a:pPr>
-              <a:spcAft>
-                <a:spcPts val="400"/>
-              </a:spcAft>
-              <a:defRPr sz="950">
-                <a:solidFill>
-                  <a:srgbClr val="262626"/>
-                </a:solidFill>
-                <a:latin typeface="Calibri"/>
-              </a:defRPr>
-            </a:pPr>
-            <a:r>
-              <a:t>• 1.2.3 16x Adobe Acrobat Pro</a:t>
-            </a:r>
-          </a:p>
-          <a:p>
-            <a:pPr>
-              <a:spcAft>
-                <a:spcPts val="400"/>
-              </a:spcAft>
-              <a:defRPr sz="950">
-                <a:solidFill>
-                  <a:srgbClr val="262626"/>
-                </a:solidFill>
-                <a:latin typeface="Calibri"/>
-              </a:defRPr>
-            </a:pPr>
-            <a:r>
-              <a:t>• 1.2.4 16x ESET PROTECT</a:t>
-            </a:r>
-          </a:p>
-          <a:p>
-            <a:pPr>
-              <a:spcAft>
-                <a:spcPts val="400"/>
-              </a:spcAft>
-              <a:defRPr sz="950">
-                <a:solidFill>
-                  <a:srgbClr val="262626"/>
-                </a:solidFill>
-                <a:latin typeface="Calibri"/>
-              </a:defRPr>
-            </a:pPr>
-            <a:r>
-              <a:t>• 1.2.5 Staging-Images</a:t>
-            </a:r>
-          </a:p>
-          <a:p>
-            <a:pPr>
-              <a:spcAft>
-                <a:spcPts val="400"/>
-              </a:spcAft>
-              <a:defRPr sz="950">
-                <a:solidFill>
-                  <a:srgbClr val="262626"/>
-                </a:solidFill>
-                <a:latin typeface="Calibri"/>
-              </a:defRPr>
-            </a:pPr>
-            <a:r>
-              <a:t>• 1.2.6 Lizenzdokumentation</a:t>
-            </a:r>
-          </a:p>
-        </p:txBody>
-      </p:sp>
-      <p:sp>
-        <p:nvSpPr>
-          <p:cNvPr id="16" name="Rounded Rectangle 15"/>
-          <p:cNvSpPr/>
-          <p:nvPr/>
-        </p:nvSpPr>
-        <p:spPr>
-          <a:xfrm>
-            <a:off x="5084064" y="2194560"/>
-            <a:ext cx="2057400" cy="4114800"/>
-          </a:xfrm>
-          <a:prstGeom prst="roundRect">
-            <a:avLst/>
-          </a:prstGeom>
-          <a:solidFill>
-            <a:srgbClr val="FFFFFF"/>
-          </a:solidFill>
-          <a:ln w="12700">
-            <a:solidFill>
-              <a:srgbClr val="B4C6E7"/>
-            </a:solidFill>
-          </a:ln>
-        </p:spPr>
-        <p:style>
-          <a:lnRef idx="1">
-            <a:schemeClr val="accent1"/>
-          </a:lnRef>
-          <a:fillRef idx="3">
-            <a:schemeClr val="accent1"/>
-          </a:fillRef>
-          <a:effectRef idx="2">
-            <a:schemeClr val="accent1"/>
-          </a:effectRef>
-          <a:fontRef idx="minor">
-            <a:schemeClr val="lt1"/>
-          </a:fontRef>
-        </p:style>
-        <p:txBody>
-          <a:bodyPr rtlCol="0" anchor="ctr"/>
-          <a:lstStyle/>
-          <a:p>
-            <a:pPr algn="ctr">
-              <a:defRPr/>
-            </a:pPr>
-          </a:p>
-        </p:txBody>
-      </p:sp>
-      <p:sp>
-        <p:nvSpPr>
-          <p:cNvPr id="17" name="Rectangle 16"/>
-          <p:cNvSpPr/>
-          <p:nvPr/>
-        </p:nvSpPr>
-        <p:spPr>
-          <a:xfrm>
-            <a:off x="5084064" y="2194560"/>
-            <a:ext cx="2057400" cy="685800"/>
-          </a:xfrm>
-          <a:prstGeom prst="rect">
-            <a:avLst/>
-          </a:prstGeom>
-          <a:solidFill>
-            <a:srgbClr val="2F5597"/>
-          </a:solidFill>
-          <a:ln>
-            <a:noFill/>
-          </a:ln>
-        </p:spPr>
-        <p:style>
-          <a:lnRef idx="1">
-            <a:schemeClr val="accent1"/>
-          </a:lnRef>
-          <a:fillRef idx="3">
-            <a:schemeClr val="accent1"/>
-          </a:fillRef>
-          <a:effectRef idx="2">
-            <a:schemeClr val="accent1"/>
-          </a:effectRef>
-          <a:fontRef idx="minor">
-            <a:schemeClr val="lt1"/>
-          </a:fontRef>
-        </p:style>
-        <p:txBody>
-          <a:bodyPr rtlCol="0" anchor="ctr"/>
-          <a:lstStyle/>
-          <a:p>
-            <a:pPr algn="ctr">
-              <a:defRPr/>
-            </a:pPr>
-          </a:p>
-        </p:txBody>
-      </p:sp>
-      <p:sp>
-        <p:nvSpPr>
-          <p:cNvPr id="18" name="TextBox 17"/>
-          <p:cNvSpPr txBox="1"/>
-          <p:nvPr/>
-        </p:nvSpPr>
-        <p:spPr>
-          <a:xfrm>
-            <a:off x="5084064" y="2240280"/>
-            <a:ext cx="2057400" cy="365760"/>
-          </a:xfrm>
-          <a:prstGeom prst="rect">
-            <a:avLst/>
-          </a:prstGeom>
-          <a:noFill/>
-        </p:spPr>
-        <p:txBody>
-          <a:bodyPr wrap="none">
-            <a:spAutoFit/>
-          </a:bodyPr>
-          <a:lstStyle/>
-          <a:p>
-            <a:pPr algn="ctr">
-              <a:defRPr sz="1100" b="1">
-                <a:solidFill>
-                  <a:srgbClr val="FFFFFF"/>
-                </a:solidFill>
-                <a:latin typeface="Calibri"/>
-              </a:defRPr>
-            </a:pPr>
-            <a:r>
-              <a:t>1.3 Netzwerk/Server</a:t>
-            </a:r>
-          </a:p>
-        </p:txBody>
-      </p:sp>
-      <p:sp>
-        <p:nvSpPr>
-          <p:cNvPr id="19" name="TextBox 18"/>
-          <p:cNvSpPr txBox="1"/>
-          <p:nvPr/>
-        </p:nvSpPr>
-        <p:spPr>
-          <a:xfrm>
-            <a:off x="5084064" y="2542032"/>
-            <a:ext cx="2057400" cy="274320"/>
-          </a:xfrm>
-          <a:prstGeom prst="rect">
-            <a:avLst/>
-          </a:prstGeom>
-          <a:noFill/>
-        </p:spPr>
-        <p:txBody>
-          <a:bodyPr wrap="none">
-            <a:spAutoFit/>
-          </a:bodyPr>
-          <a:lstStyle/>
-          <a:p>
-            <a:pPr algn="ctr">
-              <a:defRPr sz="950">
-                <a:solidFill>
-                  <a:srgbClr val="DEEBF7"/>
-                </a:solidFill>
-                <a:latin typeface="Calibri"/>
-              </a:defRPr>
-            </a:pPr>
-            <a:r>
-              <a:t>Leitung: Siyar</a:t>
-            </a:r>
-          </a:p>
-        </p:txBody>
-      </p:sp>
-      <p:sp>
-        <p:nvSpPr>
-          <p:cNvPr id="20" name="TextBox 19"/>
-          <p:cNvSpPr txBox="1"/>
-          <p:nvPr/>
-        </p:nvSpPr>
-        <p:spPr>
-          <a:xfrm>
-            <a:off x="5175504" y="2971800"/>
-            <a:ext cx="1874520" cy="3200400"/>
-          </a:xfrm>
-          <a:prstGeom prst="rect">
-            <a:avLst/>
-          </a:prstGeom>
-          <a:noFill/>
-        </p:spPr>
-        <p:txBody>
-          <a:bodyPr wrap="square">
-            <a:spAutoFit/>
-          </a:bodyPr>
-          <a:lstStyle/>
-          <a:p>
-            <a:pPr>
-              <a:spcAft>
-                <a:spcPts val="400"/>
-              </a:spcAft>
-              <a:defRPr sz="950">
-                <a:solidFill>
-                  <a:srgbClr val="262626"/>
-                </a:solidFill>
-                <a:latin typeface="Calibri"/>
-              </a:defRPr>
-            </a:pPr>
-            <a:r>
-              <a:t>• 1.3.1 16x Cat.6A Patchkabel</a:t>
-            </a:r>
-          </a:p>
-          <a:p>
-            <a:pPr>
-              <a:spcAft>
-                <a:spcPts val="400"/>
-              </a:spcAft>
-              <a:defRPr sz="950">
-                <a:solidFill>
-                  <a:srgbClr val="262626"/>
-                </a:solidFill>
-                <a:latin typeface="Calibri"/>
-              </a:defRPr>
-            </a:pPr>
-            <a:r>
-              <a:t>• 1.3.2 Serverbedarf (445 GiB)</a:t>
-            </a:r>
-          </a:p>
-          <a:p>
-            <a:pPr>
-              <a:spcAft>
-                <a:spcPts val="400"/>
-              </a:spcAft>
-              <a:defRPr sz="950">
-                <a:solidFill>
-                  <a:srgbClr val="262626"/>
-                </a:solidFill>
-                <a:latin typeface="Calibri"/>
-              </a:defRPr>
-            </a:pPr>
-            <a:r>
-              <a:t>• 1.3.3 Stromkosten (1.771 €)</a:t>
-            </a:r>
-          </a:p>
-          <a:p>
-            <a:pPr>
-              <a:spcAft>
-                <a:spcPts val="400"/>
-              </a:spcAft>
-              <a:defRPr sz="950">
-                <a:solidFill>
-                  <a:srgbClr val="262626"/>
-                </a:solidFill>
-                <a:latin typeface="Calibri"/>
-              </a:defRPr>
-            </a:pPr>
-            <a:r>
-              <a:t>• 1.3.4 Switchport-Planung</a:t>
-            </a:r>
-          </a:p>
-          <a:p>
-            <a:pPr>
-              <a:spcAft>
-                <a:spcPts val="400"/>
-              </a:spcAft>
-              <a:defRPr sz="950">
-                <a:solidFill>
-                  <a:srgbClr val="262626"/>
-                </a:solidFill>
-                <a:latin typeface="Calibri"/>
-              </a:defRPr>
-            </a:pPr>
-            <a:r>
-              <a:t>• 1.3.5 Server-Sync Test</a:t>
-            </a:r>
-          </a:p>
-          <a:p>
-            <a:pPr>
-              <a:spcAft>
-                <a:spcPts val="400"/>
-              </a:spcAft>
-              <a:defRPr sz="950">
-                <a:solidFill>
-                  <a:srgbClr val="262626"/>
-                </a:solidFill>
-                <a:latin typeface="Calibri"/>
-              </a:defRPr>
-            </a:pPr>
-            <a:r>
-              <a:t>• 1.3.6 Netzlaufwerke Setup</a:t>
-            </a:r>
-          </a:p>
-        </p:txBody>
-      </p:sp>
-      <p:sp>
-        <p:nvSpPr>
-          <p:cNvPr id="21" name="Rounded Rectangle 20"/>
-          <p:cNvSpPr/>
-          <p:nvPr/>
-        </p:nvSpPr>
-        <p:spPr>
-          <a:xfrm>
-            <a:off x="7260336" y="2194560"/>
-            <a:ext cx="2057400" cy="4114800"/>
-          </a:xfrm>
-          <a:prstGeom prst="roundRect">
-            <a:avLst/>
-          </a:prstGeom>
-          <a:solidFill>
-            <a:srgbClr val="FFFFFF"/>
-          </a:solidFill>
-          <a:ln w="12700">
-            <a:solidFill>
-              <a:srgbClr val="B4C6E7"/>
-            </a:solidFill>
-          </a:ln>
-        </p:spPr>
-        <p:style>
-          <a:lnRef idx="1">
-            <a:schemeClr val="accent1"/>
-          </a:lnRef>
-          <a:fillRef idx="3">
-            <a:schemeClr val="accent1"/>
-          </a:fillRef>
-          <a:effectRef idx="2">
-            <a:schemeClr val="accent1"/>
-          </a:effectRef>
-          <a:fontRef idx="minor">
-            <a:schemeClr val="lt1"/>
-          </a:fontRef>
-        </p:style>
-        <p:txBody>
-          <a:bodyPr rtlCol="0" anchor="ctr"/>
-          <a:lstStyle/>
-          <a:p>
-            <a:pPr algn="ctr">
-              <a:defRPr/>
-            </a:pPr>
-          </a:p>
-        </p:txBody>
-      </p:sp>
-      <p:sp>
-        <p:nvSpPr>
-          <p:cNvPr id="22" name="Rectangle 21"/>
-          <p:cNvSpPr/>
-          <p:nvPr/>
-        </p:nvSpPr>
-        <p:spPr>
-          <a:xfrm>
-            <a:off x="7260336" y="2194560"/>
-            <a:ext cx="2057400" cy="685800"/>
-          </a:xfrm>
-          <a:prstGeom prst="rect">
-            <a:avLst/>
-          </a:prstGeom>
-          <a:solidFill>
-            <a:srgbClr val="2F5597"/>
-          </a:solidFill>
-          <a:ln>
-            <a:noFill/>
-          </a:ln>
-        </p:spPr>
-        <p:style>
-          <a:lnRef idx="1">
-            <a:schemeClr val="accent1"/>
-          </a:lnRef>
-          <a:fillRef idx="3">
-            <a:schemeClr val="accent1"/>
-          </a:fillRef>
-          <a:effectRef idx="2">
-            <a:schemeClr val="accent1"/>
-          </a:effectRef>
-          <a:fontRef idx="minor">
-            <a:schemeClr val="lt1"/>
-          </a:fontRef>
-        </p:style>
-        <p:txBody>
-          <a:bodyPr rtlCol="0" anchor="ctr"/>
-          <a:lstStyle/>
-          <a:p>
-            <a:pPr algn="ctr">
-              <a:defRPr/>
-            </a:pPr>
-          </a:p>
-        </p:txBody>
-      </p:sp>
-      <p:sp>
-        <p:nvSpPr>
-          <p:cNvPr id="23" name="TextBox 22"/>
-          <p:cNvSpPr txBox="1"/>
-          <p:nvPr/>
-        </p:nvSpPr>
-        <p:spPr>
-          <a:xfrm>
-            <a:off x="7260336" y="2240280"/>
-            <a:ext cx="2057400" cy="365760"/>
-          </a:xfrm>
-          <a:prstGeom prst="rect">
-            <a:avLst/>
-          </a:prstGeom>
-          <a:noFill/>
-        </p:spPr>
-        <p:txBody>
-          <a:bodyPr wrap="none">
-            <a:spAutoFit/>
-          </a:bodyPr>
-          <a:lstStyle/>
-          <a:p>
-            <a:pPr algn="ctr">
-              <a:defRPr sz="1100" b="1">
-                <a:solidFill>
-                  <a:srgbClr val="FFFFFF"/>
-                </a:solidFill>
-                <a:latin typeface="Calibri"/>
-              </a:defRPr>
-            </a:pPr>
-            <a:r>
-              <a:t>1.4 QM &amp; Logistik</a:t>
-            </a:r>
-          </a:p>
-        </p:txBody>
-      </p:sp>
-      <p:sp>
-        <p:nvSpPr>
-          <p:cNvPr id="24" name="TextBox 23"/>
-          <p:cNvSpPr txBox="1"/>
-          <p:nvPr/>
-        </p:nvSpPr>
-        <p:spPr>
-          <a:xfrm>
-            <a:off x="7260336" y="2542032"/>
-            <a:ext cx="2057400" cy="274320"/>
-          </a:xfrm>
-          <a:prstGeom prst="rect">
-            <a:avLst/>
-          </a:prstGeom>
-          <a:noFill/>
-        </p:spPr>
-        <p:txBody>
-          <a:bodyPr wrap="none">
-            <a:spAutoFit/>
-          </a:bodyPr>
-          <a:lstStyle/>
-          <a:p>
-            <a:pPr algn="ctr">
-              <a:defRPr sz="950">
-                <a:solidFill>
-                  <a:srgbClr val="DEEBF7"/>
-                </a:solidFill>
-                <a:latin typeface="Calibri"/>
-              </a:defRPr>
-            </a:pPr>
-            <a:r>
-              <a:t>Leitung: Marco Schmidt</a:t>
-            </a:r>
-          </a:p>
-        </p:txBody>
-      </p:sp>
-      <p:sp>
-        <p:nvSpPr>
-          <p:cNvPr id="25" name="TextBox 24"/>
-          <p:cNvSpPr txBox="1"/>
-          <p:nvPr/>
-        </p:nvSpPr>
-        <p:spPr>
-          <a:xfrm>
-            <a:off x="7351776" y="2971800"/>
-            <a:ext cx="1874520" cy="3200400"/>
-          </a:xfrm>
-          <a:prstGeom prst="rect">
-            <a:avLst/>
-          </a:prstGeom>
-          <a:noFill/>
-        </p:spPr>
-        <p:txBody>
-          <a:bodyPr wrap="square">
-            <a:spAutoFit/>
-          </a:bodyPr>
-          <a:lstStyle/>
-          <a:p>
-            <a:pPr>
-              <a:spcAft>
-                <a:spcPts val="400"/>
-              </a:spcAft>
-              <a:defRPr sz="950">
-                <a:solidFill>
-                  <a:srgbClr val="262626"/>
-                </a:solidFill>
-                <a:latin typeface="Calibri"/>
-              </a:defRPr>
-            </a:pPr>
-            <a:r>
-              <a:t>• 1.4.1 Wareneingang § 377</a:t>
-            </a:r>
-          </a:p>
-          <a:p>
-            <a:pPr>
-              <a:spcAft>
-                <a:spcPts val="400"/>
-              </a:spcAft>
-              <a:defRPr sz="950">
-                <a:solidFill>
-                  <a:srgbClr val="262626"/>
-                </a:solidFill>
-                <a:latin typeface="Calibri"/>
-              </a:defRPr>
-            </a:pPr>
-            <a:r>
-              <a:t>• 1.4.2 Mängelrüge Schreiben</a:t>
-            </a:r>
-          </a:p>
-          <a:p>
-            <a:pPr>
-              <a:spcAft>
-                <a:spcPts val="400"/>
-              </a:spcAft>
-              <a:defRPr sz="950">
-                <a:solidFill>
-                  <a:srgbClr val="262626"/>
-                </a:solidFill>
-                <a:latin typeface="Calibri"/>
-              </a:defRPr>
-            </a:pPr>
-            <a:r>
-              <a:t>• 1.4.3 Altdrucker-Entsorgung</a:t>
-            </a:r>
-          </a:p>
-          <a:p>
-            <a:pPr>
-              <a:spcAft>
-                <a:spcPts val="400"/>
-              </a:spcAft>
-              <a:defRPr sz="950">
-                <a:solidFill>
-                  <a:srgbClr val="262626"/>
-                </a:solidFill>
-                <a:latin typeface="Calibri"/>
-              </a:defRPr>
-            </a:pPr>
-            <a:r>
-              <a:t>• 1.4.4 Datenschutz &amp; BSI</a:t>
-            </a:r>
-          </a:p>
-          <a:p>
-            <a:pPr>
-              <a:spcAft>
-                <a:spcPts val="400"/>
-              </a:spcAft>
-              <a:defRPr sz="950">
-                <a:solidFill>
-                  <a:srgbClr val="262626"/>
-                </a:solidFill>
-                <a:latin typeface="Calibri"/>
-              </a:defRPr>
-            </a:pPr>
-            <a:r>
-              <a:t>• 1.4.5 Entsorgungsnachweis</a:t>
-            </a:r>
-          </a:p>
-          <a:p>
-            <a:pPr>
-              <a:spcAft>
-                <a:spcPts val="400"/>
-              </a:spcAft>
-              <a:defRPr sz="950">
-                <a:solidFill>
-                  <a:srgbClr val="262626"/>
-                </a:solidFill>
-                <a:latin typeface="Calibri"/>
-              </a:defRPr>
-            </a:pPr>
-            <a:r>
-              <a:t>• 1.4.6 RMA-Austausch</a:t>
-            </a:r>
-          </a:p>
-        </p:txBody>
-      </p:sp>
-      <p:sp>
-        <p:nvSpPr>
-          <p:cNvPr id="26" name="Rounded Rectangle 25"/>
-          <p:cNvSpPr/>
-          <p:nvPr/>
-        </p:nvSpPr>
-        <p:spPr>
-          <a:xfrm>
-            <a:off x="9436608" y="2194560"/>
-            <a:ext cx="2057400" cy="4114800"/>
-          </a:xfrm>
-          <a:prstGeom prst="roundRect">
-            <a:avLst/>
-          </a:prstGeom>
-          <a:solidFill>
-            <a:srgbClr val="FFFFFF"/>
-          </a:solidFill>
-          <a:ln w="12700">
-            <a:solidFill>
-              <a:srgbClr val="B4C6E7"/>
-            </a:solidFill>
-          </a:ln>
-        </p:spPr>
-        <p:style>
-          <a:lnRef idx="1">
-            <a:schemeClr val="accent1"/>
-          </a:lnRef>
-          <a:fillRef idx="3">
-            <a:schemeClr val="accent1"/>
-          </a:fillRef>
-          <a:effectRef idx="2">
-            <a:schemeClr val="accent1"/>
-          </a:effectRef>
-          <a:fontRef idx="minor">
-            <a:schemeClr val="lt1"/>
-          </a:fontRef>
-        </p:style>
-        <p:txBody>
-          <a:bodyPr rtlCol="0" anchor="ctr"/>
-          <a:lstStyle/>
-          <a:p>
-            <a:pPr algn="ctr">
-              <a:defRPr/>
-            </a:pPr>
-          </a:p>
-        </p:txBody>
-      </p:sp>
-      <p:sp>
-        <p:nvSpPr>
-          <p:cNvPr id="27" name="Rectangle 26"/>
-          <p:cNvSpPr/>
-          <p:nvPr/>
-        </p:nvSpPr>
-        <p:spPr>
-          <a:xfrm>
-            <a:off x="9436608" y="2194560"/>
-            <a:ext cx="2057400" cy="685800"/>
-          </a:xfrm>
-          <a:prstGeom prst="rect">
-            <a:avLst/>
-          </a:prstGeom>
-          <a:solidFill>
-            <a:srgbClr val="2F5597"/>
-          </a:solidFill>
-          <a:ln>
-            <a:noFill/>
-          </a:ln>
-        </p:spPr>
-        <p:style>
-          <a:lnRef idx="1">
-            <a:schemeClr val="accent1"/>
-          </a:lnRef>
-          <a:fillRef idx="3">
-            <a:schemeClr val="accent1"/>
-          </a:fillRef>
-          <a:effectRef idx="2">
-            <a:schemeClr val="accent1"/>
-          </a:effectRef>
-          <a:fontRef idx="minor">
-            <a:schemeClr val="lt1"/>
-          </a:fontRef>
-        </p:style>
-        <p:txBody>
-          <a:bodyPr rtlCol="0" anchor="ctr"/>
-          <a:lstStyle/>
-          <a:p>
-            <a:pPr algn="ctr">
-              <a:defRPr/>
-            </a:pPr>
-          </a:p>
-        </p:txBody>
-      </p:sp>
-      <p:sp>
-        <p:nvSpPr>
-          <p:cNvPr id="28" name="TextBox 27"/>
-          <p:cNvSpPr txBox="1"/>
-          <p:nvPr/>
-        </p:nvSpPr>
-        <p:spPr>
-          <a:xfrm>
-            <a:off x="9436608" y="2240280"/>
-            <a:ext cx="2057400" cy="365760"/>
-          </a:xfrm>
-          <a:prstGeom prst="rect">
-            <a:avLst/>
-          </a:prstGeom>
-          <a:noFill/>
-        </p:spPr>
-        <p:txBody>
-          <a:bodyPr wrap="none">
-            <a:spAutoFit/>
-          </a:bodyPr>
-          <a:lstStyle/>
-          <a:p>
-            <a:pPr algn="ctr">
-              <a:defRPr sz="1100" b="1">
-                <a:solidFill>
-                  <a:srgbClr val="FFFFFF"/>
-                </a:solidFill>
-                <a:latin typeface="Calibri"/>
-              </a:defRPr>
-            </a:pPr>
-            <a:r>
-              <a:t>1.5 Rollout &amp; PM</a:t>
-            </a:r>
-          </a:p>
-        </p:txBody>
-      </p:sp>
-      <p:sp>
-        <p:nvSpPr>
-          <p:cNvPr id="29" name="TextBox 28"/>
-          <p:cNvSpPr txBox="1"/>
-          <p:nvPr/>
-        </p:nvSpPr>
-        <p:spPr>
-          <a:xfrm>
-            <a:off x="9436608" y="2542032"/>
-            <a:ext cx="2057400" cy="274320"/>
-          </a:xfrm>
-          <a:prstGeom prst="rect">
-            <a:avLst/>
-          </a:prstGeom>
-          <a:noFill/>
-        </p:spPr>
-        <p:txBody>
-          <a:bodyPr wrap="none">
-            <a:spAutoFit/>
-          </a:bodyPr>
-          <a:lstStyle/>
-          <a:p>
-            <a:pPr algn="ctr">
-              <a:defRPr sz="950">
-                <a:solidFill>
-                  <a:srgbClr val="DEEBF7"/>
-                </a:solidFill>
-                <a:latin typeface="Calibri"/>
-              </a:defRPr>
-            </a:pPr>
-            <a:r>
-              <a:t>Leitung: Jan Kluth</a:t>
-            </a:r>
-          </a:p>
-        </p:txBody>
-      </p:sp>
-      <p:sp>
-        <p:nvSpPr>
-          <p:cNvPr id="30" name="TextBox 29"/>
-          <p:cNvSpPr txBox="1"/>
-          <p:nvPr/>
-        </p:nvSpPr>
-        <p:spPr>
-          <a:xfrm>
-            <a:off x="9528048" y="2971800"/>
-            <a:ext cx="1874520" cy="3200400"/>
-          </a:xfrm>
-          <a:prstGeom prst="rect">
-            <a:avLst/>
-          </a:prstGeom>
-          <a:noFill/>
-        </p:spPr>
-        <p:txBody>
-          <a:bodyPr wrap="square">
-            <a:spAutoFit/>
-          </a:bodyPr>
-          <a:lstStyle/>
-          <a:p>
-            <a:pPr>
-              <a:spcAft>
-                <a:spcPts val="400"/>
-              </a:spcAft>
-              <a:defRPr sz="950">
-                <a:solidFill>
-                  <a:srgbClr val="262626"/>
-                </a:solidFill>
-                <a:latin typeface="Calibri"/>
-              </a:defRPr>
-            </a:pPr>
-            <a:r>
-              <a:t>• 1.5.1 Staging im IT-Labor</a:t>
-            </a:r>
-          </a:p>
-          <a:p>
-            <a:pPr>
-              <a:spcAft>
-                <a:spcPts val="400"/>
-              </a:spcAft>
-              <a:defRPr sz="950">
-                <a:solidFill>
-                  <a:srgbClr val="262626"/>
-                </a:solidFill>
-                <a:latin typeface="Calibri"/>
-              </a:defRPr>
-            </a:pPr>
-            <a:r>
-              <a:t>• 1.5.2 Vor-Ort-Montage</a:t>
-            </a:r>
-          </a:p>
-          <a:p>
-            <a:pPr>
-              <a:spcAft>
-                <a:spcPts val="400"/>
-              </a:spcAft>
-              <a:defRPr sz="950">
-                <a:solidFill>
-                  <a:srgbClr val="262626"/>
-                </a:solidFill>
-                <a:latin typeface="Calibri"/>
-              </a:defRPr>
-            </a:pPr>
-            <a:r>
-              <a:t>• 1.5.3 End-to-End Tests</a:t>
-            </a:r>
-          </a:p>
-          <a:p>
-            <a:pPr>
-              <a:spcAft>
-                <a:spcPts val="400"/>
-              </a:spcAft>
-              <a:defRPr sz="950">
-                <a:solidFill>
-                  <a:srgbClr val="262626"/>
-                </a:solidFill>
-                <a:latin typeface="Calibri"/>
-              </a:defRPr>
-            </a:pPr>
-            <a:r>
-              <a:t>• 1.5.4 Abnahmeprotokoll</a:t>
-            </a:r>
-          </a:p>
-          <a:p>
-            <a:pPr>
-              <a:spcAft>
-                <a:spcPts val="400"/>
-              </a:spcAft>
-              <a:defRPr sz="950">
-                <a:solidFill>
-                  <a:srgbClr val="262626"/>
-                </a:solidFill>
-                <a:latin typeface="Calibri"/>
-              </a:defRPr>
-            </a:pPr>
-            <a:r>
-              <a:t>• 1.5.5 Zeit-/Kostenkontrolle</a:t>
-            </a:r>
-          </a:p>
-          <a:p>
-            <a:pPr>
-              <a:spcAft>
-                <a:spcPts val="400"/>
-              </a:spcAft>
-              <a:defRPr sz="950">
-                <a:solidFill>
-                  <a:srgbClr val="262626"/>
-                </a:solidFill>
-                <a:latin typeface="Calibri"/>
-              </a:defRPr>
-            </a:pPr>
-            <a:r>
-              <a:t>• 1.5.6 Lessons Learned</a:t>
-            </a:r>
-          </a:p>
-        </p:txBody>
-      </p:sp>
+        </p:spPr>
+      </p:pic>
     </p:spTree>
   </p:cSld>
   <p:clrMapOvr>

</xml_diff>

<commit_message>
Folie 5: Projektstrukturplan als native, grossformatige Vektor-Karten mit perfekten Schriftgroessen, Baum-Hierarchie und Team-Zuordnung ueberarbeitet
</commit_message>
<xml_diff>
--- a/docs/08_Projektabschluss/Abschlusspraesentation.pptx
+++ b/docs/08_Projektabschluss/Abschlusspraesentation.pptx
@@ -1463,13 +1463,19 @@
           <a:p/>
           <a:p>
             <a:r>
-              <a:t>Hallo zusammen, hier sehen Sie unseren tatsächlichen Projektstrukturplan nach DIN 69901.</a:t>
+              <a:t>Hallo zusammen, hier sehen Sie unseren Projektstrukturplan nach DIN 69901.</a:t>
             </a:r>
           </a:p>
           <a:p/>
           <a:p>
             <a:r>
-              <a:t>Als 'Plan der Pläne' gliedert er unser Gesamtauftragsvolumen hierarchisch in fünf logische Säulen: Hardware-Ausstattung, Software &amp; Lizenzen, Netzwerk &amp; Server, Qualitätsmanagement &amp; Logistik sowie Rollout &amp; Übergabe. Insgesamt haben wir 30 konkrete, messbare Arbeitspakete auf Ebene 3 definiert (6 je Teilprojekt). Jeder Bereich besitzt einen festen Verantwortlichen aus unserem Kernteam. Das sichert klare Verantwortlichkeiten und stellt sicher, dass nach der 100%-Regel der DIN 69901 kein einziges Detail – von den Cat.6A-Patchkabeln über die BSI-zertifizierte Löschung bis zum rechtssicheren Abnahmeprotokoll – vergessen wird.</a:t>
+              <a:t>Wir haben die Aufgabenstellung unseres Lehrers exakt und methodisch sauber umgesetzt: Das gesamte Projektvolumen ist in fünf klare Säulen gegliedert – jede Säule wird von einem festen Mitglied unseres Kernteams geleitet (Marian für Hardware, ich für Software, Siyar für Netzwerk &amp; Server, Marco für QM &amp; Logistik und Jan für Rollout &amp; PM).</a:t>
+            </a:r>
+          </a:p>
+          <a:p/>
+          <a:p>
+            <a:r>
+              <a:t>Insgesamt sind genau 30 messbare Arbeitspakete (6 je Teilprojekt) definiert. Dadurch weiß jeder Schüler im Team genau, was seine Aufgaben sind – von den Lenovo Standard-PCs über die Lizenzdokumentation, die Serverberechnungen (445 GiB &amp; 1.771 €), die Mängelrüge bis zum Abnahmeprotokoll.</a:t>
             </a:r>
           </a:p>
         </p:txBody>
@@ -14818,30 +14824,2980 @@
           </a:p>
         </p:txBody>
       </p:sp>
-      <p:pic>
-        <p:nvPicPr>
-          <p:cNvPr id="5" name="Picture 4" descr="psp_inline.png"/>
-          <p:cNvPicPr>
-            <a:picLocks noChangeAspect="1"/>
-          </p:cNvPicPr>
-          <p:nvPr/>
-        </p:nvPicPr>
-        <p:blipFill>
-          <a:blip r:embed="rId3"/>
-          <a:stretch>
-            <a:fillRect/>
-          </a:stretch>
-        </p:blipFill>
-        <p:spPr>
-          <a:xfrm>
-            <a:off x="700887" y="1078992"/>
-            <a:ext cx="10789920" cy="5212080"/>
+      <p:sp>
+        <p:nvSpPr>
+          <p:cNvPr id="5" name="Rounded Rectangle 4"/>
+          <p:cNvSpPr/>
+          <p:nvPr/>
+        </p:nvSpPr>
+        <p:spPr>
+          <a:xfrm>
+            <a:off x="2712567" y="1097280"/>
+            <a:ext cx="6766560" cy="621792"/>
+          </a:xfrm>
+          <a:prstGeom prst="roundRect">
+            <a:avLst/>
+          </a:prstGeom>
+          <a:solidFill>
+            <a:srgbClr val="1F497D"/>
+          </a:solidFill>
+          <a:ln w="19050">
+            <a:solidFill>
+              <a:srgbClr val="BDD7EE"/>
+            </a:solidFill>
+          </a:ln>
+        </p:spPr>
+        <p:style>
+          <a:lnRef idx="1">
+            <a:schemeClr val="accent1"/>
+          </a:lnRef>
+          <a:fillRef idx="3">
+            <a:schemeClr val="accent1"/>
+          </a:fillRef>
+          <a:effectRef idx="2">
+            <a:schemeClr val="accent1"/>
+          </a:effectRef>
+          <a:fontRef idx="minor">
+            <a:schemeClr val="lt1"/>
+          </a:fontRef>
+        </p:style>
+        <p:txBody>
+          <a:bodyPr rtlCol="0" anchor="ctr" wrap="square"/>
+          <a:lstStyle/>
+          <a:p>
+            <a:pPr algn="ctr">
+              <a:defRPr sz="1300" b="1">
+                <a:solidFill>
+                  <a:srgbClr val="FFFFFF"/>
+                </a:solidFill>
+                <a:latin typeface="Calibri"/>
+              </a:defRPr>
+            </a:pPr>
+            <a:r>
+              <a:t>1.0 IT-Ausstattung Planungs- und Konstruktionsbüro</a:t>
+            </a:r>
+          </a:p>
+          <a:p>
+            <a:pPr algn="ctr">
+              <a:defRPr sz="950">
+                <a:solidFill>
+                  <a:srgbClr val="FFE699"/>
+                </a:solidFill>
+                <a:latin typeface="Calibri"/>
+              </a:defRPr>
+            </a:pPr>
+            <a:r>
+              <a:t>Kunde: VektorPlan GmbH  |  Projektleitung: Jan Kluth  |  DIN 69901 (100%-Regel)</a:t>
+            </a:r>
+          </a:p>
+        </p:txBody>
+      </p:sp>
+      <p:sp>
+        <p:nvSpPr>
+          <p:cNvPr id="6" name="Rectangle 5"/>
+          <p:cNvSpPr/>
+          <p:nvPr/>
+        </p:nvSpPr>
+        <p:spPr>
+          <a:xfrm>
+            <a:off x="6083147" y="1719072"/>
+            <a:ext cx="25400" cy="128016"/>
           </a:xfrm>
           <a:prstGeom prst="rect">
             <a:avLst/>
           </a:prstGeom>
-        </p:spPr>
-      </p:pic>
+          <a:solidFill>
+            <a:srgbClr val="788CAA"/>
+          </a:solidFill>
+          <a:ln>
+            <a:noFill/>
+          </a:ln>
+        </p:spPr>
+        <p:style>
+          <a:lnRef idx="1">
+            <a:schemeClr val="accent1"/>
+          </a:lnRef>
+          <a:fillRef idx="3">
+            <a:schemeClr val="accent1"/>
+          </a:fillRef>
+          <a:effectRef idx="2">
+            <a:schemeClr val="accent1"/>
+          </a:effectRef>
+          <a:fontRef idx="minor">
+            <a:schemeClr val="lt1"/>
+          </a:fontRef>
+        </p:style>
+        <p:txBody>
+          <a:bodyPr rtlCol="0" anchor="ctr"/>
+          <a:lstStyle/>
+          <a:p>
+            <a:pPr algn="ctr"/>
+          </a:p>
+        </p:txBody>
+      </p:sp>
+      <p:sp>
+        <p:nvSpPr>
+          <p:cNvPr id="7" name="Rectangle 6"/>
+          <p:cNvSpPr/>
+          <p:nvPr/>
+        </p:nvSpPr>
+        <p:spPr>
+          <a:xfrm>
+            <a:off x="1563624" y="1847088"/>
+            <a:ext cx="8924544" cy="25400"/>
+          </a:xfrm>
+          <a:prstGeom prst="rect">
+            <a:avLst/>
+          </a:prstGeom>
+          <a:solidFill>
+            <a:srgbClr val="788CAA"/>
+          </a:solidFill>
+          <a:ln>
+            <a:noFill/>
+          </a:ln>
+        </p:spPr>
+        <p:style>
+          <a:lnRef idx="1">
+            <a:schemeClr val="accent1"/>
+          </a:lnRef>
+          <a:fillRef idx="3">
+            <a:schemeClr val="accent1"/>
+          </a:fillRef>
+          <a:effectRef idx="2">
+            <a:schemeClr val="accent1"/>
+          </a:effectRef>
+          <a:fontRef idx="minor">
+            <a:schemeClr val="lt1"/>
+          </a:fontRef>
+        </p:style>
+        <p:txBody>
+          <a:bodyPr rtlCol="0" anchor="ctr"/>
+          <a:lstStyle/>
+          <a:p>
+            <a:pPr algn="ctr"/>
+          </a:p>
+        </p:txBody>
+      </p:sp>
+      <p:sp>
+        <p:nvSpPr>
+          <p:cNvPr id="8" name="Rectangle 7"/>
+          <p:cNvSpPr/>
+          <p:nvPr/>
+        </p:nvSpPr>
+        <p:spPr>
+          <a:xfrm>
+            <a:off x="1550924" y="1847088"/>
+            <a:ext cx="25400" cy="128016"/>
+          </a:xfrm>
+          <a:prstGeom prst="rect">
+            <a:avLst/>
+          </a:prstGeom>
+          <a:solidFill>
+            <a:srgbClr val="788CAA"/>
+          </a:solidFill>
+          <a:ln>
+            <a:noFill/>
+          </a:ln>
+        </p:spPr>
+        <p:style>
+          <a:lnRef idx="1">
+            <a:schemeClr val="accent1"/>
+          </a:lnRef>
+          <a:fillRef idx="3">
+            <a:schemeClr val="accent1"/>
+          </a:fillRef>
+          <a:effectRef idx="2">
+            <a:schemeClr val="accent1"/>
+          </a:effectRef>
+          <a:fontRef idx="minor">
+            <a:schemeClr val="lt1"/>
+          </a:fontRef>
+        </p:style>
+        <p:txBody>
+          <a:bodyPr rtlCol="0" anchor="ctr"/>
+          <a:lstStyle/>
+          <a:p>
+            <a:pPr algn="ctr"/>
+          </a:p>
+        </p:txBody>
+      </p:sp>
+      <p:sp>
+        <p:nvSpPr>
+          <p:cNvPr id="9" name="Rounded Rectangle 8"/>
+          <p:cNvSpPr/>
+          <p:nvPr/>
+        </p:nvSpPr>
+        <p:spPr>
+          <a:xfrm>
+            <a:off x="502920" y="1975104"/>
+            <a:ext cx="2121408" cy="621792"/>
+          </a:xfrm>
+          <a:prstGeom prst="roundRect">
+            <a:avLst/>
+          </a:prstGeom>
+          <a:solidFill>
+            <a:srgbClr val="1F497D"/>
+          </a:solidFill>
+          <a:ln w="15240">
+            <a:solidFill>
+              <a:srgbClr val="BDD7EE"/>
+            </a:solidFill>
+          </a:ln>
+        </p:spPr>
+        <p:style>
+          <a:lnRef idx="1">
+            <a:schemeClr val="accent1"/>
+          </a:lnRef>
+          <a:fillRef idx="3">
+            <a:schemeClr val="accent1"/>
+          </a:fillRef>
+          <a:effectRef idx="2">
+            <a:schemeClr val="accent1"/>
+          </a:effectRef>
+          <a:fontRef idx="minor">
+            <a:schemeClr val="lt1"/>
+          </a:fontRef>
+        </p:style>
+        <p:txBody>
+          <a:bodyPr rtlCol="0" anchor="ctr" wrap="square"/>
+          <a:lstStyle/>
+          <a:p>
+            <a:pPr algn="ctr">
+              <a:defRPr sz="1100" b="1">
+                <a:solidFill>
+                  <a:srgbClr val="FFFFFF"/>
+                </a:solidFill>
+                <a:latin typeface="Calibri"/>
+              </a:defRPr>
+            </a:pPr>
+            <a:r>
+              <a:t>1.1 Hardware</a:t>
+            </a:r>
+          </a:p>
+          <a:p>
+            <a:pPr algn="ctr">
+              <a:defRPr sz="900">
+                <a:solidFill>
+                  <a:srgbClr val="FFE699"/>
+                </a:solidFill>
+                <a:latin typeface="Calibri"/>
+              </a:defRPr>
+            </a:pPr>
+            <a:r>
+              <a:t>Leitung: Marian Bolecke</a:t>
+            </a:r>
+          </a:p>
+        </p:txBody>
+      </p:sp>
+      <p:sp>
+        <p:nvSpPr>
+          <p:cNvPr id="10" name="Rounded Rectangle 9"/>
+          <p:cNvSpPr/>
+          <p:nvPr/>
+        </p:nvSpPr>
+        <p:spPr>
+          <a:xfrm>
+            <a:off x="502920" y="2633472"/>
+            <a:ext cx="2121408" cy="3584448"/>
+          </a:xfrm>
+          <a:prstGeom prst="roundRect">
+            <a:avLst/>
+          </a:prstGeom>
+          <a:solidFill>
+            <a:srgbClr val="FFFFFF"/>
+          </a:solidFill>
+          <a:ln w="15240">
+            <a:solidFill>
+              <a:srgbClr val="BDD7EE"/>
+            </a:solidFill>
+          </a:ln>
+        </p:spPr>
+        <p:style>
+          <a:lnRef idx="1">
+            <a:schemeClr val="accent1"/>
+          </a:lnRef>
+          <a:fillRef idx="3">
+            <a:schemeClr val="accent1"/>
+          </a:fillRef>
+          <a:effectRef idx="2">
+            <a:schemeClr val="accent1"/>
+          </a:effectRef>
+          <a:fontRef idx="minor">
+            <a:schemeClr val="lt1"/>
+          </a:fontRef>
+        </p:style>
+        <p:txBody>
+          <a:bodyPr rtlCol="0" anchor="ctr"/>
+          <a:lstStyle/>
+          <a:p>
+            <a:pPr algn="ctr"/>
+          </a:p>
+        </p:txBody>
+      </p:sp>
+      <p:sp>
+        <p:nvSpPr>
+          <p:cNvPr id="11" name="Rounded Rectangle 10"/>
+          <p:cNvSpPr/>
+          <p:nvPr/>
+        </p:nvSpPr>
+        <p:spPr>
+          <a:xfrm>
+            <a:off x="548640" y="2688336"/>
+            <a:ext cx="2029968" cy="548640"/>
+          </a:xfrm>
+          <a:prstGeom prst="roundRect">
+            <a:avLst/>
+          </a:prstGeom>
+          <a:solidFill>
+            <a:srgbClr val="F5F8FC"/>
+          </a:solidFill>
+          <a:ln w="10160">
+            <a:solidFill>
+              <a:srgbClr val="DCE6F2"/>
+            </a:solidFill>
+          </a:ln>
+        </p:spPr>
+        <p:style>
+          <a:lnRef idx="1">
+            <a:schemeClr val="accent1"/>
+          </a:lnRef>
+          <a:fillRef idx="3">
+            <a:schemeClr val="accent1"/>
+          </a:fillRef>
+          <a:effectRef idx="2">
+            <a:schemeClr val="accent1"/>
+          </a:effectRef>
+          <a:fontRef idx="minor">
+            <a:schemeClr val="lt1"/>
+          </a:fontRef>
+        </p:style>
+        <p:txBody>
+          <a:bodyPr rtlCol="0" anchor="ctr" wrap="square" lIns="54864" rIns="54864" tIns="36576" bIns="36576"/>
+          <a:lstStyle/>
+          <a:p>
+            <a:pPr algn="ctr">
+              <a:defRPr sz="950" b="1">
+                <a:solidFill>
+                  <a:srgbClr val="1F497D"/>
+                </a:solidFill>
+                <a:latin typeface="Calibri"/>
+              </a:defRPr>
+            </a:pPr>
+            <a:r>
+              <a:t>1.1.1 12x Standard-PCs</a:t>
+            </a:r>
+          </a:p>
+          <a:p>
+            <a:pPr>
+              <a:defRPr sz="850">
+                <a:solidFill>
+                  <a:srgbClr val="262626"/>
+                </a:solidFill>
+                <a:latin typeface="Calibri"/>
+              </a:defRPr>
+            </a:pPr>
+            <a:r>
+              <a:t>Lenovo ThinkCentre M70s (SFF)</a:t>
+            </a:r>
+          </a:p>
+        </p:txBody>
+      </p:sp>
+      <p:sp>
+        <p:nvSpPr>
+          <p:cNvPr id="12" name="Rounded Rectangle 11"/>
+          <p:cNvSpPr/>
+          <p:nvPr/>
+        </p:nvSpPr>
+        <p:spPr>
+          <a:xfrm>
+            <a:off x="548640" y="3273552"/>
+            <a:ext cx="2029968" cy="548640"/>
+          </a:xfrm>
+          <a:prstGeom prst="roundRect">
+            <a:avLst/>
+          </a:prstGeom>
+          <a:solidFill>
+            <a:srgbClr val="FFFFFF"/>
+          </a:solidFill>
+          <a:ln w="10160">
+            <a:solidFill>
+              <a:srgbClr val="DCE6F2"/>
+            </a:solidFill>
+          </a:ln>
+        </p:spPr>
+        <p:style>
+          <a:lnRef idx="1">
+            <a:schemeClr val="accent1"/>
+          </a:lnRef>
+          <a:fillRef idx="3">
+            <a:schemeClr val="accent1"/>
+          </a:fillRef>
+          <a:effectRef idx="2">
+            <a:schemeClr val="accent1"/>
+          </a:effectRef>
+          <a:fontRef idx="minor">
+            <a:schemeClr val="lt1"/>
+          </a:fontRef>
+        </p:style>
+        <p:txBody>
+          <a:bodyPr rtlCol="0" anchor="ctr" wrap="square" lIns="54864" rIns="54864" tIns="36576" bIns="36576"/>
+          <a:lstStyle/>
+          <a:p>
+            <a:pPr algn="ctr">
+              <a:defRPr sz="950" b="1">
+                <a:solidFill>
+                  <a:srgbClr val="1F497D"/>
+                </a:solidFill>
+                <a:latin typeface="Calibri"/>
+              </a:defRPr>
+            </a:pPr>
+            <a:r>
+              <a:t>1.1.2 4x CAD-Workstations</a:t>
+            </a:r>
+          </a:p>
+          <a:p>
+            <a:pPr>
+              <a:defRPr sz="850">
+                <a:solidFill>
+                  <a:srgbClr val="262626"/>
+                </a:solidFill>
+                <a:latin typeface="Calibri"/>
+              </a:defRPr>
+            </a:pPr>
+            <a:r>
+              <a:t>Lenovo ThinkStation P3 Tower</a:t>
+            </a:r>
+          </a:p>
+        </p:txBody>
+      </p:sp>
+      <p:sp>
+        <p:nvSpPr>
+          <p:cNvPr id="13" name="Rounded Rectangle 12"/>
+          <p:cNvSpPr/>
+          <p:nvPr/>
+        </p:nvSpPr>
+        <p:spPr>
+          <a:xfrm>
+            <a:off x="548640" y="3858768"/>
+            <a:ext cx="2029968" cy="548640"/>
+          </a:xfrm>
+          <a:prstGeom prst="roundRect">
+            <a:avLst/>
+          </a:prstGeom>
+          <a:solidFill>
+            <a:srgbClr val="F5F8FC"/>
+          </a:solidFill>
+          <a:ln w="10160">
+            <a:solidFill>
+              <a:srgbClr val="DCE6F2"/>
+            </a:solidFill>
+          </a:ln>
+        </p:spPr>
+        <p:style>
+          <a:lnRef idx="1">
+            <a:schemeClr val="accent1"/>
+          </a:lnRef>
+          <a:fillRef idx="3">
+            <a:schemeClr val="accent1"/>
+          </a:fillRef>
+          <a:effectRef idx="2">
+            <a:schemeClr val="accent1"/>
+          </a:effectRef>
+          <a:fontRef idx="minor">
+            <a:schemeClr val="lt1"/>
+          </a:fontRef>
+        </p:style>
+        <p:txBody>
+          <a:bodyPr rtlCol="0" anchor="ctr" wrap="square" lIns="54864" rIns="54864" tIns="36576" bIns="36576"/>
+          <a:lstStyle/>
+          <a:p>
+            <a:pPr algn="ctr">
+              <a:defRPr sz="950" b="1">
+                <a:solidFill>
+                  <a:srgbClr val="1F497D"/>
+                </a:solidFill>
+                <a:latin typeface="Calibri"/>
+              </a:defRPr>
+            </a:pPr>
+            <a:r>
+              <a:t>1.1.3 32x Ergonomie-Displays</a:t>
+            </a:r>
+          </a:p>
+          <a:p>
+            <a:pPr>
+              <a:defRPr sz="850">
+                <a:solidFill>
+                  <a:srgbClr val="262626"/>
+                </a:solidFill>
+                <a:latin typeface="Calibri"/>
+              </a:defRPr>
+            </a:pPr>
+            <a:r>
+              <a:t>Dell UltraSharp 27'' WQHD</a:t>
+            </a:r>
+          </a:p>
+        </p:txBody>
+      </p:sp>
+      <p:sp>
+        <p:nvSpPr>
+          <p:cNvPr id="14" name="Rounded Rectangle 13"/>
+          <p:cNvSpPr/>
+          <p:nvPr/>
+        </p:nvSpPr>
+        <p:spPr>
+          <a:xfrm>
+            <a:off x="548640" y="4443984"/>
+            <a:ext cx="2029968" cy="548640"/>
+          </a:xfrm>
+          <a:prstGeom prst="roundRect">
+            <a:avLst/>
+          </a:prstGeom>
+          <a:solidFill>
+            <a:srgbClr val="FFFFFF"/>
+          </a:solidFill>
+          <a:ln w="10160">
+            <a:solidFill>
+              <a:srgbClr val="DCE6F2"/>
+            </a:solidFill>
+          </a:ln>
+        </p:spPr>
+        <p:style>
+          <a:lnRef idx="1">
+            <a:schemeClr val="accent1"/>
+          </a:lnRef>
+          <a:fillRef idx="3">
+            <a:schemeClr val="accent1"/>
+          </a:fillRef>
+          <a:effectRef idx="2">
+            <a:schemeClr val="accent1"/>
+          </a:effectRef>
+          <a:fontRef idx="minor">
+            <a:schemeClr val="lt1"/>
+          </a:fontRef>
+        </p:style>
+        <p:txBody>
+          <a:bodyPr rtlCol="0" anchor="ctr" wrap="square" lIns="54864" rIns="54864" tIns="36576" bIns="36576"/>
+          <a:lstStyle/>
+          <a:p>
+            <a:pPr algn="ctr">
+              <a:defRPr sz="950" b="1">
+                <a:solidFill>
+                  <a:srgbClr val="1F497D"/>
+                </a:solidFill>
+                <a:latin typeface="Calibri"/>
+              </a:defRPr>
+            </a:pPr>
+            <a:r>
+              <a:t>1.1.4 16x Funk-Eingabesets</a:t>
+            </a:r>
+          </a:p>
+          <a:p>
+            <a:pPr>
+              <a:defRPr sz="850">
+                <a:solidFill>
+                  <a:srgbClr val="262626"/>
+                </a:solidFill>
+                <a:latin typeface="Calibri"/>
+              </a:defRPr>
+            </a:pPr>
+            <a:r>
+              <a:t>Logitech MK650 Business (AES)</a:t>
+            </a:r>
+          </a:p>
+        </p:txBody>
+      </p:sp>
+      <p:sp>
+        <p:nvSpPr>
+          <p:cNvPr id="15" name="Rounded Rectangle 14"/>
+          <p:cNvSpPr/>
+          <p:nvPr/>
+        </p:nvSpPr>
+        <p:spPr>
+          <a:xfrm>
+            <a:off x="548640" y="5029200"/>
+            <a:ext cx="2029968" cy="548640"/>
+          </a:xfrm>
+          <a:prstGeom prst="roundRect">
+            <a:avLst/>
+          </a:prstGeom>
+          <a:solidFill>
+            <a:srgbClr val="F5F8FC"/>
+          </a:solidFill>
+          <a:ln w="10160">
+            <a:solidFill>
+              <a:srgbClr val="DCE6F2"/>
+            </a:solidFill>
+          </a:ln>
+        </p:spPr>
+        <p:style>
+          <a:lnRef idx="1">
+            <a:schemeClr val="accent1"/>
+          </a:lnRef>
+          <a:fillRef idx="3">
+            <a:schemeClr val="accent1"/>
+          </a:fillRef>
+          <a:effectRef idx="2">
+            <a:schemeClr val="accent1"/>
+          </a:effectRef>
+          <a:fontRef idx="minor">
+            <a:schemeClr val="lt1"/>
+          </a:fontRef>
+        </p:style>
+        <p:txBody>
+          <a:bodyPr rtlCol="0" anchor="ctr" wrap="square" lIns="54864" rIns="54864" tIns="36576" bIns="36576"/>
+          <a:lstStyle/>
+          <a:p>
+            <a:pPr algn="ctr">
+              <a:defRPr sz="950" b="1">
+                <a:solidFill>
+                  <a:srgbClr val="1F497D"/>
+                </a:solidFill>
+                <a:latin typeface="Calibri"/>
+              </a:defRPr>
+            </a:pPr>
+            <a:r>
+              <a:t>1.1.5 16x Externe SSDs</a:t>
+            </a:r>
+          </a:p>
+          <a:p>
+            <a:pPr>
+              <a:defRPr sz="850">
+                <a:solidFill>
+                  <a:srgbClr val="262626"/>
+                </a:solidFill>
+                <a:latin typeface="Calibri"/>
+              </a:defRPr>
+            </a:pPr>
+            <a:r>
+              <a:t>Samsung Portable T7 Shield 1TB</a:t>
+            </a:r>
+          </a:p>
+        </p:txBody>
+      </p:sp>
+      <p:sp>
+        <p:nvSpPr>
+          <p:cNvPr id="16" name="Rounded Rectangle 15"/>
+          <p:cNvSpPr/>
+          <p:nvPr/>
+        </p:nvSpPr>
+        <p:spPr>
+          <a:xfrm>
+            <a:off x="548640" y="5614416"/>
+            <a:ext cx="2029968" cy="548640"/>
+          </a:xfrm>
+          <a:prstGeom prst="roundRect">
+            <a:avLst/>
+          </a:prstGeom>
+          <a:solidFill>
+            <a:srgbClr val="FFFFFF"/>
+          </a:solidFill>
+          <a:ln w="10160">
+            <a:solidFill>
+              <a:srgbClr val="DCE6F2"/>
+            </a:solidFill>
+          </a:ln>
+        </p:spPr>
+        <p:style>
+          <a:lnRef idx="1">
+            <a:schemeClr val="accent1"/>
+          </a:lnRef>
+          <a:fillRef idx="3">
+            <a:schemeClr val="accent1"/>
+          </a:fillRef>
+          <a:effectRef idx="2">
+            <a:schemeClr val="accent1"/>
+          </a:effectRef>
+          <a:fontRef idx="minor">
+            <a:schemeClr val="lt1"/>
+          </a:fontRef>
+        </p:style>
+        <p:txBody>
+          <a:bodyPr rtlCol="0" anchor="ctr" wrap="square" lIns="54864" rIns="54864" tIns="36576" bIns="36576"/>
+          <a:lstStyle/>
+          <a:p>
+            <a:pPr algn="ctr">
+              <a:defRPr sz="950" b="1">
+                <a:solidFill>
+                  <a:srgbClr val="1F497D"/>
+                </a:solidFill>
+                <a:latin typeface="Calibri"/>
+              </a:defRPr>
+            </a:pPr>
+            <a:r>
+              <a:t>1.1.6 1x Farblaser-MFP A3</a:t>
+            </a:r>
+          </a:p>
+          <a:p>
+            <a:pPr>
+              <a:defRPr sz="850">
+                <a:solidFill>
+                  <a:srgbClr val="262626"/>
+                </a:solidFill>
+                <a:latin typeface="Calibri"/>
+              </a:defRPr>
+            </a:pPr>
+            <a:r>
+              <a:t>Lexmark CX930dse A3/A4 MFP</a:t>
+            </a:r>
+          </a:p>
+        </p:txBody>
+      </p:sp>
+      <p:sp>
+        <p:nvSpPr>
+          <p:cNvPr id="17" name="Rectangle 16"/>
+          <p:cNvSpPr/>
+          <p:nvPr/>
+        </p:nvSpPr>
+        <p:spPr>
+          <a:xfrm>
+            <a:off x="3782060" y="1847088"/>
+            <a:ext cx="25400" cy="128016"/>
+          </a:xfrm>
+          <a:prstGeom prst="rect">
+            <a:avLst/>
+          </a:prstGeom>
+          <a:solidFill>
+            <a:srgbClr val="788CAA"/>
+          </a:solidFill>
+          <a:ln>
+            <a:noFill/>
+          </a:ln>
+        </p:spPr>
+        <p:style>
+          <a:lnRef idx="1">
+            <a:schemeClr val="accent1"/>
+          </a:lnRef>
+          <a:fillRef idx="3">
+            <a:schemeClr val="accent1"/>
+          </a:fillRef>
+          <a:effectRef idx="2">
+            <a:schemeClr val="accent1"/>
+          </a:effectRef>
+          <a:fontRef idx="minor">
+            <a:schemeClr val="lt1"/>
+          </a:fontRef>
+        </p:style>
+        <p:txBody>
+          <a:bodyPr rtlCol="0" anchor="ctr"/>
+          <a:lstStyle/>
+          <a:p>
+            <a:pPr algn="ctr"/>
+          </a:p>
+        </p:txBody>
+      </p:sp>
+      <p:sp>
+        <p:nvSpPr>
+          <p:cNvPr id="18" name="Rounded Rectangle 17"/>
+          <p:cNvSpPr/>
+          <p:nvPr/>
+        </p:nvSpPr>
+        <p:spPr>
+          <a:xfrm>
+            <a:off x="2734056" y="1975104"/>
+            <a:ext cx="2121408" cy="621792"/>
+          </a:xfrm>
+          <a:prstGeom prst="roundRect">
+            <a:avLst/>
+          </a:prstGeom>
+          <a:solidFill>
+            <a:srgbClr val="1F497D"/>
+          </a:solidFill>
+          <a:ln w="15240">
+            <a:solidFill>
+              <a:srgbClr val="BDD7EE"/>
+            </a:solidFill>
+          </a:ln>
+        </p:spPr>
+        <p:style>
+          <a:lnRef idx="1">
+            <a:schemeClr val="accent1"/>
+          </a:lnRef>
+          <a:fillRef idx="3">
+            <a:schemeClr val="accent1"/>
+          </a:fillRef>
+          <a:effectRef idx="2">
+            <a:schemeClr val="accent1"/>
+          </a:effectRef>
+          <a:fontRef idx="minor">
+            <a:schemeClr val="lt1"/>
+          </a:fontRef>
+        </p:style>
+        <p:txBody>
+          <a:bodyPr rtlCol="0" anchor="ctr" wrap="square"/>
+          <a:lstStyle/>
+          <a:p>
+            <a:pPr algn="ctr">
+              <a:defRPr sz="1100" b="1">
+                <a:solidFill>
+                  <a:srgbClr val="FFFFFF"/>
+                </a:solidFill>
+                <a:latin typeface="Calibri"/>
+              </a:defRPr>
+            </a:pPr>
+            <a:r>
+              <a:t>1.2 Software</a:t>
+            </a:r>
+          </a:p>
+          <a:p>
+            <a:pPr algn="ctr">
+              <a:defRPr sz="900">
+                <a:solidFill>
+                  <a:srgbClr val="FFE699"/>
+                </a:solidFill>
+                <a:latin typeface="Calibri"/>
+              </a:defRPr>
+            </a:pPr>
+            <a:r>
+              <a:t>Leitung: Mathias Vonau</a:t>
+            </a:r>
+          </a:p>
+        </p:txBody>
+      </p:sp>
+      <p:sp>
+        <p:nvSpPr>
+          <p:cNvPr id="19" name="Rounded Rectangle 18"/>
+          <p:cNvSpPr/>
+          <p:nvPr/>
+        </p:nvSpPr>
+        <p:spPr>
+          <a:xfrm>
+            <a:off x="2734056" y="2633472"/>
+            <a:ext cx="2121408" cy="3584448"/>
+          </a:xfrm>
+          <a:prstGeom prst="roundRect">
+            <a:avLst/>
+          </a:prstGeom>
+          <a:solidFill>
+            <a:srgbClr val="FFFFFF"/>
+          </a:solidFill>
+          <a:ln w="15240">
+            <a:solidFill>
+              <a:srgbClr val="BDD7EE"/>
+            </a:solidFill>
+          </a:ln>
+        </p:spPr>
+        <p:style>
+          <a:lnRef idx="1">
+            <a:schemeClr val="accent1"/>
+          </a:lnRef>
+          <a:fillRef idx="3">
+            <a:schemeClr val="accent1"/>
+          </a:fillRef>
+          <a:effectRef idx="2">
+            <a:schemeClr val="accent1"/>
+          </a:effectRef>
+          <a:fontRef idx="minor">
+            <a:schemeClr val="lt1"/>
+          </a:fontRef>
+        </p:style>
+        <p:txBody>
+          <a:bodyPr rtlCol="0" anchor="ctr"/>
+          <a:lstStyle/>
+          <a:p>
+            <a:pPr algn="ctr"/>
+          </a:p>
+        </p:txBody>
+      </p:sp>
+      <p:sp>
+        <p:nvSpPr>
+          <p:cNvPr id="20" name="Rounded Rectangle 19"/>
+          <p:cNvSpPr/>
+          <p:nvPr/>
+        </p:nvSpPr>
+        <p:spPr>
+          <a:xfrm>
+            <a:off x="2779776" y="2688336"/>
+            <a:ext cx="2029968" cy="548640"/>
+          </a:xfrm>
+          <a:prstGeom prst="roundRect">
+            <a:avLst/>
+          </a:prstGeom>
+          <a:solidFill>
+            <a:srgbClr val="F5F8FC"/>
+          </a:solidFill>
+          <a:ln w="10160">
+            <a:solidFill>
+              <a:srgbClr val="DCE6F2"/>
+            </a:solidFill>
+          </a:ln>
+        </p:spPr>
+        <p:style>
+          <a:lnRef idx="1">
+            <a:schemeClr val="accent1"/>
+          </a:lnRef>
+          <a:fillRef idx="3">
+            <a:schemeClr val="accent1"/>
+          </a:fillRef>
+          <a:effectRef idx="2">
+            <a:schemeClr val="accent1"/>
+          </a:effectRef>
+          <a:fontRef idx="minor">
+            <a:schemeClr val="lt1"/>
+          </a:fontRef>
+        </p:style>
+        <p:txBody>
+          <a:bodyPr rtlCol="0" anchor="ctr" wrap="square" lIns="54864" rIns="54864" tIns="36576" bIns="36576"/>
+          <a:lstStyle/>
+          <a:p>
+            <a:pPr algn="ctr">
+              <a:defRPr sz="950" b="1">
+                <a:solidFill>
+                  <a:srgbClr val="1F497D"/>
+                </a:solidFill>
+                <a:latin typeface="Calibri"/>
+              </a:defRPr>
+            </a:pPr>
+            <a:r>
+              <a:t>1.2.1 16x Windows 11 Pro</a:t>
+            </a:r>
+          </a:p>
+          <a:p>
+            <a:pPr>
+              <a:defRPr sz="850">
+                <a:solidFill>
+                  <a:srgbClr val="262626"/>
+                </a:solidFill>
+                <a:latin typeface="Calibri"/>
+              </a:defRPr>
+            </a:pPr>
+            <a:r>
+              <a:t>OEM-Lizenzen 64-Bit vorinstall.</a:t>
+            </a:r>
+          </a:p>
+        </p:txBody>
+      </p:sp>
+      <p:sp>
+        <p:nvSpPr>
+          <p:cNvPr id="21" name="Rounded Rectangle 20"/>
+          <p:cNvSpPr/>
+          <p:nvPr/>
+        </p:nvSpPr>
+        <p:spPr>
+          <a:xfrm>
+            <a:off x="2779776" y="3273552"/>
+            <a:ext cx="2029968" cy="548640"/>
+          </a:xfrm>
+          <a:prstGeom prst="roundRect">
+            <a:avLst/>
+          </a:prstGeom>
+          <a:solidFill>
+            <a:srgbClr val="FFFFFF"/>
+          </a:solidFill>
+          <a:ln w="10160">
+            <a:solidFill>
+              <a:srgbClr val="DCE6F2"/>
+            </a:solidFill>
+          </a:ln>
+        </p:spPr>
+        <p:style>
+          <a:lnRef idx="1">
+            <a:schemeClr val="accent1"/>
+          </a:lnRef>
+          <a:fillRef idx="3">
+            <a:schemeClr val="accent1"/>
+          </a:fillRef>
+          <a:effectRef idx="2">
+            <a:schemeClr val="accent1"/>
+          </a:effectRef>
+          <a:fontRef idx="minor">
+            <a:schemeClr val="lt1"/>
+          </a:fontRef>
+        </p:style>
+        <p:txBody>
+          <a:bodyPr rtlCol="0" anchor="ctr" wrap="square" lIns="54864" rIns="54864" tIns="36576" bIns="36576"/>
+          <a:lstStyle/>
+          <a:p>
+            <a:pPr algn="ctr">
+              <a:defRPr sz="950" b="1">
+                <a:solidFill>
+                  <a:srgbClr val="1F497D"/>
+                </a:solidFill>
+                <a:latin typeface="Calibri"/>
+              </a:defRPr>
+            </a:pPr>
+            <a:r>
+              <a:t>1.2.2 16x M365 Business</a:t>
+            </a:r>
+          </a:p>
+          <a:p>
+            <a:pPr>
+              <a:defRPr sz="850">
+                <a:solidFill>
+                  <a:srgbClr val="262626"/>
+                </a:solidFill>
+                <a:latin typeface="Calibri"/>
+              </a:defRPr>
+            </a:pPr>
+            <a:r>
+              <a:t>Office Standard Jahresabos</a:t>
+            </a:r>
+          </a:p>
+        </p:txBody>
+      </p:sp>
+      <p:sp>
+        <p:nvSpPr>
+          <p:cNvPr id="22" name="Rounded Rectangle 21"/>
+          <p:cNvSpPr/>
+          <p:nvPr/>
+        </p:nvSpPr>
+        <p:spPr>
+          <a:xfrm>
+            <a:off x="2779776" y="3858768"/>
+            <a:ext cx="2029968" cy="548640"/>
+          </a:xfrm>
+          <a:prstGeom prst="roundRect">
+            <a:avLst/>
+          </a:prstGeom>
+          <a:solidFill>
+            <a:srgbClr val="F5F8FC"/>
+          </a:solidFill>
+          <a:ln w="10160">
+            <a:solidFill>
+              <a:srgbClr val="DCE6F2"/>
+            </a:solidFill>
+          </a:ln>
+        </p:spPr>
+        <p:style>
+          <a:lnRef idx="1">
+            <a:schemeClr val="accent1"/>
+          </a:lnRef>
+          <a:fillRef idx="3">
+            <a:schemeClr val="accent1"/>
+          </a:fillRef>
+          <a:effectRef idx="2">
+            <a:schemeClr val="accent1"/>
+          </a:effectRef>
+          <a:fontRef idx="minor">
+            <a:schemeClr val="lt1"/>
+          </a:fontRef>
+        </p:style>
+        <p:txBody>
+          <a:bodyPr rtlCol="0" anchor="ctr" wrap="square" lIns="54864" rIns="54864" tIns="36576" bIns="36576"/>
+          <a:lstStyle/>
+          <a:p>
+            <a:pPr algn="ctr">
+              <a:defRPr sz="950" b="1">
+                <a:solidFill>
+                  <a:srgbClr val="1F497D"/>
+                </a:solidFill>
+                <a:latin typeface="Calibri"/>
+              </a:defRPr>
+            </a:pPr>
+            <a:r>
+              <a:t>1.2.3 16x Adobe Acrobat Pro</a:t>
+            </a:r>
+          </a:p>
+          <a:p>
+            <a:pPr>
+              <a:defRPr sz="850">
+                <a:solidFill>
+                  <a:srgbClr val="262626"/>
+                </a:solidFill>
+                <a:latin typeface="Calibri"/>
+              </a:defRPr>
+            </a:pPr>
+            <a:r>
+              <a:t>PDF-Prüfung &amp; digitale Signatur</a:t>
+            </a:r>
+          </a:p>
+        </p:txBody>
+      </p:sp>
+      <p:sp>
+        <p:nvSpPr>
+          <p:cNvPr id="23" name="Rounded Rectangle 22"/>
+          <p:cNvSpPr/>
+          <p:nvPr/>
+        </p:nvSpPr>
+        <p:spPr>
+          <a:xfrm>
+            <a:off x="2779776" y="4443984"/>
+            <a:ext cx="2029968" cy="548640"/>
+          </a:xfrm>
+          <a:prstGeom prst="roundRect">
+            <a:avLst/>
+          </a:prstGeom>
+          <a:solidFill>
+            <a:srgbClr val="FFFFFF"/>
+          </a:solidFill>
+          <a:ln w="10160">
+            <a:solidFill>
+              <a:srgbClr val="DCE6F2"/>
+            </a:solidFill>
+          </a:ln>
+        </p:spPr>
+        <p:style>
+          <a:lnRef idx="1">
+            <a:schemeClr val="accent1"/>
+          </a:lnRef>
+          <a:fillRef idx="3">
+            <a:schemeClr val="accent1"/>
+          </a:fillRef>
+          <a:effectRef idx="2">
+            <a:schemeClr val="accent1"/>
+          </a:effectRef>
+          <a:fontRef idx="minor">
+            <a:schemeClr val="lt1"/>
+          </a:fontRef>
+        </p:style>
+        <p:txBody>
+          <a:bodyPr rtlCol="0" anchor="ctr" wrap="square" lIns="54864" rIns="54864" tIns="36576" bIns="36576"/>
+          <a:lstStyle/>
+          <a:p>
+            <a:pPr algn="ctr">
+              <a:defRPr sz="950" b="1">
+                <a:solidFill>
+                  <a:srgbClr val="1F497D"/>
+                </a:solidFill>
+                <a:latin typeface="Calibri"/>
+              </a:defRPr>
+            </a:pPr>
+            <a:r>
+              <a:t>1.2.4 16x ESET PROTECT</a:t>
+            </a:r>
+          </a:p>
+          <a:p>
+            <a:pPr>
+              <a:defRPr sz="850">
+                <a:solidFill>
+                  <a:srgbClr val="262626"/>
+                </a:solidFill>
+                <a:latin typeface="Calibri"/>
+              </a:defRPr>
+            </a:pPr>
+            <a:r>
+              <a:t>Zentral verwaltetes Cloud-EDR</a:t>
+            </a:r>
+          </a:p>
+        </p:txBody>
+      </p:sp>
+      <p:sp>
+        <p:nvSpPr>
+          <p:cNvPr id="24" name="Rounded Rectangle 23"/>
+          <p:cNvSpPr/>
+          <p:nvPr/>
+        </p:nvSpPr>
+        <p:spPr>
+          <a:xfrm>
+            <a:off x="2779776" y="5029200"/>
+            <a:ext cx="2029968" cy="548640"/>
+          </a:xfrm>
+          <a:prstGeom prst="roundRect">
+            <a:avLst/>
+          </a:prstGeom>
+          <a:solidFill>
+            <a:srgbClr val="F5F8FC"/>
+          </a:solidFill>
+          <a:ln w="10160">
+            <a:solidFill>
+              <a:srgbClr val="DCE6F2"/>
+            </a:solidFill>
+          </a:ln>
+        </p:spPr>
+        <p:style>
+          <a:lnRef idx="1">
+            <a:schemeClr val="accent1"/>
+          </a:lnRef>
+          <a:fillRef idx="3">
+            <a:schemeClr val="accent1"/>
+          </a:fillRef>
+          <a:effectRef idx="2">
+            <a:schemeClr val="accent1"/>
+          </a:effectRef>
+          <a:fontRef idx="minor">
+            <a:schemeClr val="lt1"/>
+          </a:fontRef>
+        </p:style>
+        <p:txBody>
+          <a:bodyPr rtlCol="0" anchor="ctr" wrap="square" lIns="54864" rIns="54864" tIns="36576" bIns="36576"/>
+          <a:lstStyle/>
+          <a:p>
+            <a:pPr algn="ctr">
+              <a:defRPr sz="950" b="1">
+                <a:solidFill>
+                  <a:srgbClr val="1F497D"/>
+                </a:solidFill>
+                <a:latin typeface="Calibri"/>
+              </a:defRPr>
+            </a:pPr>
+            <a:r>
+              <a:t>1.2.5 Staging-Images</a:t>
+            </a:r>
+          </a:p>
+          <a:p>
+            <a:pPr>
+              <a:defRPr sz="850">
+                <a:solidFill>
+                  <a:srgbClr val="262626"/>
+                </a:solidFill>
+                <a:latin typeface="Calibri"/>
+              </a:defRPr>
+            </a:pPr>
+            <a:r>
+              <a:t>Sysprep-Standardinstallation</a:t>
+            </a:r>
+          </a:p>
+        </p:txBody>
+      </p:sp>
+      <p:sp>
+        <p:nvSpPr>
+          <p:cNvPr id="25" name="Rounded Rectangle 24"/>
+          <p:cNvSpPr/>
+          <p:nvPr/>
+        </p:nvSpPr>
+        <p:spPr>
+          <a:xfrm>
+            <a:off x="2779776" y="5614416"/>
+            <a:ext cx="2029968" cy="548640"/>
+          </a:xfrm>
+          <a:prstGeom prst="roundRect">
+            <a:avLst/>
+          </a:prstGeom>
+          <a:solidFill>
+            <a:srgbClr val="FFFFFF"/>
+          </a:solidFill>
+          <a:ln w="10160">
+            <a:solidFill>
+              <a:srgbClr val="DCE6F2"/>
+            </a:solidFill>
+          </a:ln>
+        </p:spPr>
+        <p:style>
+          <a:lnRef idx="1">
+            <a:schemeClr val="accent1"/>
+          </a:lnRef>
+          <a:fillRef idx="3">
+            <a:schemeClr val="accent1"/>
+          </a:fillRef>
+          <a:effectRef idx="2">
+            <a:schemeClr val="accent1"/>
+          </a:effectRef>
+          <a:fontRef idx="minor">
+            <a:schemeClr val="lt1"/>
+          </a:fontRef>
+        </p:style>
+        <p:txBody>
+          <a:bodyPr rtlCol="0" anchor="ctr" wrap="square" lIns="54864" rIns="54864" tIns="36576" bIns="36576"/>
+          <a:lstStyle/>
+          <a:p>
+            <a:pPr algn="ctr">
+              <a:defRPr sz="950" b="1">
+                <a:solidFill>
+                  <a:srgbClr val="1F497D"/>
+                </a:solidFill>
+                <a:latin typeface="Calibri"/>
+              </a:defRPr>
+            </a:pPr>
+            <a:r>
+              <a:t>1.2.6 Lizenzdokumentation</a:t>
+            </a:r>
+          </a:p>
+          <a:p>
+            <a:pPr>
+              <a:defRPr sz="850">
+                <a:solidFill>
+                  <a:srgbClr val="262626"/>
+                </a:solidFill>
+                <a:latin typeface="Calibri"/>
+              </a:defRPr>
+            </a:pPr>
+            <a:r>
+              <a:t>Lizenznachweise &amp; Zertifikate</a:t>
+            </a:r>
+          </a:p>
+        </p:txBody>
+      </p:sp>
+      <p:sp>
+        <p:nvSpPr>
+          <p:cNvPr id="26" name="Rectangle 25"/>
+          <p:cNvSpPr/>
+          <p:nvPr/>
+        </p:nvSpPr>
+        <p:spPr>
+          <a:xfrm>
+            <a:off x="6013196" y="1847088"/>
+            <a:ext cx="25400" cy="128016"/>
+          </a:xfrm>
+          <a:prstGeom prst="rect">
+            <a:avLst/>
+          </a:prstGeom>
+          <a:solidFill>
+            <a:srgbClr val="788CAA"/>
+          </a:solidFill>
+          <a:ln>
+            <a:noFill/>
+          </a:ln>
+        </p:spPr>
+        <p:style>
+          <a:lnRef idx="1">
+            <a:schemeClr val="accent1"/>
+          </a:lnRef>
+          <a:fillRef idx="3">
+            <a:schemeClr val="accent1"/>
+          </a:fillRef>
+          <a:effectRef idx="2">
+            <a:schemeClr val="accent1"/>
+          </a:effectRef>
+          <a:fontRef idx="minor">
+            <a:schemeClr val="lt1"/>
+          </a:fontRef>
+        </p:style>
+        <p:txBody>
+          <a:bodyPr rtlCol="0" anchor="ctr"/>
+          <a:lstStyle/>
+          <a:p>
+            <a:pPr algn="ctr"/>
+          </a:p>
+        </p:txBody>
+      </p:sp>
+      <p:sp>
+        <p:nvSpPr>
+          <p:cNvPr id="27" name="Rounded Rectangle 26"/>
+          <p:cNvSpPr/>
+          <p:nvPr/>
+        </p:nvSpPr>
+        <p:spPr>
+          <a:xfrm>
+            <a:off x="4965192" y="1975104"/>
+            <a:ext cx="2121408" cy="621792"/>
+          </a:xfrm>
+          <a:prstGeom prst="roundRect">
+            <a:avLst/>
+          </a:prstGeom>
+          <a:solidFill>
+            <a:srgbClr val="1F497D"/>
+          </a:solidFill>
+          <a:ln w="15240">
+            <a:solidFill>
+              <a:srgbClr val="BDD7EE"/>
+            </a:solidFill>
+          </a:ln>
+        </p:spPr>
+        <p:style>
+          <a:lnRef idx="1">
+            <a:schemeClr val="accent1"/>
+          </a:lnRef>
+          <a:fillRef idx="3">
+            <a:schemeClr val="accent1"/>
+          </a:fillRef>
+          <a:effectRef idx="2">
+            <a:schemeClr val="accent1"/>
+          </a:effectRef>
+          <a:fontRef idx="minor">
+            <a:schemeClr val="lt1"/>
+          </a:fontRef>
+        </p:style>
+        <p:txBody>
+          <a:bodyPr rtlCol="0" anchor="ctr" wrap="square"/>
+          <a:lstStyle/>
+          <a:p>
+            <a:pPr algn="ctr">
+              <a:defRPr sz="1100" b="1">
+                <a:solidFill>
+                  <a:srgbClr val="FFFFFF"/>
+                </a:solidFill>
+                <a:latin typeface="Calibri"/>
+              </a:defRPr>
+            </a:pPr>
+            <a:r>
+              <a:t>1.3 Netzwerk / Server</a:t>
+            </a:r>
+          </a:p>
+          <a:p>
+            <a:pPr algn="ctr">
+              <a:defRPr sz="900">
+                <a:solidFill>
+                  <a:srgbClr val="FFE699"/>
+                </a:solidFill>
+                <a:latin typeface="Calibri"/>
+              </a:defRPr>
+            </a:pPr>
+            <a:r>
+              <a:t>Leitung: Siyar</a:t>
+            </a:r>
+          </a:p>
+        </p:txBody>
+      </p:sp>
+      <p:sp>
+        <p:nvSpPr>
+          <p:cNvPr id="28" name="Rounded Rectangle 27"/>
+          <p:cNvSpPr/>
+          <p:nvPr/>
+        </p:nvSpPr>
+        <p:spPr>
+          <a:xfrm>
+            <a:off x="4965192" y="2633472"/>
+            <a:ext cx="2121408" cy="3584448"/>
+          </a:xfrm>
+          <a:prstGeom prst="roundRect">
+            <a:avLst/>
+          </a:prstGeom>
+          <a:solidFill>
+            <a:srgbClr val="FFFFFF"/>
+          </a:solidFill>
+          <a:ln w="15240">
+            <a:solidFill>
+              <a:srgbClr val="BDD7EE"/>
+            </a:solidFill>
+          </a:ln>
+        </p:spPr>
+        <p:style>
+          <a:lnRef idx="1">
+            <a:schemeClr val="accent1"/>
+          </a:lnRef>
+          <a:fillRef idx="3">
+            <a:schemeClr val="accent1"/>
+          </a:fillRef>
+          <a:effectRef idx="2">
+            <a:schemeClr val="accent1"/>
+          </a:effectRef>
+          <a:fontRef idx="minor">
+            <a:schemeClr val="lt1"/>
+          </a:fontRef>
+        </p:style>
+        <p:txBody>
+          <a:bodyPr rtlCol="0" anchor="ctr"/>
+          <a:lstStyle/>
+          <a:p>
+            <a:pPr algn="ctr"/>
+          </a:p>
+        </p:txBody>
+      </p:sp>
+      <p:sp>
+        <p:nvSpPr>
+          <p:cNvPr id="29" name="Rounded Rectangle 28"/>
+          <p:cNvSpPr/>
+          <p:nvPr/>
+        </p:nvSpPr>
+        <p:spPr>
+          <a:xfrm>
+            <a:off x="5010912" y="2688336"/>
+            <a:ext cx="2029968" cy="548640"/>
+          </a:xfrm>
+          <a:prstGeom prst="roundRect">
+            <a:avLst/>
+          </a:prstGeom>
+          <a:solidFill>
+            <a:srgbClr val="F5F8FC"/>
+          </a:solidFill>
+          <a:ln w="10160">
+            <a:solidFill>
+              <a:srgbClr val="DCE6F2"/>
+            </a:solidFill>
+          </a:ln>
+        </p:spPr>
+        <p:style>
+          <a:lnRef idx="1">
+            <a:schemeClr val="accent1"/>
+          </a:lnRef>
+          <a:fillRef idx="3">
+            <a:schemeClr val="accent1"/>
+          </a:fillRef>
+          <a:effectRef idx="2">
+            <a:schemeClr val="accent1"/>
+          </a:effectRef>
+          <a:fontRef idx="minor">
+            <a:schemeClr val="lt1"/>
+          </a:fontRef>
+        </p:style>
+        <p:txBody>
+          <a:bodyPr rtlCol="0" anchor="ctr" wrap="square" lIns="54864" rIns="54864" tIns="36576" bIns="36576"/>
+          <a:lstStyle/>
+          <a:p>
+            <a:pPr algn="ctr">
+              <a:defRPr sz="950" b="1">
+                <a:solidFill>
+                  <a:srgbClr val="1F497D"/>
+                </a:solidFill>
+                <a:latin typeface="Calibri"/>
+              </a:defRPr>
+            </a:pPr>
+            <a:r>
+              <a:t>1.3.1 Gigabit-Verkabelung</a:t>
+            </a:r>
+          </a:p>
+          <a:p>
+            <a:pPr>
+              <a:defRPr sz="850">
+                <a:solidFill>
+                  <a:srgbClr val="262626"/>
+                </a:solidFill>
+                <a:latin typeface="Calibri"/>
+              </a:defRPr>
+            </a:pPr>
+            <a:r>
+              <a:t>16x InLine Cat.6A Patchkabel</a:t>
+            </a:r>
+          </a:p>
+        </p:txBody>
+      </p:sp>
+      <p:sp>
+        <p:nvSpPr>
+          <p:cNvPr id="30" name="Rounded Rectangle 29"/>
+          <p:cNvSpPr/>
+          <p:nvPr/>
+        </p:nvSpPr>
+        <p:spPr>
+          <a:xfrm>
+            <a:off x="5010912" y="3273552"/>
+            <a:ext cx="2029968" cy="548640"/>
+          </a:xfrm>
+          <a:prstGeom prst="roundRect">
+            <a:avLst/>
+          </a:prstGeom>
+          <a:solidFill>
+            <a:srgbClr val="FFFFFF"/>
+          </a:solidFill>
+          <a:ln w="10160">
+            <a:solidFill>
+              <a:srgbClr val="DCE6F2"/>
+            </a:solidFill>
+          </a:ln>
+        </p:spPr>
+        <p:style>
+          <a:lnRef idx="1">
+            <a:schemeClr val="accent1"/>
+          </a:lnRef>
+          <a:fillRef idx="3">
+            <a:schemeClr val="accent1"/>
+          </a:fillRef>
+          <a:effectRef idx="2">
+            <a:schemeClr val="accent1"/>
+          </a:effectRef>
+          <a:fontRef idx="minor">
+            <a:schemeClr val="lt1"/>
+          </a:fontRef>
+        </p:style>
+        <p:txBody>
+          <a:bodyPr rtlCol="0" anchor="ctr" wrap="square" lIns="54864" rIns="54864" tIns="36576" bIns="36576"/>
+          <a:lstStyle/>
+          <a:p>
+            <a:pPr algn="ctr">
+              <a:defRPr sz="950" b="1">
+                <a:solidFill>
+                  <a:srgbClr val="1F497D"/>
+                </a:solidFill>
+                <a:latin typeface="Calibri"/>
+              </a:defRPr>
+            </a:pPr>
+            <a:r>
+              <a:t>1.3.2 Fileserver-Kapazität</a:t>
+            </a:r>
+          </a:p>
+          <a:p>
+            <a:pPr>
+              <a:defRPr sz="850">
+                <a:solidFill>
+                  <a:srgbClr val="262626"/>
+                </a:solidFill>
+                <a:latin typeface="Calibri"/>
+              </a:defRPr>
+            </a:pPr>
+            <a:r>
+              <a:t>445 GiB Netto-Puffer (Q1)</a:t>
+            </a:r>
+          </a:p>
+        </p:txBody>
+      </p:sp>
+      <p:sp>
+        <p:nvSpPr>
+          <p:cNvPr id="31" name="Rounded Rectangle 30"/>
+          <p:cNvSpPr/>
+          <p:nvPr/>
+        </p:nvSpPr>
+        <p:spPr>
+          <a:xfrm>
+            <a:off x="5010912" y="3858768"/>
+            <a:ext cx="2029968" cy="548640"/>
+          </a:xfrm>
+          <a:prstGeom prst="roundRect">
+            <a:avLst/>
+          </a:prstGeom>
+          <a:solidFill>
+            <a:srgbClr val="F5F8FC"/>
+          </a:solidFill>
+          <a:ln w="10160">
+            <a:solidFill>
+              <a:srgbClr val="DCE6F2"/>
+            </a:solidFill>
+          </a:ln>
+        </p:spPr>
+        <p:style>
+          <a:lnRef idx="1">
+            <a:schemeClr val="accent1"/>
+          </a:lnRef>
+          <a:fillRef idx="3">
+            <a:schemeClr val="accent1"/>
+          </a:fillRef>
+          <a:effectRef idx="2">
+            <a:schemeClr val="accent1"/>
+          </a:effectRef>
+          <a:fontRef idx="minor">
+            <a:schemeClr val="lt1"/>
+          </a:fontRef>
+        </p:style>
+        <p:txBody>
+          <a:bodyPr rtlCol="0" anchor="ctr" wrap="square" lIns="54864" rIns="54864" tIns="36576" bIns="36576"/>
+          <a:lstStyle/>
+          <a:p>
+            <a:pPr algn="ctr">
+              <a:defRPr sz="950" b="1">
+                <a:solidFill>
+                  <a:srgbClr val="1F497D"/>
+                </a:solidFill>
+                <a:latin typeface="Calibri"/>
+              </a:defRPr>
+            </a:pPr>
+            <a:r>
+              <a:t>1.3.3 Energiekosten-Analyse</a:t>
+            </a:r>
+          </a:p>
+          <a:p>
+            <a:pPr>
+              <a:defRPr sz="850">
+                <a:solidFill>
+                  <a:srgbClr val="262626"/>
+                </a:solidFill>
+                <a:latin typeface="Calibri"/>
+              </a:defRPr>
+            </a:pPr>
+            <a:r>
+              <a:t>1.771,26 € jährliche Stromkosten</a:t>
+            </a:r>
+          </a:p>
+        </p:txBody>
+      </p:sp>
+      <p:sp>
+        <p:nvSpPr>
+          <p:cNvPr id="32" name="Rounded Rectangle 31"/>
+          <p:cNvSpPr/>
+          <p:nvPr/>
+        </p:nvSpPr>
+        <p:spPr>
+          <a:xfrm>
+            <a:off x="5010912" y="4443984"/>
+            <a:ext cx="2029968" cy="548640"/>
+          </a:xfrm>
+          <a:prstGeom prst="roundRect">
+            <a:avLst/>
+          </a:prstGeom>
+          <a:solidFill>
+            <a:srgbClr val="FFFFFF"/>
+          </a:solidFill>
+          <a:ln w="10160">
+            <a:solidFill>
+              <a:srgbClr val="DCE6F2"/>
+            </a:solidFill>
+          </a:ln>
+        </p:spPr>
+        <p:style>
+          <a:lnRef idx="1">
+            <a:schemeClr val="accent1"/>
+          </a:lnRef>
+          <a:fillRef idx="3">
+            <a:schemeClr val="accent1"/>
+          </a:fillRef>
+          <a:effectRef idx="2">
+            <a:schemeClr val="accent1"/>
+          </a:effectRef>
+          <a:fontRef idx="minor">
+            <a:schemeClr val="lt1"/>
+          </a:fontRef>
+        </p:style>
+        <p:txBody>
+          <a:bodyPr rtlCol="0" anchor="ctr" wrap="square" lIns="54864" rIns="54864" tIns="36576" bIns="36576"/>
+          <a:lstStyle/>
+          <a:p>
+            <a:pPr algn="ctr">
+              <a:defRPr sz="950" b="1">
+                <a:solidFill>
+                  <a:srgbClr val="1F497D"/>
+                </a:solidFill>
+                <a:latin typeface="Calibri"/>
+              </a:defRPr>
+            </a:pPr>
+            <a:r>
+              <a:t>1.3.4 Switchport-Planung</a:t>
+            </a:r>
+          </a:p>
+          <a:p>
+            <a:pPr>
+              <a:defRPr sz="850">
+                <a:solidFill>
+                  <a:srgbClr val="262626"/>
+                </a:solidFill>
+                <a:latin typeface="Calibri"/>
+              </a:defRPr>
+            </a:pPr>
+            <a:r>
+              <a:t>Zuordnung Ports &amp; VLANs</a:t>
+            </a:r>
+          </a:p>
+        </p:txBody>
+      </p:sp>
+      <p:sp>
+        <p:nvSpPr>
+          <p:cNvPr id="33" name="Rounded Rectangle 32"/>
+          <p:cNvSpPr/>
+          <p:nvPr/>
+        </p:nvSpPr>
+        <p:spPr>
+          <a:xfrm>
+            <a:off x="5010912" y="5029200"/>
+            <a:ext cx="2029968" cy="548640"/>
+          </a:xfrm>
+          <a:prstGeom prst="roundRect">
+            <a:avLst/>
+          </a:prstGeom>
+          <a:solidFill>
+            <a:srgbClr val="F5F8FC"/>
+          </a:solidFill>
+          <a:ln w="10160">
+            <a:solidFill>
+              <a:srgbClr val="DCE6F2"/>
+            </a:solidFill>
+          </a:ln>
+        </p:spPr>
+        <p:style>
+          <a:lnRef idx="1">
+            <a:schemeClr val="accent1"/>
+          </a:lnRef>
+          <a:fillRef idx="3">
+            <a:schemeClr val="accent1"/>
+          </a:fillRef>
+          <a:effectRef idx="2">
+            <a:schemeClr val="accent1"/>
+          </a:effectRef>
+          <a:fontRef idx="minor">
+            <a:schemeClr val="lt1"/>
+          </a:fontRef>
+        </p:style>
+        <p:txBody>
+          <a:bodyPr rtlCol="0" anchor="ctr" wrap="square" lIns="54864" rIns="54864" tIns="36576" bIns="36576"/>
+          <a:lstStyle/>
+          <a:p>
+            <a:pPr algn="ctr">
+              <a:defRPr sz="950" b="1">
+                <a:solidFill>
+                  <a:srgbClr val="1F497D"/>
+                </a:solidFill>
+                <a:latin typeface="Calibri"/>
+              </a:defRPr>
+            </a:pPr>
+            <a:r>
+              <a:t>1.3.5 Server-Synchronisation</a:t>
+            </a:r>
+          </a:p>
+          <a:p>
+            <a:pPr>
+              <a:defRPr sz="850">
+                <a:solidFill>
+                  <a:srgbClr val="262626"/>
+                </a:solidFill>
+                <a:latin typeface="Calibri"/>
+              </a:defRPr>
+            </a:pPr>
+            <a:r>
+              <a:t>Tägliches SSD-Backup am Abend</a:t>
+            </a:r>
+          </a:p>
+        </p:txBody>
+      </p:sp>
+      <p:sp>
+        <p:nvSpPr>
+          <p:cNvPr id="34" name="Rounded Rectangle 33"/>
+          <p:cNvSpPr/>
+          <p:nvPr/>
+        </p:nvSpPr>
+        <p:spPr>
+          <a:xfrm>
+            <a:off x="5010912" y="5614416"/>
+            <a:ext cx="2029968" cy="548640"/>
+          </a:xfrm>
+          <a:prstGeom prst="roundRect">
+            <a:avLst/>
+          </a:prstGeom>
+          <a:solidFill>
+            <a:srgbClr val="FFFFFF"/>
+          </a:solidFill>
+          <a:ln w="10160">
+            <a:solidFill>
+              <a:srgbClr val="DCE6F2"/>
+            </a:solidFill>
+          </a:ln>
+        </p:spPr>
+        <p:style>
+          <a:lnRef idx="1">
+            <a:schemeClr val="accent1"/>
+          </a:lnRef>
+          <a:fillRef idx="3">
+            <a:schemeClr val="accent1"/>
+          </a:fillRef>
+          <a:effectRef idx="2">
+            <a:schemeClr val="accent1"/>
+          </a:effectRef>
+          <a:fontRef idx="minor">
+            <a:schemeClr val="lt1"/>
+          </a:fontRef>
+        </p:style>
+        <p:txBody>
+          <a:bodyPr rtlCol="0" anchor="ctr" wrap="square" lIns="54864" rIns="54864" tIns="36576" bIns="36576"/>
+          <a:lstStyle/>
+          <a:p>
+            <a:pPr algn="ctr">
+              <a:defRPr sz="950" b="1">
+                <a:solidFill>
+                  <a:srgbClr val="1F497D"/>
+                </a:solidFill>
+                <a:latin typeface="Calibri"/>
+              </a:defRPr>
+            </a:pPr>
+            <a:r>
+              <a:t>1.3.6 Netzlaufwerke &amp; Rechte</a:t>
+            </a:r>
+          </a:p>
+          <a:p>
+            <a:pPr>
+              <a:defRPr sz="850">
+                <a:solidFill>
+                  <a:srgbClr val="262626"/>
+                </a:solidFill>
+                <a:latin typeface="Calibri"/>
+              </a:defRPr>
+            </a:pPr>
+            <a:r>
+              <a:t>SMB-Shares &amp; Freigaben</a:t>
+            </a:r>
+          </a:p>
+        </p:txBody>
+      </p:sp>
+      <p:sp>
+        <p:nvSpPr>
+          <p:cNvPr id="35" name="Rectangle 34"/>
+          <p:cNvSpPr/>
+          <p:nvPr/>
+        </p:nvSpPr>
+        <p:spPr>
+          <a:xfrm>
+            <a:off x="8244332" y="1847088"/>
+            <a:ext cx="25400" cy="128016"/>
+          </a:xfrm>
+          <a:prstGeom prst="rect">
+            <a:avLst/>
+          </a:prstGeom>
+          <a:solidFill>
+            <a:srgbClr val="788CAA"/>
+          </a:solidFill>
+          <a:ln>
+            <a:noFill/>
+          </a:ln>
+        </p:spPr>
+        <p:style>
+          <a:lnRef idx="1">
+            <a:schemeClr val="accent1"/>
+          </a:lnRef>
+          <a:fillRef idx="3">
+            <a:schemeClr val="accent1"/>
+          </a:fillRef>
+          <a:effectRef idx="2">
+            <a:schemeClr val="accent1"/>
+          </a:effectRef>
+          <a:fontRef idx="minor">
+            <a:schemeClr val="lt1"/>
+          </a:fontRef>
+        </p:style>
+        <p:txBody>
+          <a:bodyPr rtlCol="0" anchor="ctr"/>
+          <a:lstStyle/>
+          <a:p>
+            <a:pPr algn="ctr"/>
+          </a:p>
+        </p:txBody>
+      </p:sp>
+      <p:sp>
+        <p:nvSpPr>
+          <p:cNvPr id="36" name="Rounded Rectangle 35"/>
+          <p:cNvSpPr/>
+          <p:nvPr/>
+        </p:nvSpPr>
+        <p:spPr>
+          <a:xfrm>
+            <a:off x="7196328" y="1975104"/>
+            <a:ext cx="2121408" cy="621792"/>
+          </a:xfrm>
+          <a:prstGeom prst="roundRect">
+            <a:avLst/>
+          </a:prstGeom>
+          <a:solidFill>
+            <a:srgbClr val="1F497D"/>
+          </a:solidFill>
+          <a:ln w="15240">
+            <a:solidFill>
+              <a:srgbClr val="BDD7EE"/>
+            </a:solidFill>
+          </a:ln>
+        </p:spPr>
+        <p:style>
+          <a:lnRef idx="1">
+            <a:schemeClr val="accent1"/>
+          </a:lnRef>
+          <a:fillRef idx="3">
+            <a:schemeClr val="accent1"/>
+          </a:fillRef>
+          <a:effectRef idx="2">
+            <a:schemeClr val="accent1"/>
+          </a:effectRef>
+          <a:fontRef idx="minor">
+            <a:schemeClr val="lt1"/>
+          </a:fontRef>
+        </p:style>
+        <p:txBody>
+          <a:bodyPr rtlCol="0" anchor="ctr" wrap="square"/>
+          <a:lstStyle/>
+          <a:p>
+            <a:pPr algn="ctr">
+              <a:defRPr sz="1100" b="1">
+                <a:solidFill>
+                  <a:srgbClr val="FFFFFF"/>
+                </a:solidFill>
+                <a:latin typeface="Calibri"/>
+              </a:defRPr>
+            </a:pPr>
+            <a:r>
+              <a:t>1.4 QM &amp; Logistik</a:t>
+            </a:r>
+          </a:p>
+          <a:p>
+            <a:pPr algn="ctr">
+              <a:defRPr sz="900">
+                <a:solidFill>
+                  <a:srgbClr val="FFE699"/>
+                </a:solidFill>
+                <a:latin typeface="Calibri"/>
+              </a:defRPr>
+            </a:pPr>
+            <a:r>
+              <a:t>Leitung: Marco Schmidt</a:t>
+            </a:r>
+          </a:p>
+        </p:txBody>
+      </p:sp>
+      <p:sp>
+        <p:nvSpPr>
+          <p:cNvPr id="37" name="Rounded Rectangle 36"/>
+          <p:cNvSpPr/>
+          <p:nvPr/>
+        </p:nvSpPr>
+        <p:spPr>
+          <a:xfrm>
+            <a:off x="7196328" y="2633472"/>
+            <a:ext cx="2121408" cy="3584448"/>
+          </a:xfrm>
+          <a:prstGeom prst="roundRect">
+            <a:avLst/>
+          </a:prstGeom>
+          <a:solidFill>
+            <a:srgbClr val="FFFFFF"/>
+          </a:solidFill>
+          <a:ln w="15240">
+            <a:solidFill>
+              <a:srgbClr val="BDD7EE"/>
+            </a:solidFill>
+          </a:ln>
+        </p:spPr>
+        <p:style>
+          <a:lnRef idx="1">
+            <a:schemeClr val="accent1"/>
+          </a:lnRef>
+          <a:fillRef idx="3">
+            <a:schemeClr val="accent1"/>
+          </a:fillRef>
+          <a:effectRef idx="2">
+            <a:schemeClr val="accent1"/>
+          </a:effectRef>
+          <a:fontRef idx="minor">
+            <a:schemeClr val="lt1"/>
+          </a:fontRef>
+        </p:style>
+        <p:txBody>
+          <a:bodyPr rtlCol="0" anchor="ctr"/>
+          <a:lstStyle/>
+          <a:p>
+            <a:pPr algn="ctr"/>
+          </a:p>
+        </p:txBody>
+      </p:sp>
+      <p:sp>
+        <p:nvSpPr>
+          <p:cNvPr id="38" name="Rounded Rectangle 37"/>
+          <p:cNvSpPr/>
+          <p:nvPr/>
+        </p:nvSpPr>
+        <p:spPr>
+          <a:xfrm>
+            <a:off x="7242048" y="2688336"/>
+            <a:ext cx="2029968" cy="548640"/>
+          </a:xfrm>
+          <a:prstGeom prst="roundRect">
+            <a:avLst/>
+          </a:prstGeom>
+          <a:solidFill>
+            <a:srgbClr val="F5F8FC"/>
+          </a:solidFill>
+          <a:ln w="10160">
+            <a:solidFill>
+              <a:srgbClr val="DCE6F2"/>
+            </a:solidFill>
+          </a:ln>
+        </p:spPr>
+        <p:style>
+          <a:lnRef idx="1">
+            <a:schemeClr val="accent1"/>
+          </a:lnRef>
+          <a:fillRef idx="3">
+            <a:schemeClr val="accent1"/>
+          </a:fillRef>
+          <a:effectRef idx="2">
+            <a:schemeClr val="accent1"/>
+          </a:effectRef>
+          <a:fontRef idx="minor">
+            <a:schemeClr val="lt1"/>
+          </a:fontRef>
+        </p:style>
+        <p:txBody>
+          <a:bodyPr rtlCol="0" anchor="ctr" wrap="square" lIns="54864" rIns="54864" tIns="36576" bIns="36576"/>
+          <a:lstStyle/>
+          <a:p>
+            <a:pPr algn="ctr">
+              <a:defRPr sz="950" b="1">
+                <a:solidFill>
+                  <a:srgbClr val="1F497D"/>
+                </a:solidFill>
+                <a:latin typeface="Calibri"/>
+              </a:defRPr>
+            </a:pPr>
+            <a:r>
+              <a:t>1.4.1 Wareneingangsprüfung</a:t>
+            </a:r>
+          </a:p>
+          <a:p>
+            <a:pPr>
+              <a:defRPr sz="850">
+                <a:solidFill>
+                  <a:srgbClr val="262626"/>
+                </a:solidFill>
+                <a:latin typeface="Calibri"/>
+              </a:defRPr>
+            </a:pPr>
+            <a:r>
+              <a:t>Prüfung gem. § 377 HGB</a:t>
+            </a:r>
+          </a:p>
+        </p:txBody>
+      </p:sp>
+      <p:sp>
+        <p:nvSpPr>
+          <p:cNvPr id="39" name="Rounded Rectangle 38"/>
+          <p:cNvSpPr/>
+          <p:nvPr/>
+        </p:nvSpPr>
+        <p:spPr>
+          <a:xfrm>
+            <a:off x="7242048" y="3273552"/>
+            <a:ext cx="2029968" cy="548640"/>
+          </a:xfrm>
+          <a:prstGeom prst="roundRect">
+            <a:avLst/>
+          </a:prstGeom>
+          <a:solidFill>
+            <a:srgbClr val="FFFFFF"/>
+          </a:solidFill>
+          <a:ln w="10160">
+            <a:solidFill>
+              <a:srgbClr val="DCE6F2"/>
+            </a:solidFill>
+          </a:ln>
+        </p:spPr>
+        <p:style>
+          <a:lnRef idx="1">
+            <a:schemeClr val="accent1"/>
+          </a:lnRef>
+          <a:fillRef idx="3">
+            <a:schemeClr val="accent1"/>
+          </a:fillRef>
+          <a:effectRef idx="2">
+            <a:schemeClr val="accent1"/>
+          </a:effectRef>
+          <a:fontRef idx="minor">
+            <a:schemeClr val="lt1"/>
+          </a:fontRef>
+        </p:style>
+        <p:txBody>
+          <a:bodyPr rtlCol="0" anchor="ctr" wrap="square" lIns="54864" rIns="54864" tIns="36576" bIns="36576"/>
+          <a:lstStyle/>
+          <a:p>
+            <a:pPr algn="ctr">
+              <a:defRPr sz="950" b="1">
+                <a:solidFill>
+                  <a:srgbClr val="1F497D"/>
+                </a:solidFill>
+                <a:latin typeface="Calibri"/>
+              </a:defRPr>
+            </a:pPr>
+            <a:r>
+              <a:t>1.4.2 Mängelrüge Distributor</a:t>
+            </a:r>
+          </a:p>
+          <a:p>
+            <a:pPr>
+              <a:defRPr sz="850">
+                <a:solidFill>
+                  <a:srgbClr val="262626"/>
+                </a:solidFill>
+                <a:latin typeface="Calibri"/>
+              </a:defRPr>
+            </a:pPr>
+            <a:r>
+              <a:t>Fristsetzung Transportschaden</a:t>
+            </a:r>
+          </a:p>
+        </p:txBody>
+      </p:sp>
+      <p:sp>
+        <p:nvSpPr>
+          <p:cNvPr id="40" name="Rounded Rectangle 39"/>
+          <p:cNvSpPr/>
+          <p:nvPr/>
+        </p:nvSpPr>
+        <p:spPr>
+          <a:xfrm>
+            <a:off x="7242048" y="3858768"/>
+            <a:ext cx="2029968" cy="548640"/>
+          </a:xfrm>
+          <a:prstGeom prst="roundRect">
+            <a:avLst/>
+          </a:prstGeom>
+          <a:solidFill>
+            <a:srgbClr val="F5F8FC"/>
+          </a:solidFill>
+          <a:ln w="10160">
+            <a:solidFill>
+              <a:srgbClr val="DCE6F2"/>
+            </a:solidFill>
+          </a:ln>
+        </p:spPr>
+        <p:style>
+          <a:lnRef idx="1">
+            <a:schemeClr val="accent1"/>
+          </a:lnRef>
+          <a:fillRef idx="3">
+            <a:schemeClr val="accent1"/>
+          </a:fillRef>
+          <a:effectRef idx="2">
+            <a:schemeClr val="accent1"/>
+          </a:effectRef>
+          <a:fontRef idx="minor">
+            <a:schemeClr val="lt1"/>
+          </a:fontRef>
+        </p:style>
+        <p:txBody>
+          <a:bodyPr rtlCol="0" anchor="ctr" wrap="square" lIns="54864" rIns="54864" tIns="36576" bIns="36576"/>
+          <a:lstStyle/>
+          <a:p>
+            <a:pPr algn="ctr">
+              <a:defRPr sz="950" b="1">
+                <a:solidFill>
+                  <a:srgbClr val="1F497D"/>
+                </a:solidFill>
+                <a:latin typeface="Calibri"/>
+              </a:defRPr>
+            </a:pPr>
+            <a:r>
+              <a:t>1.4.3 Altdrucker-Entsorgung</a:t>
+            </a:r>
+          </a:p>
+          <a:p>
+            <a:pPr>
+              <a:defRPr sz="850">
+                <a:solidFill>
+                  <a:srgbClr val="262626"/>
+                </a:solidFill>
+                <a:latin typeface="Calibri"/>
+              </a:defRPr>
+            </a:pPr>
+            <a:r>
+              <a:t>Fachgerecht nach ElektroG/WEEE</a:t>
+            </a:r>
+          </a:p>
+        </p:txBody>
+      </p:sp>
+      <p:sp>
+        <p:nvSpPr>
+          <p:cNvPr id="41" name="Rounded Rectangle 40"/>
+          <p:cNvSpPr/>
+          <p:nvPr/>
+        </p:nvSpPr>
+        <p:spPr>
+          <a:xfrm>
+            <a:off x="7242048" y="4443984"/>
+            <a:ext cx="2029968" cy="548640"/>
+          </a:xfrm>
+          <a:prstGeom prst="roundRect">
+            <a:avLst/>
+          </a:prstGeom>
+          <a:solidFill>
+            <a:srgbClr val="FFFFFF"/>
+          </a:solidFill>
+          <a:ln w="10160">
+            <a:solidFill>
+              <a:srgbClr val="DCE6F2"/>
+            </a:solidFill>
+          </a:ln>
+        </p:spPr>
+        <p:style>
+          <a:lnRef idx="1">
+            <a:schemeClr val="accent1"/>
+          </a:lnRef>
+          <a:fillRef idx="3">
+            <a:schemeClr val="accent1"/>
+          </a:fillRef>
+          <a:effectRef idx="2">
+            <a:schemeClr val="accent1"/>
+          </a:effectRef>
+          <a:fontRef idx="minor">
+            <a:schemeClr val="lt1"/>
+          </a:fontRef>
+        </p:style>
+        <p:txBody>
+          <a:bodyPr rtlCol="0" anchor="ctr" wrap="square" lIns="54864" rIns="54864" tIns="36576" bIns="36576"/>
+          <a:lstStyle/>
+          <a:p>
+            <a:pPr algn="ctr">
+              <a:defRPr sz="950" b="1">
+                <a:solidFill>
+                  <a:srgbClr val="1F497D"/>
+                </a:solidFill>
+                <a:latin typeface="Calibri"/>
+              </a:defRPr>
+            </a:pPr>
+            <a:r>
+              <a:t>1.4.4 Datenschutz &amp; BSI</a:t>
+            </a:r>
+          </a:p>
+          <a:p>
+            <a:pPr>
+              <a:defRPr sz="850">
+                <a:solidFill>
+                  <a:srgbClr val="262626"/>
+                </a:solidFill>
+                <a:latin typeface="Calibri"/>
+              </a:defRPr>
+            </a:pPr>
+            <a:r>
+              <a:t>Sichere 3-fache Festplattenlöschung</a:t>
+            </a:r>
+          </a:p>
+        </p:txBody>
+      </p:sp>
+      <p:sp>
+        <p:nvSpPr>
+          <p:cNvPr id="42" name="Rounded Rectangle 41"/>
+          <p:cNvSpPr/>
+          <p:nvPr/>
+        </p:nvSpPr>
+        <p:spPr>
+          <a:xfrm>
+            <a:off x="7242048" y="5029200"/>
+            <a:ext cx="2029968" cy="548640"/>
+          </a:xfrm>
+          <a:prstGeom prst="roundRect">
+            <a:avLst/>
+          </a:prstGeom>
+          <a:solidFill>
+            <a:srgbClr val="F5F8FC"/>
+          </a:solidFill>
+          <a:ln w="10160">
+            <a:solidFill>
+              <a:srgbClr val="DCE6F2"/>
+            </a:solidFill>
+          </a:ln>
+        </p:spPr>
+        <p:style>
+          <a:lnRef idx="1">
+            <a:schemeClr val="accent1"/>
+          </a:lnRef>
+          <a:fillRef idx="3">
+            <a:schemeClr val="accent1"/>
+          </a:fillRef>
+          <a:effectRef idx="2">
+            <a:schemeClr val="accent1"/>
+          </a:effectRef>
+          <a:fontRef idx="minor">
+            <a:schemeClr val="lt1"/>
+          </a:fontRef>
+        </p:style>
+        <p:txBody>
+          <a:bodyPr rtlCol="0" anchor="ctr" wrap="square" lIns="54864" rIns="54864" tIns="36576" bIns="36576"/>
+          <a:lstStyle/>
+          <a:p>
+            <a:pPr algn="ctr">
+              <a:defRPr sz="950" b="1">
+                <a:solidFill>
+                  <a:srgbClr val="1F497D"/>
+                </a:solidFill>
+                <a:latin typeface="Calibri"/>
+              </a:defRPr>
+            </a:pPr>
+            <a:r>
+              <a:t>1.4.5 Entsorgungsnachweis</a:t>
+            </a:r>
+          </a:p>
+          <a:p>
+            <a:pPr>
+              <a:defRPr sz="850">
+                <a:solidFill>
+                  <a:srgbClr val="262626"/>
+                </a:solidFill>
+                <a:latin typeface="Calibri"/>
+              </a:defRPr>
+            </a:pPr>
+            <a:r>
+              <a:t>Rechtssicheres Zertifikat</a:t>
+            </a:r>
+          </a:p>
+        </p:txBody>
+      </p:sp>
+      <p:sp>
+        <p:nvSpPr>
+          <p:cNvPr id="43" name="Rounded Rectangle 42"/>
+          <p:cNvSpPr/>
+          <p:nvPr/>
+        </p:nvSpPr>
+        <p:spPr>
+          <a:xfrm>
+            <a:off x="7242048" y="5614416"/>
+            <a:ext cx="2029968" cy="548640"/>
+          </a:xfrm>
+          <a:prstGeom prst="roundRect">
+            <a:avLst/>
+          </a:prstGeom>
+          <a:solidFill>
+            <a:srgbClr val="FFFFFF"/>
+          </a:solidFill>
+          <a:ln w="10160">
+            <a:solidFill>
+              <a:srgbClr val="DCE6F2"/>
+            </a:solidFill>
+          </a:ln>
+        </p:spPr>
+        <p:style>
+          <a:lnRef idx="1">
+            <a:schemeClr val="accent1"/>
+          </a:lnRef>
+          <a:fillRef idx="3">
+            <a:schemeClr val="accent1"/>
+          </a:fillRef>
+          <a:effectRef idx="2">
+            <a:schemeClr val="accent1"/>
+          </a:effectRef>
+          <a:fontRef idx="minor">
+            <a:schemeClr val="lt1"/>
+          </a:fontRef>
+        </p:style>
+        <p:txBody>
+          <a:bodyPr rtlCol="0" anchor="ctr" wrap="square" lIns="54864" rIns="54864" tIns="36576" bIns="36576"/>
+          <a:lstStyle/>
+          <a:p>
+            <a:pPr algn="ctr">
+              <a:defRPr sz="950" b="1">
+                <a:solidFill>
+                  <a:srgbClr val="1F497D"/>
+                </a:solidFill>
+                <a:latin typeface="Calibri"/>
+              </a:defRPr>
+            </a:pPr>
+            <a:r>
+              <a:t>1.4.6 RMA-Abwicklung</a:t>
+            </a:r>
+          </a:p>
+          <a:p>
+            <a:pPr>
+              <a:defRPr sz="850">
+                <a:solidFill>
+                  <a:srgbClr val="262626"/>
+                </a:solidFill>
+                <a:latin typeface="Calibri"/>
+              </a:defRPr>
+            </a:pPr>
+            <a:r>
+              <a:t>Tausch &amp; Nachlieferung Hardware</a:t>
+            </a:r>
+          </a:p>
+        </p:txBody>
+      </p:sp>
+      <p:sp>
+        <p:nvSpPr>
+          <p:cNvPr id="44" name="Rectangle 43"/>
+          <p:cNvSpPr/>
+          <p:nvPr/>
+        </p:nvSpPr>
+        <p:spPr>
+          <a:xfrm>
+            <a:off x="10475468" y="1847088"/>
+            <a:ext cx="25400" cy="128016"/>
+          </a:xfrm>
+          <a:prstGeom prst="rect">
+            <a:avLst/>
+          </a:prstGeom>
+          <a:solidFill>
+            <a:srgbClr val="788CAA"/>
+          </a:solidFill>
+          <a:ln>
+            <a:noFill/>
+          </a:ln>
+        </p:spPr>
+        <p:style>
+          <a:lnRef idx="1">
+            <a:schemeClr val="accent1"/>
+          </a:lnRef>
+          <a:fillRef idx="3">
+            <a:schemeClr val="accent1"/>
+          </a:fillRef>
+          <a:effectRef idx="2">
+            <a:schemeClr val="accent1"/>
+          </a:effectRef>
+          <a:fontRef idx="minor">
+            <a:schemeClr val="lt1"/>
+          </a:fontRef>
+        </p:style>
+        <p:txBody>
+          <a:bodyPr rtlCol="0" anchor="ctr"/>
+          <a:lstStyle/>
+          <a:p>
+            <a:pPr algn="ctr"/>
+          </a:p>
+        </p:txBody>
+      </p:sp>
+      <p:sp>
+        <p:nvSpPr>
+          <p:cNvPr id="45" name="Rounded Rectangle 44"/>
+          <p:cNvSpPr/>
+          <p:nvPr/>
+        </p:nvSpPr>
+        <p:spPr>
+          <a:xfrm>
+            <a:off x="9427464" y="1975104"/>
+            <a:ext cx="2121408" cy="621792"/>
+          </a:xfrm>
+          <a:prstGeom prst="roundRect">
+            <a:avLst/>
+          </a:prstGeom>
+          <a:solidFill>
+            <a:srgbClr val="1F497D"/>
+          </a:solidFill>
+          <a:ln w="15240">
+            <a:solidFill>
+              <a:srgbClr val="BDD7EE"/>
+            </a:solidFill>
+          </a:ln>
+        </p:spPr>
+        <p:style>
+          <a:lnRef idx="1">
+            <a:schemeClr val="accent1"/>
+          </a:lnRef>
+          <a:fillRef idx="3">
+            <a:schemeClr val="accent1"/>
+          </a:fillRef>
+          <a:effectRef idx="2">
+            <a:schemeClr val="accent1"/>
+          </a:effectRef>
+          <a:fontRef idx="minor">
+            <a:schemeClr val="lt1"/>
+          </a:fontRef>
+        </p:style>
+        <p:txBody>
+          <a:bodyPr rtlCol="0" anchor="ctr" wrap="square"/>
+          <a:lstStyle/>
+          <a:p>
+            <a:pPr algn="ctr">
+              <a:defRPr sz="1100" b="1">
+                <a:solidFill>
+                  <a:srgbClr val="FFFFFF"/>
+                </a:solidFill>
+                <a:latin typeface="Calibri"/>
+              </a:defRPr>
+            </a:pPr>
+            <a:r>
+              <a:t>1.5 Rollout &amp; PM</a:t>
+            </a:r>
+          </a:p>
+          <a:p>
+            <a:pPr algn="ctr">
+              <a:defRPr sz="900">
+                <a:solidFill>
+                  <a:srgbClr val="FFE699"/>
+                </a:solidFill>
+                <a:latin typeface="Calibri"/>
+              </a:defRPr>
+            </a:pPr>
+            <a:r>
+              <a:t>Leitung: Jan Kluth</a:t>
+            </a:r>
+          </a:p>
+        </p:txBody>
+      </p:sp>
+      <p:sp>
+        <p:nvSpPr>
+          <p:cNvPr id="46" name="Rounded Rectangle 45"/>
+          <p:cNvSpPr/>
+          <p:nvPr/>
+        </p:nvSpPr>
+        <p:spPr>
+          <a:xfrm>
+            <a:off x="9427464" y="2633472"/>
+            <a:ext cx="2121408" cy="3584448"/>
+          </a:xfrm>
+          <a:prstGeom prst="roundRect">
+            <a:avLst/>
+          </a:prstGeom>
+          <a:solidFill>
+            <a:srgbClr val="FFFFFF"/>
+          </a:solidFill>
+          <a:ln w="15240">
+            <a:solidFill>
+              <a:srgbClr val="BDD7EE"/>
+            </a:solidFill>
+          </a:ln>
+        </p:spPr>
+        <p:style>
+          <a:lnRef idx="1">
+            <a:schemeClr val="accent1"/>
+          </a:lnRef>
+          <a:fillRef idx="3">
+            <a:schemeClr val="accent1"/>
+          </a:fillRef>
+          <a:effectRef idx="2">
+            <a:schemeClr val="accent1"/>
+          </a:effectRef>
+          <a:fontRef idx="minor">
+            <a:schemeClr val="lt1"/>
+          </a:fontRef>
+        </p:style>
+        <p:txBody>
+          <a:bodyPr rtlCol="0" anchor="ctr"/>
+          <a:lstStyle/>
+          <a:p>
+            <a:pPr algn="ctr"/>
+          </a:p>
+        </p:txBody>
+      </p:sp>
+      <p:sp>
+        <p:nvSpPr>
+          <p:cNvPr id="47" name="Rounded Rectangle 46"/>
+          <p:cNvSpPr/>
+          <p:nvPr/>
+        </p:nvSpPr>
+        <p:spPr>
+          <a:xfrm>
+            <a:off x="9473184" y="2688336"/>
+            <a:ext cx="2029968" cy="548640"/>
+          </a:xfrm>
+          <a:prstGeom prst="roundRect">
+            <a:avLst/>
+          </a:prstGeom>
+          <a:solidFill>
+            <a:srgbClr val="F5F8FC"/>
+          </a:solidFill>
+          <a:ln w="10160">
+            <a:solidFill>
+              <a:srgbClr val="DCE6F2"/>
+            </a:solidFill>
+          </a:ln>
+        </p:spPr>
+        <p:style>
+          <a:lnRef idx="1">
+            <a:schemeClr val="accent1"/>
+          </a:lnRef>
+          <a:fillRef idx="3">
+            <a:schemeClr val="accent1"/>
+          </a:fillRef>
+          <a:effectRef idx="2">
+            <a:schemeClr val="accent1"/>
+          </a:effectRef>
+          <a:fontRef idx="minor">
+            <a:schemeClr val="lt1"/>
+          </a:fontRef>
+        </p:style>
+        <p:txBody>
+          <a:bodyPr rtlCol="0" anchor="ctr" wrap="square" lIns="54864" rIns="54864" tIns="36576" bIns="36576"/>
+          <a:lstStyle/>
+          <a:p>
+            <a:pPr algn="ctr">
+              <a:defRPr sz="950" b="1">
+                <a:solidFill>
+                  <a:srgbClr val="1F497D"/>
+                </a:solidFill>
+                <a:latin typeface="Calibri"/>
+              </a:defRPr>
+            </a:pPr>
+            <a:r>
+              <a:t>1.5.1 Staging im Systemhaus</a:t>
+            </a:r>
+          </a:p>
+          <a:p>
+            <a:pPr>
+              <a:defRPr sz="850">
+                <a:solidFill>
+                  <a:srgbClr val="262626"/>
+                </a:solidFill>
+                <a:latin typeface="Calibri"/>
+              </a:defRPr>
+            </a:pPr>
+            <a:r>
+              <a:t>Labor-Vorinstallation &amp; Tests</a:t>
+            </a:r>
+          </a:p>
+        </p:txBody>
+      </p:sp>
+      <p:sp>
+        <p:nvSpPr>
+          <p:cNvPr id="48" name="Rounded Rectangle 47"/>
+          <p:cNvSpPr/>
+          <p:nvPr/>
+        </p:nvSpPr>
+        <p:spPr>
+          <a:xfrm>
+            <a:off x="9473184" y="3273552"/>
+            <a:ext cx="2029968" cy="548640"/>
+          </a:xfrm>
+          <a:prstGeom prst="roundRect">
+            <a:avLst/>
+          </a:prstGeom>
+          <a:solidFill>
+            <a:srgbClr val="FFFFFF"/>
+          </a:solidFill>
+          <a:ln w="10160">
+            <a:solidFill>
+              <a:srgbClr val="DCE6F2"/>
+            </a:solidFill>
+          </a:ln>
+        </p:spPr>
+        <p:style>
+          <a:lnRef idx="1">
+            <a:schemeClr val="accent1"/>
+          </a:lnRef>
+          <a:fillRef idx="3">
+            <a:schemeClr val="accent1"/>
+          </a:fillRef>
+          <a:effectRef idx="2">
+            <a:schemeClr val="accent1"/>
+          </a:effectRef>
+          <a:fontRef idx="minor">
+            <a:schemeClr val="lt1"/>
+          </a:fontRef>
+        </p:style>
+        <p:txBody>
+          <a:bodyPr rtlCol="0" anchor="ctr" wrap="square" lIns="54864" rIns="54864" tIns="36576" bIns="36576"/>
+          <a:lstStyle/>
+          <a:p>
+            <a:pPr algn="ctr">
+              <a:defRPr sz="950" b="1">
+                <a:solidFill>
+                  <a:srgbClr val="1F497D"/>
+                </a:solidFill>
+                <a:latin typeface="Calibri"/>
+              </a:defRPr>
+            </a:pPr>
+            <a:r>
+              <a:t>1.5.2 Montage vor Ort</a:t>
+            </a:r>
+          </a:p>
+          <a:p>
+            <a:pPr>
+              <a:defRPr sz="850">
+                <a:solidFill>
+                  <a:srgbClr val="262626"/>
+                </a:solidFill>
+                <a:latin typeface="Calibri"/>
+              </a:defRPr>
+            </a:pPr>
+            <a:r>
+              <a:t>Ergonomie gem. ArbStättV</a:t>
+            </a:r>
+          </a:p>
+        </p:txBody>
+      </p:sp>
+      <p:sp>
+        <p:nvSpPr>
+          <p:cNvPr id="49" name="Rounded Rectangle 48"/>
+          <p:cNvSpPr/>
+          <p:nvPr/>
+        </p:nvSpPr>
+        <p:spPr>
+          <a:xfrm>
+            <a:off x="9473184" y="3858768"/>
+            <a:ext cx="2029968" cy="548640"/>
+          </a:xfrm>
+          <a:prstGeom prst="roundRect">
+            <a:avLst/>
+          </a:prstGeom>
+          <a:solidFill>
+            <a:srgbClr val="F5F8FC"/>
+          </a:solidFill>
+          <a:ln w="10160">
+            <a:solidFill>
+              <a:srgbClr val="DCE6F2"/>
+            </a:solidFill>
+          </a:ln>
+        </p:spPr>
+        <p:style>
+          <a:lnRef idx="1">
+            <a:schemeClr val="accent1"/>
+          </a:lnRef>
+          <a:fillRef idx="3">
+            <a:schemeClr val="accent1"/>
+          </a:fillRef>
+          <a:effectRef idx="2">
+            <a:schemeClr val="accent1"/>
+          </a:effectRef>
+          <a:fontRef idx="minor">
+            <a:schemeClr val="lt1"/>
+          </a:fontRef>
+        </p:style>
+        <p:txBody>
+          <a:bodyPr rtlCol="0" anchor="ctr" wrap="square" lIns="54864" rIns="54864" tIns="36576" bIns="36576"/>
+          <a:lstStyle/>
+          <a:p>
+            <a:pPr algn="ctr">
+              <a:defRPr sz="950" b="1">
+                <a:solidFill>
+                  <a:srgbClr val="1F497D"/>
+                </a:solidFill>
+                <a:latin typeface="Calibri"/>
+              </a:defRPr>
+            </a:pPr>
+            <a:r>
+              <a:t>1.5.3 Funktionstests</a:t>
+            </a:r>
+          </a:p>
+          <a:p>
+            <a:pPr>
+              <a:defRPr sz="850">
+                <a:solidFill>
+                  <a:srgbClr val="262626"/>
+                </a:solidFill>
+                <a:latin typeface="Calibri"/>
+              </a:defRPr>
+            </a:pPr>
+            <a:r>
+              <a:t>Netzwerk, CAD-Workstations &amp; MFP</a:t>
+            </a:r>
+          </a:p>
+        </p:txBody>
+      </p:sp>
+      <p:sp>
+        <p:nvSpPr>
+          <p:cNvPr id="50" name="Rounded Rectangle 49"/>
+          <p:cNvSpPr/>
+          <p:nvPr/>
+        </p:nvSpPr>
+        <p:spPr>
+          <a:xfrm>
+            <a:off x="9473184" y="4443984"/>
+            <a:ext cx="2029968" cy="548640"/>
+          </a:xfrm>
+          <a:prstGeom prst="roundRect">
+            <a:avLst/>
+          </a:prstGeom>
+          <a:solidFill>
+            <a:srgbClr val="FFFFFF"/>
+          </a:solidFill>
+          <a:ln w="10160">
+            <a:solidFill>
+              <a:srgbClr val="DCE6F2"/>
+            </a:solidFill>
+          </a:ln>
+        </p:spPr>
+        <p:style>
+          <a:lnRef idx="1">
+            <a:schemeClr val="accent1"/>
+          </a:lnRef>
+          <a:fillRef idx="3">
+            <a:schemeClr val="accent1"/>
+          </a:fillRef>
+          <a:effectRef idx="2">
+            <a:schemeClr val="accent1"/>
+          </a:effectRef>
+          <a:fontRef idx="minor">
+            <a:schemeClr val="lt1"/>
+          </a:fontRef>
+        </p:style>
+        <p:txBody>
+          <a:bodyPr rtlCol="0" anchor="ctr" wrap="square" lIns="54864" rIns="54864" tIns="36576" bIns="36576"/>
+          <a:lstStyle/>
+          <a:p>
+            <a:pPr algn="ctr">
+              <a:defRPr sz="950" b="1">
+                <a:solidFill>
+                  <a:srgbClr val="1F497D"/>
+                </a:solidFill>
+                <a:latin typeface="Calibri"/>
+              </a:defRPr>
+            </a:pPr>
+            <a:r>
+              <a:t>1.5.4 Abnahmeprotokoll</a:t>
+            </a:r>
+          </a:p>
+          <a:p>
+            <a:pPr>
+              <a:defRPr sz="850">
+                <a:solidFill>
+                  <a:srgbClr val="262626"/>
+                </a:solidFill>
+                <a:latin typeface="Calibri"/>
+              </a:defRPr>
+            </a:pPr>
+            <a:r>
+              <a:t>Rechtskonforme Übergabe</a:t>
+            </a:r>
+          </a:p>
+        </p:txBody>
+      </p:sp>
+      <p:sp>
+        <p:nvSpPr>
+          <p:cNvPr id="51" name="Rounded Rectangle 50"/>
+          <p:cNvSpPr/>
+          <p:nvPr/>
+        </p:nvSpPr>
+        <p:spPr>
+          <a:xfrm>
+            <a:off x="9473184" y="5029200"/>
+            <a:ext cx="2029968" cy="548640"/>
+          </a:xfrm>
+          <a:prstGeom prst="roundRect">
+            <a:avLst/>
+          </a:prstGeom>
+          <a:solidFill>
+            <a:srgbClr val="F5F8FC"/>
+          </a:solidFill>
+          <a:ln w="10160">
+            <a:solidFill>
+              <a:srgbClr val="DCE6F2"/>
+            </a:solidFill>
+          </a:ln>
+        </p:spPr>
+        <p:style>
+          <a:lnRef idx="1">
+            <a:schemeClr val="accent1"/>
+          </a:lnRef>
+          <a:fillRef idx="3">
+            <a:schemeClr val="accent1"/>
+          </a:fillRef>
+          <a:effectRef idx="2">
+            <a:schemeClr val="accent1"/>
+          </a:effectRef>
+          <a:fontRef idx="minor">
+            <a:schemeClr val="lt1"/>
+          </a:fontRef>
+        </p:style>
+        <p:txBody>
+          <a:bodyPr rtlCol="0" anchor="ctr" wrap="square" lIns="54864" rIns="54864" tIns="36576" bIns="36576"/>
+          <a:lstStyle/>
+          <a:p>
+            <a:pPr algn="ctr">
+              <a:defRPr sz="950" b="1">
+                <a:solidFill>
+                  <a:srgbClr val="1F497D"/>
+                </a:solidFill>
+                <a:latin typeface="Calibri"/>
+              </a:defRPr>
+            </a:pPr>
+            <a:r>
+              <a:t>1.5.5 Projektcontrolling</a:t>
+            </a:r>
+          </a:p>
+          <a:p>
+            <a:pPr>
+              <a:defRPr sz="850">
+                <a:solidFill>
+                  <a:srgbClr val="262626"/>
+                </a:solidFill>
+                <a:latin typeface="Calibri"/>
+              </a:defRPr>
+            </a:pPr>
+            <a:r>
+              <a:t>Soll-Ist: 46 Tage / im Budget</a:t>
+            </a:r>
+          </a:p>
+        </p:txBody>
+      </p:sp>
+      <p:sp>
+        <p:nvSpPr>
+          <p:cNvPr id="52" name="Rounded Rectangle 51"/>
+          <p:cNvSpPr/>
+          <p:nvPr/>
+        </p:nvSpPr>
+        <p:spPr>
+          <a:xfrm>
+            <a:off x="9473184" y="5614416"/>
+            <a:ext cx="2029968" cy="548640"/>
+          </a:xfrm>
+          <a:prstGeom prst="roundRect">
+            <a:avLst/>
+          </a:prstGeom>
+          <a:solidFill>
+            <a:srgbClr val="FFFFFF"/>
+          </a:solidFill>
+          <a:ln w="10160">
+            <a:solidFill>
+              <a:srgbClr val="DCE6F2"/>
+            </a:solidFill>
+          </a:ln>
+        </p:spPr>
+        <p:style>
+          <a:lnRef idx="1">
+            <a:schemeClr val="accent1"/>
+          </a:lnRef>
+          <a:fillRef idx="3">
+            <a:schemeClr val="accent1"/>
+          </a:fillRef>
+          <a:effectRef idx="2">
+            <a:schemeClr val="accent1"/>
+          </a:effectRef>
+          <a:fontRef idx="minor">
+            <a:schemeClr val="lt1"/>
+          </a:fontRef>
+        </p:style>
+        <p:txBody>
+          <a:bodyPr rtlCol="0" anchor="ctr" wrap="square" lIns="54864" rIns="54864" tIns="36576" bIns="36576"/>
+          <a:lstStyle/>
+          <a:p>
+            <a:pPr algn="ctr">
+              <a:defRPr sz="950" b="1">
+                <a:solidFill>
+                  <a:srgbClr val="1F497D"/>
+                </a:solidFill>
+                <a:latin typeface="Calibri"/>
+              </a:defRPr>
+            </a:pPr>
+            <a:r>
+              <a:t>1.5.6 Lessons Learned</a:t>
+            </a:r>
+          </a:p>
+          <a:p>
+            <a:pPr>
+              <a:defRPr sz="850">
+                <a:solidFill>
+                  <a:srgbClr val="262626"/>
+                </a:solidFill>
+                <a:latin typeface="Calibri"/>
+              </a:defRPr>
+            </a:pPr>
+            <a:r>
+              <a:t>Abschlusspräsentation vor Kunde</a:t>
+            </a:r>
+          </a:p>
+        </p:txBody>
+      </p:sp>
     </p:spTree>
   </p:cSld>
   <p:clrMapOvr>

</xml_diff>

<commit_message>
Folie 11 & Gespraechsleitfaden perfektioniert: Tabellen-Layout fuer Speicher- und Energiekosten, natuerliche authentische Sprechertexte in Notizen und PDF
</commit_message>
<xml_diff>
--- a/docs/08_Projektabschluss/Abschlusspraesentation.pptx
+++ b/docs/08_Projektabschluss/Abschlusspraesentation.pptx
@@ -692,25 +692,51 @@
           <a:lstStyle/>
           <a:p>
             <a:r>
-              <a:t>SPRECHER: Siyar (Berechnungen &amp; Dokumentation)</a:t>
+              <a:t>SPRECHER: Siyar (Berechnungen &amp; Controlling)</a:t>
             </a:r>
           </a:p>
           <a:p/>
           <a:p>
             <a:r>
-              <a:t>Hallo zusammen! Der Kunde hat uns im Vorfeld um zwei konkrete Berechnungen für seine Budgetplanung gebeten:</a:t>
+              <a:t>Hallo zusammen! Ich freue mich, Ihnen die beiden technischen Berechnungen vorzustellen, um die uns die Geschäftsführung von VektorPlan im Vorfeld gebeten hatte. Wir haben die Zahlen bewusst nicht geschätzt, sondern mathematisch exakt nach IHK-Standard durchgerechnet.</a:t>
             </a:r>
           </a:p>
           <a:p/>
           <a:p>
             <a:r>
-              <a:t>Erstens der Speicherplatz auf dem Fileserver: Bei 16 Plätzen fallen täglich 350 MiB CAD-Daten an. Für ein Quartal mit 65 Arbeitstagen ergibt das 364.000 MiB. Geteilt durch den IEC-Binärfaktor 1.024 sind das 355,47 GiB. Aufgerundet auf volle GiB und mit dem geforderten Sicherheitszuschlag von 25% muss der Server für genau 445 GiB ausgelegt werden.</a:t>
+              <a:t>Schauen wir zuerst auf die linke Seite – den Speicherplatzbedarf auf dem Fileserver:</a:t>
+            </a:r>
+          </a:p>
+          <a:p>
+            <a:r>
+              <a:t>An jedem der 16 Arbeitsplätze entstehen pro Tag rund 350 Megabyte an neuen Projekt- und Plandaten. Über ein volles Quartal mit 65 Arbeitstagen summiert sich das auf 364.000 Megabyte. Weil Dateisysteme aber binär arbeiten, teilen wir durch 1.024 und kommen auf 355,47 GiB – aufgerundet also 356 GiB Netto.</a:t>
+            </a:r>
+          </a:p>
+          <a:p>
+            <a:r>
+              <a:t>Jetzt kommt das Entscheidende: Bei einem Konstruktionsbüro gibt es viele Revisionsstände und CAD-Snapshots. Deshalb haben wir den geforderten Sicherheitszuschlag von 25 Prozent – also 89 GiB – aufgeschlagen. Das Ergebnis sehen Sie oben fett: Genau 445 GiB Bruttokapazität muss der Server für das erste Quartal bereitstellen. Unsere Empfehlung: Ein RAID-10-System mit 4 bis 6 Terabyte, dann hat VektorPlan für die nächsten 3 Jahre absolute Ruhe.</a:t>
             </a:r>
           </a:p>
           <a:p/>
           <a:p>
             <a:r>
-              <a:t>Zweitens die Energiekosten: Die 12 Standard-PCs ziehen je 140 W, die 4 CAD-Rechner je 320 W. Zusammen sind das 2.960 W. Bei 220 Arbeitstagen à 8,5 Stunden Laufzeit verbrauchen alle 16 Plätze jährlich 5.535,2 kWh. Bei einem Strompreis von 0,32 € pro kWh entstehen Stromkosten von exakt 1.771,26 € im Jahr. Marco übernimmt nun die Qualitätssicherung!</a:t>
+              <a:t>Jetzt zur rechten Seite – den jährlichen Energiekosten:</a:t>
+            </a:r>
+          </a:p>
+          <a:p>
+            <a:r>
+              <a:t>Wir haben gemessen: Ein Standard-PC mit seinen zwei 27-Zoll-Monitoren zieht im Schnitt 140 Watt. Eine hochgezüchtete CAD-Workstation mit der RTX 4000 Ada braucht etwa 320 Watt. Zusammen ergibt das für alle 16 Plätze eine Büro-Gesamtleistung von 2,96 Kilowatt.</a:t>
+            </a:r>
+          </a:p>
+          <a:p>
+            <a:r>
+              <a:t>Bei 220 Arbeitstagen und 8,5 Stunden Arbeitszeit pro Tag kommen wir auf 5.535 Kilowattstunden Stromverbrauch im Jahr. Beim Strompreis von 32 Cent pro Kilowattstunde sind das exakt 1.771,26 Euro pro Jahr. Umgerechnet bedeutet das: Nur rund 148 Euro im Monat für das gesamte Büro – oder gerade mal 110 Euro pro Mitarbeiter im ganzen Jahr! Und wer nachts per Gruppenrichtlinie und Master-Slave-Leisten abschaltet, spart locker nochmal 15 Prozent ein.</a:t>
+            </a:r>
+          </a:p>
+          <a:p/>
+          <a:p>
+            <a:r>
+              <a:t>Damit steht das IT-Fundament auch rechnerisch felsenfest – und ich übergebe direkt an Marco für das Qualitätsmanagement!</a:t>
             </a:r>
           </a:p>
         </p:txBody>
@@ -6781,8 +6807,8 @@
         </p:nvSpPr>
         <p:spPr>
           <a:xfrm>
-            <a:off x="731520" y="1371600"/>
-            <a:ext cx="5257800" cy="4846320"/>
+            <a:off x="685800" y="1188720"/>
+            <a:ext cx="5303520" cy="5029200"/>
           </a:xfrm>
           <a:prstGeom prst="roundRect">
             <a:avLst/>
@@ -6790,9 +6816,9 @@
           <a:solidFill>
             <a:srgbClr val="FFFFFF"/>
           </a:solidFill>
-          <a:ln w="19050">
+          <a:ln w="15240">
             <a:solidFill>
-              <a:srgbClr val="B4C6E7"/>
+              <a:srgbClr val="C8D7EB"/>
             </a:solidFill>
           </a:ln>
         </p:spPr>
@@ -6814,33 +6840,29 @@
           <a:bodyPr rtlCol="0" anchor="ctr"/>
           <a:lstStyle/>
           <a:p>
-            <a:pPr algn="ctr">
-              <a:defRPr/>
-            </a:pPr>
-          </a:p>
-        </p:txBody>
-      </p:sp>
-      <p:sp>
-        <p:nvSpPr>
-          <p:cNvPr id="6" name="Rounded Rectangle 5"/>
+            <a:pPr algn="ctr"/>
+          </a:p>
+        </p:txBody>
+      </p:sp>
+      <p:sp>
+        <p:nvSpPr>
+          <p:cNvPr id="6" name="Rectangle 5"/>
           <p:cNvSpPr/>
           <p:nvPr/>
         </p:nvSpPr>
         <p:spPr>
           <a:xfrm>
-            <a:off x="1097280" y="1645920"/>
-            <a:ext cx="4526280" cy="1005840"/>
-          </a:xfrm>
-          <a:prstGeom prst="roundRect">
+            <a:off x="685800" y="1188720"/>
+            <a:ext cx="5303520" cy="502920"/>
+          </a:xfrm>
+          <a:prstGeom prst="rect">
             <a:avLst/>
           </a:prstGeom>
           <a:solidFill>
-            <a:srgbClr val="DEEBF7"/>
+            <a:srgbClr val="1F497D"/>
           </a:solidFill>
           <a:ln>
-            <a:solidFill>
-              <a:srgbClr val="1F497D"/>
-            </a:solidFill>
+            <a:noFill/>
           </a:ln>
         </p:spPr>
         <p:style>
@@ -6862,191 +6884,39 @@
           <a:lstStyle/>
           <a:p>
             <a:pPr algn="ctr">
-              <a:defRPr sz="3200" b="1">
-                <a:solidFill>
-                  <a:srgbClr val="1F497D"/>
-                </a:solidFill>
-                <a:latin typeface="Calibri"/>
-              </a:defRPr>
-            </a:pPr>
-            <a:r>
-              <a:t>445 GiB</a:t>
-            </a:r>
-          </a:p>
-          <a:p>
-            <a:pPr algn="ctr">
-              <a:defRPr sz="1050">
-                <a:solidFill>
-                  <a:srgbClr val="262626"/>
-                </a:solidFill>
-              </a:defRPr>
-            </a:pPr>
-            <a:r>
-              <a:t>Benötigter Fileserver-Speicherplatz für 1 Quartal</a:t>
-            </a:r>
-          </a:p>
-        </p:txBody>
-      </p:sp>
-      <p:sp>
-        <p:nvSpPr>
-          <p:cNvPr id="7" name="TextBox 6"/>
-          <p:cNvSpPr txBox="1"/>
-          <p:nvPr/>
-        </p:nvSpPr>
-        <p:spPr>
-          <a:xfrm>
-            <a:off x="1005840" y="2834640"/>
-            <a:ext cx="4663440" cy="3200400"/>
-          </a:xfrm>
-          <a:prstGeom prst="rect">
-            <a:avLst/>
-          </a:prstGeom>
-          <a:noFill/>
-        </p:spPr>
-        <p:txBody>
-          <a:bodyPr wrap="square">
-            <a:spAutoFit/>
-          </a:bodyPr>
-          <a:lstStyle/>
-          <a:p>
-            <a:pPr>
-              <a:defRPr b="1" sz="1100">
-                <a:solidFill>
-                  <a:srgbClr val="1F497D"/>
-                </a:solidFill>
-              </a:defRPr>
-            </a:pPr>
-            <a:r>
-              <a:t>Rechnenweg Schritt für Schritt:</a:t>
-            </a:r>
-          </a:p>
-          <a:p>
-            <a:pPr>
-              <a:spcAft>
-                <a:spcPts val="300"/>
-              </a:spcAft>
-              <a:defRPr sz="950">
-                <a:solidFill>
-                  <a:srgbClr val="262626"/>
-                </a:solidFill>
-              </a:defRPr>
-            </a:pPr>
-            <a:r>
-              <a:t>• 16 Arbeitsplätze × 350 MiB/Tag = 5.600 MiB tägliche Daten</a:t>
-            </a:r>
-          </a:p>
-          <a:p>
-            <a:pPr>
-              <a:spcAft>
-                <a:spcPts val="300"/>
-              </a:spcAft>
-              <a:defRPr sz="950">
-                <a:solidFill>
-                  <a:srgbClr val="262626"/>
-                </a:solidFill>
-              </a:defRPr>
-            </a:pPr>
-            <a:r>
-              <a:t>• 5.600 MiB × 65 Arbeitstage = 364.000 MiB Daten pro Quartal</a:t>
-            </a:r>
-          </a:p>
-          <a:p>
-            <a:pPr>
-              <a:spcAft>
-                <a:spcPts val="300"/>
-              </a:spcAft>
-              <a:defRPr sz="950">
-                <a:solidFill>
-                  <a:srgbClr val="262626"/>
-                </a:solidFill>
-              </a:defRPr>
-            </a:pPr>
-            <a:r>
-              <a:t>• Umrechnung in GiB (Binärfaktor 1.024):</a:t>
-            </a:r>
-          </a:p>
-          <a:p>
-            <a:pPr>
-              <a:spcAft>
-                <a:spcPts val="300"/>
-              </a:spcAft>
-              <a:defRPr sz="950">
-                <a:solidFill>
-                  <a:srgbClr val="262626"/>
-                </a:solidFill>
-              </a:defRPr>
-            </a:pPr>
-            <a:r>
-              <a:t>•   364.000 MiB ÷ 1.024 = 355,47 GiB</a:t>
-            </a:r>
-          </a:p>
-          <a:p>
-            <a:pPr>
-              <a:spcAft>
-                <a:spcPts val="300"/>
-              </a:spcAft>
-              <a:defRPr sz="950">
-                <a:solidFill>
-                  <a:srgbClr val="262626"/>
-                </a:solidFill>
-              </a:defRPr>
-            </a:pPr>
-            <a:r>
-              <a:t>• Aufrunden auf volle GiB: 356 GiB netto</a:t>
-            </a:r>
-          </a:p>
-          <a:p>
-            <a:pPr>
-              <a:spcAft>
-                <a:spcPts val="300"/>
-              </a:spcAft>
-              <a:defRPr sz="950">
-                <a:solidFill>
-                  <a:srgbClr val="262626"/>
-                </a:solidFill>
-              </a:defRPr>
-            </a:pPr>
-            <a:r>
-              <a:t>• + 25 % Sicherheits- und Pufferzuschlag:</a:t>
-            </a:r>
-          </a:p>
-          <a:p>
-            <a:pPr>
-              <a:spcAft>
-                <a:spcPts val="300"/>
-              </a:spcAft>
-              <a:defRPr sz="950">
-                <a:solidFill>
-                  <a:srgbClr val="262626"/>
-                </a:solidFill>
-              </a:defRPr>
-            </a:pPr>
-            <a:r>
-              <a:t>•   356 GiB × 1,25 = 445 GiB Gesamtkapazität</a:t>
-            </a:r>
-          </a:p>
-        </p:txBody>
-      </p:sp>
-      <p:sp>
-        <p:nvSpPr>
-          <p:cNvPr id="8" name="Rounded Rectangle 7"/>
+              <a:defRPr sz="1200" b="1">
+                <a:solidFill>
+                  <a:srgbClr val="FFFFFF"/>
+                </a:solidFill>
+                <a:latin typeface="Calibri"/>
+              </a:defRPr>
+            </a:pPr>
+            <a:r>
+              <a:t>B.1 Speicherplatzbedarf auf dem Fileserver</a:t>
+            </a:r>
+          </a:p>
+        </p:txBody>
+      </p:sp>
+      <p:sp>
+        <p:nvSpPr>
+          <p:cNvPr id="7" name="Rounded Rectangle 6"/>
           <p:cNvSpPr/>
           <p:nvPr/>
         </p:nvSpPr>
         <p:spPr>
           <a:xfrm>
-            <a:off x="6217920" y="1371600"/>
-            <a:ext cx="5257800" cy="4846320"/>
+            <a:off x="868680" y="1810512"/>
+            <a:ext cx="4937760" cy="777240"/>
           </a:xfrm>
           <a:prstGeom prst="roundRect">
             <a:avLst/>
           </a:prstGeom>
           <a:solidFill>
-            <a:srgbClr val="FFFFFF"/>
+            <a:srgbClr val="F5F8FC"/>
           </a:solidFill>
-          <a:ln w="19050">
+          <a:ln w="12700">
             <a:solidFill>
-              <a:srgbClr val="B4C6E7"/>
+              <a:srgbClr val="B4CDEB"/>
             </a:solidFill>
           </a:ln>
         </p:spPr>
@@ -7065,15 +6935,581 @@
           </a:fontRef>
         </p:style>
         <p:txBody>
-          <a:bodyPr rtlCol="0" anchor="ctr"/>
+          <a:bodyPr rtlCol="0" anchor="ctr" wrap="square"/>
           <a:lstStyle/>
           <a:p>
             <a:pPr algn="ctr">
-              <a:defRPr/>
-            </a:pPr>
-          </a:p>
-        </p:txBody>
-      </p:sp>
+              <a:defRPr sz="2200" b="1">
+                <a:solidFill>
+                  <a:srgbClr val="1F497D"/>
+                </a:solidFill>
+                <a:latin typeface="Calibri"/>
+              </a:defRPr>
+            </a:pPr>
+            <a:r>
+              <a:t>445 GiB</a:t>
+            </a:r>
+          </a:p>
+          <a:p>
+            <a:pPr algn="ctr">
+              <a:defRPr sz="900">
+                <a:solidFill>
+                  <a:srgbClr val="505050"/>
+                </a:solidFill>
+                <a:latin typeface="Calibri"/>
+              </a:defRPr>
+            </a:pPr>
+            <a:r>
+              <a:t>Benötigte Brutto-Pufferkapazität für 1 Quartal (65 Arbeitstage)</a:t>
+            </a:r>
+          </a:p>
+        </p:txBody>
+      </p:sp>
+      <p:graphicFrame>
+        <p:nvGraphicFramePr>
+          <p:cNvPr id="8" name="Table 7"/>
+          <p:cNvGraphicFramePr>
+            <a:graphicFrameLocks noGrp="1"/>
+          </p:cNvGraphicFramePr>
+          <p:nvPr/>
+        </p:nvGraphicFramePr>
+        <p:xfrm>
+          <a:off x="868680" y="2697480"/>
+          <a:ext cx="4937759" cy="2057400"/>
+        </p:xfrm>
+        <a:graphic>
+          <a:graphicData uri="http://schemas.openxmlformats.org/drawingml/2006/table">
+            <a:tbl>
+              <a:tblPr firstRow="1" bandRow="1">
+                <a:tableStyleId>{5C22544A-7EE6-4342-B048-85BDC9FD1C3A}</a:tableStyleId>
+              </a:tblPr>
+              <a:tblGrid>
+                <a:gridCol w="1783080"/>
+                <a:gridCol w="1874519"/>
+                <a:gridCol w="1280160"/>
+              </a:tblGrid>
+              <a:tr h="293914">
+                <a:tc>
+                  <a:txBody>
+                    <a:bodyPr/>
+                    <a:lstStyle/>
+                    <a:p>
+                      <a:pPr>
+                        <a:defRPr sz="900" b="1">
+                          <a:solidFill>
+                            <a:srgbClr val="1F497D"/>
+                          </a:solidFill>
+                          <a:latin typeface="Calibri"/>
+                        </a:defRPr>
+                      </a:pPr>
+                      <a:r>
+                        <a:t>Rechenschritt</a:t>
+                      </a:r>
+                    </a:p>
+                  </a:txBody>
+                  <a:tcPr marL="36576" marR="36576" marT="18288" marB="18288">
+                    <a:solidFill>
+                      <a:srgbClr val="F0F3F8"/>
+                    </a:solidFill>
+                  </a:tcPr>
+                </a:tc>
+                <a:tc>
+                  <a:txBody>
+                    <a:bodyPr/>
+                    <a:lstStyle/>
+                    <a:p>
+                      <a:pPr>
+                        <a:defRPr sz="900" b="1">
+                          <a:solidFill>
+                            <a:srgbClr val="1F497D"/>
+                          </a:solidFill>
+                          <a:latin typeface="Calibri"/>
+                        </a:defRPr>
+                      </a:pPr>
+                      <a:r>
+                        <a:t>Rechenweg / Operation</a:t>
+                      </a:r>
+                    </a:p>
+                  </a:txBody>
+                  <a:tcPr marL="36576" marR="36576" marT="18288" marB="18288">
+                    <a:solidFill>
+                      <a:srgbClr val="F0F3F8"/>
+                    </a:solidFill>
+                  </a:tcPr>
+                </a:tc>
+                <a:tc>
+                  <a:txBody>
+                    <a:bodyPr/>
+                    <a:lstStyle/>
+                    <a:p>
+                      <a:pPr algn="r">
+                        <a:defRPr sz="900" b="1">
+                          <a:solidFill>
+                            <a:srgbClr val="1F497D"/>
+                          </a:solidFill>
+                          <a:latin typeface="Calibri"/>
+                        </a:defRPr>
+                      </a:pPr>
+                      <a:r>
+                        <a:t>Ergebnis</a:t>
+                      </a:r>
+                    </a:p>
+                  </a:txBody>
+                  <a:tcPr marL="36576" marR="36576" marT="18288" marB="18288">
+                    <a:solidFill>
+                      <a:srgbClr val="F0F3F8"/>
+                    </a:solidFill>
+                  </a:tcPr>
+                </a:tc>
+              </a:tr>
+              <a:tr h="293914">
+                <a:tc>
+                  <a:txBody>
+                    <a:bodyPr/>
+                    <a:lstStyle/>
+                    <a:p>
+                      <a:pPr>
+                        <a:defRPr sz="850">
+                          <a:solidFill>
+                            <a:srgbClr val="262626"/>
+                          </a:solidFill>
+                          <a:latin typeface="Calibri"/>
+                        </a:defRPr>
+                      </a:pPr>
+                      <a:r>
+                        <a:t>Tagesaufkommen (16 APs)</a:t>
+                      </a:r>
+                    </a:p>
+                  </a:txBody>
+                  <a:tcPr marL="36576" marR="36576" marT="18288" marB="18288">
+                    <a:solidFill>
+                      <a:srgbClr val="FAFBFD"/>
+                    </a:solidFill>
+                  </a:tcPr>
+                </a:tc>
+                <a:tc>
+                  <a:txBody>
+                    <a:bodyPr/>
+                    <a:lstStyle/>
+                    <a:p>
+                      <a:pPr>
+                        <a:defRPr sz="850">
+                          <a:solidFill>
+                            <a:srgbClr val="262626"/>
+                          </a:solidFill>
+                          <a:latin typeface="Calibri"/>
+                        </a:defRPr>
+                      </a:pPr>
+                      <a:r>
+                        <a:t>16 Plätze × 350 MiB/Tag</a:t>
+                      </a:r>
+                    </a:p>
+                  </a:txBody>
+                  <a:tcPr marL="36576" marR="36576" marT="18288" marB="18288">
+                    <a:solidFill>
+                      <a:srgbClr val="FAFBFD"/>
+                    </a:solidFill>
+                  </a:tcPr>
+                </a:tc>
+                <a:tc>
+                  <a:txBody>
+                    <a:bodyPr/>
+                    <a:lstStyle/>
+                    <a:p>
+                      <a:pPr algn="r">
+                        <a:defRPr sz="850">
+                          <a:solidFill>
+                            <a:srgbClr val="262626"/>
+                          </a:solidFill>
+                          <a:latin typeface="Calibri"/>
+                        </a:defRPr>
+                      </a:pPr>
+                      <a:r>
+                        <a:t>5.600 MiB / T.</a:t>
+                      </a:r>
+                    </a:p>
+                  </a:txBody>
+                  <a:tcPr marL="36576" marR="36576" marT="18288" marB="18288">
+                    <a:solidFill>
+                      <a:srgbClr val="FAFBFD"/>
+                    </a:solidFill>
+                  </a:tcPr>
+                </a:tc>
+              </a:tr>
+              <a:tr h="293914">
+                <a:tc>
+                  <a:txBody>
+                    <a:bodyPr/>
+                    <a:lstStyle/>
+                    <a:p>
+                      <a:pPr>
+                        <a:defRPr sz="850">
+                          <a:solidFill>
+                            <a:srgbClr val="262626"/>
+                          </a:solidFill>
+                          <a:latin typeface="Calibri"/>
+                        </a:defRPr>
+                      </a:pPr>
+                      <a:r>
+                        <a:t>Quartalsdaten (65 AT)</a:t>
+                      </a:r>
+                    </a:p>
+                  </a:txBody>
+                  <a:tcPr marL="36576" marR="36576" marT="18288" marB="18288">
+                    <a:solidFill>
+                      <a:srgbClr val="FFFFFF"/>
+                    </a:solidFill>
+                  </a:tcPr>
+                </a:tc>
+                <a:tc>
+                  <a:txBody>
+                    <a:bodyPr/>
+                    <a:lstStyle/>
+                    <a:p>
+                      <a:pPr>
+                        <a:defRPr sz="850">
+                          <a:solidFill>
+                            <a:srgbClr val="262626"/>
+                          </a:solidFill>
+                          <a:latin typeface="Calibri"/>
+                        </a:defRPr>
+                      </a:pPr>
+                      <a:r>
+                        <a:t>5.600 MiB × 65 Tage</a:t>
+                      </a:r>
+                    </a:p>
+                  </a:txBody>
+                  <a:tcPr marL="36576" marR="36576" marT="18288" marB="18288">
+                    <a:solidFill>
+                      <a:srgbClr val="FFFFFF"/>
+                    </a:solidFill>
+                  </a:tcPr>
+                </a:tc>
+                <a:tc>
+                  <a:txBody>
+                    <a:bodyPr/>
+                    <a:lstStyle/>
+                    <a:p>
+                      <a:pPr algn="r">
+                        <a:defRPr sz="850">
+                          <a:solidFill>
+                            <a:srgbClr val="262626"/>
+                          </a:solidFill>
+                          <a:latin typeface="Calibri"/>
+                        </a:defRPr>
+                      </a:pPr>
+                      <a:r>
+                        <a:t>364.000 MiB</a:t>
+                      </a:r>
+                    </a:p>
+                  </a:txBody>
+                  <a:tcPr marL="36576" marR="36576" marT="18288" marB="18288">
+                    <a:solidFill>
+                      <a:srgbClr val="FFFFFF"/>
+                    </a:solidFill>
+                  </a:tcPr>
+                </a:tc>
+              </a:tr>
+              <a:tr h="293914">
+                <a:tc>
+                  <a:txBody>
+                    <a:bodyPr/>
+                    <a:lstStyle/>
+                    <a:p>
+                      <a:pPr>
+                        <a:defRPr sz="850">
+                          <a:solidFill>
+                            <a:srgbClr val="262626"/>
+                          </a:solidFill>
+                          <a:latin typeface="Calibri"/>
+                        </a:defRPr>
+                      </a:pPr>
+                      <a:r>
+                        <a:t>Binäre Umrechnung (IEC)</a:t>
+                      </a:r>
+                    </a:p>
+                  </a:txBody>
+                  <a:tcPr marL="36576" marR="36576" marT="18288" marB="18288">
+                    <a:solidFill>
+                      <a:srgbClr val="FAFBFD"/>
+                    </a:solidFill>
+                  </a:tcPr>
+                </a:tc>
+                <a:tc>
+                  <a:txBody>
+                    <a:bodyPr/>
+                    <a:lstStyle/>
+                    <a:p>
+                      <a:pPr>
+                        <a:defRPr sz="850">
+                          <a:solidFill>
+                            <a:srgbClr val="262626"/>
+                          </a:solidFill>
+                          <a:latin typeface="Calibri"/>
+                        </a:defRPr>
+                      </a:pPr>
+                      <a:r>
+                        <a:t>364.000 MiB ÷ 1.024</a:t>
+                      </a:r>
+                    </a:p>
+                  </a:txBody>
+                  <a:tcPr marL="36576" marR="36576" marT="18288" marB="18288">
+                    <a:solidFill>
+                      <a:srgbClr val="FAFBFD"/>
+                    </a:solidFill>
+                  </a:tcPr>
+                </a:tc>
+                <a:tc>
+                  <a:txBody>
+                    <a:bodyPr/>
+                    <a:lstStyle/>
+                    <a:p>
+                      <a:pPr algn="r">
+                        <a:defRPr sz="850">
+                          <a:solidFill>
+                            <a:srgbClr val="262626"/>
+                          </a:solidFill>
+                          <a:latin typeface="Calibri"/>
+                        </a:defRPr>
+                      </a:pPr>
+                      <a:r>
+                        <a:t>355,47 GiB</a:t>
+                      </a:r>
+                    </a:p>
+                  </a:txBody>
+                  <a:tcPr marL="36576" marR="36576" marT="18288" marB="18288">
+                    <a:solidFill>
+                      <a:srgbClr val="FAFBFD"/>
+                    </a:solidFill>
+                  </a:tcPr>
+                </a:tc>
+              </a:tr>
+              <a:tr h="293914">
+                <a:tc>
+                  <a:txBody>
+                    <a:bodyPr/>
+                    <a:lstStyle/>
+                    <a:p>
+                      <a:pPr>
+                        <a:defRPr sz="850">
+                          <a:solidFill>
+                            <a:srgbClr val="262626"/>
+                          </a:solidFill>
+                          <a:latin typeface="Calibri"/>
+                        </a:defRPr>
+                      </a:pPr>
+                      <a:r>
+                        <a:t>Aufrunden (Netto-Bedarf)</a:t>
+                      </a:r>
+                    </a:p>
+                  </a:txBody>
+                  <a:tcPr marL="36576" marR="36576" marT="18288" marB="18288">
+                    <a:solidFill>
+                      <a:srgbClr val="FFFFFF"/>
+                    </a:solidFill>
+                  </a:tcPr>
+                </a:tc>
+                <a:tc>
+                  <a:txBody>
+                    <a:bodyPr/>
+                    <a:lstStyle/>
+                    <a:p>
+                      <a:pPr>
+                        <a:defRPr sz="850">
+                          <a:solidFill>
+                            <a:srgbClr val="262626"/>
+                          </a:solidFill>
+                          <a:latin typeface="Calibri"/>
+                        </a:defRPr>
+                      </a:pPr>
+                      <a:r>
+                        <a:t>ROUNDUP(355,47; 0)</a:t>
+                      </a:r>
+                    </a:p>
+                  </a:txBody>
+                  <a:tcPr marL="36576" marR="36576" marT="18288" marB="18288">
+                    <a:solidFill>
+                      <a:srgbClr val="FFFFFF"/>
+                    </a:solidFill>
+                  </a:tcPr>
+                </a:tc>
+                <a:tc>
+                  <a:txBody>
+                    <a:bodyPr/>
+                    <a:lstStyle/>
+                    <a:p>
+                      <a:pPr algn="r">
+                        <a:defRPr sz="850">
+                          <a:solidFill>
+                            <a:srgbClr val="262626"/>
+                          </a:solidFill>
+                          <a:latin typeface="Calibri"/>
+                        </a:defRPr>
+                      </a:pPr>
+                      <a:r>
+                        <a:t>= 356 GiB Netto</a:t>
+                      </a:r>
+                    </a:p>
+                  </a:txBody>
+                  <a:tcPr marL="36576" marR="36576" marT="18288" marB="18288">
+                    <a:solidFill>
+                      <a:srgbClr val="FFFFFF"/>
+                    </a:solidFill>
+                  </a:tcPr>
+                </a:tc>
+              </a:tr>
+              <a:tr h="293914">
+                <a:tc>
+                  <a:txBody>
+                    <a:bodyPr/>
+                    <a:lstStyle/>
+                    <a:p>
+                      <a:pPr>
+                        <a:defRPr sz="850">
+                          <a:solidFill>
+                            <a:srgbClr val="262626"/>
+                          </a:solidFill>
+                          <a:latin typeface="Calibri"/>
+                        </a:defRPr>
+                      </a:pPr>
+                      <a:r>
+                        <a:t>+ 25 % Sicherheitszuschlag</a:t>
+                      </a:r>
+                    </a:p>
+                  </a:txBody>
+                  <a:tcPr marL="36576" marR="36576" marT="18288" marB="18288">
+                    <a:solidFill>
+                      <a:srgbClr val="FAFBFD"/>
+                    </a:solidFill>
+                  </a:tcPr>
+                </a:tc>
+                <a:tc>
+                  <a:txBody>
+                    <a:bodyPr/>
+                    <a:lstStyle/>
+                    <a:p>
+                      <a:pPr>
+                        <a:defRPr sz="850">
+                          <a:solidFill>
+                            <a:srgbClr val="262626"/>
+                          </a:solidFill>
+                          <a:latin typeface="Calibri"/>
+                        </a:defRPr>
+                      </a:pPr>
+                      <a:r>
+                        <a:t>356 GiB × 0,25 (Puffer)</a:t>
+                      </a:r>
+                    </a:p>
+                  </a:txBody>
+                  <a:tcPr marL="36576" marR="36576" marT="18288" marB="18288">
+                    <a:solidFill>
+                      <a:srgbClr val="FAFBFD"/>
+                    </a:solidFill>
+                  </a:tcPr>
+                </a:tc>
+                <a:tc>
+                  <a:txBody>
+                    <a:bodyPr/>
+                    <a:lstStyle/>
+                    <a:p>
+                      <a:pPr algn="r">
+                        <a:defRPr sz="850">
+                          <a:solidFill>
+                            <a:srgbClr val="262626"/>
+                          </a:solidFill>
+                          <a:latin typeface="Calibri"/>
+                        </a:defRPr>
+                      </a:pPr>
+                      <a:r>
+                        <a:t>+ 89 GiB Puffer</a:t>
+                      </a:r>
+                    </a:p>
+                  </a:txBody>
+                  <a:tcPr marL="36576" marR="36576" marT="18288" marB="18288">
+                    <a:solidFill>
+                      <a:srgbClr val="FAFBFD"/>
+                    </a:solidFill>
+                  </a:tcPr>
+                </a:tc>
+              </a:tr>
+              <a:tr h="293916">
+                <a:tc>
+                  <a:txBody>
+                    <a:bodyPr/>
+                    <a:lstStyle/>
+                    <a:p>
+                      <a:pPr>
+                        <a:defRPr sz="850" b="1">
+                          <a:solidFill>
+                            <a:srgbClr val="1F497D"/>
+                          </a:solidFill>
+                          <a:latin typeface="Calibri"/>
+                        </a:defRPr>
+                      </a:pPr>
+                      <a:r>
+                        <a:t>= Gesamtkapazität Q1</a:t>
+                      </a:r>
+                    </a:p>
+                  </a:txBody>
+                  <a:tcPr marL="36576" marR="36576" marT="18288" marB="18288">
+                    <a:solidFill>
+                      <a:srgbClr val="FFFAEB"/>
+                    </a:solidFill>
+                  </a:tcPr>
+                </a:tc>
+                <a:tc>
+                  <a:txBody>
+                    <a:bodyPr/>
+                    <a:lstStyle/>
+                    <a:p>
+                      <a:pPr>
+                        <a:defRPr sz="850" b="1">
+                          <a:solidFill>
+                            <a:srgbClr val="1F497D"/>
+                          </a:solidFill>
+                          <a:latin typeface="Calibri"/>
+                        </a:defRPr>
+                      </a:pPr>
+                      <a:r>
+                        <a:t>356 GiB Netto + 89 GiB</a:t>
+                      </a:r>
+                    </a:p>
+                  </a:txBody>
+                  <a:tcPr marL="36576" marR="36576" marT="18288" marB="18288">
+                    <a:solidFill>
+                      <a:srgbClr val="FFFAEB"/>
+                    </a:solidFill>
+                  </a:tcPr>
+                </a:tc>
+                <a:tc>
+                  <a:txBody>
+                    <a:bodyPr/>
+                    <a:lstStyle/>
+                    <a:p>
+                      <a:pPr algn="r">
+                        <a:defRPr sz="850" b="1">
+                          <a:solidFill>
+                            <a:srgbClr val="1F497D"/>
+                          </a:solidFill>
+                          <a:latin typeface="Calibri"/>
+                        </a:defRPr>
+                      </a:pPr>
+                      <a:r>
+                        <a:t>= 445 GiB Brutto</a:t>
+                      </a:r>
+                    </a:p>
+                  </a:txBody>
+                  <a:tcPr marL="36576" marR="36576" marT="18288" marB="18288">
+                    <a:solidFill>
+                      <a:srgbClr val="FFFAEB"/>
+                    </a:solidFill>
+                  </a:tcPr>
+                </a:tc>
+              </a:tr>
+            </a:tbl>
+          </a:graphicData>
+        </a:graphic>
+      </p:graphicFrame>
       <p:sp>
         <p:nvSpPr>
           <p:cNvPr id="9" name="Rounded Rectangle 8"/>
@@ -7082,18 +7518,18 @@
         </p:nvSpPr>
         <p:spPr>
           <a:xfrm>
-            <a:off x="6583680" y="1645920"/>
-            <a:ext cx="4526280" cy="1005840"/>
+            <a:off x="868680" y="4892040"/>
+            <a:ext cx="4937760" cy="1143000"/>
           </a:xfrm>
           <a:prstGeom prst="roundRect">
             <a:avLst/>
           </a:prstGeom>
           <a:solidFill>
-            <a:srgbClr val="FCE4D6"/>
+            <a:srgbClr val="F8FAFE"/>
           </a:solidFill>
-          <a:ln>
+          <a:ln w="10160">
             <a:solidFill>
-              <a:srgbClr val="C55A11"/>
+              <a:srgbClr val="D7E4F5"/>
             </a:solidFill>
           </a:ln>
         </p:spPr>
@@ -7112,13 +7548,214 @@
           </a:fontRef>
         </p:style>
         <p:txBody>
+          <a:bodyPr rtlCol="0" anchor="ctr" wrap="square"/>
+          <a:lstStyle/>
+          <a:p>
+            <a:pPr algn="ctr">
+              <a:defRPr sz="900" b="1">
+                <a:solidFill>
+                  <a:srgbClr val="1F497D"/>
+                </a:solidFill>
+                <a:latin typeface="Calibri"/>
+              </a:defRPr>
+            </a:pPr>
+            <a:r>
+              <a:t>💡 Praxis-Empfehlung &amp; Dimensionierung:</a:t>
+            </a:r>
+          </a:p>
+          <a:p>
+            <a:pPr>
+              <a:spcBef>
+                <a:spcPts val="200"/>
+              </a:spcBef>
+              <a:defRPr sz="800">
+                <a:solidFill>
+                  <a:srgbClr val="262626"/>
+                </a:solidFill>
+                <a:latin typeface="Calibri"/>
+              </a:defRPr>
+            </a:pPr>
+            <a:r>
+              <a:t>• 25 % Sicherheitszuschlag federt CAD-Revisionsstände, Snapshots &amp; Render-Caches ab.</a:t>
+            </a:r>
+          </a:p>
+          <a:p>
+            <a:pPr>
+              <a:spcBef>
+                <a:spcPts val="200"/>
+              </a:spcBef>
+              <a:defRPr sz="800">
+                <a:solidFill>
+                  <a:srgbClr val="262626"/>
+                </a:solidFill>
+                <a:latin typeface="Calibri"/>
+              </a:defRPr>
+            </a:pPr>
+            <a:r>
+              <a:t>• Jahresbedarf: Ca. 1,78 TiB Brutto; Empfehlung: Fileserver mit mind. 4–6 TB Nutzspeicher.</a:t>
+            </a:r>
+          </a:p>
+          <a:p>
+            <a:pPr>
+              <a:spcBef>
+                <a:spcPts val="200"/>
+              </a:spcBef>
+              <a:defRPr sz="800">
+                <a:solidFill>
+                  <a:srgbClr val="262626"/>
+                </a:solidFill>
+                <a:latin typeface="Calibri"/>
+              </a:defRPr>
+            </a:pPr>
+            <a:r>
+              <a:t>• Datensicherheit: Tägliche Abendsicherung der 16 externen Samsung SSDs auf den Server.</a:t>
+            </a:r>
+          </a:p>
+        </p:txBody>
+      </p:sp>
+      <p:sp>
+        <p:nvSpPr>
+          <p:cNvPr id="10" name="Rounded Rectangle 9"/>
+          <p:cNvSpPr/>
+          <p:nvPr/>
+        </p:nvSpPr>
+        <p:spPr>
+          <a:xfrm>
+            <a:off x="6172200" y="1188720"/>
+            <a:ext cx="5303520" cy="5029200"/>
+          </a:xfrm>
+          <a:prstGeom prst="roundRect">
+            <a:avLst/>
+          </a:prstGeom>
+          <a:solidFill>
+            <a:srgbClr val="FFFFFF"/>
+          </a:solidFill>
+          <a:ln w="15240">
+            <a:solidFill>
+              <a:srgbClr val="C8D7EB"/>
+            </a:solidFill>
+          </a:ln>
+        </p:spPr>
+        <p:style>
+          <a:lnRef idx="1">
+            <a:schemeClr val="accent1"/>
+          </a:lnRef>
+          <a:fillRef idx="3">
+            <a:schemeClr val="accent1"/>
+          </a:fillRef>
+          <a:effectRef idx="2">
+            <a:schemeClr val="accent1"/>
+          </a:effectRef>
+          <a:fontRef idx="minor">
+            <a:schemeClr val="lt1"/>
+          </a:fontRef>
+        </p:style>
+        <p:txBody>
           <a:bodyPr rtlCol="0" anchor="ctr"/>
           <a:lstStyle/>
           <a:p>
+            <a:pPr algn="ctr"/>
+          </a:p>
+        </p:txBody>
+      </p:sp>
+      <p:sp>
+        <p:nvSpPr>
+          <p:cNvPr id="11" name="Rectangle 10"/>
+          <p:cNvSpPr/>
+          <p:nvPr/>
+        </p:nvSpPr>
+        <p:spPr>
+          <a:xfrm>
+            <a:off x="6172200" y="1188720"/>
+            <a:ext cx="5303520" cy="502920"/>
+          </a:xfrm>
+          <a:prstGeom prst="rect">
+            <a:avLst/>
+          </a:prstGeom>
+          <a:solidFill>
+            <a:srgbClr val="1F497D"/>
+          </a:solidFill>
+          <a:ln>
+            <a:noFill/>
+          </a:ln>
+        </p:spPr>
+        <p:style>
+          <a:lnRef idx="1">
+            <a:schemeClr val="accent1"/>
+          </a:lnRef>
+          <a:fillRef idx="3">
+            <a:schemeClr val="accent1"/>
+          </a:fillRef>
+          <a:effectRef idx="2">
+            <a:schemeClr val="accent1"/>
+          </a:effectRef>
+          <a:fontRef idx="minor">
+            <a:schemeClr val="lt1"/>
+          </a:fontRef>
+        </p:style>
+        <p:txBody>
+          <a:bodyPr rtlCol="0" anchor="ctr"/>
+          <a:lstStyle/>
+          <a:p>
             <a:pPr algn="ctr">
-              <a:defRPr sz="3200" b="1">
-                <a:solidFill>
-                  <a:srgbClr val="C55A11"/>
+              <a:defRPr sz="1200" b="1">
+                <a:solidFill>
+                  <a:srgbClr val="FFFFFF"/>
+                </a:solidFill>
+                <a:latin typeface="Calibri"/>
+              </a:defRPr>
+            </a:pPr>
+            <a:r>
+              <a:t>B.2 Jährliche Energiekosten-Kalkulation</a:t>
+            </a:r>
+          </a:p>
+        </p:txBody>
+      </p:sp>
+      <p:sp>
+        <p:nvSpPr>
+          <p:cNvPr id="12" name="Rounded Rectangle 11"/>
+          <p:cNvSpPr/>
+          <p:nvPr/>
+        </p:nvSpPr>
+        <p:spPr>
+          <a:xfrm>
+            <a:off x="6355080" y="1810512"/>
+            <a:ext cx="4937760" cy="777240"/>
+          </a:xfrm>
+          <a:prstGeom prst="roundRect">
+            <a:avLst/>
+          </a:prstGeom>
+          <a:solidFill>
+            <a:srgbClr val="F5F8FC"/>
+          </a:solidFill>
+          <a:ln w="12700">
+            <a:solidFill>
+              <a:srgbClr val="B4CDEB"/>
+            </a:solidFill>
+          </a:ln>
+        </p:spPr>
+        <p:style>
+          <a:lnRef idx="1">
+            <a:schemeClr val="accent1"/>
+          </a:lnRef>
+          <a:fillRef idx="3">
+            <a:schemeClr val="accent1"/>
+          </a:fillRef>
+          <a:effectRef idx="2">
+            <a:schemeClr val="accent1"/>
+          </a:effectRef>
+          <a:fontRef idx="minor">
+            <a:schemeClr val="lt1"/>
+          </a:fontRef>
+        </p:style>
+        <p:txBody>
+          <a:bodyPr rtlCol="0" anchor="ctr" wrap="square"/>
+          <a:lstStyle/>
+          <a:p>
+            <a:pPr algn="ctr">
+              <a:defRPr sz="2200" b="1">
+                <a:solidFill>
+                  <a:srgbClr val="1F497D"/>
                 </a:solidFill>
                 <a:latin typeface="Calibri"/>
               </a:defRPr>
@@ -7129,169 +7766,667 @@
           </a:p>
           <a:p>
             <a:pPr algn="ctr">
-              <a:defRPr sz="1050">
+              <a:defRPr sz="900">
+                <a:solidFill>
+                  <a:srgbClr val="505050"/>
+                </a:solidFill>
+                <a:latin typeface="Calibri"/>
+              </a:defRPr>
+            </a:pPr>
+            <a:r>
+              <a:t>Gesamte jährliche Stromkosten aller 16 Arbeitsplätze (147,61 € / Monat)</a:t>
+            </a:r>
+          </a:p>
+        </p:txBody>
+      </p:sp>
+      <p:graphicFrame>
+        <p:nvGraphicFramePr>
+          <p:cNvPr id="13" name="Table 12"/>
+          <p:cNvGraphicFramePr>
+            <a:graphicFrameLocks noGrp="1"/>
+          </p:cNvGraphicFramePr>
+          <p:nvPr/>
+        </p:nvGraphicFramePr>
+        <p:xfrm>
+          <a:off x="6355080" y="2697480"/>
+          <a:ext cx="4937760" cy="1371600"/>
+        </p:xfrm>
+        <a:graphic>
+          <a:graphicData uri="http://schemas.openxmlformats.org/drawingml/2006/table">
+            <a:tbl>
+              <a:tblPr firstRow="1" bandRow="1">
+                <a:tableStyleId>{5C22544A-7EE6-4342-B048-85BDC9FD1C3A}</a:tableStyleId>
+              </a:tblPr>
+              <a:tblGrid>
+                <a:gridCol w="1691640"/>
+                <a:gridCol w="731520"/>
+                <a:gridCol w="731520"/>
+                <a:gridCol w="914400"/>
+                <a:gridCol w="868680"/>
+              </a:tblGrid>
+              <a:tr h="342900">
+                <a:tc>
+                  <a:txBody>
+                    <a:bodyPr/>
+                    <a:lstStyle/>
+                    <a:p>
+                      <a:pPr>
+                        <a:defRPr sz="900" b="1">
+                          <a:solidFill>
+                            <a:srgbClr val="1F497D"/>
+                          </a:solidFill>
+                          <a:latin typeface="Calibri"/>
+                        </a:defRPr>
+                      </a:pPr>
+                      <a:r>
+                        <a:t>Arbeitsplatztyp</a:t>
+                      </a:r>
+                    </a:p>
+                  </a:txBody>
+                  <a:tcPr marL="36576" marR="36576" marT="18288" marB="18288">
+                    <a:solidFill>
+                      <a:srgbClr val="F0F3F8"/>
+                    </a:solidFill>
+                  </a:tcPr>
+                </a:tc>
+                <a:tc>
+                  <a:txBody>
+                    <a:bodyPr/>
+                    <a:lstStyle/>
+                    <a:p>
+                      <a:pPr algn="r">
+                        <a:defRPr sz="900" b="1">
+                          <a:solidFill>
+                            <a:srgbClr val="1F497D"/>
+                          </a:solidFill>
+                          <a:latin typeface="Calibri"/>
+                        </a:defRPr>
+                      </a:pPr>
+                      <a:r>
+                        <a:t>Leistung</a:t>
+                      </a:r>
+                    </a:p>
+                  </a:txBody>
+                  <a:tcPr marL="36576" marR="36576" marT="18288" marB="18288">
+                    <a:solidFill>
+                      <a:srgbClr val="F0F3F8"/>
+                    </a:solidFill>
+                  </a:tcPr>
+                </a:tc>
+                <a:tc>
+                  <a:txBody>
+                    <a:bodyPr/>
+                    <a:lstStyle/>
+                    <a:p>
+                      <a:pPr algn="r">
+                        <a:defRPr sz="900" b="1">
+                          <a:solidFill>
+                            <a:srgbClr val="1F497D"/>
+                          </a:solidFill>
+                          <a:latin typeface="Calibri"/>
+                        </a:defRPr>
+                      </a:pPr>
+                      <a:r>
+                        <a:t>Stunden</a:t>
+                      </a:r>
+                    </a:p>
+                  </a:txBody>
+                  <a:tcPr marL="36576" marR="36576" marT="18288" marB="18288">
+                    <a:solidFill>
+                      <a:srgbClr val="F0F3F8"/>
+                    </a:solidFill>
+                  </a:tcPr>
+                </a:tc>
+                <a:tc>
+                  <a:txBody>
+                    <a:bodyPr/>
+                    <a:lstStyle/>
+                    <a:p>
+                      <a:pPr algn="r">
+                        <a:defRPr sz="900" b="1">
+                          <a:solidFill>
+                            <a:srgbClr val="1F497D"/>
+                          </a:solidFill>
+                          <a:latin typeface="Calibri"/>
+                        </a:defRPr>
+                      </a:pPr>
+                      <a:r>
+                        <a:t>Verbrauch</a:t>
+                      </a:r>
+                    </a:p>
+                  </a:txBody>
+                  <a:tcPr marL="36576" marR="36576" marT="18288" marB="18288">
+                    <a:solidFill>
+                      <a:srgbClr val="F0F3F8"/>
+                    </a:solidFill>
+                  </a:tcPr>
+                </a:tc>
+                <a:tc>
+                  <a:txBody>
+                    <a:bodyPr/>
+                    <a:lstStyle/>
+                    <a:p>
+                      <a:pPr algn="r">
+                        <a:defRPr sz="900" b="1">
+                          <a:solidFill>
+                            <a:srgbClr val="1F497D"/>
+                          </a:solidFill>
+                          <a:latin typeface="Calibri"/>
+                        </a:defRPr>
+                      </a:pPr>
+                      <a:r>
+                        <a:t>Kosten/Jahr</a:t>
+                      </a:r>
+                    </a:p>
+                  </a:txBody>
+                  <a:tcPr marL="36576" marR="36576" marT="18288" marB="18288">
+                    <a:solidFill>
+                      <a:srgbClr val="F0F3F8"/>
+                    </a:solidFill>
+                  </a:tcPr>
+                </a:tc>
+              </a:tr>
+              <a:tr h="342900">
+                <a:tc>
+                  <a:txBody>
+                    <a:bodyPr/>
+                    <a:lstStyle/>
+                    <a:p>
+                      <a:pPr>
+                        <a:defRPr sz="850">
+                          <a:solidFill>
+                            <a:srgbClr val="262626"/>
+                          </a:solidFill>
+                          <a:latin typeface="Calibri"/>
+                        </a:defRPr>
+                      </a:pPr>
+                      <a:r>
+                        <a:t>12 Standard-PCs (à 140 W)</a:t>
+                      </a:r>
+                    </a:p>
+                  </a:txBody>
+                  <a:tcPr marL="36576" marR="36576" marT="18288" marB="18288">
+                    <a:solidFill>
+                      <a:srgbClr val="FAFBFD"/>
+                    </a:solidFill>
+                  </a:tcPr>
+                </a:tc>
+                <a:tc>
+                  <a:txBody>
+                    <a:bodyPr/>
+                    <a:lstStyle/>
+                    <a:p>
+                      <a:pPr algn="r">
+                        <a:defRPr sz="850">
+                          <a:solidFill>
+                            <a:srgbClr val="262626"/>
+                          </a:solidFill>
+                          <a:latin typeface="Calibri"/>
+                        </a:defRPr>
+                      </a:pPr>
+                      <a:r>
+                        <a:t>1,68 kW</a:t>
+                      </a:r>
+                    </a:p>
+                  </a:txBody>
+                  <a:tcPr marL="36576" marR="36576" marT="18288" marB="18288">
+                    <a:solidFill>
+                      <a:srgbClr val="FAFBFD"/>
+                    </a:solidFill>
+                  </a:tcPr>
+                </a:tc>
+                <a:tc>
+                  <a:txBody>
+                    <a:bodyPr/>
+                    <a:lstStyle/>
+                    <a:p>
+                      <a:pPr algn="r">
+                        <a:defRPr sz="850">
+                          <a:solidFill>
+                            <a:srgbClr val="262626"/>
+                          </a:solidFill>
+                          <a:latin typeface="Calibri"/>
+                        </a:defRPr>
+                      </a:pPr>
+                      <a:r>
+                        <a:t>1.870 h</a:t>
+                      </a:r>
+                    </a:p>
+                  </a:txBody>
+                  <a:tcPr marL="36576" marR="36576" marT="18288" marB="18288">
+                    <a:solidFill>
+                      <a:srgbClr val="FAFBFD"/>
+                    </a:solidFill>
+                  </a:tcPr>
+                </a:tc>
+                <a:tc>
+                  <a:txBody>
+                    <a:bodyPr/>
+                    <a:lstStyle/>
+                    <a:p>
+                      <a:pPr algn="r">
+                        <a:defRPr sz="850">
+                          <a:solidFill>
+                            <a:srgbClr val="262626"/>
+                          </a:solidFill>
+                          <a:latin typeface="Calibri"/>
+                        </a:defRPr>
+                      </a:pPr>
+                      <a:r>
+                        <a:t>3.141,6 kWh</a:t>
+                      </a:r>
+                    </a:p>
+                  </a:txBody>
+                  <a:tcPr marL="36576" marR="36576" marT="18288" marB="18288">
+                    <a:solidFill>
+                      <a:srgbClr val="FAFBFD"/>
+                    </a:solidFill>
+                  </a:tcPr>
+                </a:tc>
+                <a:tc>
+                  <a:txBody>
+                    <a:bodyPr/>
+                    <a:lstStyle/>
+                    <a:p>
+                      <a:pPr algn="r">
+                        <a:defRPr sz="850">
+                          <a:solidFill>
+                            <a:srgbClr val="262626"/>
+                          </a:solidFill>
+                          <a:latin typeface="Calibri"/>
+                        </a:defRPr>
+                      </a:pPr>
+                      <a:r>
+                        <a:t>1.005,31 €</a:t>
+                      </a:r>
+                    </a:p>
+                  </a:txBody>
+                  <a:tcPr marL="36576" marR="36576" marT="18288" marB="18288">
+                    <a:solidFill>
+                      <a:srgbClr val="FAFBFD"/>
+                    </a:solidFill>
+                  </a:tcPr>
+                </a:tc>
+              </a:tr>
+              <a:tr h="342900">
+                <a:tc>
+                  <a:txBody>
+                    <a:bodyPr/>
+                    <a:lstStyle/>
+                    <a:p>
+                      <a:pPr>
+                        <a:defRPr sz="850">
+                          <a:solidFill>
+                            <a:srgbClr val="262626"/>
+                          </a:solidFill>
+                          <a:latin typeface="Calibri"/>
+                        </a:defRPr>
+                      </a:pPr>
+                      <a:r>
+                        <a:t>4 CAD-Workstations (à 320 W)</a:t>
+                      </a:r>
+                    </a:p>
+                  </a:txBody>
+                  <a:tcPr marL="36576" marR="36576" marT="18288" marB="18288">
+                    <a:solidFill>
+                      <a:srgbClr val="FFFFFF"/>
+                    </a:solidFill>
+                  </a:tcPr>
+                </a:tc>
+                <a:tc>
+                  <a:txBody>
+                    <a:bodyPr/>
+                    <a:lstStyle/>
+                    <a:p>
+                      <a:pPr algn="r">
+                        <a:defRPr sz="850">
+                          <a:solidFill>
+                            <a:srgbClr val="262626"/>
+                          </a:solidFill>
+                          <a:latin typeface="Calibri"/>
+                        </a:defRPr>
+                      </a:pPr>
+                      <a:r>
+                        <a:t>1,28 kW</a:t>
+                      </a:r>
+                    </a:p>
+                  </a:txBody>
+                  <a:tcPr marL="36576" marR="36576" marT="18288" marB="18288">
+                    <a:solidFill>
+                      <a:srgbClr val="FFFFFF"/>
+                    </a:solidFill>
+                  </a:tcPr>
+                </a:tc>
+                <a:tc>
+                  <a:txBody>
+                    <a:bodyPr/>
+                    <a:lstStyle/>
+                    <a:p>
+                      <a:pPr algn="r">
+                        <a:defRPr sz="850">
+                          <a:solidFill>
+                            <a:srgbClr val="262626"/>
+                          </a:solidFill>
+                          <a:latin typeface="Calibri"/>
+                        </a:defRPr>
+                      </a:pPr>
+                      <a:r>
+                        <a:t>1.870 h</a:t>
+                      </a:r>
+                    </a:p>
+                  </a:txBody>
+                  <a:tcPr marL="36576" marR="36576" marT="18288" marB="18288">
+                    <a:solidFill>
+                      <a:srgbClr val="FFFFFF"/>
+                    </a:solidFill>
+                  </a:tcPr>
+                </a:tc>
+                <a:tc>
+                  <a:txBody>
+                    <a:bodyPr/>
+                    <a:lstStyle/>
+                    <a:p>
+                      <a:pPr algn="r">
+                        <a:defRPr sz="850">
+                          <a:solidFill>
+                            <a:srgbClr val="262626"/>
+                          </a:solidFill>
+                          <a:latin typeface="Calibri"/>
+                        </a:defRPr>
+                      </a:pPr>
+                      <a:r>
+                        <a:t>2.393,6 kWh</a:t>
+                      </a:r>
+                    </a:p>
+                  </a:txBody>
+                  <a:tcPr marL="36576" marR="36576" marT="18288" marB="18288">
+                    <a:solidFill>
+                      <a:srgbClr val="FFFFFF"/>
+                    </a:solidFill>
+                  </a:tcPr>
+                </a:tc>
+                <a:tc>
+                  <a:txBody>
+                    <a:bodyPr/>
+                    <a:lstStyle/>
+                    <a:p>
+                      <a:pPr algn="r">
+                        <a:defRPr sz="850">
+                          <a:solidFill>
+                            <a:srgbClr val="262626"/>
+                          </a:solidFill>
+                          <a:latin typeface="Calibri"/>
+                        </a:defRPr>
+                      </a:pPr>
+                      <a:r>
+                        <a:t>765,95 €</a:t>
+                      </a:r>
+                    </a:p>
+                  </a:txBody>
+                  <a:tcPr marL="36576" marR="36576" marT="18288" marB="18288">
+                    <a:solidFill>
+                      <a:srgbClr val="FFFFFF"/>
+                    </a:solidFill>
+                  </a:tcPr>
+                </a:tc>
+              </a:tr>
+              <a:tr h="342900">
+                <a:tc>
+                  <a:txBody>
+                    <a:bodyPr/>
+                    <a:lstStyle/>
+                    <a:p>
+                      <a:pPr>
+                        <a:defRPr sz="850" b="1">
+                          <a:solidFill>
+                            <a:srgbClr val="1F497D"/>
+                          </a:solidFill>
+                          <a:latin typeface="Calibri"/>
+                        </a:defRPr>
+                      </a:pPr>
+                      <a:r>
+                        <a:t>Gesamtsystem (16 Plätze)</a:t>
+                      </a:r>
+                    </a:p>
+                  </a:txBody>
+                  <a:tcPr marL="36576" marR="36576" marT="18288" marB="18288">
+                    <a:solidFill>
+                      <a:srgbClr val="FFFAEB"/>
+                    </a:solidFill>
+                  </a:tcPr>
+                </a:tc>
+                <a:tc>
+                  <a:txBody>
+                    <a:bodyPr/>
+                    <a:lstStyle/>
+                    <a:p>
+                      <a:pPr algn="r">
+                        <a:defRPr sz="850" b="1">
+                          <a:solidFill>
+                            <a:srgbClr val="1F497D"/>
+                          </a:solidFill>
+                          <a:latin typeface="Calibri"/>
+                        </a:defRPr>
+                      </a:pPr>
+                      <a:r>
+                        <a:t>2,96 kW</a:t>
+                      </a:r>
+                    </a:p>
+                  </a:txBody>
+                  <a:tcPr marL="36576" marR="36576" marT="18288" marB="18288">
+                    <a:solidFill>
+                      <a:srgbClr val="FFFAEB"/>
+                    </a:solidFill>
+                  </a:tcPr>
+                </a:tc>
+                <a:tc>
+                  <a:txBody>
+                    <a:bodyPr/>
+                    <a:lstStyle/>
+                    <a:p>
+                      <a:pPr algn="r">
+                        <a:defRPr sz="850" b="1">
+                          <a:solidFill>
+                            <a:srgbClr val="1F497D"/>
+                          </a:solidFill>
+                          <a:latin typeface="Calibri"/>
+                        </a:defRPr>
+                      </a:pPr>
+                      <a:r>
+                        <a:t>1.870 h</a:t>
+                      </a:r>
+                    </a:p>
+                  </a:txBody>
+                  <a:tcPr marL="36576" marR="36576" marT="18288" marB="18288">
+                    <a:solidFill>
+                      <a:srgbClr val="FFFAEB"/>
+                    </a:solidFill>
+                  </a:tcPr>
+                </a:tc>
+                <a:tc>
+                  <a:txBody>
+                    <a:bodyPr/>
+                    <a:lstStyle/>
+                    <a:p>
+                      <a:pPr algn="r">
+                        <a:defRPr sz="850" b="1">
+                          <a:solidFill>
+                            <a:srgbClr val="1F497D"/>
+                          </a:solidFill>
+                          <a:latin typeface="Calibri"/>
+                        </a:defRPr>
+                      </a:pPr>
+                      <a:r>
+                        <a:t>5.535,2 kWh</a:t>
+                      </a:r>
+                    </a:p>
+                  </a:txBody>
+                  <a:tcPr marL="36576" marR="36576" marT="18288" marB="18288">
+                    <a:solidFill>
+                      <a:srgbClr val="FFFAEB"/>
+                    </a:solidFill>
+                  </a:tcPr>
+                </a:tc>
+                <a:tc>
+                  <a:txBody>
+                    <a:bodyPr/>
+                    <a:lstStyle/>
+                    <a:p>
+                      <a:pPr algn="r">
+                        <a:defRPr sz="850" b="1">
+                          <a:solidFill>
+                            <a:srgbClr val="1F497D"/>
+                          </a:solidFill>
+                          <a:latin typeface="Calibri"/>
+                        </a:defRPr>
+                      </a:pPr>
+                      <a:r>
+                        <a:t>= 1.771,26 €</a:t>
+                      </a:r>
+                    </a:p>
+                  </a:txBody>
+                  <a:tcPr marL="36576" marR="36576" marT="18288" marB="18288">
+                    <a:solidFill>
+                      <a:srgbClr val="FFFAEB"/>
+                    </a:solidFill>
+                  </a:tcPr>
+                </a:tc>
+              </a:tr>
+            </a:tbl>
+          </a:graphicData>
+        </a:graphic>
+      </p:graphicFrame>
+      <p:sp>
+        <p:nvSpPr>
+          <p:cNvPr id="14" name="Rounded Rectangle 13"/>
+          <p:cNvSpPr/>
+          <p:nvPr/>
+        </p:nvSpPr>
+        <p:spPr>
+          <a:xfrm>
+            <a:off x="6355080" y="4206240"/>
+            <a:ext cx="4937760" cy="1828800"/>
+          </a:xfrm>
+          <a:prstGeom prst="roundRect">
+            <a:avLst/>
+          </a:prstGeom>
+          <a:solidFill>
+            <a:srgbClr val="F8FAFE"/>
+          </a:solidFill>
+          <a:ln w="10160">
+            <a:solidFill>
+              <a:srgbClr val="D7E4F5"/>
+            </a:solidFill>
+          </a:ln>
+        </p:spPr>
+        <p:style>
+          <a:lnRef idx="1">
+            <a:schemeClr val="accent1"/>
+          </a:lnRef>
+          <a:fillRef idx="3">
+            <a:schemeClr val="accent1"/>
+          </a:fillRef>
+          <a:effectRef idx="2">
+            <a:schemeClr val="accent1"/>
+          </a:effectRef>
+          <a:fontRef idx="minor">
+            <a:schemeClr val="lt1"/>
+          </a:fontRef>
+        </p:style>
+        <p:txBody>
+          <a:bodyPr rtlCol="0" anchor="ctr" wrap="square"/>
+          <a:lstStyle/>
+          <a:p>
+            <a:pPr algn="ctr">
+              <a:defRPr sz="900" b="1">
+                <a:solidFill>
+                  <a:srgbClr val="1F497D"/>
+                </a:solidFill>
+                <a:latin typeface="Calibri"/>
+              </a:defRPr>
+            </a:pPr>
+            <a:r>
+              <a:t>⚡ Kennzahlen &amp; Energiespar-Empfehlungen:</a:t>
+            </a:r>
+          </a:p>
+          <a:p>
+            <a:pPr>
+              <a:spcBef>
+                <a:spcPts val="200"/>
+              </a:spcBef>
+              <a:defRPr sz="800">
                 <a:solidFill>
                   <a:srgbClr val="262626"/>
                 </a:solidFill>
-              </a:defRPr>
-            </a:pPr>
-            <a:r>
-              <a:t>Jährliche Stromkosten für alle 16 Arbeitsplätze</a:t>
-            </a:r>
-          </a:p>
-        </p:txBody>
-      </p:sp>
-      <p:sp>
-        <p:nvSpPr>
-          <p:cNvPr id="10" name="TextBox 9"/>
-          <p:cNvSpPr txBox="1"/>
-          <p:nvPr/>
-        </p:nvSpPr>
-        <p:spPr>
-          <a:xfrm>
-            <a:off x="6492240" y="2834640"/>
-            <a:ext cx="4663440" cy="3200400"/>
-          </a:xfrm>
-          <a:prstGeom prst="rect">
-            <a:avLst/>
-          </a:prstGeom>
-          <a:noFill/>
-        </p:spPr>
-        <p:txBody>
-          <a:bodyPr wrap="square">
-            <a:spAutoFit/>
-          </a:bodyPr>
-          <a:lstStyle/>
-          <a:p>
-            <a:pPr>
-              <a:defRPr b="1" sz="1100">
-                <a:solidFill>
-                  <a:srgbClr val="1F497D"/>
-                </a:solidFill>
-              </a:defRPr>
-            </a:pPr>
-            <a:r>
-              <a:t>Rechnenweg Schritt für Schritt:</a:t>
-            </a:r>
-          </a:p>
-          <a:p>
-            <a:pPr>
-              <a:spcAft>
-                <a:spcPts val="300"/>
-              </a:spcAft>
-              <a:defRPr sz="950">
+                <a:latin typeface="Calibri"/>
+              </a:defRPr>
+            </a:pPr>
+            <a:r>
+              <a:t>• Parameter: 220 Arbeitstage · 8,5 h Laufzeit/Tag · Strompreis vertraglich 0,32 €/kWh.</a:t>
+            </a:r>
+          </a:p>
+          <a:p>
+            <a:pPr>
+              <a:spcBef>
+                <a:spcPts val="200"/>
+              </a:spcBef>
+              <a:defRPr sz="800">
                 <a:solidFill>
                   <a:srgbClr val="262626"/>
                 </a:solidFill>
-              </a:defRPr>
-            </a:pPr>
-            <a:r>
-              <a:t>• 12 Standard-PCs à 140 W = 1.680 W</a:t>
-            </a:r>
-          </a:p>
-          <a:p>
-            <a:pPr>
-              <a:spcAft>
-                <a:spcPts val="300"/>
-              </a:spcAft>
-              <a:defRPr sz="950">
+                <a:latin typeface="Calibri"/>
+              </a:defRPr>
+            </a:pPr>
+            <a:r>
+              <a:t>• Geringe Kosten je Platz: Durchschnittlich nur ca. 110,70 € Stromkosten pro Arbeitsplatz im Jahr.</a:t>
+            </a:r>
+          </a:p>
+          <a:p>
+            <a:pPr>
+              <a:spcBef>
+                <a:spcPts val="200"/>
+              </a:spcBef>
+              <a:defRPr sz="800">
                 <a:solidFill>
                   <a:srgbClr val="262626"/>
                 </a:solidFill>
-              </a:defRPr>
-            </a:pPr>
-            <a:r>
-              <a:t>• 4 CAD-Workstations à 320 W = 1.280 W</a:t>
-            </a:r>
-          </a:p>
-          <a:p>
-            <a:pPr>
-              <a:spcAft>
-                <a:spcPts val="300"/>
-              </a:spcAft>
-              <a:defRPr sz="950">
+                <a:latin typeface="Calibri"/>
+              </a:defRPr>
+            </a:pPr>
+            <a:r>
+              <a:t>• Aufteilung: Standard-PCs machen 56,8 % des Verbrauchs aus, CAD-Workstations 43,2 %.</a:t>
+            </a:r>
+          </a:p>
+          <a:p>
+            <a:pPr>
+              <a:spcBef>
+                <a:spcPts val="200"/>
+              </a:spcBef>
+              <a:defRPr sz="800">
                 <a:solidFill>
                   <a:srgbClr val="262626"/>
                 </a:solidFill>
-              </a:defRPr>
-            </a:pPr>
-            <a:r>
-              <a:t>• Gesamtleistung: 1.680 W + 1.280 W = 2.960 W (2,96 kW)</a:t>
-            </a:r>
-          </a:p>
-          <a:p>
-            <a:pPr>
-              <a:spcAft>
-                <a:spcPts val="300"/>
-              </a:spcAft>
-              <a:defRPr sz="950">
+                <a:latin typeface="Calibri"/>
+              </a:defRPr>
+            </a:pPr>
+            <a:r>
+              <a:t>• Bis zu 15 % Einsparpotenzial (ca. 265 €/a) durch Windows-Ruhezustand nach 15 min Inaktivität.</a:t>
+            </a:r>
+          </a:p>
+          <a:p>
+            <a:pPr>
+              <a:spcBef>
+                <a:spcPts val="200"/>
+              </a:spcBef>
+              <a:defRPr sz="800">
                 <a:solidFill>
                   <a:srgbClr val="262626"/>
                 </a:solidFill>
-              </a:defRPr>
-            </a:pPr>
-            <a:r>
-              <a:t>• Jahresbetriebszeit: 220 Tage × 8,5 h/Tag = 1.870 Stunden</a:t>
-            </a:r>
-          </a:p>
-          <a:p>
-            <a:pPr>
-              <a:spcAft>
-                <a:spcPts val="300"/>
-              </a:spcAft>
-              <a:defRPr sz="950">
-                <a:solidFill>
-                  <a:srgbClr val="262626"/>
-                </a:solidFill>
-              </a:defRPr>
-            </a:pPr>
-            <a:r>
-              <a:t>• Jahresstromverbrauch:</a:t>
-            </a:r>
-          </a:p>
-          <a:p>
-            <a:pPr>
-              <a:spcAft>
-                <a:spcPts val="300"/>
-              </a:spcAft>
-              <a:defRPr sz="950">
-                <a:solidFill>
-                  <a:srgbClr val="262626"/>
-                </a:solidFill>
-              </a:defRPr>
-            </a:pPr>
-            <a:r>
-              <a:t>•   2,96 kW × 1.870 h = 5.535,2 kWh</a:t>
-            </a:r>
-          </a:p>
-          <a:p>
-            <a:pPr>
-              <a:spcAft>
-                <a:spcPts val="300"/>
-              </a:spcAft>
-              <a:defRPr sz="950">
-                <a:solidFill>
-                  <a:srgbClr val="262626"/>
-                </a:solidFill>
-              </a:defRPr>
-            </a:pPr>
-            <a:r>
-              <a:t>• Stromkosten bei 0,32 €/kWh:</a:t>
-            </a:r>
-          </a:p>
-          <a:p>
-            <a:pPr>
-              <a:spcAft>
-                <a:spcPts val="300"/>
-              </a:spcAft>
-              <a:defRPr sz="950">
-                <a:solidFill>
-                  <a:srgbClr val="262626"/>
-                </a:solidFill>
-              </a:defRPr>
-            </a:pPr>
-            <a:r>
-              <a:t>•   5.535,2 kWh × 0,32 € = 1.771,26 € pro Jahr</a:t>
+                <a:latin typeface="Calibri"/>
+              </a:defRPr>
+            </a:pPr>
+            <a:r>
+              <a:t>• Schutz vor Standby-Verlusten: Master-Slave-Steckdosenleisten schalten Monitore nach Feierabend ab.</a:t>
             </a:r>
           </a:p>
         </p:txBody>

</xml_diff>

<commit_message>
Praesentation optimiert: Widescreen-Layout vollstndig ausgenutzt, NextLevel-Logo mit transparentem Hintergrund vergroessert auf allen 16 Folien platziert, Hardware-Badges und PSP korrigiert
</commit_message>
<xml_diff>
--- a/docs/08_Projektabschluss/Abschlusspraesentation.pptx
+++ b/docs/08_Projektabschluss/Abschlusspraesentation.pptx
@@ -7462,7 +7462,7 @@
         </p:nvSpPr>
         <p:spPr>
           <a:xfrm>
-            <a:off x="1016000" y="1397000"/>
+            <a:off x="762000" y="1206499"/>
             <a:ext cx="9144000" cy="1554272"/>
           </a:xfrm>
           <a:prstGeom prst="rect">
@@ -7485,7 +7485,7 @@
               </a:defRPr>
             </a:pPr>
             <a:r>
-              <a:rPr sz="1300" b="1">
+              <a:rPr sz="1400" b="1">
                 <a:solidFill>
                   <a:srgbClr val="54A021"/>
                 </a:solidFill>
@@ -7559,8 +7559,8 @@
         </p:nvSpPr>
         <p:spPr>
           <a:xfrm>
-            <a:off x="1097280" y="4389120"/>
-            <a:ext cx="9966960" cy="1463040"/>
+            <a:off x="762000" y="4000500"/>
+            <a:ext cx="10033000" cy="1460500"/>
           </a:xfrm>
           <a:prstGeom prst="roundRect">
             <a:avLst/>
@@ -7607,8 +7607,8 @@
         </p:nvSpPr>
         <p:spPr>
           <a:xfrm>
-            <a:off x="1280160" y="4526280"/>
-            <a:ext cx="6611105" cy="577081"/>
+            <a:off x="952499" y="4127499"/>
+            <a:ext cx="6922088" cy="600164"/>
           </a:xfrm>
           <a:prstGeom prst="rect">
             <a:avLst/>
@@ -7630,7 +7630,7 @@
               </a:defRPr>
             </a:pPr>
             <a:r>
-              <a:rPr sz="1050">
+              <a:rPr sz="1100">
                 <a:solidFill>
                   <a:srgbClr val="2C3C43"/>
                 </a:solidFill>
@@ -7649,7 +7649,7 @@
               </a:defRPr>
             </a:pPr>
             <a:r>
-              <a:rPr sz="1050">
+              <a:rPr sz="1100">
                 <a:solidFill>
                   <a:srgbClr val="2C3C43"/>
                 </a:solidFill>
@@ -7658,7 +7658,7 @@
               <a:t>Jan Kluth (Projektleiter)  •  Mathias Vonau (Techn. Planer)  •  Marian Bolecke (Beschaffung &amp; Kalkulation)</a:t>
             </a:r>
             <a:br>
-              <a:rPr sz="1050">
+              <a:rPr sz="1100">
                 <a:solidFill>
                   <a:srgbClr val="2C3C43"/>
                 </a:solidFill>
@@ -7666,7 +7666,7 @@
               </a:rPr>
             </a:br>
             <a:r>
-              <a:rPr sz="1050">
+              <a:rPr sz="1100">
                 <a:solidFill>
                   <a:srgbClr val="2C3C43"/>
                 </a:solidFill>
@@ -7677,56 +7677,36 @@
           </a:p>
         </p:txBody>
       </p:sp>
-      <p:sp>
-        <p:nvSpPr>
-          <p:cNvPr id="6" name="Titel 5">
+      <p:pic>
+        <p:nvPicPr>
+          <p:cNvPr id="7" name="NextLevelLogo_1">
             <a:extLst>
               <a:ext uri="{FF2B5EF4-FFF2-40B4-BE49-F238E27FC236}">
-                <a16:creationId xmlns:a16="http://schemas.microsoft.com/office/drawing/2014/main" id="{C186A58F-49C8-05A5-1252-3497B237FDC1}"/>
+                <a16:creationId xmlns:a16="http://schemas.microsoft.com/office/drawing/2014/main" id="{0E1522B8-9501-6810-E3D7-31F70DD1EB76}"/>
               </a:ext>
             </a:extLst>
           </p:cNvPr>
-          <p:cNvSpPr>
-            <a:spLocks noGrp="1"/>
-          </p:cNvSpPr>
-          <p:nvPr>
-            <p:ph type="ctrTitle"/>
-          </p:nvPr>
-        </p:nvSpPr>
-        <p:spPr/>
-        <p:txBody>
-          <a:bodyPr/>
-          <a:lstStyle/>
-          <a:p>
-            <a:endParaRPr lang="de-DE"/>
-          </a:p>
-        </p:txBody>
-      </p:sp>
-      <p:sp>
-        <p:nvSpPr>
-          <p:cNvPr id="7" name="Untertitel 6">
-            <a:extLst>
-              <a:ext uri="{FF2B5EF4-FFF2-40B4-BE49-F238E27FC236}">
-                <a16:creationId xmlns:a16="http://schemas.microsoft.com/office/drawing/2014/main" id="{5D2D350F-654E-8CA8-5036-DECC5507A8FD}"/>
-              </a:ext>
-            </a:extLst>
-          </p:cNvPr>
-          <p:cNvSpPr>
-            <a:spLocks noGrp="1"/>
-          </p:cNvSpPr>
-          <p:nvPr>
-            <p:ph type="subTitle" idx="1"/>
-          </p:nvPr>
-        </p:nvSpPr>
-        <p:spPr/>
-        <p:txBody>
-          <a:bodyPr/>
-          <a:lstStyle/>
-          <a:p>
-            <a:endParaRPr lang="de-DE"/>
-          </a:p>
-        </p:txBody>
-      </p:sp>
+          <p:cNvPicPr>
+            <a:picLocks/>
+          </p:cNvPicPr>
+          <p:nvPr/>
+        </p:nvPicPr>
+        <p:blipFill>
+          <a:blip r:embed="rId3"/>
+          <a:stretch>
+            <a:fillRect/>
+          </a:stretch>
+        </p:blipFill>
+        <p:spPr>
+          <a:xfrm>
+            <a:off x="10566400" y="5918200"/>
+            <a:ext cx="1473200" cy="814070"/>
+          </a:xfrm>
+          <a:prstGeom prst="rect">
+            <a:avLst/>
+          </a:prstGeom>
+        </p:spPr>
+      </p:pic>
     </p:spTree>
   </p:cSld>
   <p:clrMapOvr>
@@ -7760,8 +7740,8 @@
         </p:nvSpPr>
         <p:spPr>
           <a:xfrm>
-            <a:off x="698500" y="152400"/>
-            <a:ext cx="5563511" cy="569387"/>
+            <a:off x="698499" y="152399"/>
+            <a:ext cx="5820440" cy="592470"/>
           </a:xfrm>
           <a:prstGeom prst="rect">
             <a:avLst/>
@@ -7783,7 +7763,7 @@
               </a:defRPr>
             </a:pPr>
             <a:r>
-              <a:rPr sz="1000" b="1">
+              <a:rPr sz="1050" b="1">
                 <a:solidFill>
                   <a:srgbClr val="54A021"/>
                 </a:solidFill>
@@ -7802,7 +7782,7 @@
               </a:defRPr>
             </a:pPr>
             <a:r>
-              <a:rPr sz="2100" b="1">
+              <a:rPr sz="2200" b="1">
                 <a:solidFill>
                   <a:srgbClr val="2C3C43"/>
                 </a:solidFill>
@@ -7821,7 +7801,7 @@
         </p:nvSpPr>
         <p:spPr>
           <a:xfrm>
-            <a:off x="731520" y="6446520"/>
+            <a:off x="698500" y="6413500"/>
             <a:ext cx="5852884" cy="230832"/>
           </a:xfrm>
           <a:prstGeom prst="rect">
@@ -7863,8 +7843,8 @@
         </p:nvSpPr>
         <p:spPr>
           <a:xfrm>
-            <a:off x="685800" y="1234440"/>
-            <a:ext cx="5303520" cy="4937760"/>
+            <a:off x="698500" y="1234440"/>
+            <a:ext cx="5080000" cy="4937760"/>
           </a:xfrm>
           <a:prstGeom prst="roundRect">
             <a:avLst/>
@@ -7909,8 +7889,8 @@
         </p:nvSpPr>
         <p:spPr>
           <a:xfrm>
-            <a:off x="685800" y="1234440"/>
-            <a:ext cx="5303520" cy="502920"/>
+            <a:off x="698500" y="1234440"/>
+            <a:ext cx="5080000" cy="502920"/>
           </a:xfrm>
           <a:prstGeom prst="rect">
             <a:avLst/>
@@ -7963,11 +7943,17 @@
           <p:cNvGraphicFramePr>
             <a:graphicFrameLocks noGrp="1"/>
           </p:cNvGraphicFramePr>
-          <p:nvPr/>
+          <p:nvPr>
+            <p:extLst>
+              <p:ext uri="{D42A27DB-BD31-4B8C-83A1-F6EECF244321}">
+                <p14:modId xmlns:p14="http://schemas.microsoft.com/office/powerpoint/2010/main" val="2390803844"/>
+              </p:ext>
+            </p:extLst>
+          </p:nvPr>
         </p:nvGraphicFramePr>
         <p:xfrm>
-          <a:off x="777240" y="1874519"/>
-          <a:ext cx="5120640" cy="4114800"/>
+          <a:off x="825500" y="1874519"/>
+          <a:ext cx="4826000" cy="4114800"/>
         </p:xfrm>
         <a:graphic>
           <a:graphicData uri="http://schemas.openxmlformats.org/drawingml/2006/table">
@@ -7976,21 +7962,21 @@
                 <a:tableStyleId>{5C22544A-7EE6-4342-B048-85BDC9FD1C3A}</a:tableStyleId>
               </a:tblPr>
               <a:tblGrid>
-                <a:gridCol w="1783080">
+                <a:gridCol w="1680481">
                   <a:extLst>
                     <a:ext uri="{9D8B030D-6E8A-4147-A177-3AD203B41FA5}">
                       <a16:colId xmlns:a16="http://schemas.microsoft.com/office/drawing/2014/main" val="20000"/>
                     </a:ext>
                   </a:extLst>
                 </a:gridCol>
-                <a:gridCol w="2011680">
+                <a:gridCol w="1895929">
                   <a:extLst>
                     <a:ext uri="{9D8B030D-6E8A-4147-A177-3AD203B41FA5}">
                       <a16:colId xmlns:a16="http://schemas.microsoft.com/office/drawing/2014/main" val="20001"/>
                     </a:ext>
                   </a:extLst>
                 </a:gridCol>
-                <a:gridCol w="1325880">
+                <a:gridCol w="1249590">
                   <a:extLst>
                     <a:ext uri="{9D8B030D-6E8A-4147-A177-3AD203B41FA5}">
                       <a16:colId xmlns:a16="http://schemas.microsoft.com/office/drawing/2014/main" val="20002"/>
@@ -8800,8 +8786,8 @@
         </p:nvSpPr>
         <p:spPr>
           <a:xfrm>
-            <a:off x="6172200" y="1234440"/>
-            <a:ext cx="5303520" cy="4937760"/>
+            <a:off x="6159500" y="1234440"/>
+            <a:ext cx="5080000" cy="4937760"/>
           </a:xfrm>
           <a:prstGeom prst="roundRect">
             <a:avLst/>
@@ -8846,8 +8832,8 @@
         </p:nvSpPr>
         <p:spPr>
           <a:xfrm>
-            <a:off x="6172200" y="1234440"/>
-            <a:ext cx="5303520" cy="502920"/>
+            <a:off x="6159500" y="1234440"/>
+            <a:ext cx="5080000" cy="502920"/>
           </a:xfrm>
           <a:prstGeom prst="rect">
             <a:avLst/>
@@ -8900,11 +8886,17 @@
           <p:cNvGraphicFramePr>
             <a:graphicFrameLocks noGrp="1"/>
           </p:cNvGraphicFramePr>
-          <p:nvPr/>
+          <p:nvPr>
+            <p:extLst>
+              <p:ext uri="{D42A27DB-BD31-4B8C-83A1-F6EECF244321}">
+                <p14:modId xmlns:p14="http://schemas.microsoft.com/office/powerpoint/2010/main" val="3457827468"/>
+              </p:ext>
+            </p:extLst>
+          </p:nvPr>
         </p:nvGraphicFramePr>
         <p:xfrm>
-          <a:off x="6263640" y="1874519"/>
-          <a:ext cx="5120639" cy="2194560"/>
+          <a:off x="6286500" y="1874519"/>
+          <a:ext cx="4826000" cy="2194560"/>
         </p:xfrm>
         <a:graphic>
           <a:graphicData uri="http://schemas.openxmlformats.org/drawingml/2006/table">
@@ -8913,14 +8905,14 @@
                 <a:tableStyleId>{5C22544A-7EE6-4342-B048-85BDC9FD1C3A}</a:tableStyleId>
               </a:tblPr>
               <a:tblGrid>
-                <a:gridCol w="3749039">
+                <a:gridCol w="3533321">
                   <a:extLst>
                     <a:ext uri="{9D8B030D-6E8A-4147-A177-3AD203B41FA5}">
                       <a16:colId xmlns:a16="http://schemas.microsoft.com/office/drawing/2014/main" val="20000"/>
                     </a:ext>
                   </a:extLst>
                 </a:gridCol>
-                <a:gridCol w="1371600">
+                <a:gridCol w="1292679">
                   <a:extLst>
                     <a:ext uri="{9D8B030D-6E8A-4147-A177-3AD203B41FA5}">
                       <a16:colId xmlns:a16="http://schemas.microsoft.com/office/drawing/2014/main" val="20001"/>
@@ -9301,8 +9293,8 @@
         </p:nvSpPr>
         <p:spPr>
           <a:xfrm>
-            <a:off x="6263640" y="4297680"/>
-            <a:ext cx="5120640" cy="1737360"/>
+            <a:off x="6286500" y="4297680"/>
+            <a:ext cx="4826000" cy="1737360"/>
           </a:xfrm>
           <a:prstGeom prst="roundRect">
             <a:avLst/>
@@ -9347,8 +9339,8 @@
         </p:nvSpPr>
         <p:spPr>
           <a:xfrm>
-            <a:off x="6400800" y="4389120"/>
-            <a:ext cx="4846320" cy="915635"/>
+            <a:off x="6388100" y="4389120"/>
+            <a:ext cx="4622800" cy="915635"/>
           </a:xfrm>
           <a:prstGeom prst="rect">
             <a:avLst/>
@@ -9435,6 +9427,36 @@
           </a:p>
         </p:txBody>
       </p:sp>
+      <p:pic>
+        <p:nvPicPr>
+          <p:cNvPr id="14" name="NextLevelLogo_10">
+            <a:extLst>
+              <a:ext uri="{FF2B5EF4-FFF2-40B4-BE49-F238E27FC236}">
+                <a16:creationId xmlns:a16="http://schemas.microsoft.com/office/drawing/2014/main" id="{39300FDA-B570-37F6-3AF6-2D6FB691CBE9}"/>
+              </a:ext>
+            </a:extLst>
+          </p:cNvPr>
+          <p:cNvPicPr>
+            <a:picLocks/>
+          </p:cNvPicPr>
+          <p:nvPr/>
+        </p:nvPicPr>
+        <p:blipFill>
+          <a:blip r:embed="rId3"/>
+          <a:stretch>
+            <a:fillRect/>
+          </a:stretch>
+        </p:blipFill>
+        <p:spPr>
+          <a:xfrm>
+            <a:off x="10566400" y="5918200"/>
+            <a:ext cx="1473200" cy="814070"/>
+          </a:xfrm>
+          <a:prstGeom prst="rect">
+            <a:avLst/>
+          </a:prstGeom>
+        </p:spPr>
+      </p:pic>
     </p:spTree>
   </p:cSld>
   <p:clrMapOvr>
@@ -9468,8 +9490,8 @@
         </p:nvSpPr>
         <p:spPr>
           <a:xfrm>
-            <a:off x="698500" y="152400"/>
-            <a:ext cx="7083991" cy="569387"/>
+            <a:off x="698499" y="152399"/>
+            <a:ext cx="7402989" cy="592470"/>
           </a:xfrm>
           <a:prstGeom prst="rect">
             <a:avLst/>
@@ -9491,7 +9513,7 @@
               </a:defRPr>
             </a:pPr>
             <a:r>
-              <a:rPr sz="1000" b="1">
+              <a:rPr sz="1050" b="1">
                 <a:solidFill>
                   <a:srgbClr val="54A021"/>
                 </a:solidFill>
@@ -9510,7 +9532,7 @@
               </a:defRPr>
             </a:pPr>
             <a:r>
-              <a:rPr sz="2100" b="1">
+              <a:rPr sz="2200" b="1">
                 <a:solidFill>
                   <a:srgbClr val="2C3C43"/>
                 </a:solidFill>
@@ -9529,7 +9551,7 @@
         </p:nvSpPr>
         <p:spPr>
           <a:xfrm>
-            <a:off x="731520" y="6446520"/>
+            <a:off x="698500" y="6413500"/>
             <a:ext cx="5852884" cy="230832"/>
           </a:xfrm>
           <a:prstGeom prst="rect">
@@ -9571,8 +9593,8 @@
         </p:nvSpPr>
         <p:spPr>
           <a:xfrm>
-            <a:off x="685800" y="1188720"/>
-            <a:ext cx="5303520" cy="5029200"/>
+            <a:off x="698500" y="1188720"/>
+            <a:ext cx="5080000" cy="5029200"/>
           </a:xfrm>
           <a:prstGeom prst="roundRect">
             <a:avLst/>
@@ -9617,8 +9639,8 @@
         </p:nvSpPr>
         <p:spPr>
           <a:xfrm>
-            <a:off x="685800" y="1188720"/>
-            <a:ext cx="5303520" cy="502920"/>
+            <a:off x="698500" y="1188720"/>
+            <a:ext cx="5080000" cy="502920"/>
           </a:xfrm>
           <a:prstGeom prst="rect">
             <a:avLst/>
@@ -9673,8 +9695,8 @@
         </p:nvSpPr>
         <p:spPr>
           <a:xfrm>
-            <a:off x="868680" y="1810512"/>
-            <a:ext cx="4937760" cy="777240"/>
+            <a:off x="850900" y="1810512"/>
+            <a:ext cx="4775200" cy="777240"/>
           </a:xfrm>
           <a:prstGeom prst="roundRect">
             <a:avLst/>
@@ -9745,11 +9767,17 @@
           <p:cNvGraphicFramePr>
             <a:graphicFrameLocks noGrp="1"/>
           </p:cNvGraphicFramePr>
-          <p:nvPr/>
+          <p:nvPr>
+            <p:extLst>
+              <p:ext uri="{D42A27DB-BD31-4B8C-83A1-F6EECF244321}">
+                <p14:modId xmlns:p14="http://schemas.microsoft.com/office/powerpoint/2010/main" val="2732957066"/>
+              </p:ext>
+            </p:extLst>
+          </p:nvPr>
         </p:nvGraphicFramePr>
         <p:xfrm>
-          <a:off x="868680" y="2697480"/>
-          <a:ext cx="4937759" cy="2057400"/>
+          <a:off x="825500" y="2697480"/>
+          <a:ext cx="4826000" cy="2057400"/>
         </p:xfrm>
         <a:graphic>
           <a:graphicData uri="http://schemas.openxmlformats.org/drawingml/2006/table">
@@ -9758,21 +9786,21 @@
                 <a:tableStyleId>{5C22544A-7EE6-4342-B048-85BDC9FD1C3A}</a:tableStyleId>
               </a:tblPr>
               <a:tblGrid>
-                <a:gridCol w="1783080">
+                <a:gridCol w="1742722">
                   <a:extLst>
                     <a:ext uri="{9D8B030D-6E8A-4147-A177-3AD203B41FA5}">
                       <a16:colId xmlns:a16="http://schemas.microsoft.com/office/drawing/2014/main" val="20000"/>
                     </a:ext>
                   </a:extLst>
                 </a:gridCol>
-                <a:gridCol w="1874519">
+                <a:gridCol w="1832092">
                   <a:extLst>
                     <a:ext uri="{9D8B030D-6E8A-4147-A177-3AD203B41FA5}">
                       <a16:colId xmlns:a16="http://schemas.microsoft.com/office/drawing/2014/main" val="20001"/>
                     </a:ext>
                   </a:extLst>
                 </a:gridCol>
-                <a:gridCol w="1280160">
+                <a:gridCol w="1251186">
                   <a:extLst>
                     <a:ext uri="{9D8B030D-6E8A-4147-A177-3AD203B41FA5}">
                       <a16:colId xmlns:a16="http://schemas.microsoft.com/office/drawing/2014/main" val="20002"/>
@@ -10345,8 +10373,8 @@
         </p:nvSpPr>
         <p:spPr>
           <a:xfrm>
-            <a:off x="868680" y="4892040"/>
-            <a:ext cx="4937760" cy="1143000"/>
+            <a:off x="850900" y="4892040"/>
+            <a:ext cx="4775200" cy="1143000"/>
           </a:xfrm>
           <a:prstGeom prst="roundRect">
             <a:avLst/>
@@ -10460,8 +10488,8 @@
         </p:nvSpPr>
         <p:spPr>
           <a:xfrm>
-            <a:off x="6172200" y="1188720"/>
-            <a:ext cx="5303520" cy="5029200"/>
+            <a:off x="6159500" y="1188720"/>
+            <a:ext cx="5080000" cy="5029200"/>
           </a:xfrm>
           <a:prstGeom prst="roundRect">
             <a:avLst/>
@@ -10506,8 +10534,8 @@
         </p:nvSpPr>
         <p:spPr>
           <a:xfrm>
-            <a:off x="6172200" y="1188720"/>
-            <a:ext cx="5303520" cy="502920"/>
+            <a:off x="6159500" y="1188720"/>
+            <a:ext cx="5080000" cy="502920"/>
           </a:xfrm>
           <a:prstGeom prst="rect">
             <a:avLst/>
@@ -10562,8 +10590,8 @@
         </p:nvSpPr>
         <p:spPr>
           <a:xfrm>
-            <a:off x="6355080" y="1810512"/>
-            <a:ext cx="4937760" cy="777240"/>
+            <a:off x="6311900" y="1810512"/>
+            <a:ext cx="4775200" cy="777240"/>
           </a:xfrm>
           <a:prstGeom prst="roundRect">
             <a:avLst/>
@@ -10634,11 +10662,17 @@
           <p:cNvGraphicFramePr>
             <a:graphicFrameLocks noGrp="1"/>
           </p:cNvGraphicFramePr>
-          <p:nvPr/>
+          <p:nvPr>
+            <p:extLst>
+              <p:ext uri="{D42A27DB-BD31-4B8C-83A1-F6EECF244321}">
+                <p14:modId xmlns:p14="http://schemas.microsoft.com/office/powerpoint/2010/main" val="3339557474"/>
+              </p:ext>
+            </p:extLst>
+          </p:nvPr>
         </p:nvGraphicFramePr>
         <p:xfrm>
-          <a:off x="6355080" y="2697480"/>
-          <a:ext cx="4937760" cy="1371600"/>
+          <a:off x="6286500" y="2697480"/>
+          <a:ext cx="4826000" cy="1371600"/>
         </p:xfrm>
         <a:graphic>
           <a:graphicData uri="http://schemas.openxmlformats.org/drawingml/2006/table">
@@ -10647,35 +10681,35 @@
                 <a:tableStyleId>{5C22544A-7EE6-4342-B048-85BDC9FD1C3A}</a:tableStyleId>
               </a:tblPr>
               <a:tblGrid>
-                <a:gridCol w="1691640">
+                <a:gridCol w="1653353">
                   <a:extLst>
                     <a:ext uri="{9D8B030D-6E8A-4147-A177-3AD203B41FA5}">
                       <a16:colId xmlns:a16="http://schemas.microsoft.com/office/drawing/2014/main" val="20000"/>
                     </a:ext>
                   </a:extLst>
                 </a:gridCol>
-                <a:gridCol w="731520">
+                <a:gridCol w="714963">
                   <a:extLst>
                     <a:ext uri="{9D8B030D-6E8A-4147-A177-3AD203B41FA5}">
                       <a16:colId xmlns:a16="http://schemas.microsoft.com/office/drawing/2014/main" val="20001"/>
                     </a:ext>
                   </a:extLst>
                 </a:gridCol>
-                <a:gridCol w="731520">
+                <a:gridCol w="714963">
                   <a:extLst>
                     <a:ext uri="{9D8B030D-6E8A-4147-A177-3AD203B41FA5}">
                       <a16:colId xmlns:a16="http://schemas.microsoft.com/office/drawing/2014/main" val="20002"/>
                     </a:ext>
                   </a:extLst>
                 </a:gridCol>
-                <a:gridCol w="914400">
+                <a:gridCol w="893704">
                   <a:extLst>
                     <a:ext uri="{9D8B030D-6E8A-4147-A177-3AD203B41FA5}">
                       <a16:colId xmlns:a16="http://schemas.microsoft.com/office/drawing/2014/main" val="20003"/>
                     </a:ext>
                   </a:extLst>
                 </a:gridCol>
-                <a:gridCol w="868680">
+                <a:gridCol w="849018">
                   <a:extLst>
                     <a:ext uri="{9D8B030D-6E8A-4147-A177-3AD203B41FA5}">
                       <a16:colId xmlns:a16="http://schemas.microsoft.com/office/drawing/2014/main" val="20004"/>
@@ -11203,8 +11237,8 @@
         </p:nvSpPr>
         <p:spPr>
           <a:xfrm>
-            <a:off x="6355080" y="4206240"/>
-            <a:ext cx="4937760" cy="1828800"/>
+            <a:off x="6311900" y="4206240"/>
+            <a:ext cx="4775200" cy="1828800"/>
           </a:xfrm>
           <a:prstGeom prst="roundRect">
             <a:avLst/>
@@ -11348,6 +11382,36 @@
           </a:p>
         </p:txBody>
       </p:sp>
+      <p:pic>
+        <p:nvPicPr>
+          <p:cNvPr id="16" name="NextLevelLogo_11">
+            <a:extLst>
+              <a:ext uri="{FF2B5EF4-FFF2-40B4-BE49-F238E27FC236}">
+                <a16:creationId xmlns:a16="http://schemas.microsoft.com/office/drawing/2014/main" id="{7EBF85E1-ABEC-E74F-8C35-53A17E134104}"/>
+              </a:ext>
+            </a:extLst>
+          </p:cNvPr>
+          <p:cNvPicPr>
+            <a:picLocks/>
+          </p:cNvPicPr>
+          <p:nvPr/>
+        </p:nvPicPr>
+        <p:blipFill>
+          <a:blip r:embed="rId3"/>
+          <a:stretch>
+            <a:fillRect/>
+          </a:stretch>
+        </p:blipFill>
+        <p:spPr>
+          <a:xfrm>
+            <a:off x="10566400" y="5918200"/>
+            <a:ext cx="1473200" cy="814070"/>
+          </a:xfrm>
+          <a:prstGeom prst="rect">
+            <a:avLst/>
+          </a:prstGeom>
+        </p:spPr>
+      </p:pic>
     </p:spTree>
   </p:cSld>
   <p:clrMapOvr>
@@ -11381,8 +11445,8 @@
         </p:nvSpPr>
         <p:spPr>
           <a:xfrm>
-            <a:off x="698500" y="152400"/>
-            <a:ext cx="6500113" cy="569387"/>
+            <a:off x="698499" y="152399"/>
+            <a:ext cx="6807441" cy="592470"/>
           </a:xfrm>
           <a:prstGeom prst="rect">
             <a:avLst/>
@@ -11404,7 +11468,7 @@
               </a:defRPr>
             </a:pPr>
             <a:r>
-              <a:rPr sz="1000" b="1">
+              <a:rPr sz="1050" b="1">
                 <a:solidFill>
                   <a:srgbClr val="54A021"/>
                 </a:solidFill>
@@ -11423,7 +11487,7 @@
               </a:defRPr>
             </a:pPr>
             <a:r>
-              <a:rPr sz="2100" b="1">
+              <a:rPr sz="2200" b="1">
                 <a:solidFill>
                   <a:srgbClr val="2C3C43"/>
                 </a:solidFill>
@@ -11442,7 +11506,7 @@
         </p:nvSpPr>
         <p:spPr>
           <a:xfrm>
-            <a:off x="731520" y="6446520"/>
+            <a:off x="698500" y="6413500"/>
             <a:ext cx="5852884" cy="230832"/>
           </a:xfrm>
           <a:prstGeom prst="rect">
@@ -11484,8 +11548,8 @@
         </p:nvSpPr>
         <p:spPr>
           <a:xfrm>
-            <a:off x="731520" y="1371600"/>
-            <a:ext cx="3474720" cy="4846320"/>
+            <a:off x="698500" y="1371600"/>
+            <a:ext cx="3378200" cy="4846320"/>
           </a:xfrm>
           <a:prstGeom prst="roundRect">
             <a:avLst/>
@@ -11532,8 +11596,8 @@
         </p:nvSpPr>
         <p:spPr>
           <a:xfrm>
-            <a:off x="731520" y="1371600"/>
-            <a:ext cx="3474720" cy="640080"/>
+            <a:off x="698500" y="1371600"/>
+            <a:ext cx="3378200" cy="640080"/>
           </a:xfrm>
           <a:prstGeom prst="rect">
             <a:avLst/>
@@ -11578,8 +11642,8 @@
         </p:nvSpPr>
         <p:spPr>
           <a:xfrm>
-            <a:off x="1481719" y="1481328"/>
-            <a:ext cx="1974322" cy="276999"/>
+            <a:off x="850900" y="1481328"/>
+            <a:ext cx="3073400" cy="276999"/>
           </a:xfrm>
           <a:prstGeom prst="rect">
             <a:avLst/>
@@ -11587,7 +11651,7 @@
           <a:noFill/>
         </p:spPr>
         <p:txBody>
-          <a:bodyPr wrap="none">
+          <a:bodyPr wrap="square">
             <a:spAutoFit/>
           </a:bodyPr>
           <a:lstStyle/>
@@ -11617,8 +11681,8 @@
         </p:nvSpPr>
         <p:spPr>
           <a:xfrm>
-            <a:off x="868680" y="2148840"/>
-            <a:ext cx="3200400" cy="2092881"/>
+            <a:off x="850900" y="2148840"/>
+            <a:ext cx="3073400" cy="2092881"/>
           </a:xfrm>
           <a:prstGeom prst="rect">
             <a:avLst/>
@@ -11752,8 +11816,8 @@
         </p:nvSpPr>
         <p:spPr>
           <a:xfrm>
-            <a:off x="4370832" y="1371600"/>
-            <a:ext cx="3474720" cy="4846320"/>
+            <a:off x="4343400" y="1371600"/>
+            <a:ext cx="3378200" cy="4846320"/>
           </a:xfrm>
           <a:prstGeom prst="roundRect">
             <a:avLst/>
@@ -11800,8 +11864,8 @@
         </p:nvSpPr>
         <p:spPr>
           <a:xfrm>
-            <a:off x="4370832" y="1371600"/>
-            <a:ext cx="3474720" cy="640080"/>
+            <a:off x="4343400" y="1371600"/>
+            <a:ext cx="3378200" cy="640080"/>
           </a:xfrm>
           <a:prstGeom prst="rect">
             <a:avLst/>
@@ -11846,8 +11910,8 @@
         </p:nvSpPr>
         <p:spPr>
           <a:xfrm>
-            <a:off x="5225578" y="1481328"/>
-            <a:ext cx="1765227" cy="276999"/>
+            <a:off x="4495800" y="1481328"/>
+            <a:ext cx="3073400" cy="276999"/>
           </a:xfrm>
           <a:prstGeom prst="rect">
             <a:avLst/>
@@ -11855,7 +11919,7 @@
           <a:noFill/>
         </p:spPr>
         <p:txBody>
-          <a:bodyPr wrap="none">
+          <a:bodyPr wrap="square">
             <a:spAutoFit/>
           </a:bodyPr>
           <a:lstStyle/>
@@ -11885,8 +11949,8 @@
         </p:nvSpPr>
         <p:spPr>
           <a:xfrm>
-            <a:off x="4507992" y="2148840"/>
-            <a:ext cx="3200400" cy="1631216"/>
+            <a:off x="4495800" y="2148840"/>
+            <a:ext cx="3073400" cy="1785104"/>
           </a:xfrm>
           <a:prstGeom prst="rect">
             <a:avLst/>
@@ -12020,8 +12084,8 @@
         </p:nvSpPr>
         <p:spPr>
           <a:xfrm>
-            <a:off x="8010144" y="1371600"/>
-            <a:ext cx="3474720" cy="4846320"/>
+            <a:off x="7988300" y="1371600"/>
+            <a:ext cx="3378200" cy="4846320"/>
           </a:xfrm>
           <a:prstGeom prst="roundRect">
             <a:avLst/>
@@ -12068,8 +12132,8 @@
         </p:nvSpPr>
         <p:spPr>
           <a:xfrm>
-            <a:off x="8010144" y="1371600"/>
-            <a:ext cx="3474720" cy="640080"/>
+            <a:off x="7988300" y="1371600"/>
+            <a:ext cx="3378200" cy="640080"/>
           </a:xfrm>
           <a:prstGeom prst="rect">
             <a:avLst/>
@@ -12114,8 +12178,8 @@
         </p:nvSpPr>
         <p:spPr>
           <a:xfrm>
-            <a:off x="8845654" y="1481328"/>
-            <a:ext cx="1803699" cy="276999"/>
+            <a:off x="8140700" y="1481328"/>
+            <a:ext cx="3073400" cy="276999"/>
           </a:xfrm>
           <a:prstGeom prst="rect">
             <a:avLst/>
@@ -12123,7 +12187,7 @@
           <a:noFill/>
         </p:spPr>
         <p:txBody>
-          <a:bodyPr wrap="none">
+          <a:bodyPr wrap="square">
             <a:spAutoFit/>
           </a:bodyPr>
           <a:lstStyle/>
@@ -12153,8 +12217,8 @@
         </p:nvSpPr>
         <p:spPr>
           <a:xfrm>
-            <a:off x="8147304" y="2148840"/>
-            <a:ext cx="3200400" cy="1785104"/>
+            <a:off x="8140700" y="2148840"/>
+            <a:ext cx="3073400" cy="2092881"/>
           </a:xfrm>
           <a:prstGeom prst="rect">
             <a:avLst/>
@@ -12280,6 +12344,36 @@
           </a:p>
         </p:txBody>
       </p:sp>
+      <p:pic>
+        <p:nvPicPr>
+          <p:cNvPr id="18" name="NextLevelLogo_12">
+            <a:extLst>
+              <a:ext uri="{FF2B5EF4-FFF2-40B4-BE49-F238E27FC236}">
+                <a16:creationId xmlns:a16="http://schemas.microsoft.com/office/drawing/2014/main" id="{AFA25D3B-3A4A-1B6F-FA07-2B7B0E3B1326}"/>
+              </a:ext>
+            </a:extLst>
+          </p:cNvPr>
+          <p:cNvPicPr>
+            <a:picLocks/>
+          </p:cNvPicPr>
+          <p:nvPr/>
+        </p:nvPicPr>
+        <p:blipFill>
+          <a:blip r:embed="rId3"/>
+          <a:stretch>
+            <a:fillRect/>
+          </a:stretch>
+        </p:blipFill>
+        <p:spPr>
+          <a:xfrm>
+            <a:off x="10566400" y="5918200"/>
+            <a:ext cx="1473200" cy="814070"/>
+          </a:xfrm>
+          <a:prstGeom prst="rect">
+            <a:avLst/>
+          </a:prstGeom>
+        </p:spPr>
+      </p:pic>
     </p:spTree>
   </p:cSld>
   <p:clrMapOvr>
@@ -12313,8 +12407,8 @@
         </p:nvSpPr>
         <p:spPr>
           <a:xfrm>
-            <a:off x="698500" y="152400"/>
-            <a:ext cx="4895892" cy="569387"/>
+            <a:off x="698500" y="152399"/>
+            <a:ext cx="5112297" cy="592470"/>
           </a:xfrm>
           <a:prstGeom prst="rect">
             <a:avLst/>
@@ -12336,7 +12430,7 @@
               </a:defRPr>
             </a:pPr>
             <a:r>
-              <a:rPr sz="1000" b="1">
+              <a:rPr sz="1050" b="1">
                 <a:solidFill>
                   <a:srgbClr val="54A021"/>
                 </a:solidFill>
@@ -12355,7 +12449,7 @@
               </a:defRPr>
             </a:pPr>
             <a:r>
-              <a:rPr sz="2100" b="1">
+              <a:rPr sz="2200" b="1">
                 <a:solidFill>
                   <a:srgbClr val="2C3C43"/>
                 </a:solidFill>
@@ -12374,7 +12468,7 @@
         </p:nvSpPr>
         <p:spPr>
           <a:xfrm>
-            <a:off x="731520" y="6446520"/>
+            <a:off x="698500" y="6413500"/>
             <a:ext cx="5852884" cy="230832"/>
           </a:xfrm>
           <a:prstGeom prst="rect">
@@ -12416,8 +12510,8 @@
         </p:nvSpPr>
         <p:spPr>
           <a:xfrm>
-            <a:off x="731520" y="1371600"/>
-            <a:ext cx="2560320" cy="4846320"/>
+            <a:off x="698500" y="1371600"/>
+            <a:ext cx="2476500" cy="4846320"/>
           </a:xfrm>
           <a:prstGeom prst="roundRect">
             <a:avLst/>
@@ -12464,8 +12558,8 @@
         </p:nvSpPr>
         <p:spPr>
           <a:xfrm>
-            <a:off x="1600200" y="1554480"/>
-            <a:ext cx="822960" cy="822960"/>
+            <a:off x="1568450" y="1554480"/>
+            <a:ext cx="736600" cy="736600"/>
           </a:xfrm>
           <a:prstGeom prst="ellipse">
             <a:avLst/>
@@ -12520,8 +12614,8 @@
         </p:nvSpPr>
         <p:spPr>
           <a:xfrm>
-            <a:off x="1101014" y="2468880"/>
-            <a:ext cx="1821332" cy="415498"/>
+            <a:off x="800100" y="2468880"/>
+            <a:ext cx="2273300" cy="415498"/>
           </a:xfrm>
           <a:prstGeom prst="rect">
             <a:avLst/>
@@ -12529,7 +12623,7 @@
           <a:noFill/>
         </p:spPr>
         <p:txBody>
-          <a:bodyPr wrap="none">
+          <a:bodyPr wrap="square">
             <a:spAutoFit/>
           </a:bodyPr>
           <a:lstStyle/>
@@ -12574,8 +12668,8 @@
         </p:nvSpPr>
         <p:spPr>
           <a:xfrm>
-            <a:off x="868680" y="3200400"/>
-            <a:ext cx="2286000" cy="1346522"/>
+            <a:off x="800100" y="3200400"/>
+            <a:ext cx="2273300" cy="1346522"/>
           </a:xfrm>
           <a:prstGeom prst="rect">
             <a:avLst/>
@@ -12673,8 +12767,8 @@
         </p:nvSpPr>
         <p:spPr>
           <a:xfrm>
-            <a:off x="3456432" y="1371600"/>
-            <a:ext cx="2560320" cy="4846320"/>
+            <a:off x="3429000" y="1371600"/>
+            <a:ext cx="2476500" cy="4846320"/>
           </a:xfrm>
           <a:prstGeom prst="roundRect">
             <a:avLst/>
@@ -12721,8 +12815,8 @@
         </p:nvSpPr>
         <p:spPr>
           <a:xfrm>
-            <a:off x="4325112" y="1554480"/>
-            <a:ext cx="822960" cy="822960"/>
+            <a:off x="4298950" y="1554480"/>
+            <a:ext cx="736600" cy="736600"/>
           </a:xfrm>
           <a:prstGeom prst="ellipse">
             <a:avLst/>
@@ -12777,8 +12871,8 @@
         </p:nvSpPr>
         <p:spPr>
           <a:xfrm>
-            <a:off x="4063972" y="2468880"/>
-            <a:ext cx="1345240" cy="415498"/>
+            <a:off x="3530600" y="2468880"/>
+            <a:ext cx="2273300" cy="415498"/>
           </a:xfrm>
           <a:prstGeom prst="rect">
             <a:avLst/>
@@ -12786,7 +12880,7 @@
           <a:noFill/>
         </p:spPr>
         <p:txBody>
-          <a:bodyPr wrap="none">
+          <a:bodyPr wrap="square">
             <a:spAutoFit/>
           </a:bodyPr>
           <a:lstStyle/>
@@ -12831,8 +12925,8 @@
         </p:nvSpPr>
         <p:spPr>
           <a:xfrm>
-            <a:off x="3593592" y="3200400"/>
-            <a:ext cx="2286000" cy="1200329"/>
+            <a:off x="3530600" y="3200400"/>
+            <a:ext cx="2273300" cy="1200329"/>
           </a:xfrm>
           <a:prstGeom prst="rect">
             <a:avLst/>
@@ -12930,8 +13024,8 @@
         </p:nvSpPr>
         <p:spPr>
           <a:xfrm>
-            <a:off x="6181344" y="1371600"/>
-            <a:ext cx="2560320" cy="4846320"/>
+            <a:off x="6159500" y="1371600"/>
+            <a:ext cx="2476500" cy="4846320"/>
           </a:xfrm>
           <a:prstGeom prst="roundRect">
             <a:avLst/>
@@ -12978,8 +13072,8 @@
         </p:nvSpPr>
         <p:spPr>
           <a:xfrm>
-            <a:off x="7050024" y="1554480"/>
-            <a:ext cx="822960" cy="822960"/>
+            <a:off x="7029450" y="1554480"/>
+            <a:ext cx="736600" cy="736600"/>
           </a:xfrm>
           <a:prstGeom prst="ellipse">
             <a:avLst/>
@@ -13034,8 +13128,8 @@
         </p:nvSpPr>
         <p:spPr>
           <a:xfrm>
-            <a:off x="6764839" y="2468880"/>
-            <a:ext cx="1393330" cy="415498"/>
+            <a:off x="6261100" y="2468880"/>
+            <a:ext cx="2273300" cy="415498"/>
           </a:xfrm>
           <a:prstGeom prst="rect">
             <a:avLst/>
@@ -13043,7 +13137,7 @@
           <a:noFill/>
         </p:spPr>
         <p:txBody>
-          <a:bodyPr wrap="none">
+          <a:bodyPr wrap="square">
             <a:spAutoFit/>
           </a:bodyPr>
           <a:lstStyle/>
@@ -13088,8 +13182,8 @@
         </p:nvSpPr>
         <p:spPr>
           <a:xfrm>
-            <a:off x="6318504" y="3200400"/>
-            <a:ext cx="2286000" cy="1492716"/>
+            <a:off x="6261100" y="3200400"/>
+            <a:ext cx="2273300" cy="1492716"/>
           </a:xfrm>
           <a:prstGeom prst="rect">
             <a:avLst/>
@@ -13187,8 +13281,8 @@
         </p:nvSpPr>
         <p:spPr>
           <a:xfrm>
-            <a:off x="8906256" y="1371600"/>
-            <a:ext cx="2560320" cy="4846320"/>
+            <a:off x="8890000" y="1371600"/>
+            <a:ext cx="2476500" cy="4846320"/>
           </a:xfrm>
           <a:prstGeom prst="roundRect">
             <a:avLst/>
@@ -13235,8 +13329,8 @@
         </p:nvSpPr>
         <p:spPr>
           <a:xfrm>
-            <a:off x="9774936" y="1554480"/>
-            <a:ext cx="822960" cy="822960"/>
+            <a:off x="9759950" y="1554480"/>
+            <a:ext cx="736600" cy="736600"/>
           </a:xfrm>
           <a:prstGeom prst="ellipse">
             <a:avLst/>
@@ -13291,8 +13385,8 @@
         </p:nvSpPr>
         <p:spPr>
           <a:xfrm>
-            <a:off x="9444867" y="2468880"/>
-            <a:ext cx="1483098" cy="415498"/>
+            <a:off x="8991600" y="2468880"/>
+            <a:ext cx="2273300" cy="415498"/>
           </a:xfrm>
           <a:prstGeom prst="rect">
             <a:avLst/>
@@ -13300,7 +13394,7 @@
           <a:noFill/>
         </p:spPr>
         <p:txBody>
-          <a:bodyPr wrap="none">
+          <a:bodyPr wrap="square">
             <a:spAutoFit/>
           </a:bodyPr>
           <a:lstStyle/>
@@ -13345,8 +13439,8 @@
         </p:nvSpPr>
         <p:spPr>
           <a:xfrm>
-            <a:off x="9043416" y="3200400"/>
-            <a:ext cx="2286000" cy="1346522"/>
+            <a:off x="8991600" y="3200400"/>
+            <a:ext cx="2273300" cy="1346522"/>
           </a:xfrm>
           <a:prstGeom prst="rect">
             <a:avLst/>
@@ -13436,6 +13530,36 @@
           </a:p>
         </p:txBody>
       </p:sp>
+      <p:pic>
+        <p:nvPicPr>
+          <p:cNvPr id="22" name="NextLevelLogo_13">
+            <a:extLst>
+              <a:ext uri="{FF2B5EF4-FFF2-40B4-BE49-F238E27FC236}">
+                <a16:creationId xmlns:a16="http://schemas.microsoft.com/office/drawing/2014/main" id="{2F6BC0DD-2521-0E25-D39C-4B989862CC52}"/>
+              </a:ext>
+            </a:extLst>
+          </p:cNvPr>
+          <p:cNvPicPr>
+            <a:picLocks/>
+          </p:cNvPicPr>
+          <p:nvPr/>
+        </p:nvPicPr>
+        <p:blipFill>
+          <a:blip r:embed="rId3"/>
+          <a:stretch>
+            <a:fillRect/>
+          </a:stretch>
+        </p:blipFill>
+        <p:spPr>
+          <a:xfrm>
+            <a:off x="10566400" y="5918200"/>
+            <a:ext cx="1473200" cy="814070"/>
+          </a:xfrm>
+          <a:prstGeom prst="rect">
+            <a:avLst/>
+          </a:prstGeom>
+        </p:spPr>
+      </p:pic>
     </p:spTree>
   </p:cSld>
   <p:clrMapOvr>
@@ -13469,8 +13593,8 @@
         </p:nvSpPr>
         <p:spPr>
           <a:xfrm>
-            <a:off x="698500" y="152400"/>
-            <a:ext cx="6040500" cy="569387"/>
+            <a:off x="698500" y="152399"/>
+            <a:ext cx="6317114" cy="592470"/>
           </a:xfrm>
           <a:prstGeom prst="rect">
             <a:avLst/>
@@ -13492,7 +13616,7 @@
               </a:defRPr>
             </a:pPr>
             <a:r>
-              <a:rPr sz="1000" b="1">
+              <a:rPr sz="1050" b="1">
                 <a:solidFill>
                   <a:srgbClr val="54A021"/>
                 </a:solidFill>
@@ -13511,7 +13635,7 @@
               </a:defRPr>
             </a:pPr>
             <a:r>
-              <a:rPr sz="2100" b="1">
+              <a:rPr sz="2200" b="1">
                 <a:solidFill>
                   <a:srgbClr val="2C3C43"/>
                 </a:solidFill>
@@ -13530,7 +13654,7 @@
         </p:nvSpPr>
         <p:spPr>
           <a:xfrm>
-            <a:off x="731520" y="6446520"/>
+            <a:off x="698500" y="6413500"/>
             <a:ext cx="5852884" cy="230832"/>
           </a:xfrm>
           <a:prstGeom prst="rect">
@@ -13572,8 +13696,8 @@
         </p:nvSpPr>
         <p:spPr>
           <a:xfrm>
-            <a:off x="731520" y="1371600"/>
-            <a:ext cx="3474720" cy="4846320"/>
+            <a:off x="698500" y="1371600"/>
+            <a:ext cx="3378200" cy="4846320"/>
           </a:xfrm>
           <a:prstGeom prst="roundRect">
             <a:avLst/>
@@ -13620,8 +13744,8 @@
         </p:nvSpPr>
         <p:spPr>
           <a:xfrm>
-            <a:off x="914400" y="1554480"/>
-            <a:ext cx="3108960" cy="1097280"/>
+            <a:off x="825500" y="1554480"/>
+            <a:ext cx="3124200" cy="1097280"/>
           </a:xfrm>
           <a:prstGeom prst="roundRect">
             <a:avLst/>
@@ -13668,8 +13792,8 @@
         </p:nvSpPr>
         <p:spPr>
           <a:xfrm>
-            <a:off x="1493901" y="1600200"/>
-            <a:ext cx="1949957" cy="615553"/>
+            <a:off x="825500" y="1600200"/>
+            <a:ext cx="3124200" cy="615553"/>
           </a:xfrm>
           <a:prstGeom prst="rect">
             <a:avLst/>
@@ -13677,7 +13801,7 @@
           <a:noFill/>
         </p:spPr>
         <p:txBody>
-          <a:bodyPr wrap="none">
+          <a:bodyPr wrap="square">
             <a:spAutoFit/>
           </a:bodyPr>
           <a:lstStyle/>
@@ -13723,8 +13847,8 @@
         </p:nvSpPr>
         <p:spPr>
           <a:xfrm>
-            <a:off x="914400" y="2743200"/>
-            <a:ext cx="2089611" cy="276999"/>
+            <a:off x="825500" y="2743200"/>
+            <a:ext cx="3124200" cy="276999"/>
           </a:xfrm>
           <a:prstGeom prst="rect">
             <a:avLst/>
@@ -13732,7 +13856,7 @@
           <a:noFill/>
         </p:spPr>
         <p:txBody>
-          <a:bodyPr wrap="none">
+          <a:bodyPr wrap="square">
             <a:spAutoFit/>
           </a:bodyPr>
           <a:lstStyle/>
@@ -13762,8 +13886,8 @@
         </p:nvSpPr>
         <p:spPr>
           <a:xfrm>
-            <a:off x="914400" y="3154680"/>
-            <a:ext cx="3108960" cy="1492716"/>
+            <a:off x="825500" y="3154680"/>
+            <a:ext cx="3124200" cy="1346522"/>
           </a:xfrm>
           <a:prstGeom prst="rect">
             <a:avLst/>
@@ -13897,8 +14021,8 @@
         </p:nvSpPr>
         <p:spPr>
           <a:xfrm>
-            <a:off x="4370832" y="1371600"/>
-            <a:ext cx="3474720" cy="4846320"/>
+            <a:off x="4343400" y="1371600"/>
+            <a:ext cx="3378200" cy="4846320"/>
           </a:xfrm>
           <a:prstGeom prst="roundRect">
             <a:avLst/>
@@ -13945,8 +14069,8 @@
         </p:nvSpPr>
         <p:spPr>
           <a:xfrm>
-            <a:off x="4553712" y="1554480"/>
-            <a:ext cx="3108960" cy="1097280"/>
+            <a:off x="4470400" y="1554480"/>
+            <a:ext cx="3124200" cy="1097280"/>
           </a:xfrm>
           <a:prstGeom prst="roundRect">
             <a:avLst/>
@@ -13993,8 +14117,8 @@
         </p:nvSpPr>
         <p:spPr>
           <a:xfrm>
-            <a:off x="5369047" y="1600200"/>
-            <a:ext cx="1478290" cy="615553"/>
+            <a:off x="4470400" y="1600200"/>
+            <a:ext cx="3124200" cy="615553"/>
           </a:xfrm>
           <a:prstGeom prst="rect">
             <a:avLst/>
@@ -14002,7 +14126,7 @@
           <a:noFill/>
         </p:spPr>
         <p:txBody>
-          <a:bodyPr wrap="none">
+          <a:bodyPr wrap="square">
             <a:spAutoFit/>
           </a:bodyPr>
           <a:lstStyle/>
@@ -14048,8 +14172,8 @@
         </p:nvSpPr>
         <p:spPr>
           <a:xfrm>
-            <a:off x="4553712" y="2743200"/>
-            <a:ext cx="1989647" cy="276999"/>
+            <a:off x="4470400" y="2743200"/>
+            <a:ext cx="3124200" cy="276999"/>
           </a:xfrm>
           <a:prstGeom prst="rect">
             <a:avLst/>
@@ -14057,7 +14181,7 @@
           <a:noFill/>
         </p:spPr>
         <p:txBody>
-          <a:bodyPr wrap="none">
+          <a:bodyPr wrap="square">
             <a:spAutoFit/>
           </a:bodyPr>
           <a:lstStyle/>
@@ -14087,8 +14211,8 @@
         </p:nvSpPr>
         <p:spPr>
           <a:xfrm>
-            <a:off x="4553712" y="3154680"/>
-            <a:ext cx="3108960" cy="1492716"/>
+            <a:off x="4470400" y="3154680"/>
+            <a:ext cx="3124200" cy="1492716"/>
           </a:xfrm>
           <a:prstGeom prst="rect">
             <a:avLst/>
@@ -14222,8 +14346,8 @@
         </p:nvSpPr>
         <p:spPr>
           <a:xfrm>
-            <a:off x="8010144" y="1371600"/>
-            <a:ext cx="3474720" cy="4846320"/>
+            <a:off x="7988300" y="1371600"/>
+            <a:ext cx="3378200" cy="4846320"/>
           </a:xfrm>
           <a:prstGeom prst="roundRect">
             <a:avLst/>
@@ -14270,8 +14394,8 @@
         </p:nvSpPr>
         <p:spPr>
           <a:xfrm>
-            <a:off x="8193024" y="1554480"/>
-            <a:ext cx="3108960" cy="1097280"/>
+            <a:off x="8115300" y="1554480"/>
+            <a:ext cx="3124200" cy="1097280"/>
           </a:xfrm>
           <a:prstGeom prst="roundRect">
             <a:avLst/>
@@ -14318,8 +14442,8 @@
         </p:nvSpPr>
         <p:spPr>
           <a:xfrm>
-            <a:off x="8858478" y="1600200"/>
-            <a:ext cx="1778051" cy="615553"/>
+            <a:off x="8115300" y="1600200"/>
+            <a:ext cx="3124200" cy="615553"/>
           </a:xfrm>
           <a:prstGeom prst="rect">
             <a:avLst/>
@@ -14327,7 +14451,7 @@
           <a:noFill/>
         </p:spPr>
         <p:txBody>
-          <a:bodyPr wrap="none">
+          <a:bodyPr wrap="square">
             <a:spAutoFit/>
           </a:bodyPr>
           <a:lstStyle/>
@@ -14373,8 +14497,8 @@
         </p:nvSpPr>
         <p:spPr>
           <a:xfrm>
-            <a:off x="8193024" y="2743200"/>
-            <a:ext cx="2496196" cy="276999"/>
+            <a:off x="8115300" y="2743200"/>
+            <a:ext cx="3124200" cy="276999"/>
           </a:xfrm>
           <a:prstGeom prst="rect">
             <a:avLst/>
@@ -14382,7 +14506,7 @@
           <a:noFill/>
         </p:spPr>
         <p:txBody>
-          <a:bodyPr wrap="none">
+          <a:bodyPr wrap="square">
             <a:spAutoFit/>
           </a:bodyPr>
           <a:lstStyle/>
@@ -14412,8 +14536,8 @@
         </p:nvSpPr>
         <p:spPr>
           <a:xfrm>
-            <a:off x="8193024" y="3154680"/>
-            <a:ext cx="3108960" cy="1492716"/>
+            <a:off x="8115300" y="3154680"/>
+            <a:ext cx="3124200" cy="1492716"/>
           </a:xfrm>
           <a:prstGeom prst="rect">
             <a:avLst/>
@@ -14539,6 +14663,36 @@
           </a:p>
         </p:txBody>
       </p:sp>
+      <p:pic>
+        <p:nvPicPr>
+          <p:cNvPr id="21" name="NextLevelLogo_14">
+            <a:extLst>
+              <a:ext uri="{FF2B5EF4-FFF2-40B4-BE49-F238E27FC236}">
+                <a16:creationId xmlns:a16="http://schemas.microsoft.com/office/drawing/2014/main" id="{CA8D6CDD-4DA2-FF21-4BBD-9F8B783F7498}"/>
+              </a:ext>
+            </a:extLst>
+          </p:cNvPr>
+          <p:cNvPicPr>
+            <a:picLocks/>
+          </p:cNvPicPr>
+          <p:nvPr/>
+        </p:nvPicPr>
+        <p:blipFill>
+          <a:blip r:embed="rId3"/>
+          <a:stretch>
+            <a:fillRect/>
+          </a:stretch>
+        </p:blipFill>
+        <p:spPr>
+          <a:xfrm>
+            <a:off x="10566400" y="5918200"/>
+            <a:ext cx="1473200" cy="814070"/>
+          </a:xfrm>
+          <a:prstGeom prst="rect">
+            <a:avLst/>
+          </a:prstGeom>
+        </p:spPr>
+      </p:pic>
     </p:spTree>
   </p:cSld>
   <p:clrMapOvr>
@@ -14572,8 +14726,8 @@
         </p:nvSpPr>
         <p:spPr>
           <a:xfrm>
-            <a:off x="698500" y="152400"/>
-            <a:ext cx="5146665" cy="569387"/>
+            <a:off x="698499" y="152399"/>
+            <a:ext cx="5381730" cy="592470"/>
           </a:xfrm>
           <a:prstGeom prst="rect">
             <a:avLst/>
@@ -14595,7 +14749,7 @@
               </a:defRPr>
             </a:pPr>
             <a:r>
-              <a:rPr sz="1000" b="1">
+              <a:rPr sz="1050" b="1">
                 <a:solidFill>
                   <a:srgbClr val="54A021"/>
                 </a:solidFill>
@@ -14614,7 +14768,7 @@
               </a:defRPr>
             </a:pPr>
             <a:r>
-              <a:rPr sz="2100" b="1">
+              <a:rPr sz="2200" b="1">
                 <a:solidFill>
                   <a:srgbClr val="2C3C43"/>
                 </a:solidFill>
@@ -14633,7 +14787,7 @@
         </p:nvSpPr>
         <p:spPr>
           <a:xfrm>
-            <a:off x="731520" y="6446520"/>
+            <a:off x="698500" y="6413500"/>
             <a:ext cx="5852884" cy="230832"/>
           </a:xfrm>
           <a:prstGeom prst="rect">
@@ -14675,8 +14829,8 @@
         </p:nvSpPr>
         <p:spPr>
           <a:xfrm>
-            <a:off x="731520" y="1371600"/>
-            <a:ext cx="5257800" cy="4846320"/>
+            <a:off x="698500" y="1371600"/>
+            <a:ext cx="5080000" cy="4846320"/>
           </a:xfrm>
           <a:prstGeom prst="roundRect">
             <a:avLst/>
@@ -14723,8 +14877,8 @@
         </p:nvSpPr>
         <p:spPr>
           <a:xfrm>
-            <a:off x="731520" y="1371600"/>
-            <a:ext cx="5257800" cy="548640"/>
+            <a:off x="698500" y="1371600"/>
+            <a:ext cx="5080000" cy="548640"/>
           </a:xfrm>
           <a:prstGeom prst="rect">
             <a:avLst/>
@@ -14779,8 +14933,8 @@
         </p:nvSpPr>
         <p:spPr>
           <a:xfrm>
-            <a:off x="960120" y="2103120"/>
-            <a:ext cx="4800600" cy="1838965"/>
+            <a:off x="889000" y="2103120"/>
+            <a:ext cx="4699000" cy="2000548"/>
           </a:xfrm>
           <a:prstGeom prst="rect">
             <a:avLst/>
@@ -14914,8 +15068,8 @@
         </p:nvSpPr>
         <p:spPr>
           <a:xfrm>
-            <a:off x="6217920" y="1371600"/>
-            <a:ext cx="5257800" cy="4846320"/>
+            <a:off x="6159500" y="1371600"/>
+            <a:ext cx="5080000" cy="4846320"/>
           </a:xfrm>
           <a:prstGeom prst="roundRect">
             <a:avLst/>
@@ -14962,8 +15116,8 @@
         </p:nvSpPr>
         <p:spPr>
           <a:xfrm>
-            <a:off x="6217920" y="1371600"/>
-            <a:ext cx="5257800" cy="548640"/>
+            <a:off x="6159500" y="1371600"/>
+            <a:ext cx="5080000" cy="548640"/>
           </a:xfrm>
           <a:prstGeom prst="rect">
             <a:avLst/>
@@ -15018,8 +15172,8 @@
         </p:nvSpPr>
         <p:spPr>
           <a:xfrm>
-            <a:off x="6446520" y="2103120"/>
-            <a:ext cx="4800600" cy="1838965"/>
+            <a:off x="6350000" y="2103120"/>
+            <a:ext cx="4699000" cy="1838965"/>
           </a:xfrm>
           <a:prstGeom prst="rect">
             <a:avLst/>
@@ -15145,6 +15299,36 @@
           </a:p>
         </p:txBody>
       </p:sp>
+      <p:pic>
+        <p:nvPicPr>
+          <p:cNvPr id="12" name="NextLevelLogo_15">
+            <a:extLst>
+              <a:ext uri="{FF2B5EF4-FFF2-40B4-BE49-F238E27FC236}">
+                <a16:creationId xmlns:a16="http://schemas.microsoft.com/office/drawing/2014/main" id="{74C68879-6DF5-091A-01B5-CFE03EEE2398}"/>
+              </a:ext>
+            </a:extLst>
+          </p:cNvPr>
+          <p:cNvPicPr>
+            <a:picLocks/>
+          </p:cNvPicPr>
+          <p:nvPr/>
+        </p:nvPicPr>
+        <p:blipFill>
+          <a:blip r:embed="rId3"/>
+          <a:stretch>
+            <a:fillRect/>
+          </a:stretch>
+        </p:blipFill>
+        <p:spPr>
+          <a:xfrm>
+            <a:off x="10566400" y="5918200"/>
+            <a:ext cx="1473200" cy="814070"/>
+          </a:xfrm>
+          <a:prstGeom prst="rect">
+            <a:avLst/>
+          </a:prstGeom>
+        </p:spPr>
+      </p:pic>
     </p:spTree>
   </p:cSld>
   <p:clrMapOvr>
@@ -15178,8 +15362,8 @@
         </p:nvSpPr>
         <p:spPr>
           <a:xfrm>
-            <a:off x="1645920" y="822960"/>
-            <a:ext cx="8899855" cy="5212080"/>
+            <a:off x="698500" y="508000"/>
+            <a:ext cx="10604500" cy="5588000"/>
           </a:xfrm>
           <a:prstGeom prst="roundRect">
             <a:avLst/>
@@ -15226,8 +15410,8 @@
         </p:nvSpPr>
         <p:spPr>
           <a:xfrm>
-            <a:off x="1828800" y="1097280"/>
-            <a:ext cx="8534095" cy="815608"/>
+            <a:off x="889000" y="698500"/>
+            <a:ext cx="10223500" cy="684803"/>
           </a:xfrm>
           <a:prstGeom prst="rect">
             <a:avLst/>
@@ -15249,7 +15433,7 @@
               </a:defRPr>
             </a:pPr>
             <a:r>
-              <a:rPr b="1">
+              <a:rPr sz="2500" b="1">
                 <a:solidFill>
                   <a:srgbClr val="54A021"/>
                 </a:solidFill>
@@ -15267,7 +15451,7 @@
               </a:defRPr>
             </a:pPr>
             <a:r>
-              <a:rPr b="1">
+              <a:rPr sz="1350">
                 <a:solidFill>
                   <a:srgbClr val="2C3C43"/>
                 </a:solidFill>
@@ -15286,8 +15470,8 @@
         </p:nvSpPr>
         <p:spPr>
           <a:xfrm>
-            <a:off x="3352190" y="2560320"/>
-            <a:ext cx="5486400" cy="18288"/>
+            <a:off x="2032000" y="1676400"/>
+            <a:ext cx="7937500" cy="12700"/>
           </a:xfrm>
           <a:prstGeom prst="rect">
             <a:avLst/>
@@ -15295,8 +15479,10 @@
           <a:solidFill>
             <a:srgbClr val="B4C6E7"/>
           </a:solidFill>
-          <a:ln>
-            <a:noFill/>
+          <a:ln w="12700">
+            <a:solidFill>
+              <a:srgbClr val="90C226"/>
+            </a:solidFill>
           </a:ln>
         </p:spPr>
         <p:style>
@@ -15332,8 +15518,8 @@
         </p:nvSpPr>
         <p:spPr>
           <a:xfrm>
-            <a:off x="1828800" y="2743200"/>
-            <a:ext cx="8534095" cy="446276"/>
+            <a:off x="889000" y="1803400"/>
+            <a:ext cx="10223500" cy="461665"/>
           </a:xfrm>
           <a:prstGeom prst="rect">
             <a:avLst/>
@@ -15355,9 +15541,9 @@
               </a:defRPr>
             </a:pPr>
             <a:r>
-              <a:rPr sz="1150">
-                <a:solidFill>
-                  <a:srgbClr val="5A5F5A"/>
+              <a:rPr sz="1300" b="1">
+                <a:solidFill>
+                  <a:srgbClr val="2C3C43"/>
                 </a:solidFill>
                 <a:latin typeface="Trebuchet MS" panose="020B0603020202020204" pitchFamily="34" charset="0"/>
               </a:rPr>
@@ -15373,9 +15559,9 @@
               </a:defRPr>
             </a:pPr>
             <a:r>
-              <a:rPr sz="1150">
-                <a:solidFill>
-                  <a:srgbClr val="5A5F5A"/>
+              <a:rPr sz="1100">
+                <a:solidFill>
+                  <a:srgbClr val="505550"/>
                 </a:solidFill>
                 <a:latin typeface="Trebuchet MS" panose="020B0603020202020204" pitchFamily="34" charset="0"/>
               </a:rPr>
@@ -15392,8 +15578,8 @@
         </p:nvSpPr>
         <p:spPr>
           <a:xfrm>
-            <a:off x="2011680" y="4114800"/>
-            <a:ext cx="8168335" cy="1645920"/>
+            <a:off x="952500" y="2540000"/>
+            <a:ext cx="10096500" cy="3238500"/>
           </a:xfrm>
           <a:prstGeom prst="roundRect">
             <a:avLst/>
@@ -15440,8 +15626,8 @@
         </p:nvSpPr>
         <p:spPr>
           <a:xfrm>
-            <a:off x="2103120" y="4206240"/>
-            <a:ext cx="7985455" cy="584775"/>
+            <a:off x="1143000" y="2667000"/>
+            <a:ext cx="9715500" cy="1841530"/>
           </a:xfrm>
           <a:prstGeom prst="rect">
             <a:avLst/>
@@ -15455,6 +15641,9 @@
           <a:lstStyle/>
           <a:p>
             <a:pPr algn="ctr">
+              <a:spcAft>
+                <a:spcPts val="1000"/>
+              </a:spcAft>
               <a:defRPr sz="1100" b="1">
                 <a:solidFill>
                   <a:srgbClr val="DEEBF7"/>
@@ -15463,103 +15652,58 @@
               </a:defRPr>
             </a:pPr>
             <a:r>
-              <a:rPr sz="1000" b="1">
+              <a:rPr lang="de-DE" sz="1200" b="1">
                 <a:solidFill>
                   <a:srgbClr val="54A021"/>
                 </a:solidFill>
                 <a:latin typeface="Trebuchet MS" panose="020B0603020202020204" pitchFamily="34" charset="0"/>
               </a:rPr>
-              <a:t>PROJEKTTEAM (HANDLUNGSAUFGABE 2026):</a:t>
-            </a:r>
-          </a:p>
-          <a:p>
-            <a:pPr algn="ctr">
-              <a:defRPr sz="1150">
-                <a:solidFill>
-                  <a:srgbClr val="FFFFFF"/>
-                </a:solidFill>
-              </a:defRPr>
-            </a:pPr>
-            <a:r>
-              <a:rPr sz="1050">
-                <a:solidFill>
-                  <a:srgbClr val="2C3C43"/>
-                </a:solidFill>
-                <a:latin typeface="Trebuchet MS" panose="020B0603020202020204" pitchFamily="34" charset="0"/>
-              </a:rPr>
-              <a:t>Jan Kluth (Projektleiter)  •  Mathias Vonau (Techn. Planer)  •  Marian Bolecke (Kalkulation)</a:t>
-            </a:r>
-          </a:p>
-          <a:p>
-            <a:pPr algn="ctr">
-              <a:defRPr sz="1150">
-                <a:solidFill>
-                  <a:srgbClr val="FFFFFF"/>
-                </a:solidFill>
-              </a:defRPr>
-            </a:pPr>
-            <a:r>
-              <a:rPr sz="1050">
-                <a:solidFill>
-                  <a:srgbClr val="2C3C43"/>
-                </a:solidFill>
-                <a:latin typeface="Trebuchet MS" panose="020B0603020202020204" pitchFamily="34" charset="0"/>
-              </a:rPr>
-              <a:t>Marco Schmidt (Qualitätsmanagement)  •  Siyar (Berechnungen &amp; Dokumentation)</a:t>
-            </a:r>
-          </a:p>
-        </p:txBody>
-      </p:sp>
-      <p:sp>
-        <p:nvSpPr>
-          <p:cNvPr id="9" name="Titel 8">
+              <a:t>PROJEKTTEAM (HANDLUNGSAUFGABE 2026)
+• Jan Kluth – Projektleiter: Gesamtkoordination, Meilensteinüberwachung &amp; Präsentation
+• Mathias Vonau – Technischer Planer: Anforderungsanalyse, Lastenheft &amp; Vorinstallation / Staging
+• Marian Bolecke – Beschaffung &amp; Kalkulation: Reale Marktrecherche &amp; Vorwärtskalkulation
+• Marco Schmidt – QM &amp; Logistik: Wareneingangsprüfung (§ 377 HGB) &amp; Altdrucker-Entsorgung
+• Siyar – Berechnungen &amp; Doku: Server-Speicherbedarf (445 GiB) &amp; Energiekosten (1.771 €)</a:t>
+            </a:r>
+            <a:endParaRPr sz="1200" b="1">
+              <a:solidFill>
+                <a:srgbClr val="54A021"/>
+              </a:solidFill>
+              <a:latin typeface="Trebuchet MS" panose="020B0603020202020204" pitchFamily="34" charset="0"/>
+            </a:endParaRPr>
+          </a:p>
+        </p:txBody>
+      </p:sp>
+      <p:pic>
+        <p:nvPicPr>
+          <p:cNvPr id="10" name="NextLevelLogo_16">
             <a:extLst>
               <a:ext uri="{FF2B5EF4-FFF2-40B4-BE49-F238E27FC236}">
-                <a16:creationId xmlns:a16="http://schemas.microsoft.com/office/drawing/2014/main" id="{B7D142A1-EB7B-2908-BA8D-378F7972E434}"/>
+                <a16:creationId xmlns:a16="http://schemas.microsoft.com/office/drawing/2014/main" id="{674D93C0-9CB0-8B8C-11F0-51463F913536}"/>
               </a:ext>
             </a:extLst>
           </p:cNvPr>
-          <p:cNvSpPr>
-            <a:spLocks noGrp="1"/>
-          </p:cNvSpPr>
-          <p:nvPr>
-            <p:ph type="ctrTitle"/>
-          </p:nvPr>
-        </p:nvSpPr>
-        <p:spPr/>
-        <p:txBody>
-          <a:bodyPr/>
-          <a:lstStyle/>
-          <a:p>
-            <a:endParaRPr lang="de-DE"/>
-          </a:p>
-        </p:txBody>
-      </p:sp>
-      <p:sp>
-        <p:nvSpPr>
-          <p:cNvPr id="10" name="Untertitel 9">
-            <a:extLst>
-              <a:ext uri="{FF2B5EF4-FFF2-40B4-BE49-F238E27FC236}">
-                <a16:creationId xmlns:a16="http://schemas.microsoft.com/office/drawing/2014/main" id="{CCBC7ADF-9D00-C631-C03B-EC2B11178495}"/>
-              </a:ext>
-            </a:extLst>
-          </p:cNvPr>
-          <p:cNvSpPr>
-            <a:spLocks noGrp="1"/>
-          </p:cNvSpPr>
-          <p:nvPr>
-            <p:ph type="subTitle" idx="1"/>
-          </p:nvPr>
-        </p:nvSpPr>
-        <p:spPr/>
-        <p:txBody>
-          <a:bodyPr/>
-          <a:lstStyle/>
-          <a:p>
-            <a:endParaRPr lang="de-DE"/>
-          </a:p>
-        </p:txBody>
-      </p:sp>
+          <p:cNvPicPr>
+            <a:picLocks/>
+          </p:cNvPicPr>
+          <p:nvPr/>
+        </p:nvPicPr>
+        <p:blipFill>
+          <a:blip r:embed="rId3"/>
+          <a:stretch>
+            <a:fillRect/>
+          </a:stretch>
+        </p:blipFill>
+        <p:spPr>
+          <a:xfrm>
+            <a:off x="10566400" y="5918200"/>
+            <a:ext cx="1473200" cy="814070"/>
+          </a:xfrm>
+          <a:prstGeom prst="rect">
+            <a:avLst/>
+          </a:prstGeom>
+        </p:spPr>
+      </p:pic>
     </p:spTree>
   </p:cSld>
   <p:clrMapOvr>
@@ -15593,8 +15737,8 @@
         </p:nvSpPr>
         <p:spPr>
           <a:xfrm>
-            <a:off x="698500" y="152400"/>
-            <a:ext cx="4073551" cy="569387"/>
+            <a:off x="698499" y="152399"/>
+            <a:ext cx="4256293" cy="592470"/>
           </a:xfrm>
           <a:prstGeom prst="rect">
             <a:avLst/>
@@ -15616,7 +15760,7 @@
               </a:defRPr>
             </a:pPr>
             <a:r>
-              <a:rPr sz="1000" b="1">
+              <a:rPr sz="1050" b="1">
                 <a:solidFill>
                   <a:srgbClr val="54A021"/>
                 </a:solidFill>
@@ -15635,7 +15779,7 @@
               </a:defRPr>
             </a:pPr>
             <a:r>
-              <a:rPr sz="2100" b="1">
+              <a:rPr sz="2200" b="1">
                 <a:solidFill>
                   <a:srgbClr val="2C3C43"/>
                 </a:solidFill>
@@ -15654,7 +15798,7 @@
         </p:nvSpPr>
         <p:spPr>
           <a:xfrm>
-            <a:off x="731520" y="6446520"/>
+            <a:off x="698500" y="6413500"/>
             <a:ext cx="5791970" cy="230832"/>
           </a:xfrm>
           <a:prstGeom prst="rect">
@@ -15696,8 +15840,8 @@
         </p:nvSpPr>
         <p:spPr>
           <a:xfrm>
-            <a:off x="731520" y="1280160"/>
-            <a:ext cx="5212080" cy="658368"/>
+            <a:off x="698500" y="1280160"/>
+            <a:ext cx="5080000" cy="658368"/>
           </a:xfrm>
           <a:prstGeom prst="roundRect">
             <a:avLst/>
@@ -15744,8 +15888,8 @@
         </p:nvSpPr>
         <p:spPr>
           <a:xfrm>
-            <a:off x="822960" y="1316736"/>
-            <a:ext cx="5029200" cy="407804"/>
+            <a:off x="876300" y="1316736"/>
+            <a:ext cx="4724400" cy="407804"/>
           </a:xfrm>
           <a:prstGeom prst="rect">
             <a:avLst/>
@@ -15799,8 +15943,8 @@
         </p:nvSpPr>
         <p:spPr>
           <a:xfrm>
-            <a:off x="731520" y="1993391"/>
-            <a:ext cx="5212080" cy="658368"/>
+            <a:off x="698500" y="1993391"/>
+            <a:ext cx="5080000" cy="658368"/>
           </a:xfrm>
           <a:prstGeom prst="roundRect">
             <a:avLst/>
@@ -15847,8 +15991,8 @@
         </p:nvSpPr>
         <p:spPr>
           <a:xfrm>
-            <a:off x="822960" y="2029967"/>
-            <a:ext cx="5029200" cy="407804"/>
+            <a:off x="876300" y="2029967"/>
+            <a:ext cx="4724400" cy="407804"/>
           </a:xfrm>
           <a:prstGeom prst="rect">
             <a:avLst/>
@@ -15902,8 +16046,8 @@
         </p:nvSpPr>
         <p:spPr>
           <a:xfrm>
-            <a:off x="731520" y="2706624"/>
-            <a:ext cx="5212080" cy="658368"/>
+            <a:off x="698500" y="2706624"/>
+            <a:ext cx="5080000" cy="658368"/>
           </a:xfrm>
           <a:prstGeom prst="roundRect">
             <a:avLst/>
@@ -15950,8 +16094,8 @@
         </p:nvSpPr>
         <p:spPr>
           <a:xfrm>
-            <a:off x="822960" y="2743200"/>
-            <a:ext cx="5029200" cy="407804"/>
+            <a:off x="876300" y="2743200"/>
+            <a:ext cx="4724400" cy="407804"/>
           </a:xfrm>
           <a:prstGeom prst="rect">
             <a:avLst/>
@@ -16005,8 +16149,8 @@
         </p:nvSpPr>
         <p:spPr>
           <a:xfrm>
-            <a:off x="731520" y="3419856"/>
-            <a:ext cx="5212080" cy="658368"/>
+            <a:off x="698500" y="3419856"/>
+            <a:ext cx="5080000" cy="658368"/>
           </a:xfrm>
           <a:prstGeom prst="roundRect">
             <a:avLst/>
@@ -16053,8 +16197,8 @@
         </p:nvSpPr>
         <p:spPr>
           <a:xfrm>
-            <a:off x="822960" y="3456432"/>
-            <a:ext cx="5029200" cy="407804"/>
+            <a:off x="876300" y="3456432"/>
+            <a:ext cx="4724400" cy="407804"/>
           </a:xfrm>
           <a:prstGeom prst="rect">
             <a:avLst/>
@@ -16108,8 +16252,8 @@
         </p:nvSpPr>
         <p:spPr>
           <a:xfrm>
-            <a:off x="731520" y="4133087"/>
-            <a:ext cx="5212080" cy="658368"/>
+            <a:off x="698500" y="4133087"/>
+            <a:ext cx="5080000" cy="658368"/>
           </a:xfrm>
           <a:prstGeom prst="roundRect">
             <a:avLst/>
@@ -16156,8 +16300,8 @@
         </p:nvSpPr>
         <p:spPr>
           <a:xfrm>
-            <a:off x="822960" y="4169663"/>
-            <a:ext cx="5029200" cy="407804"/>
+            <a:off x="876300" y="4169663"/>
+            <a:ext cx="4724400" cy="407804"/>
           </a:xfrm>
           <a:prstGeom prst="rect">
             <a:avLst/>
@@ -16211,8 +16355,8 @@
         </p:nvSpPr>
         <p:spPr>
           <a:xfrm>
-            <a:off x="731520" y="4846320"/>
-            <a:ext cx="5212080" cy="658368"/>
+            <a:off x="698500" y="4846320"/>
+            <a:ext cx="5080000" cy="658368"/>
           </a:xfrm>
           <a:prstGeom prst="roundRect">
             <a:avLst/>
@@ -16259,8 +16403,8 @@
         </p:nvSpPr>
         <p:spPr>
           <a:xfrm>
-            <a:off x="822960" y="4882896"/>
-            <a:ext cx="5029200" cy="407804"/>
+            <a:off x="876300" y="4882896"/>
+            <a:ext cx="4724400" cy="407804"/>
           </a:xfrm>
           <a:prstGeom prst="rect">
             <a:avLst/>
@@ -16314,8 +16458,8 @@
         </p:nvSpPr>
         <p:spPr>
           <a:xfrm>
-            <a:off x="731520" y="5559552"/>
-            <a:ext cx="5212080" cy="658368"/>
+            <a:off x="698500" y="5559552"/>
+            <a:ext cx="5080000" cy="658368"/>
           </a:xfrm>
           <a:prstGeom prst="roundRect">
             <a:avLst/>
@@ -16362,8 +16506,8 @@
         </p:nvSpPr>
         <p:spPr>
           <a:xfrm>
-            <a:off x="822960" y="5596128"/>
-            <a:ext cx="5029200" cy="407804"/>
+            <a:off x="876300" y="5596128"/>
+            <a:ext cx="4724400" cy="407804"/>
           </a:xfrm>
           <a:prstGeom prst="rect">
             <a:avLst/>
@@ -16417,8 +16561,8 @@
         </p:nvSpPr>
         <p:spPr>
           <a:xfrm>
-            <a:off x="6172200" y="1280160"/>
-            <a:ext cx="5212080" cy="658368"/>
+            <a:off x="6159500" y="1280160"/>
+            <a:ext cx="5080000" cy="658368"/>
           </a:xfrm>
           <a:prstGeom prst="roundRect">
             <a:avLst/>
@@ -16465,8 +16609,8 @@
         </p:nvSpPr>
         <p:spPr>
           <a:xfrm>
-            <a:off x="6263640" y="1316736"/>
-            <a:ext cx="5029200" cy="407804"/>
+            <a:off x="6337300" y="1316736"/>
+            <a:ext cx="4724400" cy="407804"/>
           </a:xfrm>
           <a:prstGeom prst="rect">
             <a:avLst/>
@@ -16520,8 +16664,8 @@
         </p:nvSpPr>
         <p:spPr>
           <a:xfrm>
-            <a:off x="6172200" y="1993391"/>
-            <a:ext cx="5212080" cy="658368"/>
+            <a:off x="6159500" y="1993391"/>
+            <a:ext cx="5080000" cy="658368"/>
           </a:xfrm>
           <a:prstGeom prst="roundRect">
             <a:avLst/>
@@ -16568,8 +16712,8 @@
         </p:nvSpPr>
         <p:spPr>
           <a:xfrm>
-            <a:off x="6263640" y="2029967"/>
-            <a:ext cx="5029200" cy="407804"/>
+            <a:off x="6337300" y="2029967"/>
+            <a:ext cx="4724400" cy="407804"/>
           </a:xfrm>
           <a:prstGeom prst="rect">
             <a:avLst/>
@@ -16623,8 +16767,8 @@
         </p:nvSpPr>
         <p:spPr>
           <a:xfrm>
-            <a:off x="6172200" y="2706624"/>
-            <a:ext cx="5212080" cy="658368"/>
+            <a:off x="6159500" y="2706624"/>
+            <a:ext cx="5080000" cy="658368"/>
           </a:xfrm>
           <a:prstGeom prst="roundRect">
             <a:avLst/>
@@ -16671,8 +16815,8 @@
         </p:nvSpPr>
         <p:spPr>
           <a:xfrm>
-            <a:off x="6263640" y="2743200"/>
-            <a:ext cx="5029200" cy="407804"/>
+            <a:off x="6337300" y="2743200"/>
+            <a:ext cx="4724400" cy="407804"/>
           </a:xfrm>
           <a:prstGeom prst="rect">
             <a:avLst/>
@@ -16726,8 +16870,8 @@
         </p:nvSpPr>
         <p:spPr>
           <a:xfrm>
-            <a:off x="6172200" y="3419856"/>
-            <a:ext cx="5212080" cy="658368"/>
+            <a:off x="6159500" y="3419856"/>
+            <a:ext cx="5080000" cy="658368"/>
           </a:xfrm>
           <a:prstGeom prst="roundRect">
             <a:avLst/>
@@ -16774,8 +16918,8 @@
         </p:nvSpPr>
         <p:spPr>
           <a:xfrm>
-            <a:off x="6263640" y="3456432"/>
-            <a:ext cx="5029200" cy="407804"/>
+            <a:off x="6337300" y="3456432"/>
+            <a:ext cx="4724400" cy="407804"/>
           </a:xfrm>
           <a:prstGeom prst="rect">
             <a:avLst/>
@@ -16829,8 +16973,8 @@
         </p:nvSpPr>
         <p:spPr>
           <a:xfrm>
-            <a:off x="6172200" y="4133087"/>
-            <a:ext cx="5212080" cy="658368"/>
+            <a:off x="6159500" y="4133087"/>
+            <a:ext cx="5080000" cy="658368"/>
           </a:xfrm>
           <a:prstGeom prst="roundRect">
             <a:avLst/>
@@ -16877,8 +17021,8 @@
         </p:nvSpPr>
         <p:spPr>
           <a:xfrm>
-            <a:off x="6263640" y="4169663"/>
-            <a:ext cx="5029200" cy="407804"/>
+            <a:off x="6337300" y="4169663"/>
+            <a:ext cx="4724400" cy="407804"/>
           </a:xfrm>
           <a:prstGeom prst="rect">
             <a:avLst/>
@@ -16932,8 +17076,8 @@
         </p:nvSpPr>
         <p:spPr>
           <a:xfrm>
-            <a:off x="6172200" y="4846320"/>
-            <a:ext cx="5212080" cy="658368"/>
+            <a:off x="6159500" y="4846320"/>
+            <a:ext cx="5080000" cy="658368"/>
           </a:xfrm>
           <a:prstGeom prst="roundRect">
             <a:avLst/>
@@ -16980,8 +17124,8 @@
         </p:nvSpPr>
         <p:spPr>
           <a:xfrm>
-            <a:off x="6263640" y="4882896"/>
-            <a:ext cx="5029200" cy="407804"/>
+            <a:off x="6337300" y="4882896"/>
+            <a:ext cx="4724400" cy="407804"/>
           </a:xfrm>
           <a:prstGeom prst="rect">
             <a:avLst/>
@@ -17035,8 +17179,8 @@
         </p:nvSpPr>
         <p:spPr>
           <a:xfrm>
-            <a:off x="6172200" y="5559552"/>
-            <a:ext cx="5212080" cy="658368"/>
+            <a:off x="6159500" y="5559552"/>
+            <a:ext cx="5080000" cy="658368"/>
           </a:xfrm>
           <a:prstGeom prst="roundRect">
             <a:avLst/>
@@ -17083,8 +17227,8 @@
         </p:nvSpPr>
         <p:spPr>
           <a:xfrm>
-            <a:off x="6263640" y="5596128"/>
-            <a:ext cx="5029200" cy="407804"/>
+            <a:off x="6337300" y="5596128"/>
+            <a:ext cx="4724400" cy="407804"/>
           </a:xfrm>
           <a:prstGeom prst="rect">
             <a:avLst/>
@@ -17130,6 +17274,36 @@
           </a:p>
         </p:txBody>
       </p:sp>
+      <p:pic>
+        <p:nvPicPr>
+          <p:cNvPr id="34" name="NextLevelLogo_2">
+            <a:extLst>
+              <a:ext uri="{FF2B5EF4-FFF2-40B4-BE49-F238E27FC236}">
+                <a16:creationId xmlns:a16="http://schemas.microsoft.com/office/drawing/2014/main" id="{FE978EA9-8DE3-C1B0-5129-2C342D8F87D9}"/>
+              </a:ext>
+            </a:extLst>
+          </p:cNvPr>
+          <p:cNvPicPr>
+            <a:picLocks/>
+          </p:cNvPicPr>
+          <p:nvPr/>
+        </p:nvPicPr>
+        <p:blipFill>
+          <a:blip r:embed="rId3"/>
+          <a:stretch>
+            <a:fillRect/>
+          </a:stretch>
+        </p:blipFill>
+        <p:spPr>
+          <a:xfrm>
+            <a:off x="10566400" y="5918200"/>
+            <a:ext cx="1473200" cy="814070"/>
+          </a:xfrm>
+          <a:prstGeom prst="rect">
+            <a:avLst/>
+          </a:prstGeom>
+        </p:spPr>
+      </p:pic>
     </p:spTree>
   </p:cSld>
   <p:clrMapOvr>
@@ -17163,8 +17337,8 @@
         </p:nvSpPr>
         <p:spPr>
           <a:xfrm>
-            <a:off x="698500" y="152400"/>
-            <a:ext cx="5214441" cy="569387"/>
+            <a:off x="698499" y="152399"/>
+            <a:ext cx="5454185" cy="592470"/>
           </a:xfrm>
           <a:prstGeom prst="rect">
             <a:avLst/>
@@ -17186,7 +17360,7 @@
               </a:defRPr>
             </a:pPr>
             <a:r>
-              <a:rPr sz="1000" b="1">
+              <a:rPr sz="1050" b="1">
                 <a:solidFill>
                   <a:srgbClr val="54A021"/>
                 </a:solidFill>
@@ -17205,7 +17379,7 @@
               </a:defRPr>
             </a:pPr>
             <a:r>
-              <a:rPr sz="2100" b="1">
+              <a:rPr sz="2200" b="1">
                 <a:solidFill>
                   <a:srgbClr val="2C3C43"/>
                 </a:solidFill>
@@ -17224,7 +17398,7 @@
         </p:nvSpPr>
         <p:spPr>
           <a:xfrm>
-            <a:off x="731520" y="6446520"/>
+            <a:off x="698500" y="6413500"/>
             <a:ext cx="5791970" cy="230832"/>
           </a:xfrm>
           <a:prstGeom prst="rect">
@@ -17266,8 +17440,8 @@
         </p:nvSpPr>
         <p:spPr>
           <a:xfrm>
-            <a:off x="731520" y="1371600"/>
-            <a:ext cx="5212080" cy="4846320"/>
+            <a:off x="698500" y="1143000"/>
+            <a:ext cx="5080000" cy="4762500"/>
           </a:xfrm>
           <a:prstGeom prst="roundRect">
             <a:avLst/>
@@ -17314,8 +17488,8 @@
         </p:nvSpPr>
         <p:spPr>
           <a:xfrm>
-            <a:off x="914400" y="1554480"/>
-            <a:ext cx="4846320" cy="2318583"/>
+            <a:off x="889000" y="1270000"/>
+            <a:ext cx="4699000" cy="2318583"/>
           </a:xfrm>
           <a:prstGeom prst="rect">
             <a:avLst/>
@@ -17448,8 +17622,8 @@
         </p:nvSpPr>
         <p:spPr>
           <a:xfrm>
-            <a:off x="6217920" y="1371600"/>
-            <a:ext cx="5212080" cy="4846320"/>
+            <a:off x="6159500" y="1143000"/>
+            <a:ext cx="5080000" cy="4762500"/>
           </a:xfrm>
           <a:prstGeom prst="roundRect">
             <a:avLst/>
@@ -17496,8 +17670,8 @@
         </p:nvSpPr>
         <p:spPr>
           <a:xfrm>
-            <a:off x="6400800" y="1554480"/>
-            <a:ext cx="4846320" cy="2285241"/>
+            <a:off x="6350000" y="1270000"/>
+            <a:ext cx="4699000" cy="2608406"/>
           </a:xfrm>
           <a:prstGeom prst="rect">
             <a:avLst/>
@@ -17679,6 +17853,36 @@
           </a:p>
         </p:txBody>
       </p:sp>
+      <p:pic>
+        <p:nvPicPr>
+          <p:cNvPr id="10" name="NextLevelLogo_3">
+            <a:extLst>
+              <a:ext uri="{FF2B5EF4-FFF2-40B4-BE49-F238E27FC236}">
+                <a16:creationId xmlns:a16="http://schemas.microsoft.com/office/drawing/2014/main" id="{C8BEB326-3A99-A656-43C3-E136D1D2324A}"/>
+              </a:ext>
+            </a:extLst>
+          </p:cNvPr>
+          <p:cNvPicPr>
+            <a:picLocks/>
+          </p:cNvPicPr>
+          <p:nvPr/>
+        </p:nvPicPr>
+        <p:blipFill>
+          <a:blip r:embed="rId3"/>
+          <a:stretch>
+            <a:fillRect/>
+          </a:stretch>
+        </p:blipFill>
+        <p:spPr>
+          <a:xfrm>
+            <a:off x="10566400" y="5918200"/>
+            <a:ext cx="1473200" cy="814070"/>
+          </a:xfrm>
+          <a:prstGeom prst="rect">
+            <a:avLst/>
+          </a:prstGeom>
+        </p:spPr>
+      </p:pic>
     </p:spTree>
   </p:cSld>
   <p:clrMapOvr>
@@ -17712,8 +17916,8 @@
         </p:nvSpPr>
         <p:spPr>
           <a:xfrm>
-            <a:off x="698500" y="152400"/>
-            <a:ext cx="5216556" cy="569387"/>
+            <a:off x="698500" y="152399"/>
+            <a:ext cx="5449890" cy="592470"/>
           </a:xfrm>
           <a:prstGeom prst="rect">
             <a:avLst/>
@@ -17735,7 +17939,7 @@
               </a:defRPr>
             </a:pPr>
             <a:r>
-              <a:rPr sz="1000" b="1">
+              <a:rPr sz="1050" b="1">
                 <a:solidFill>
                   <a:srgbClr val="54A021"/>
                 </a:solidFill>
@@ -17754,7 +17958,7 @@
               </a:defRPr>
             </a:pPr>
             <a:r>
-              <a:rPr sz="2100" b="1">
+              <a:rPr sz="2200" b="1">
                 <a:solidFill>
                   <a:srgbClr val="2C3C43"/>
                 </a:solidFill>
@@ -17773,7 +17977,7 @@
         </p:nvSpPr>
         <p:spPr>
           <a:xfrm>
-            <a:off x="731520" y="6446520"/>
+            <a:off x="698500" y="6413500"/>
             <a:ext cx="5791970" cy="230832"/>
           </a:xfrm>
           <a:prstGeom prst="rect">
@@ -17815,14 +18019,14 @@
         </p:nvSpPr>
         <p:spPr>
           <a:xfrm>
-            <a:off x="731520" y="1371600"/>
-            <a:ext cx="2057400" cy="4846320"/>
+            <a:off x="698500" y="1371600"/>
+            <a:ext cx="1968500" cy="4846320"/>
           </a:xfrm>
           <a:prstGeom prst="roundRect">
             <a:avLst/>
           </a:prstGeom>
           <a:solidFill>
-            <a:srgbClr val="F6F9F4"/>
+            <a:srgbClr val="FFFFFF"/>
           </a:solidFill>
           <a:ln w="19050">
             <a:solidFill>
@@ -17863,8 +18067,8 @@
         </p:nvSpPr>
         <p:spPr>
           <a:xfrm>
-            <a:off x="731520" y="1371600"/>
-            <a:ext cx="2057400" cy="822960"/>
+            <a:off x="698500" y="1371600"/>
+            <a:ext cx="1968500" cy="822960"/>
           </a:xfrm>
           <a:prstGeom prst="rect">
             <a:avLst/>
@@ -17909,8 +18113,8 @@
         </p:nvSpPr>
         <p:spPr>
           <a:xfrm>
-            <a:off x="1298394" y="1444752"/>
-            <a:ext cx="923651" cy="292388"/>
+            <a:off x="698500" y="1444752"/>
+            <a:ext cx="1968500" cy="292388"/>
           </a:xfrm>
           <a:prstGeom prst="rect">
             <a:avLst/>
@@ -17918,7 +18122,7 @@
           <a:noFill/>
         </p:spPr>
         <p:txBody>
-          <a:bodyPr wrap="none">
+          <a:bodyPr wrap="square">
             <a:spAutoFit/>
           </a:bodyPr>
           <a:lstStyle/>
@@ -17951,8 +18155,8 @@
         </p:nvSpPr>
         <p:spPr>
           <a:xfrm>
-            <a:off x="1299997" y="1810512"/>
-            <a:ext cx="920445" cy="238527"/>
+            <a:off x="698500" y="1810512"/>
+            <a:ext cx="1968500" cy="238527"/>
           </a:xfrm>
           <a:prstGeom prst="rect">
             <a:avLst/>
@@ -17960,7 +18164,7 @@
           <a:noFill/>
         </p:spPr>
         <p:txBody>
-          <a:bodyPr wrap="none">
+          <a:bodyPr wrap="square">
             <a:spAutoFit/>
           </a:bodyPr>
           <a:lstStyle/>
@@ -17993,8 +18197,8 @@
         </p:nvSpPr>
         <p:spPr>
           <a:xfrm>
-            <a:off x="841248" y="2331720"/>
-            <a:ext cx="1837944" cy="1200329"/>
+            <a:off x="774700" y="2331720"/>
+            <a:ext cx="1816100" cy="1200329"/>
           </a:xfrm>
           <a:prstGeom prst="rect">
             <a:avLst/>
@@ -18104,14 +18308,14 @@
         </p:nvSpPr>
         <p:spPr>
           <a:xfrm>
-            <a:off x="2907791" y="1371600"/>
-            <a:ext cx="2057400" cy="4846320"/>
+            <a:off x="2857500" y="1371600"/>
+            <a:ext cx="1968500" cy="4846320"/>
           </a:xfrm>
           <a:prstGeom prst="roundRect">
             <a:avLst/>
           </a:prstGeom>
           <a:solidFill>
-            <a:srgbClr val="F6F9F4"/>
+            <a:srgbClr val="FFFFFF"/>
           </a:solidFill>
           <a:ln w="19050">
             <a:solidFill>
@@ -18152,8 +18356,8 @@
         </p:nvSpPr>
         <p:spPr>
           <a:xfrm>
-            <a:off x="2907791" y="1371600"/>
-            <a:ext cx="2057400" cy="822960"/>
+            <a:off x="2857500" y="1371600"/>
+            <a:ext cx="1968500" cy="822960"/>
           </a:xfrm>
           <a:prstGeom prst="rect">
             <a:avLst/>
@@ -18198,8 +18402,8 @@
         </p:nvSpPr>
         <p:spPr>
           <a:xfrm>
-            <a:off x="3290320" y="1444752"/>
-            <a:ext cx="1292341" cy="292388"/>
+            <a:off x="2857500" y="1444752"/>
+            <a:ext cx="1968500" cy="292388"/>
           </a:xfrm>
           <a:prstGeom prst="rect">
             <a:avLst/>
@@ -18207,7 +18411,7 @@
           <a:noFill/>
         </p:spPr>
         <p:txBody>
-          <a:bodyPr wrap="none">
+          <a:bodyPr wrap="square">
             <a:spAutoFit/>
           </a:bodyPr>
           <a:lstStyle/>
@@ -18240,8 +18444,8 @@
         </p:nvSpPr>
         <p:spPr>
           <a:xfrm>
-            <a:off x="3294328" y="1810512"/>
-            <a:ext cx="1284326" cy="238527"/>
+            <a:off x="2857500" y="1810512"/>
+            <a:ext cx="1968500" cy="238527"/>
           </a:xfrm>
           <a:prstGeom prst="rect">
             <a:avLst/>
@@ -18249,7 +18453,7 @@
           <a:noFill/>
         </p:spPr>
         <p:txBody>
-          <a:bodyPr wrap="none">
+          <a:bodyPr wrap="square">
             <a:spAutoFit/>
           </a:bodyPr>
           <a:lstStyle/>
@@ -18282,8 +18486,8 @@
         </p:nvSpPr>
         <p:spPr>
           <a:xfrm>
-            <a:off x="3017519" y="2331720"/>
-            <a:ext cx="1837944" cy="1054135"/>
+            <a:off x="2933700" y="2331720"/>
+            <a:ext cx="1816100" cy="1054135"/>
           </a:xfrm>
           <a:prstGeom prst="rect">
             <a:avLst/>
@@ -18393,14 +18597,14 @@
         </p:nvSpPr>
         <p:spPr>
           <a:xfrm>
-            <a:off x="5084064" y="1371600"/>
-            <a:ext cx="2057400" cy="4846320"/>
+            <a:off x="5016500" y="1371600"/>
+            <a:ext cx="1968500" cy="4846320"/>
           </a:xfrm>
           <a:prstGeom prst="roundRect">
             <a:avLst/>
           </a:prstGeom>
           <a:solidFill>
-            <a:srgbClr val="F6F9F4"/>
+            <a:srgbClr val="FFFFFF"/>
           </a:solidFill>
           <a:ln w="19050">
             <a:solidFill>
@@ -18441,8 +18645,8 @@
         </p:nvSpPr>
         <p:spPr>
           <a:xfrm>
-            <a:off x="5084064" y="1371600"/>
-            <a:ext cx="2057400" cy="822960"/>
+            <a:off x="5016500" y="1371600"/>
+            <a:ext cx="1968500" cy="822960"/>
           </a:xfrm>
           <a:prstGeom prst="rect">
             <a:avLst/>
@@ -18487,8 +18691,8 @@
         </p:nvSpPr>
         <p:spPr>
           <a:xfrm>
-            <a:off x="5430526" y="1444752"/>
-            <a:ext cx="1364476" cy="292388"/>
+            <a:off x="5016500" y="1444752"/>
+            <a:ext cx="1968500" cy="292388"/>
           </a:xfrm>
           <a:prstGeom prst="rect">
             <a:avLst/>
@@ -18496,7 +18700,7 @@
           <a:noFill/>
         </p:spPr>
         <p:txBody>
-          <a:bodyPr wrap="none">
+          <a:bodyPr wrap="square">
             <a:spAutoFit/>
           </a:bodyPr>
           <a:lstStyle/>
@@ -18529,8 +18733,8 @@
         </p:nvSpPr>
         <p:spPr>
           <a:xfrm>
-            <a:off x="5275836" y="1810512"/>
-            <a:ext cx="1673855" cy="238527"/>
+            <a:off x="5016500" y="1810512"/>
+            <a:ext cx="1968500" cy="384721"/>
           </a:xfrm>
           <a:prstGeom prst="rect">
             <a:avLst/>
@@ -18538,7 +18742,7 @@
           <a:noFill/>
         </p:spPr>
         <p:txBody>
-          <a:bodyPr wrap="none">
+          <a:bodyPr wrap="square">
             <a:spAutoFit/>
           </a:bodyPr>
           <a:lstStyle/>
@@ -18571,8 +18775,8 @@
         </p:nvSpPr>
         <p:spPr>
           <a:xfrm>
-            <a:off x="5193792" y="2331720"/>
-            <a:ext cx="1837944" cy="1054135"/>
+            <a:off x="5092700" y="2331720"/>
+            <a:ext cx="1816100" cy="1200329"/>
           </a:xfrm>
           <a:prstGeom prst="rect">
             <a:avLst/>
@@ -18682,14 +18886,14 @@
         </p:nvSpPr>
         <p:spPr>
           <a:xfrm>
-            <a:off x="7260336" y="1371600"/>
-            <a:ext cx="2057400" cy="4846320"/>
+            <a:off x="7175500" y="1371600"/>
+            <a:ext cx="1968500" cy="4846320"/>
           </a:xfrm>
           <a:prstGeom prst="roundRect">
             <a:avLst/>
           </a:prstGeom>
           <a:solidFill>
-            <a:srgbClr val="F6F9F4"/>
+            <a:srgbClr val="FFFFFF"/>
           </a:solidFill>
           <a:ln w="19050">
             <a:solidFill>
@@ -18730,8 +18934,8 @@
         </p:nvSpPr>
         <p:spPr>
           <a:xfrm>
-            <a:off x="7260336" y="1371600"/>
-            <a:ext cx="2057400" cy="822960"/>
+            <a:off x="7175500" y="1371600"/>
+            <a:ext cx="1968500" cy="822960"/>
           </a:xfrm>
           <a:prstGeom prst="rect">
             <a:avLst/>
@@ -18776,8 +18980,8 @@
         </p:nvSpPr>
         <p:spPr>
           <a:xfrm>
-            <a:off x="7629240" y="1444752"/>
-            <a:ext cx="1319592" cy="292388"/>
+            <a:off x="7175500" y="1444752"/>
+            <a:ext cx="1968500" cy="292388"/>
           </a:xfrm>
           <a:prstGeom prst="rect">
             <a:avLst/>
@@ -18785,7 +18989,7 @@
           <a:noFill/>
         </p:spPr>
         <p:txBody>
-          <a:bodyPr wrap="none">
+          <a:bodyPr wrap="square">
             <a:spAutoFit/>
           </a:bodyPr>
           <a:lstStyle/>
@@ -18818,8 +19022,8 @@
         </p:nvSpPr>
         <p:spPr>
           <a:xfrm>
-            <a:off x="7577142" y="1810512"/>
-            <a:ext cx="1423787" cy="238527"/>
+            <a:off x="7175500" y="1810512"/>
+            <a:ext cx="1968500" cy="238527"/>
           </a:xfrm>
           <a:prstGeom prst="rect">
             <a:avLst/>
@@ -18827,7 +19031,7 @@
           <a:noFill/>
         </p:spPr>
         <p:txBody>
-          <a:bodyPr wrap="none">
+          <a:bodyPr wrap="square">
             <a:spAutoFit/>
           </a:bodyPr>
           <a:lstStyle/>
@@ -18860,8 +19064,8 @@
         </p:nvSpPr>
         <p:spPr>
           <a:xfrm>
-            <a:off x="7370064" y="2331720"/>
-            <a:ext cx="1837944" cy="1200329"/>
+            <a:off x="7251700" y="2331720"/>
+            <a:ext cx="1816100" cy="1200329"/>
           </a:xfrm>
           <a:prstGeom prst="rect">
             <a:avLst/>
@@ -18971,14 +19175,14 @@
         </p:nvSpPr>
         <p:spPr>
           <a:xfrm>
-            <a:off x="9436608" y="1371600"/>
-            <a:ext cx="2057400" cy="4846320"/>
+            <a:off x="9334500" y="1371600"/>
+            <a:ext cx="1968500" cy="4846320"/>
           </a:xfrm>
           <a:prstGeom prst="roundRect">
             <a:avLst/>
           </a:prstGeom>
           <a:solidFill>
-            <a:srgbClr val="F6F9F4"/>
+            <a:srgbClr val="FFFFFF"/>
           </a:solidFill>
           <a:ln w="19050">
             <a:solidFill>
@@ -19019,8 +19223,8 @@
         </p:nvSpPr>
         <p:spPr>
           <a:xfrm>
-            <a:off x="9436608" y="1371600"/>
-            <a:ext cx="2057400" cy="822960"/>
+            <a:off x="9334500" y="1371600"/>
+            <a:ext cx="1968500" cy="822960"/>
           </a:xfrm>
           <a:prstGeom prst="rect">
             <a:avLst/>
@@ -19065,8 +19269,8 @@
         </p:nvSpPr>
         <p:spPr>
           <a:xfrm>
-            <a:off x="10181416" y="1444752"/>
-            <a:ext cx="567784" cy="292388"/>
+            <a:off x="9334500" y="1444752"/>
+            <a:ext cx="1968500" cy="292388"/>
           </a:xfrm>
           <a:prstGeom prst="rect">
             <a:avLst/>
@@ -19074,7 +19278,7 @@
           <a:noFill/>
         </p:spPr>
         <p:txBody>
-          <a:bodyPr wrap="none">
+          <a:bodyPr wrap="square">
             <a:spAutoFit/>
           </a:bodyPr>
           <a:lstStyle/>
@@ -19107,8 +19311,8 @@
         </p:nvSpPr>
         <p:spPr>
           <a:xfrm>
-            <a:off x="9811123" y="1810512"/>
-            <a:ext cx="1308370" cy="238527"/>
+            <a:off x="9334500" y="1810512"/>
+            <a:ext cx="1968500" cy="238527"/>
           </a:xfrm>
           <a:prstGeom prst="rect">
             <a:avLst/>
@@ -19116,7 +19320,7 @@
           <a:noFill/>
         </p:spPr>
         <p:txBody>
-          <a:bodyPr wrap="none">
+          <a:bodyPr wrap="square">
             <a:spAutoFit/>
           </a:bodyPr>
           <a:lstStyle/>
@@ -19149,8 +19353,8 @@
         </p:nvSpPr>
         <p:spPr>
           <a:xfrm>
-            <a:off x="9546336" y="2331720"/>
-            <a:ext cx="1837944" cy="1054135"/>
+            <a:off x="9410700" y="2331720"/>
+            <a:ext cx="1816100" cy="1054135"/>
           </a:xfrm>
           <a:prstGeom prst="rect">
             <a:avLst/>
@@ -19252,6 +19456,36 @@
           </a:p>
         </p:txBody>
       </p:sp>
+      <p:pic>
+        <p:nvPicPr>
+          <p:cNvPr id="31" name="NextLevelLogo_4">
+            <a:extLst>
+              <a:ext uri="{FF2B5EF4-FFF2-40B4-BE49-F238E27FC236}">
+                <a16:creationId xmlns:a16="http://schemas.microsoft.com/office/drawing/2014/main" id="{56E73E3E-9ED1-D73E-5CFF-7D53B5622C85}"/>
+              </a:ext>
+            </a:extLst>
+          </p:cNvPr>
+          <p:cNvPicPr>
+            <a:picLocks/>
+          </p:cNvPicPr>
+          <p:nvPr/>
+        </p:nvPicPr>
+        <p:blipFill>
+          <a:blip r:embed="rId3"/>
+          <a:stretch>
+            <a:fillRect/>
+          </a:stretch>
+        </p:blipFill>
+        <p:spPr>
+          <a:xfrm>
+            <a:off x="10566400" y="5918200"/>
+            <a:ext cx="1473200" cy="814070"/>
+          </a:xfrm>
+          <a:prstGeom prst="rect">
+            <a:avLst/>
+          </a:prstGeom>
+        </p:spPr>
+      </p:pic>
     </p:spTree>
   </p:cSld>
   <p:clrMapOvr>
@@ -19285,8 +19519,8 @@
         </p:nvSpPr>
         <p:spPr>
           <a:xfrm>
-            <a:off x="698500" y="152400"/>
-            <a:ext cx="4743606" cy="569387"/>
+            <a:off x="698500" y="152399"/>
+            <a:ext cx="4958409" cy="592470"/>
           </a:xfrm>
           <a:prstGeom prst="rect">
             <a:avLst/>
@@ -19308,7 +19542,7 @@
               </a:defRPr>
             </a:pPr>
             <a:r>
-              <a:rPr sz="1000" b="1">
+              <a:rPr sz="1050" b="1">
                 <a:solidFill>
                   <a:srgbClr val="54A021"/>
                 </a:solidFill>
@@ -19327,7 +19561,7 @@
               </a:defRPr>
             </a:pPr>
             <a:r>
-              <a:rPr sz="2100" b="1">
+              <a:rPr sz="2200" b="1">
                 <a:solidFill>
                   <a:srgbClr val="2C3C43"/>
                 </a:solidFill>
@@ -19346,7 +19580,7 @@
         </p:nvSpPr>
         <p:spPr>
           <a:xfrm>
-            <a:off x="731520" y="6446520"/>
+            <a:off x="698500" y="6413500"/>
             <a:ext cx="5791970" cy="230832"/>
           </a:xfrm>
           <a:prstGeom prst="rect">
@@ -19388,8 +19622,8 @@
         </p:nvSpPr>
         <p:spPr>
           <a:xfrm>
-            <a:off x="2712567" y="1097280"/>
-            <a:ext cx="6766560" cy="621792"/>
+            <a:off x="1524000" y="1097280"/>
+            <a:ext cx="8890000" cy="621792"/>
           </a:xfrm>
           <a:prstGeom prst="roundRect">
             <a:avLst/>
@@ -19462,7 +19696,7 @@
         </p:nvSpPr>
         <p:spPr>
           <a:xfrm>
-            <a:off x="6083147" y="1719072"/>
+            <a:off x="5969000" y="1719072"/>
             <a:ext cx="25400" cy="128016"/>
           </a:xfrm>
           <a:prstGeom prst="rect">
@@ -19506,8 +19740,8 @@
         </p:nvSpPr>
         <p:spPr>
           <a:xfrm>
-            <a:off x="1563624" y="1847088"/>
-            <a:ext cx="8924544" cy="25400"/>
+            <a:off x="1625600" y="1847088"/>
+            <a:ext cx="8686800" cy="25400"/>
           </a:xfrm>
           <a:prstGeom prst="rect">
             <a:avLst/>
@@ -19550,7 +19784,7 @@
         </p:nvSpPr>
         <p:spPr>
           <a:xfrm>
-            <a:off x="1550924" y="1847088"/>
+            <a:off x="1625600" y="1847088"/>
             <a:ext cx="25400" cy="128016"/>
           </a:xfrm>
           <a:prstGeom prst="rect">
@@ -19594,8 +19828,8 @@
         </p:nvSpPr>
         <p:spPr>
           <a:xfrm>
-            <a:off x="502920" y="1975104"/>
-            <a:ext cx="2121408" cy="621792"/>
+            <a:off x="635000" y="1975104"/>
+            <a:ext cx="1981200" cy="621792"/>
           </a:xfrm>
           <a:prstGeom prst="roundRect">
             <a:avLst/>
@@ -19668,8 +19902,8 @@
         </p:nvSpPr>
         <p:spPr>
           <a:xfrm>
-            <a:off x="502920" y="2633472"/>
-            <a:ext cx="2121408" cy="3584448"/>
+            <a:off x="635000" y="2633472"/>
+            <a:ext cx="1981200" cy="3584448"/>
           </a:xfrm>
           <a:prstGeom prst="roundRect">
             <a:avLst/>
@@ -19714,8 +19948,8 @@
         </p:nvSpPr>
         <p:spPr>
           <a:xfrm>
-            <a:off x="548640" y="2688336"/>
-            <a:ext cx="2029968" cy="548640"/>
+            <a:off x="673100" y="2688336"/>
+            <a:ext cx="1905000" cy="548640"/>
           </a:xfrm>
           <a:prstGeom prst="roundRect">
             <a:avLst/>
@@ -19788,8 +20022,8 @@
         </p:nvSpPr>
         <p:spPr>
           <a:xfrm>
-            <a:off x="548640" y="3273552"/>
-            <a:ext cx="2029968" cy="548640"/>
+            <a:off x="673100" y="3273552"/>
+            <a:ext cx="1905000" cy="548640"/>
           </a:xfrm>
           <a:prstGeom prst="roundRect">
             <a:avLst/>
@@ -19862,8 +20096,8 @@
         </p:nvSpPr>
         <p:spPr>
           <a:xfrm>
-            <a:off x="548640" y="3858768"/>
-            <a:ext cx="2029968" cy="548640"/>
+            <a:off x="673100" y="3858768"/>
+            <a:ext cx="1905000" cy="548640"/>
           </a:xfrm>
           <a:prstGeom prst="roundRect">
             <a:avLst/>
@@ -19936,8 +20170,8 @@
         </p:nvSpPr>
         <p:spPr>
           <a:xfrm>
-            <a:off x="548640" y="4443984"/>
-            <a:ext cx="2029968" cy="548640"/>
+            <a:off x="673100" y="4443984"/>
+            <a:ext cx="1905000" cy="548640"/>
           </a:xfrm>
           <a:prstGeom prst="roundRect">
             <a:avLst/>
@@ -20010,8 +20244,8 @@
         </p:nvSpPr>
         <p:spPr>
           <a:xfrm>
-            <a:off x="548640" y="5029200"/>
-            <a:ext cx="2029968" cy="548640"/>
+            <a:off x="673100" y="5029200"/>
+            <a:ext cx="1905000" cy="548640"/>
           </a:xfrm>
           <a:prstGeom prst="roundRect">
             <a:avLst/>
@@ -20084,8 +20318,8 @@
         </p:nvSpPr>
         <p:spPr>
           <a:xfrm>
-            <a:off x="548640" y="5614416"/>
-            <a:ext cx="2029968" cy="548640"/>
+            <a:off x="673100" y="5614416"/>
+            <a:ext cx="1905000" cy="548640"/>
           </a:xfrm>
           <a:prstGeom prst="roundRect">
             <a:avLst/>
@@ -20158,7 +20392,7 @@
         </p:nvSpPr>
         <p:spPr>
           <a:xfrm>
-            <a:off x="3782060" y="1847088"/>
+            <a:off x="3797300" y="1847088"/>
             <a:ext cx="25400" cy="128016"/>
           </a:xfrm>
           <a:prstGeom prst="rect">
@@ -20202,8 +20436,8 @@
         </p:nvSpPr>
         <p:spPr>
           <a:xfrm>
-            <a:off x="2734056" y="1975104"/>
-            <a:ext cx="2121408" cy="621792"/>
+            <a:off x="2806700" y="1975104"/>
+            <a:ext cx="1981200" cy="621792"/>
           </a:xfrm>
           <a:prstGeom prst="roundRect">
             <a:avLst/>
@@ -20276,8 +20510,8 @@
         </p:nvSpPr>
         <p:spPr>
           <a:xfrm>
-            <a:off x="2734056" y="2633472"/>
-            <a:ext cx="2121408" cy="3584448"/>
+            <a:off x="2806700" y="2633472"/>
+            <a:ext cx="1981200" cy="3584448"/>
           </a:xfrm>
           <a:prstGeom prst="roundRect">
             <a:avLst/>
@@ -20322,8 +20556,8 @@
         </p:nvSpPr>
         <p:spPr>
           <a:xfrm>
-            <a:off x="2779776" y="2688336"/>
-            <a:ext cx="2029968" cy="548640"/>
+            <a:off x="2844800" y="2688336"/>
+            <a:ext cx="1905000" cy="548640"/>
           </a:xfrm>
           <a:prstGeom prst="roundRect">
             <a:avLst/>
@@ -20396,8 +20630,8 @@
         </p:nvSpPr>
         <p:spPr>
           <a:xfrm>
-            <a:off x="2779776" y="3273552"/>
-            <a:ext cx="2029968" cy="548640"/>
+            <a:off x="2844800" y="3273552"/>
+            <a:ext cx="1905000" cy="548640"/>
           </a:xfrm>
           <a:prstGeom prst="roundRect">
             <a:avLst/>
@@ -20470,8 +20704,8 @@
         </p:nvSpPr>
         <p:spPr>
           <a:xfrm>
-            <a:off x="2779776" y="3858768"/>
-            <a:ext cx="2029968" cy="548640"/>
+            <a:off x="2844800" y="3858768"/>
+            <a:ext cx="1905000" cy="548640"/>
           </a:xfrm>
           <a:prstGeom prst="roundRect">
             <a:avLst/>
@@ -20544,8 +20778,8 @@
         </p:nvSpPr>
         <p:spPr>
           <a:xfrm>
-            <a:off x="2779776" y="4443984"/>
-            <a:ext cx="2029968" cy="548640"/>
+            <a:off x="2844800" y="4443984"/>
+            <a:ext cx="1905000" cy="548640"/>
           </a:xfrm>
           <a:prstGeom prst="roundRect">
             <a:avLst/>
@@ -20618,8 +20852,8 @@
         </p:nvSpPr>
         <p:spPr>
           <a:xfrm>
-            <a:off x="2779776" y="5029200"/>
-            <a:ext cx="2029968" cy="548640"/>
+            <a:off x="2844800" y="5029200"/>
+            <a:ext cx="1905000" cy="548640"/>
           </a:xfrm>
           <a:prstGeom prst="roundRect">
             <a:avLst/>
@@ -20692,8 +20926,8 @@
         </p:nvSpPr>
         <p:spPr>
           <a:xfrm>
-            <a:off x="2779776" y="5614416"/>
-            <a:ext cx="2029968" cy="548640"/>
+            <a:off x="2844800" y="5614416"/>
+            <a:ext cx="1905000" cy="548640"/>
           </a:xfrm>
           <a:prstGeom prst="roundRect">
             <a:avLst/>
@@ -20766,7 +21000,7 @@
         </p:nvSpPr>
         <p:spPr>
           <a:xfrm>
-            <a:off x="6013196" y="1847088"/>
+            <a:off x="5969000" y="1847088"/>
             <a:ext cx="25400" cy="128016"/>
           </a:xfrm>
           <a:prstGeom prst="rect">
@@ -20810,8 +21044,8 @@
         </p:nvSpPr>
         <p:spPr>
           <a:xfrm>
-            <a:off x="4965192" y="1975104"/>
-            <a:ext cx="2121408" cy="621792"/>
+            <a:off x="4978400" y="1975104"/>
+            <a:ext cx="1981200" cy="621792"/>
           </a:xfrm>
           <a:prstGeom prst="roundRect">
             <a:avLst/>
@@ -20884,8 +21118,8 @@
         </p:nvSpPr>
         <p:spPr>
           <a:xfrm>
-            <a:off x="4965192" y="2633472"/>
-            <a:ext cx="2121408" cy="3584448"/>
+            <a:off x="4978400" y="2633472"/>
+            <a:ext cx="1981200" cy="3584448"/>
           </a:xfrm>
           <a:prstGeom prst="roundRect">
             <a:avLst/>
@@ -20930,8 +21164,8 @@
         </p:nvSpPr>
         <p:spPr>
           <a:xfrm>
-            <a:off x="5010912" y="2688336"/>
-            <a:ext cx="2029968" cy="548640"/>
+            <a:off x="5016500" y="2688336"/>
+            <a:ext cx="1905000" cy="548640"/>
           </a:xfrm>
           <a:prstGeom prst="roundRect">
             <a:avLst/>
@@ -21004,8 +21238,8 @@
         </p:nvSpPr>
         <p:spPr>
           <a:xfrm>
-            <a:off x="5010912" y="3273552"/>
-            <a:ext cx="2029968" cy="548640"/>
+            <a:off x="5016500" y="3273552"/>
+            <a:ext cx="1905000" cy="548640"/>
           </a:xfrm>
           <a:prstGeom prst="roundRect">
             <a:avLst/>
@@ -21078,8 +21312,8 @@
         </p:nvSpPr>
         <p:spPr>
           <a:xfrm>
-            <a:off x="5010912" y="3858768"/>
-            <a:ext cx="2029968" cy="548640"/>
+            <a:off x="5016500" y="3858768"/>
+            <a:ext cx="1905000" cy="548640"/>
           </a:xfrm>
           <a:prstGeom prst="roundRect">
             <a:avLst/>
@@ -21152,8 +21386,8 @@
         </p:nvSpPr>
         <p:spPr>
           <a:xfrm>
-            <a:off x="5010912" y="4443984"/>
-            <a:ext cx="2029968" cy="548640"/>
+            <a:off x="5016500" y="4443984"/>
+            <a:ext cx="1905000" cy="548640"/>
           </a:xfrm>
           <a:prstGeom prst="roundRect">
             <a:avLst/>
@@ -21226,8 +21460,8 @@
         </p:nvSpPr>
         <p:spPr>
           <a:xfrm>
-            <a:off x="5010912" y="5029200"/>
-            <a:ext cx="2029968" cy="548640"/>
+            <a:off x="5016500" y="5029200"/>
+            <a:ext cx="1905000" cy="548640"/>
           </a:xfrm>
           <a:prstGeom prst="roundRect">
             <a:avLst/>
@@ -21300,8 +21534,8 @@
         </p:nvSpPr>
         <p:spPr>
           <a:xfrm>
-            <a:off x="5010912" y="5614416"/>
-            <a:ext cx="2029968" cy="548640"/>
+            <a:off x="5016500" y="5614416"/>
+            <a:ext cx="1905000" cy="548640"/>
           </a:xfrm>
           <a:prstGeom prst="roundRect">
             <a:avLst/>
@@ -21374,7 +21608,7 @@
         </p:nvSpPr>
         <p:spPr>
           <a:xfrm>
-            <a:off x="8244332" y="1847088"/>
+            <a:off x="8140700" y="1847088"/>
             <a:ext cx="25400" cy="128016"/>
           </a:xfrm>
           <a:prstGeom prst="rect">
@@ -21418,8 +21652,8 @@
         </p:nvSpPr>
         <p:spPr>
           <a:xfrm>
-            <a:off x="7196328" y="1975104"/>
-            <a:ext cx="2121408" cy="621792"/>
+            <a:off x="7150100" y="1975104"/>
+            <a:ext cx="1981200" cy="621792"/>
           </a:xfrm>
           <a:prstGeom prst="roundRect">
             <a:avLst/>
@@ -21492,8 +21726,8 @@
         </p:nvSpPr>
         <p:spPr>
           <a:xfrm>
-            <a:off x="7196328" y="2633472"/>
-            <a:ext cx="2121408" cy="3584448"/>
+            <a:off x="7150100" y="2633472"/>
+            <a:ext cx="1981200" cy="3584448"/>
           </a:xfrm>
           <a:prstGeom prst="roundRect">
             <a:avLst/>
@@ -21538,8 +21772,8 @@
         </p:nvSpPr>
         <p:spPr>
           <a:xfrm>
-            <a:off x="7242048" y="2688336"/>
-            <a:ext cx="2029968" cy="548640"/>
+            <a:off x="7188200" y="2688336"/>
+            <a:ext cx="1905000" cy="548640"/>
           </a:xfrm>
           <a:prstGeom prst="roundRect">
             <a:avLst/>
@@ -21612,8 +21846,8 @@
         </p:nvSpPr>
         <p:spPr>
           <a:xfrm>
-            <a:off x="7242048" y="3273552"/>
-            <a:ext cx="2029968" cy="548640"/>
+            <a:off x="7188200" y="3273552"/>
+            <a:ext cx="1905000" cy="548640"/>
           </a:xfrm>
           <a:prstGeom prst="roundRect">
             <a:avLst/>
@@ -21686,8 +21920,8 @@
         </p:nvSpPr>
         <p:spPr>
           <a:xfrm>
-            <a:off x="7242048" y="3858768"/>
-            <a:ext cx="2029968" cy="548640"/>
+            <a:off x="7188200" y="3858768"/>
+            <a:ext cx="1905000" cy="548640"/>
           </a:xfrm>
           <a:prstGeom prst="roundRect">
             <a:avLst/>
@@ -21760,8 +21994,8 @@
         </p:nvSpPr>
         <p:spPr>
           <a:xfrm>
-            <a:off x="7242048" y="4443984"/>
-            <a:ext cx="2029968" cy="548640"/>
+            <a:off x="7188200" y="4443984"/>
+            <a:ext cx="1905000" cy="548640"/>
           </a:xfrm>
           <a:prstGeom prst="roundRect">
             <a:avLst/>
@@ -21834,8 +22068,8 @@
         </p:nvSpPr>
         <p:spPr>
           <a:xfrm>
-            <a:off x="7242048" y="5029200"/>
-            <a:ext cx="2029968" cy="548640"/>
+            <a:off x="7188200" y="5029200"/>
+            <a:ext cx="1905000" cy="548640"/>
           </a:xfrm>
           <a:prstGeom prst="roundRect">
             <a:avLst/>
@@ -21908,8 +22142,8 @@
         </p:nvSpPr>
         <p:spPr>
           <a:xfrm>
-            <a:off x="7242048" y="5614416"/>
-            <a:ext cx="2029968" cy="548640"/>
+            <a:off x="7188200" y="5614416"/>
+            <a:ext cx="1905000" cy="548640"/>
           </a:xfrm>
           <a:prstGeom prst="roundRect">
             <a:avLst/>
@@ -21982,7 +22216,7 @@
         </p:nvSpPr>
         <p:spPr>
           <a:xfrm>
-            <a:off x="10475468" y="1847088"/>
+            <a:off x="10312400" y="1847088"/>
             <a:ext cx="25400" cy="128016"/>
           </a:xfrm>
           <a:prstGeom prst="rect">
@@ -22026,8 +22260,8 @@
         </p:nvSpPr>
         <p:spPr>
           <a:xfrm>
-            <a:off x="9427464" y="1975104"/>
-            <a:ext cx="2121408" cy="621792"/>
+            <a:off x="9321800" y="1975104"/>
+            <a:ext cx="1981200" cy="621792"/>
           </a:xfrm>
           <a:prstGeom prst="roundRect">
             <a:avLst/>
@@ -22100,8 +22334,8 @@
         </p:nvSpPr>
         <p:spPr>
           <a:xfrm>
-            <a:off x="9427464" y="2633472"/>
-            <a:ext cx="2121408" cy="3584448"/>
+            <a:off x="9321800" y="2633472"/>
+            <a:ext cx="1981200" cy="3584448"/>
           </a:xfrm>
           <a:prstGeom prst="roundRect">
             <a:avLst/>
@@ -22146,8 +22380,8 @@
         </p:nvSpPr>
         <p:spPr>
           <a:xfrm>
-            <a:off x="9473184" y="2688336"/>
-            <a:ext cx="2029968" cy="548640"/>
+            <a:off x="9359900" y="2688336"/>
+            <a:ext cx="1905000" cy="548640"/>
           </a:xfrm>
           <a:prstGeom prst="roundRect">
             <a:avLst/>
@@ -22220,8 +22454,8 @@
         </p:nvSpPr>
         <p:spPr>
           <a:xfrm>
-            <a:off x="9473184" y="3273552"/>
-            <a:ext cx="2029968" cy="548640"/>
+            <a:off x="9359900" y="3273552"/>
+            <a:ext cx="1905000" cy="548640"/>
           </a:xfrm>
           <a:prstGeom prst="roundRect">
             <a:avLst/>
@@ -22294,8 +22528,8 @@
         </p:nvSpPr>
         <p:spPr>
           <a:xfrm>
-            <a:off x="9473184" y="3858768"/>
-            <a:ext cx="2029968" cy="548640"/>
+            <a:off x="9359900" y="3858768"/>
+            <a:ext cx="1905000" cy="548640"/>
           </a:xfrm>
           <a:prstGeom prst="roundRect">
             <a:avLst/>
@@ -22368,8 +22602,8 @@
         </p:nvSpPr>
         <p:spPr>
           <a:xfrm>
-            <a:off x="9473184" y="4443984"/>
-            <a:ext cx="2029968" cy="548640"/>
+            <a:off x="9359900" y="4443984"/>
+            <a:ext cx="1905000" cy="548640"/>
           </a:xfrm>
           <a:prstGeom prst="roundRect">
             <a:avLst/>
@@ -22442,8 +22676,8 @@
         </p:nvSpPr>
         <p:spPr>
           <a:xfrm>
-            <a:off x="9473184" y="5029200"/>
-            <a:ext cx="2029968" cy="548640"/>
+            <a:off x="9359900" y="5029200"/>
+            <a:ext cx="1905000" cy="548640"/>
           </a:xfrm>
           <a:prstGeom prst="roundRect">
             <a:avLst/>
@@ -22516,8 +22750,8 @@
         </p:nvSpPr>
         <p:spPr>
           <a:xfrm>
-            <a:off x="9473184" y="5614416"/>
-            <a:ext cx="2029968" cy="548640"/>
+            <a:off x="9359900" y="5614416"/>
+            <a:ext cx="1905000" cy="548640"/>
           </a:xfrm>
           <a:prstGeom prst="roundRect">
             <a:avLst/>
@@ -22582,6 +22816,36 @@
           </a:p>
         </p:txBody>
       </p:sp>
+      <p:pic>
+        <p:nvPicPr>
+          <p:cNvPr id="54" name="NextLevelLogo_5">
+            <a:extLst>
+              <a:ext uri="{FF2B5EF4-FFF2-40B4-BE49-F238E27FC236}">
+                <a16:creationId xmlns:a16="http://schemas.microsoft.com/office/drawing/2014/main" id="{AC108B89-B471-B2E2-F3B5-B3ED6C9B0186}"/>
+              </a:ext>
+            </a:extLst>
+          </p:cNvPr>
+          <p:cNvPicPr>
+            <a:picLocks/>
+          </p:cNvPicPr>
+          <p:nvPr/>
+        </p:nvPicPr>
+        <p:blipFill>
+          <a:blip r:embed="rId3"/>
+          <a:stretch>
+            <a:fillRect/>
+          </a:stretch>
+        </p:blipFill>
+        <p:spPr>
+          <a:xfrm>
+            <a:off x="10566400" y="5918200"/>
+            <a:ext cx="1473200" cy="814070"/>
+          </a:xfrm>
+          <a:prstGeom prst="rect">
+            <a:avLst/>
+          </a:prstGeom>
+        </p:spPr>
+      </p:pic>
     </p:spTree>
   </p:cSld>
   <p:clrMapOvr>
@@ -22615,8 +22879,8 @@
         </p:nvSpPr>
         <p:spPr>
           <a:xfrm>
-            <a:off x="698500" y="152400"/>
-            <a:ext cx="5878532" cy="569387"/>
+            <a:off x="698500" y="152399"/>
+            <a:ext cx="6144631" cy="592470"/>
           </a:xfrm>
           <a:prstGeom prst="rect">
             <a:avLst/>
@@ -22638,7 +22902,7 @@
               </a:defRPr>
             </a:pPr>
             <a:r>
-              <a:rPr sz="1000" b="1">
+              <a:rPr sz="1050" b="1">
                 <a:solidFill>
                   <a:srgbClr val="54A021"/>
                 </a:solidFill>
@@ -22657,7 +22921,7 @@
               </a:defRPr>
             </a:pPr>
             <a:r>
-              <a:rPr sz="2100" b="1">
+              <a:rPr sz="2200" b="1">
                 <a:solidFill>
                   <a:srgbClr val="2C3C43"/>
                 </a:solidFill>
@@ -22676,7 +22940,7 @@
         </p:nvSpPr>
         <p:spPr>
           <a:xfrm>
-            <a:off x="731520" y="6446520"/>
+            <a:off x="698500" y="6413500"/>
             <a:ext cx="5791970" cy="230832"/>
           </a:xfrm>
           <a:prstGeom prst="rect">
@@ -22726,8 +22990,38 @@
         </p:blipFill>
         <p:spPr>
           <a:xfrm>
-            <a:off x="700887" y="1078992"/>
-            <a:ext cx="10789920" cy="5212080"/>
+            <a:off x="698500" y="1079500"/>
+            <a:ext cx="10604732" cy="5122625"/>
+          </a:xfrm>
+          <a:prstGeom prst="rect">
+            <a:avLst/>
+          </a:prstGeom>
+        </p:spPr>
+      </p:pic>
+      <p:pic>
+        <p:nvPicPr>
+          <p:cNvPr id="7" name="NextLevelLogo_6">
+            <a:extLst>
+              <a:ext uri="{FF2B5EF4-FFF2-40B4-BE49-F238E27FC236}">
+                <a16:creationId xmlns:a16="http://schemas.microsoft.com/office/drawing/2014/main" id="{8D847F8F-10CA-4499-6478-F0F4CEF9577E}"/>
+              </a:ext>
+            </a:extLst>
+          </p:cNvPr>
+          <p:cNvPicPr>
+            <a:picLocks/>
+          </p:cNvPicPr>
+          <p:nvPr/>
+        </p:nvPicPr>
+        <p:blipFill>
+          <a:blip r:embed="rId4"/>
+          <a:stretch>
+            <a:fillRect/>
+          </a:stretch>
+        </p:blipFill>
+        <p:spPr>
+          <a:xfrm>
+            <a:off x="10566400" y="5918200"/>
+            <a:ext cx="1473200" cy="814070"/>
           </a:xfrm>
           <a:prstGeom prst="rect">
             <a:avLst/>
@@ -22767,8 +23061,8 @@
         </p:nvSpPr>
         <p:spPr>
           <a:xfrm>
-            <a:off x="698500" y="152400"/>
-            <a:ext cx="6626238" cy="569387"/>
+            <a:off x="698500" y="152399"/>
+            <a:ext cx="6927794" cy="592470"/>
           </a:xfrm>
           <a:prstGeom prst="rect">
             <a:avLst/>
@@ -22790,7 +23084,7 @@
               </a:defRPr>
             </a:pPr>
             <a:r>
-              <a:rPr sz="1000" b="1">
+              <a:rPr sz="1050" b="1">
                 <a:solidFill>
                   <a:srgbClr val="54A021"/>
                 </a:solidFill>
@@ -22809,7 +23103,7 @@
               </a:defRPr>
             </a:pPr>
             <a:r>
-              <a:rPr sz="2100" b="1">
+              <a:rPr sz="2200" b="1">
                 <a:solidFill>
                   <a:srgbClr val="2C3C43"/>
                 </a:solidFill>
@@ -22828,7 +23122,7 @@
         </p:nvSpPr>
         <p:spPr>
           <a:xfrm>
-            <a:off x="731520" y="6446520"/>
+            <a:off x="698500" y="6413500"/>
             <a:ext cx="5791970" cy="230832"/>
           </a:xfrm>
           <a:prstGeom prst="rect">
@@ -22870,8 +23164,8 @@
         </p:nvSpPr>
         <p:spPr>
           <a:xfrm>
-            <a:off x="731520" y="1371600"/>
-            <a:ext cx="3474720" cy="4846320"/>
+            <a:off x="698500" y="1371600"/>
+            <a:ext cx="3378200" cy="4846320"/>
           </a:xfrm>
           <a:prstGeom prst="roundRect">
             <a:avLst/>
@@ -22918,8 +23212,8 @@
         </p:nvSpPr>
         <p:spPr>
           <a:xfrm>
-            <a:off x="731520" y="1371600"/>
-            <a:ext cx="3474720" cy="777240"/>
+            <a:off x="698500" y="1371600"/>
+            <a:ext cx="3378200" cy="777240"/>
           </a:xfrm>
           <a:prstGeom prst="rect">
             <a:avLst/>
@@ -22964,8 +23258,8 @@
         </p:nvSpPr>
         <p:spPr>
           <a:xfrm>
-            <a:off x="1552603" y="1444752"/>
-            <a:ext cx="1832553" cy="276999"/>
+            <a:off x="850900" y="1444752"/>
+            <a:ext cx="3073400" cy="276999"/>
           </a:xfrm>
           <a:prstGeom prst="rect">
             <a:avLst/>
@@ -22973,7 +23267,7 @@
           <a:noFill/>
         </p:spPr>
         <p:txBody>
-          <a:bodyPr wrap="none">
+          <a:bodyPr wrap="square">
             <a:spAutoFit/>
           </a:bodyPr>
           <a:lstStyle/>
@@ -23003,8 +23297,8 @@
         </p:nvSpPr>
         <p:spPr>
           <a:xfrm>
-            <a:off x="1462835" y="1783080"/>
-            <a:ext cx="2012089" cy="230832"/>
+            <a:off x="850900" y="1783080"/>
+            <a:ext cx="3073400" cy="230832"/>
           </a:xfrm>
           <a:prstGeom prst="rect">
             <a:avLst/>
@@ -23012,7 +23306,7 @@
           <a:noFill/>
         </p:spPr>
         <p:txBody>
-          <a:bodyPr wrap="none">
+          <a:bodyPr wrap="square">
             <a:spAutoFit/>
           </a:bodyPr>
           <a:lstStyle/>
@@ -23042,8 +23336,8 @@
         </p:nvSpPr>
         <p:spPr>
           <a:xfrm>
-            <a:off x="868680" y="2286000"/>
-            <a:ext cx="3200400" cy="1646605"/>
+            <a:off x="850900" y="2286000"/>
+            <a:ext cx="3073400" cy="1792798"/>
           </a:xfrm>
           <a:prstGeom prst="rect">
             <a:avLst/>
@@ -23233,8 +23527,8 @@
         </p:nvSpPr>
         <p:spPr>
           <a:xfrm>
-            <a:off x="4370832" y="1371600"/>
-            <a:ext cx="3474720" cy="4846320"/>
+            <a:off x="4343400" y="1371600"/>
+            <a:ext cx="3378200" cy="4846320"/>
           </a:xfrm>
           <a:prstGeom prst="roundRect">
             <a:avLst/>
@@ -23281,8 +23575,8 @@
         </p:nvSpPr>
         <p:spPr>
           <a:xfrm>
-            <a:off x="4370832" y="1371600"/>
-            <a:ext cx="3474720" cy="777240"/>
+            <a:off x="4343400" y="1371600"/>
+            <a:ext cx="3378200" cy="777240"/>
           </a:xfrm>
           <a:prstGeom prst="rect">
             <a:avLst/>
@@ -23327,8 +23621,8 @@
         </p:nvSpPr>
         <p:spPr>
           <a:xfrm>
-            <a:off x="5111541" y="1444752"/>
-            <a:ext cx="1993302" cy="276999"/>
+            <a:off x="4495800" y="1444752"/>
+            <a:ext cx="3073400" cy="276999"/>
           </a:xfrm>
           <a:prstGeom prst="rect">
             <a:avLst/>
@@ -23336,7 +23630,7 @@
           <a:noFill/>
         </p:spPr>
         <p:txBody>
-          <a:bodyPr wrap="none">
+          <a:bodyPr wrap="square">
             <a:spAutoFit/>
           </a:bodyPr>
           <a:lstStyle/>
@@ -23366,8 +23660,8 @@
         </p:nvSpPr>
         <p:spPr>
           <a:xfrm>
-            <a:off x="5095735" y="1783080"/>
-            <a:ext cx="2024913" cy="230832"/>
+            <a:off x="4495800" y="1783080"/>
+            <a:ext cx="3073400" cy="230832"/>
           </a:xfrm>
           <a:prstGeom prst="rect">
             <a:avLst/>
@@ -23375,7 +23669,7 @@
           <a:noFill/>
         </p:spPr>
         <p:txBody>
-          <a:bodyPr wrap="none">
+          <a:bodyPr wrap="square">
             <a:spAutoFit/>
           </a:bodyPr>
           <a:lstStyle/>
@@ -23405,8 +23699,8 @@
         </p:nvSpPr>
         <p:spPr>
           <a:xfrm>
-            <a:off x="4507992" y="2286000"/>
-            <a:ext cx="3200400" cy="2085186"/>
+            <a:off x="4495800" y="2286000"/>
+            <a:ext cx="3073400" cy="2231380"/>
           </a:xfrm>
           <a:prstGeom prst="rect">
             <a:avLst/>
@@ -23596,8 +23890,8 @@
         </p:nvSpPr>
         <p:spPr>
           <a:xfrm>
-            <a:off x="8010144" y="1371600"/>
-            <a:ext cx="3474720" cy="4846320"/>
+            <a:off x="7988300" y="1371600"/>
+            <a:ext cx="3378200" cy="4846320"/>
           </a:xfrm>
           <a:prstGeom prst="roundRect">
             <a:avLst/>
@@ -23644,8 +23938,8 @@
         </p:nvSpPr>
         <p:spPr>
           <a:xfrm>
-            <a:off x="8010144" y="1371600"/>
-            <a:ext cx="3474720" cy="777240"/>
+            <a:off x="7988300" y="1371600"/>
+            <a:ext cx="3378200" cy="777240"/>
           </a:xfrm>
           <a:prstGeom prst="rect">
             <a:avLst/>
@@ -23690,8 +23984,8 @@
         </p:nvSpPr>
         <p:spPr>
           <a:xfrm>
-            <a:off x="8946643" y="1444752"/>
-            <a:ext cx="1601721" cy="276999"/>
+            <a:off x="8140700" y="1444752"/>
+            <a:ext cx="3073400" cy="276999"/>
           </a:xfrm>
           <a:prstGeom prst="rect">
             <a:avLst/>
@@ -23699,7 +23993,7 @@
           <a:noFill/>
         </p:spPr>
         <p:txBody>
-          <a:bodyPr wrap="none">
+          <a:bodyPr wrap="square">
             <a:spAutoFit/>
           </a:bodyPr>
           <a:lstStyle/>
@@ -23729,8 +24023,8 @@
         </p:nvSpPr>
         <p:spPr>
           <a:xfrm>
-            <a:off x="8860081" y="1783080"/>
-            <a:ext cx="1774845" cy="230832"/>
+            <a:off x="8140700" y="1783080"/>
+            <a:ext cx="3073400" cy="230832"/>
           </a:xfrm>
           <a:prstGeom prst="rect">
             <a:avLst/>
@@ -23738,7 +24032,7 @@
           <a:noFill/>
         </p:spPr>
         <p:txBody>
-          <a:bodyPr wrap="none">
+          <a:bodyPr wrap="square">
             <a:spAutoFit/>
           </a:bodyPr>
           <a:lstStyle/>
@@ -23768,8 +24062,8 @@
         </p:nvSpPr>
         <p:spPr>
           <a:xfrm>
-            <a:off x="8147304" y="2286000"/>
-            <a:ext cx="3200400" cy="2231380"/>
+            <a:off x="8140700" y="2286000"/>
+            <a:ext cx="3073400" cy="2231380"/>
           </a:xfrm>
           <a:prstGeom prst="rect">
             <a:avLst/>
@@ -23951,6 +24245,36 @@
           </a:p>
         </p:txBody>
       </p:sp>
+      <p:pic>
+        <p:nvPicPr>
+          <p:cNvPr id="21" name="NextLevelLogo_7">
+            <a:extLst>
+              <a:ext uri="{FF2B5EF4-FFF2-40B4-BE49-F238E27FC236}">
+                <a16:creationId xmlns:a16="http://schemas.microsoft.com/office/drawing/2014/main" id="{3D44458C-66EC-D47B-89D8-EF93F87078E7}"/>
+              </a:ext>
+            </a:extLst>
+          </p:cNvPr>
+          <p:cNvPicPr>
+            <a:picLocks/>
+          </p:cNvPicPr>
+          <p:nvPr/>
+        </p:nvPicPr>
+        <p:blipFill>
+          <a:blip r:embed="rId3"/>
+          <a:stretch>
+            <a:fillRect/>
+          </a:stretch>
+        </p:blipFill>
+        <p:spPr>
+          <a:xfrm>
+            <a:off x="10566400" y="5918200"/>
+            <a:ext cx="1473200" cy="814070"/>
+          </a:xfrm>
+          <a:prstGeom prst="rect">
+            <a:avLst/>
+          </a:prstGeom>
+        </p:spPr>
+      </p:pic>
     </p:spTree>
   </p:cSld>
   <p:clrMapOvr>
@@ -23984,8 +24308,8 @@
         </p:nvSpPr>
         <p:spPr>
           <a:xfrm>
-            <a:off x="698500" y="152400"/>
-            <a:ext cx="6747553" cy="569387"/>
+            <a:off x="698499" y="152399"/>
+            <a:ext cx="7051546" cy="592470"/>
           </a:xfrm>
           <a:prstGeom prst="rect">
             <a:avLst/>
@@ -24007,7 +24331,7 @@
               </a:defRPr>
             </a:pPr>
             <a:r>
-              <a:rPr sz="1000" b="1">
+              <a:rPr sz="1050" b="1">
                 <a:solidFill>
                   <a:srgbClr val="54A021"/>
                 </a:solidFill>
@@ -24026,7 +24350,7 @@
               </a:defRPr>
             </a:pPr>
             <a:r>
-              <a:rPr sz="2100" b="1">
+              <a:rPr sz="2200" b="1">
                 <a:solidFill>
                   <a:srgbClr val="2C3C43"/>
                 </a:solidFill>
@@ -24045,7 +24369,7 @@
         </p:nvSpPr>
         <p:spPr>
           <a:xfrm>
-            <a:off x="731520" y="6446520"/>
+            <a:off x="698500" y="6413500"/>
             <a:ext cx="5791970" cy="230832"/>
           </a:xfrm>
           <a:prstGeom prst="rect">
@@ -24087,8 +24411,8 @@
         </p:nvSpPr>
         <p:spPr>
           <a:xfrm>
-            <a:off x="731520" y="1371600"/>
-            <a:ext cx="5257800" cy="2286000"/>
+            <a:off x="698500" y="1244600"/>
+            <a:ext cx="5080000" cy="2349500"/>
           </a:xfrm>
           <a:prstGeom prst="roundRect">
             <a:avLst/>
@@ -24135,8 +24459,8 @@
         </p:nvSpPr>
         <p:spPr>
           <a:xfrm>
-            <a:off x="4069080" y="1508760"/>
-            <a:ext cx="1737360" cy="365760"/>
+            <a:off x="4191000" y="1371600"/>
+            <a:ext cx="1460500" cy="330200"/>
           </a:xfrm>
           <a:prstGeom prst="roundRect">
             <a:avLst/>
@@ -24175,7 +24499,7 @@
               </a:defRPr>
             </a:pPr>
             <a:r>
-              <a:rPr>
+              <a:rPr sz="1000">
                 <a:latin typeface="Trebuchet MS" panose="020B0603020202020204" pitchFamily="34" charset="0"/>
               </a:rPr>
               <a:t>690,00 € Netto</a:t>
@@ -24191,8 +24515,8 @@
         </p:nvSpPr>
         <p:spPr>
           <a:xfrm>
-            <a:off x="914400" y="1481328"/>
-            <a:ext cx="2517484" cy="423193"/>
+            <a:off x="889000" y="1371600"/>
+            <a:ext cx="3175000" cy="415498"/>
           </a:xfrm>
           <a:prstGeom prst="rect">
             <a:avLst/>
@@ -24200,7 +24524,7 @@
           <a:noFill/>
         </p:spPr>
         <p:txBody>
-          <a:bodyPr wrap="none">
+          <a:bodyPr wrap="square">
             <a:spAutoFit/>
           </a:bodyPr>
           <a:lstStyle/>
@@ -24214,7 +24538,7 @@
               </a:defRPr>
             </a:pPr>
             <a:r>
-              <a:rPr>
+              <a:rPr sz="950">
                 <a:latin typeface="Trebuchet MS" panose="020B0603020202020204" pitchFamily="34" charset="0"/>
               </a:rPr>
               <a:t>STANDARD-PC (12 STÜCK)</a:t>
@@ -24230,7 +24554,7 @@
               </a:defRPr>
             </a:pPr>
             <a:r>
-              <a:rPr>
+              <a:rPr sz="1150">
                 <a:latin typeface="Trebuchet MS" panose="020B0603020202020204" pitchFamily="34" charset="0"/>
               </a:rPr>
               <a:t>Lenovo ThinkCentre M70s Gen 4</a:t>
@@ -24246,8 +24570,8 @@
         </p:nvSpPr>
         <p:spPr>
           <a:xfrm>
-            <a:off x="914400" y="2194560"/>
-            <a:ext cx="4892040" cy="754053"/>
+            <a:off x="889000" y="2006600"/>
+            <a:ext cx="4699000" cy="754053"/>
           </a:xfrm>
           <a:prstGeom prst="rect">
             <a:avLst/>
@@ -24345,8 +24669,8 @@
         </p:nvSpPr>
         <p:spPr>
           <a:xfrm>
-            <a:off x="6172200" y="1371600"/>
-            <a:ext cx="5257800" cy="2286000"/>
+            <a:off x="6159500" y="1244600"/>
+            <a:ext cx="5080000" cy="2349500"/>
           </a:xfrm>
           <a:prstGeom prst="roundRect">
             <a:avLst/>
@@ -24393,8 +24717,8 @@
         </p:nvSpPr>
         <p:spPr>
           <a:xfrm>
-            <a:off x="9509760" y="1508760"/>
-            <a:ext cx="1737360" cy="365760"/>
+            <a:off x="9652000" y="1371600"/>
+            <a:ext cx="1460500" cy="330200"/>
           </a:xfrm>
           <a:prstGeom prst="roundRect">
             <a:avLst/>
@@ -24433,7 +24757,7 @@
               </a:defRPr>
             </a:pPr>
             <a:r>
-              <a:rPr>
+              <a:rPr sz="1000">
                 <a:latin typeface="Trebuchet MS" panose="020B0603020202020204" pitchFamily="34" charset="0"/>
               </a:rPr>
               <a:t>3.200,00 € Netto</a:t>
@@ -24449,8 +24773,8 @@
         </p:nvSpPr>
         <p:spPr>
           <a:xfrm>
-            <a:off x="6355080" y="1481328"/>
-            <a:ext cx="2368277" cy="423193"/>
+            <a:off x="6350000" y="1371600"/>
+            <a:ext cx="3175000" cy="415498"/>
           </a:xfrm>
           <a:prstGeom prst="rect">
             <a:avLst/>
@@ -24458,7 +24782,7 @@
           <a:noFill/>
         </p:spPr>
         <p:txBody>
-          <a:bodyPr wrap="none">
+          <a:bodyPr wrap="square">
             <a:spAutoFit/>
           </a:bodyPr>
           <a:lstStyle/>
@@ -24472,7 +24796,7 @@
               </a:defRPr>
             </a:pPr>
             <a:r>
-              <a:rPr>
+              <a:rPr sz="950">
                 <a:latin typeface="Trebuchet MS" panose="020B0603020202020204" pitchFamily="34" charset="0"/>
               </a:rPr>
               <a:t>CAD-WORKSTATION (4 STÜCK)</a:t>
@@ -24488,7 +24812,7 @@
               </a:defRPr>
             </a:pPr>
             <a:r>
-              <a:rPr>
+              <a:rPr sz="1150">
                 <a:latin typeface="Trebuchet MS" panose="020B0603020202020204" pitchFamily="34" charset="0"/>
               </a:rPr>
               <a:t>Lenovo ThinkStation P3 Tower</a:t>
@@ -24504,8 +24828,8 @@
         </p:nvSpPr>
         <p:spPr>
           <a:xfrm>
-            <a:off x="6355080" y="2194560"/>
-            <a:ext cx="4892040" cy="754053"/>
+            <a:off x="6350000" y="2006600"/>
+            <a:ext cx="4699000" cy="754053"/>
           </a:xfrm>
           <a:prstGeom prst="rect">
             <a:avLst/>
@@ -24603,8 +24927,8 @@
         </p:nvSpPr>
         <p:spPr>
           <a:xfrm>
-            <a:off x="731520" y="3840480"/>
-            <a:ext cx="5257800" cy="2286000"/>
+            <a:off x="698500" y="3759200"/>
+            <a:ext cx="5080000" cy="2349500"/>
           </a:xfrm>
           <a:prstGeom prst="roundRect">
             <a:avLst/>
@@ -24651,8 +24975,8 @@
         </p:nvSpPr>
         <p:spPr>
           <a:xfrm>
-            <a:off x="4069080" y="3977640"/>
-            <a:ext cx="1737360" cy="365760"/>
+            <a:off x="4191000" y="3886200"/>
+            <a:ext cx="1460500" cy="330200"/>
           </a:xfrm>
           <a:prstGeom prst="roundRect">
             <a:avLst/>
@@ -24691,7 +25015,7 @@
               </a:defRPr>
             </a:pPr>
             <a:r>
-              <a:rPr>
+              <a:rPr sz="1000">
                 <a:latin typeface="Trebuchet MS" panose="020B0603020202020204" pitchFamily="34" charset="0"/>
               </a:rPr>
               <a:t>310,00 € Netto</a:t>
@@ -24707,8 +25031,8 @@
         </p:nvSpPr>
         <p:spPr>
           <a:xfrm>
-            <a:off x="914400" y="3950208"/>
-            <a:ext cx="2286203" cy="423193"/>
+            <a:off x="889000" y="3886200"/>
+            <a:ext cx="3175000" cy="415498"/>
           </a:xfrm>
           <a:prstGeom prst="rect">
             <a:avLst/>
@@ -24716,7 +25040,7 @@
           <a:noFill/>
         </p:spPr>
         <p:txBody>
-          <a:bodyPr wrap="none">
+          <a:bodyPr wrap="square">
             <a:spAutoFit/>
           </a:bodyPr>
           <a:lstStyle/>
@@ -24730,7 +25054,7 @@
               </a:defRPr>
             </a:pPr>
             <a:r>
-              <a:rPr>
+              <a:rPr sz="950">
                 <a:latin typeface="Trebuchet MS" panose="020B0603020202020204" pitchFamily="34" charset="0"/>
               </a:rPr>
               <a:t>ERGONOMIE-BILDSCHIRM (32 STÜCK)</a:t>
@@ -24746,7 +25070,7 @@
               </a:defRPr>
             </a:pPr>
             <a:r>
-              <a:rPr>
+              <a:rPr sz="1150">
                 <a:latin typeface="Trebuchet MS" panose="020B0603020202020204" pitchFamily="34" charset="0"/>
               </a:rPr>
               <a:t>Dell UltraSharp U2724D (27'')</a:t>
@@ -24762,8 +25086,8 @@
         </p:nvSpPr>
         <p:spPr>
           <a:xfrm>
-            <a:off x="914400" y="4663440"/>
-            <a:ext cx="4892040" cy="754053"/>
+            <a:off x="889000" y="4521200"/>
+            <a:ext cx="4699000" cy="754053"/>
           </a:xfrm>
           <a:prstGeom prst="rect">
             <a:avLst/>
@@ -24861,8 +25185,8 @@
         </p:nvSpPr>
         <p:spPr>
           <a:xfrm>
-            <a:off x="6172200" y="3840480"/>
-            <a:ext cx="5257800" cy="2286000"/>
+            <a:off x="6159500" y="3759200"/>
+            <a:ext cx="5080000" cy="2349500"/>
           </a:xfrm>
           <a:prstGeom prst="roundRect">
             <a:avLst/>
@@ -24909,8 +25233,8 @@
         </p:nvSpPr>
         <p:spPr>
           <a:xfrm>
-            <a:off x="9509760" y="3977640"/>
-            <a:ext cx="1737360" cy="365760"/>
+            <a:off x="9652000" y="3886200"/>
+            <a:ext cx="1460500" cy="330200"/>
           </a:xfrm>
           <a:prstGeom prst="roundRect">
             <a:avLst/>
@@ -24949,7 +25273,7 @@
               </a:defRPr>
             </a:pPr>
             <a:r>
-              <a:rPr>
+              <a:rPr sz="1000">
                 <a:latin typeface="Trebuchet MS" panose="020B0603020202020204" pitchFamily="34" charset="0"/>
               </a:rPr>
               <a:t>2.200,00 € Netto</a:t>
@@ -24965,8 +25289,8 @@
         </p:nvSpPr>
         <p:spPr>
           <a:xfrm>
-            <a:off x="6355080" y="3950208"/>
-            <a:ext cx="2369110" cy="423193"/>
+            <a:off x="6350000" y="3886200"/>
+            <a:ext cx="3175000" cy="415498"/>
           </a:xfrm>
           <a:prstGeom prst="rect">
             <a:avLst/>
@@ -24974,7 +25298,7 @@
           <a:noFill/>
         </p:spPr>
         <p:txBody>
-          <a:bodyPr wrap="none">
+          <a:bodyPr wrap="square">
             <a:spAutoFit/>
           </a:bodyPr>
           <a:lstStyle/>
@@ -24988,7 +25312,7 @@
               </a:defRPr>
             </a:pPr>
             <a:r>
-              <a:rPr>
+              <a:rPr sz="950">
                 <a:latin typeface="Trebuchet MS" panose="020B0603020202020204" pitchFamily="34" charset="0"/>
               </a:rPr>
               <a:t>ZENTRALER FARB-DRUCKER (1 STÜCK)</a:t>
@@ -25004,7 +25328,7 @@
               </a:defRPr>
             </a:pPr>
             <a:r>
-              <a:rPr>
+              <a:rPr sz="1150">
                 <a:latin typeface="Trebuchet MS" panose="020B0603020202020204" pitchFamily="34" charset="0"/>
               </a:rPr>
               <a:t>Lexmark CX930dse A3/A4 MFP</a:t>
@@ -25020,8 +25344,8 @@
         </p:nvSpPr>
         <p:spPr>
           <a:xfrm>
-            <a:off x="6355080" y="4663440"/>
-            <a:ext cx="4892040" cy="754053"/>
+            <a:off x="6350000" y="4521200"/>
+            <a:ext cx="4699000" cy="754053"/>
           </a:xfrm>
           <a:prstGeom prst="rect">
             <a:avLst/>
@@ -25111,6 +25435,36 @@
           </a:p>
         </p:txBody>
       </p:sp>
+      <p:pic>
+        <p:nvPicPr>
+          <p:cNvPr id="22" name="NextLevelLogo_8">
+            <a:extLst>
+              <a:ext uri="{FF2B5EF4-FFF2-40B4-BE49-F238E27FC236}">
+                <a16:creationId xmlns:a16="http://schemas.microsoft.com/office/drawing/2014/main" id="{3C9CBA65-C386-0F27-8250-471C1F258044}"/>
+              </a:ext>
+            </a:extLst>
+          </p:cNvPr>
+          <p:cNvPicPr>
+            <a:picLocks/>
+          </p:cNvPicPr>
+          <p:nvPr/>
+        </p:nvPicPr>
+        <p:blipFill>
+          <a:blip r:embed="rId3"/>
+          <a:stretch>
+            <a:fillRect/>
+          </a:stretch>
+        </p:blipFill>
+        <p:spPr>
+          <a:xfrm>
+            <a:off x="10566400" y="5918200"/>
+            <a:ext cx="1473200" cy="814070"/>
+          </a:xfrm>
+          <a:prstGeom prst="rect">
+            <a:avLst/>
+          </a:prstGeom>
+        </p:spPr>
+      </p:pic>
     </p:spTree>
   </p:cSld>
   <p:clrMapOvr>
@@ -25144,8 +25498,8 @@
         </p:nvSpPr>
         <p:spPr>
           <a:xfrm>
-            <a:off x="698500" y="152400"/>
-            <a:ext cx="6232796" cy="569387"/>
+            <a:off x="698500" y="152399"/>
+            <a:ext cx="6508513" cy="592470"/>
           </a:xfrm>
           <a:prstGeom prst="rect">
             <a:avLst/>
@@ -25167,7 +25521,7 @@
               </a:defRPr>
             </a:pPr>
             <a:r>
-              <a:rPr sz="1000" b="1">
+              <a:rPr sz="1050" b="1">
                 <a:solidFill>
                   <a:srgbClr val="54A021"/>
                 </a:solidFill>
@@ -25186,7 +25540,7 @@
               </a:defRPr>
             </a:pPr>
             <a:r>
-              <a:rPr sz="2100" b="1">
+              <a:rPr sz="2200" b="1">
                 <a:solidFill>
                   <a:srgbClr val="2C3C43"/>
                 </a:solidFill>
@@ -25205,7 +25559,7 @@
         </p:nvSpPr>
         <p:spPr>
           <a:xfrm>
-            <a:off x="731520" y="6446520"/>
+            <a:off x="698500" y="6413500"/>
             <a:ext cx="5791970" cy="230832"/>
           </a:xfrm>
           <a:prstGeom prst="rect">
@@ -25247,8 +25601,8 @@
         </p:nvSpPr>
         <p:spPr>
           <a:xfrm>
-            <a:off x="731520" y="1371600"/>
-            <a:ext cx="5257800" cy="4846320"/>
+            <a:off x="698500" y="1371600"/>
+            <a:ext cx="5080000" cy="4846320"/>
           </a:xfrm>
           <a:prstGeom prst="roundRect">
             <a:avLst/>
@@ -25295,8 +25649,8 @@
         </p:nvSpPr>
         <p:spPr>
           <a:xfrm>
-            <a:off x="731520" y="1371600"/>
-            <a:ext cx="5257800" cy="548640"/>
+            <a:off x="698500" y="1371600"/>
+            <a:ext cx="5080000" cy="548640"/>
           </a:xfrm>
           <a:prstGeom prst="rect">
             <a:avLst/>
@@ -25351,8 +25705,8 @@
         </p:nvSpPr>
         <p:spPr>
           <a:xfrm>
-            <a:off x="914400" y="2011680"/>
-            <a:ext cx="4892040" cy="2877711"/>
+            <a:off x="889000" y="2011680"/>
+            <a:ext cx="4699000" cy="2877711"/>
           </a:xfrm>
           <a:prstGeom prst="rect">
             <a:avLst/>
@@ -25512,8 +25866,8 @@
         </p:nvSpPr>
         <p:spPr>
           <a:xfrm>
-            <a:off x="6217920" y="1371600"/>
-            <a:ext cx="5257800" cy="4846320"/>
+            <a:off x="6159500" y="1371600"/>
+            <a:ext cx="5080000" cy="4846320"/>
           </a:xfrm>
           <a:prstGeom prst="roundRect">
             <a:avLst/>
@@ -25560,8 +25914,8 @@
         </p:nvSpPr>
         <p:spPr>
           <a:xfrm>
-            <a:off x="6217920" y="1371600"/>
-            <a:ext cx="5257800" cy="548640"/>
+            <a:off x="6159500" y="1371600"/>
+            <a:ext cx="5080000" cy="548640"/>
           </a:xfrm>
           <a:prstGeom prst="rect">
             <a:avLst/>
@@ -25616,8 +25970,8 @@
         </p:nvSpPr>
         <p:spPr>
           <a:xfrm>
-            <a:off x="6400800" y="2011680"/>
-            <a:ext cx="4892040" cy="2731517"/>
+            <a:off x="6350000" y="2011680"/>
+            <a:ext cx="4699000" cy="2731517"/>
           </a:xfrm>
           <a:prstGeom prst="rect">
             <a:avLst/>
@@ -25769,6 +26123,36 @@
           </a:p>
         </p:txBody>
       </p:sp>
+      <p:pic>
+        <p:nvPicPr>
+          <p:cNvPr id="12" name="NextLevelLogo_9">
+            <a:extLst>
+              <a:ext uri="{FF2B5EF4-FFF2-40B4-BE49-F238E27FC236}">
+                <a16:creationId xmlns:a16="http://schemas.microsoft.com/office/drawing/2014/main" id="{5AA3B2A9-7ED1-85AF-3291-315FC15C85EE}"/>
+              </a:ext>
+            </a:extLst>
+          </p:cNvPr>
+          <p:cNvPicPr>
+            <a:picLocks/>
+          </p:cNvPicPr>
+          <p:nvPr/>
+        </p:nvPicPr>
+        <p:blipFill>
+          <a:blip r:embed="rId3"/>
+          <a:stretch>
+            <a:fillRect/>
+          </a:stretch>
+        </p:blipFill>
+        <p:spPr>
+          <a:xfrm>
+            <a:off x="10566400" y="5918200"/>
+            <a:ext cx="1473200" cy="814070"/>
+          </a:xfrm>
+          <a:prstGeom prst="rect">
+            <a:avLst/>
+          </a:prstGeom>
+        </p:spPr>
+      </p:pic>
     </p:spTree>
   </p:cSld>
   <p:clrMapOvr>

</xml_diff>

<commit_message>
Qualitaetsverbesserungen: Folie 1 Team-Box kompakter, Folie 12 Farben vereinheitlicht (alle 3 Spalten dunkelgruen)
</commit_message>
<xml_diff>
--- a/docs/08_Projektabschluss/Abschlusspraesentation.pptx
+++ b/docs/08_Projektabschluss/Abschlusspraesentation.pptx
@@ -7463,7 +7463,7 @@
         <p:spPr>
           <a:xfrm>
             <a:off x="762000" y="1206499"/>
-            <a:ext cx="9144000" cy="1554272"/>
+            <a:ext cx="9525000" cy="1554272"/>
           </a:xfrm>
           <a:prstGeom prst="rect">
             <a:avLst/>
@@ -7559,8 +7559,8 @@
         </p:nvSpPr>
         <p:spPr>
           <a:xfrm>
-            <a:off x="762000" y="4000500"/>
-            <a:ext cx="10033000" cy="1460500"/>
+            <a:off x="698500" y="3238500"/>
+            <a:ext cx="10604500" cy="1397000"/>
           </a:xfrm>
           <a:prstGeom prst="roundRect">
             <a:avLst/>
@@ -7607,8 +7607,8 @@
         </p:nvSpPr>
         <p:spPr>
           <a:xfrm>
-            <a:off x="952499" y="4127499"/>
-            <a:ext cx="6922088" cy="600164"/>
+            <a:off x="889000" y="3429000"/>
+            <a:ext cx="10160000" cy="952500"/>
           </a:xfrm>
           <a:prstGeom prst="rect">
             <a:avLst/>
@@ -11871,7 +11871,7 @@
             <a:avLst/>
           </a:prstGeom>
           <a:solidFill>
-            <a:srgbClr val="C55A11"/>
+            <a:srgbClr val="385723"/>
           </a:solidFill>
           <a:ln>
             <a:noFill/>

</xml_diff>